<commit_message>
feat(poster): give the 407M callout its scale context
The results column opened with 407 M and then LAION's .108 -> .143,
which invites reading .143 as weak performance rather than as what
finding 100 items among 407 million looks like. A line between them now
carries the footprint the scale implies -- 29.3 GB at 72 B/vec, 28x
compressed -- so the low absolute recall reads as task difficulty, and
the memory claim that motivates 1-bit coding lands where it is actually
meaningful. All three figures are the paper's own Sec. 4.1 values and
follow from the committed CSV (n_db 407,314,954 x 72 B; 2048/72).

The gap-ordered table directly below now does the rest of the work: .65,
.75 and .83 in the small-corpus rows make clear the LAION cell is low
because the task is hard, not because the correction is weak.
</commit_message>
<xml_diff>
--- a/poster/PMC_CIKM2026_poster.pptx
+++ b/poster/PMC_CIKM2026_poster.pptx
@@ -5624,7 +5624,7 @@
         </p:nvSpPr>
         <p:spPr>
           <a:xfrm>
-            <a:off x="20794690" y="9189720"/>
+            <a:off x="20794690" y="8961120"/>
             <a:ext cx="8520974" cy="548640"/>
           </a:xfrm>
           <a:prstGeom prst="rect">
@@ -5647,26 +5647,68 @@
               </a:spcAft>
             </a:pPr>
             <a:r>
+              <a:rPr sz="2400" b="1" i="0">
+                <a:solidFill>
+                  <a:srgbClr val="6F6F6F"/>
+                </a:solidFill>
+                <a:latin typeface="Times New Roman"/>
+              </a:rPr>
+              <a:t>LAION-400M  ·  29.3 GB at 72 B/vec  ·  28× compressed</a:t>
+            </a:r>
+          </a:p>
+        </p:txBody>
+      </p:sp>
+      <p:sp>
+        <p:nvSpPr>
+          <p:cNvPr id="57" name="TextBox 56"/>
+          <p:cNvSpPr txBox="1"/>
+          <p:nvPr/>
+        </p:nvSpPr>
+        <p:spPr>
+          <a:xfrm>
+            <a:off x="20794690" y="9692640"/>
+            <a:ext cx="8520974" cy="548640"/>
+          </a:xfrm>
+          <a:prstGeom prst="rect">
+            <a:avLst/>
+          </a:prstGeom>
+          <a:noFill/>
+        </p:spPr>
+        <p:txBody>
+          <a:bodyPr wrap="square" anchor="t" lIns="0" rIns="0" tIns="0" bIns="0">
+            <a:spAutoFit/>
+          </a:bodyPr>
+          <a:lstStyle/>
+          <a:p>
+            <a:pPr algn="l">
+              <a:lnSpc>
+                <a:spcPct val="108000"/>
+              </a:lnSpc>
+              <a:spcAft>
+                <a:spcPts val="0"/>
+              </a:spcAft>
+            </a:pPr>
+            <a:r>
               <a:rPr sz="2300" b="1" i="0">
                 <a:solidFill>
                   <a:srgbClr val="1F1F1F"/>
                 </a:solidFill>
                 <a:latin typeface="Times New Roman"/>
               </a:rPr>
-              <a:t>LAION-400M · CLIP · R@100, no reranking</a:t>
-            </a:r>
-          </a:p>
-        </p:txBody>
-      </p:sp>
-      <p:sp>
-        <p:nvSpPr>
-          <p:cNvPr id="57" name="Rectangle 56"/>
+              <a:t>CLIP · R@100, no reranking</a:t>
+            </a:r>
+          </a:p>
+        </p:txBody>
+      </p:sp>
+      <p:sp>
+        <p:nvSpPr>
+          <p:cNvPr id="58" name="Rectangle 57"/>
           <p:cNvSpPr/>
           <p:nvPr/>
         </p:nvSpPr>
         <p:spPr>
           <a:xfrm>
-            <a:off x="20794690" y="9875520"/>
+            <a:off x="20794690" y="10378440"/>
             <a:ext cx="6692174" cy="731520"/>
           </a:xfrm>
           <a:prstGeom prst="rect">
@@ -5706,13 +5748,13 @@
       </p:sp>
       <p:sp>
         <p:nvSpPr>
-          <p:cNvPr id="58" name="Rectangle 57"/>
+          <p:cNvPr id="59" name="Rectangle 58"/>
           <p:cNvSpPr/>
           <p:nvPr/>
         </p:nvSpPr>
         <p:spPr>
           <a:xfrm>
-            <a:off x="20794690" y="9875520"/>
+            <a:off x="20794690" y="10378440"/>
             <a:ext cx="5054229" cy="731520"/>
           </a:xfrm>
           <a:prstGeom prst="rect">
@@ -5750,13 +5792,13 @@
       </p:sp>
       <p:sp>
         <p:nvSpPr>
-          <p:cNvPr id="59" name="TextBox 58"/>
+          <p:cNvPr id="60" name="TextBox 59"/>
           <p:cNvSpPr txBox="1"/>
           <p:nvPr/>
         </p:nvSpPr>
         <p:spPr>
           <a:xfrm>
-            <a:off x="20977570" y="9875520"/>
+            <a:off x="20977570" y="10378440"/>
             <a:ext cx="6372134" cy="731520"/>
           </a:xfrm>
           <a:prstGeom prst="rect">
@@ -5792,13 +5834,13 @@
       </p:sp>
       <p:sp>
         <p:nvSpPr>
-          <p:cNvPr id="60" name="TextBox 59"/>
+          <p:cNvPr id="61" name="TextBox 60"/>
           <p:cNvSpPr txBox="1"/>
           <p:nvPr/>
         </p:nvSpPr>
         <p:spPr>
           <a:xfrm>
-            <a:off x="27651456" y="9875520"/>
+            <a:off x="27651456" y="10378440"/>
             <a:ext cx="1645920" cy="731520"/>
           </a:xfrm>
           <a:prstGeom prst="rect">
@@ -5834,13 +5876,13 @@
       </p:sp>
       <p:sp>
         <p:nvSpPr>
-          <p:cNvPr id="61" name="Rectangle 60"/>
+          <p:cNvPr id="62" name="Rectangle 61"/>
           <p:cNvSpPr/>
           <p:nvPr/>
         </p:nvSpPr>
         <p:spPr>
           <a:xfrm>
-            <a:off x="20794690" y="10771632"/>
+            <a:off x="20794690" y="11274552"/>
             <a:ext cx="6692174" cy="731520"/>
           </a:xfrm>
           <a:prstGeom prst="rect">
@@ -5880,13 +5922,13 @@
       </p:sp>
       <p:sp>
         <p:nvSpPr>
-          <p:cNvPr id="62" name="Rectangle 61"/>
+          <p:cNvPr id="63" name="Rectangle 62"/>
           <p:cNvSpPr/>
           <p:nvPr/>
         </p:nvSpPr>
         <p:spPr>
           <a:xfrm>
-            <a:off x="20794690" y="10771632"/>
+            <a:off x="20794690" y="11274552"/>
             <a:ext cx="6692174" cy="731520"/>
           </a:xfrm>
           <a:prstGeom prst="rect">
@@ -5924,13 +5966,13 @@
       </p:sp>
       <p:sp>
         <p:nvSpPr>
-          <p:cNvPr id="63" name="TextBox 62"/>
+          <p:cNvPr id="64" name="TextBox 63"/>
           <p:cNvSpPr txBox="1"/>
           <p:nvPr/>
         </p:nvSpPr>
         <p:spPr>
           <a:xfrm>
-            <a:off x="20977570" y="10771632"/>
+            <a:off x="20977570" y="11274552"/>
             <a:ext cx="6372134" cy="731520"/>
           </a:xfrm>
           <a:prstGeom prst="rect">
@@ -5966,13 +6008,13 @@
       </p:sp>
       <p:sp>
         <p:nvSpPr>
-          <p:cNvPr id="64" name="TextBox 63"/>
+          <p:cNvPr id="65" name="TextBox 64"/>
           <p:cNvSpPr txBox="1"/>
           <p:nvPr/>
         </p:nvSpPr>
         <p:spPr>
           <a:xfrm>
-            <a:off x="27651456" y="10771632"/>
+            <a:off x="27651456" y="11274552"/>
             <a:ext cx="1645920" cy="731520"/>
           </a:xfrm>
           <a:prstGeom prst="rect">
@@ -6008,13 +6050,13 @@
       </p:sp>
       <p:sp>
         <p:nvSpPr>
-          <p:cNvPr id="65" name="TextBox 64"/>
+          <p:cNvPr id="66" name="TextBox 65"/>
           <p:cNvSpPr txBox="1"/>
           <p:nvPr/>
         </p:nvSpPr>
         <p:spPr>
           <a:xfrm>
-            <a:off x="20794690" y="11795760"/>
+            <a:off x="20794690" y="12298680"/>
             <a:ext cx="8520974" cy="548640"/>
           </a:xfrm>
           <a:prstGeom prst="rect">
@@ -6059,13 +6101,13 @@
       </p:sp>
       <p:sp>
         <p:nvSpPr>
-          <p:cNvPr id="66" name="TextBox 65"/>
+          <p:cNvPr id="67" name="TextBox 66"/>
           <p:cNvSpPr txBox="1"/>
           <p:nvPr/>
         </p:nvSpPr>
         <p:spPr>
           <a:xfrm>
-            <a:off x="20794690" y="12801600"/>
+            <a:off x="20794690" y="13304520"/>
             <a:ext cx="8520974" cy="685800"/>
           </a:xfrm>
           <a:prstGeom prst="rect">
@@ -6101,13 +6143,13 @@
       </p:sp>
       <p:sp>
         <p:nvSpPr>
-          <p:cNvPr id="67" name="TextBox 66"/>
+          <p:cNvPr id="68" name="TextBox 67"/>
           <p:cNvSpPr txBox="1"/>
           <p:nvPr/>
         </p:nvSpPr>
         <p:spPr>
           <a:xfrm>
-            <a:off x="20794690" y="13578840"/>
+            <a:off x="20794690" y="14081760"/>
             <a:ext cx="777240" cy="548640"/>
           </a:xfrm>
           <a:prstGeom prst="rect">
@@ -6143,13 +6185,13 @@
       </p:sp>
       <p:sp>
         <p:nvSpPr>
-          <p:cNvPr id="68" name="TextBox 67"/>
+          <p:cNvPr id="69" name="TextBox 68"/>
           <p:cNvSpPr txBox="1"/>
           <p:nvPr/>
         </p:nvSpPr>
         <p:spPr>
           <a:xfrm>
-            <a:off x="21571930" y="13578840"/>
+            <a:off x="21571930" y="14081760"/>
             <a:ext cx="2743200" cy="548640"/>
           </a:xfrm>
           <a:prstGeom prst="rect">
@@ -6185,13 +6227,13 @@
       </p:sp>
       <p:sp>
         <p:nvSpPr>
-          <p:cNvPr id="69" name="TextBox 68"/>
+          <p:cNvPr id="70" name="TextBox 69"/>
           <p:cNvSpPr txBox="1"/>
           <p:nvPr/>
         </p:nvSpPr>
         <p:spPr>
           <a:xfrm>
-            <a:off x="24315130" y="13578840"/>
+            <a:off x="24315130" y="14081760"/>
             <a:ext cx="2500267" cy="548640"/>
           </a:xfrm>
           <a:prstGeom prst="rect">
@@ -6227,13 +6269,13 @@
       </p:sp>
       <p:sp>
         <p:nvSpPr>
-          <p:cNvPr id="70" name="TextBox 69"/>
+          <p:cNvPr id="71" name="TextBox 70"/>
           <p:cNvSpPr txBox="1"/>
           <p:nvPr/>
         </p:nvSpPr>
         <p:spPr>
           <a:xfrm>
-            <a:off x="26815397" y="13578840"/>
+            <a:off x="26815397" y="14081760"/>
             <a:ext cx="2500267" cy="548640"/>
           </a:xfrm>
           <a:prstGeom prst="rect">
@@ -6269,13 +6311,13 @@
       </p:sp>
       <p:sp>
         <p:nvSpPr>
-          <p:cNvPr id="71" name="Rectangle 70"/>
+          <p:cNvPr id="72" name="Rectangle 71"/>
           <p:cNvSpPr/>
           <p:nvPr/>
         </p:nvSpPr>
         <p:spPr>
           <a:xfrm>
-            <a:off x="20794690" y="14200632"/>
+            <a:off x="20794690" y="14703552"/>
             <a:ext cx="8520974" cy="20320"/>
           </a:xfrm>
           <a:prstGeom prst="rect">
@@ -6313,13 +6355,13 @@
       </p:sp>
       <p:sp>
         <p:nvSpPr>
-          <p:cNvPr id="72" name="TextBox 71"/>
+          <p:cNvPr id="73" name="TextBox 72"/>
           <p:cNvSpPr txBox="1"/>
           <p:nvPr/>
         </p:nvSpPr>
         <p:spPr>
           <a:xfrm>
-            <a:off x="20794690" y="14401800"/>
+            <a:off x="20794690" y="14904720"/>
             <a:ext cx="777240" cy="566928"/>
           </a:xfrm>
           <a:prstGeom prst="rect">
@@ -6355,13 +6397,13 @@
       </p:sp>
       <p:sp>
         <p:nvSpPr>
-          <p:cNvPr id="73" name="TextBox 72"/>
+          <p:cNvPr id="74" name="TextBox 73"/>
           <p:cNvSpPr txBox="1"/>
           <p:nvPr/>
         </p:nvSpPr>
         <p:spPr>
           <a:xfrm>
-            <a:off x="21571930" y="14401800"/>
+            <a:off x="21571930" y="14904720"/>
             <a:ext cx="2743200" cy="566928"/>
           </a:xfrm>
           <a:prstGeom prst="rect">
@@ -6397,13 +6439,13 @@
       </p:sp>
       <p:sp>
         <p:nvSpPr>
-          <p:cNvPr id="74" name="TextBox 73"/>
+          <p:cNvPr id="75" name="TextBox 74"/>
           <p:cNvSpPr txBox="1"/>
           <p:nvPr/>
         </p:nvSpPr>
         <p:spPr>
           <a:xfrm>
-            <a:off x="24315130" y="14346936"/>
+            <a:off x="24315130" y="14849856"/>
             <a:ext cx="2500267" cy="658368"/>
           </a:xfrm>
           <a:prstGeom prst="rect">
@@ -6457,13 +6499,13 @@
       </p:sp>
       <p:sp>
         <p:nvSpPr>
-          <p:cNvPr id="75" name="TextBox 74"/>
+          <p:cNvPr id="76" name="TextBox 75"/>
           <p:cNvSpPr txBox="1"/>
           <p:nvPr/>
         </p:nvSpPr>
         <p:spPr>
           <a:xfrm>
-            <a:off x="26815397" y="14346936"/>
+            <a:off x="26815397" y="14849856"/>
             <a:ext cx="2500267" cy="658368"/>
           </a:xfrm>
           <a:prstGeom prst="rect">
@@ -6517,13 +6559,13 @@
       </p:sp>
       <p:sp>
         <p:nvSpPr>
-          <p:cNvPr id="76" name="Rectangle 75"/>
+          <p:cNvPr id="77" name="Rectangle 76"/>
           <p:cNvSpPr/>
           <p:nvPr/>
         </p:nvSpPr>
         <p:spPr>
           <a:xfrm>
-            <a:off x="20794690" y="15041880"/>
+            <a:off x="20794690" y="15544800"/>
             <a:ext cx="8520974" cy="10160"/>
           </a:xfrm>
           <a:prstGeom prst="rect">
@@ -6561,13 +6603,13 @@
       </p:sp>
       <p:sp>
         <p:nvSpPr>
-          <p:cNvPr id="77" name="TextBox 76"/>
+          <p:cNvPr id="78" name="TextBox 77"/>
           <p:cNvSpPr txBox="1"/>
           <p:nvPr/>
         </p:nvSpPr>
         <p:spPr>
           <a:xfrm>
-            <a:off x="20794690" y="15151608"/>
+            <a:off x="20794690" y="15654528"/>
             <a:ext cx="777240" cy="566928"/>
           </a:xfrm>
           <a:prstGeom prst="rect">
@@ -6603,13 +6645,13 @@
       </p:sp>
       <p:sp>
         <p:nvSpPr>
-          <p:cNvPr id="78" name="TextBox 77"/>
+          <p:cNvPr id="79" name="TextBox 78"/>
           <p:cNvSpPr txBox="1"/>
           <p:nvPr/>
         </p:nvSpPr>
         <p:spPr>
           <a:xfrm>
-            <a:off x="21571930" y="15151608"/>
+            <a:off x="21571930" y="15654528"/>
             <a:ext cx="2743200" cy="566928"/>
           </a:xfrm>
           <a:prstGeom prst="rect">
@@ -6645,13 +6687,13 @@
       </p:sp>
       <p:sp>
         <p:nvSpPr>
-          <p:cNvPr id="79" name="TextBox 78"/>
+          <p:cNvPr id="80" name="TextBox 79"/>
           <p:cNvSpPr txBox="1"/>
           <p:nvPr/>
         </p:nvSpPr>
         <p:spPr>
           <a:xfrm>
-            <a:off x="24315130" y="15096744"/>
+            <a:off x="24315130" y="15599664"/>
             <a:ext cx="2500267" cy="658368"/>
           </a:xfrm>
           <a:prstGeom prst="rect">
@@ -6705,13 +6747,13 @@
       </p:sp>
       <p:sp>
         <p:nvSpPr>
-          <p:cNvPr id="80" name="TextBox 79"/>
+          <p:cNvPr id="81" name="TextBox 80"/>
           <p:cNvSpPr txBox="1"/>
           <p:nvPr/>
         </p:nvSpPr>
         <p:spPr>
           <a:xfrm>
-            <a:off x="26815397" y="15096744"/>
+            <a:off x="26815397" y="15599664"/>
             <a:ext cx="2500267" cy="658368"/>
           </a:xfrm>
           <a:prstGeom prst="rect">
@@ -6765,13 +6807,13 @@
       </p:sp>
       <p:sp>
         <p:nvSpPr>
-          <p:cNvPr id="81" name="Rectangle 80"/>
+          <p:cNvPr id="82" name="Rectangle 81"/>
           <p:cNvSpPr/>
           <p:nvPr/>
         </p:nvSpPr>
         <p:spPr>
           <a:xfrm>
-            <a:off x="20794690" y="15791688"/>
+            <a:off x="20794690" y="16294608"/>
             <a:ext cx="8520974" cy="10160"/>
           </a:xfrm>
           <a:prstGeom prst="rect">
@@ -6809,13 +6851,13 @@
       </p:sp>
       <p:sp>
         <p:nvSpPr>
-          <p:cNvPr id="82" name="TextBox 81"/>
+          <p:cNvPr id="83" name="TextBox 82"/>
           <p:cNvSpPr txBox="1"/>
           <p:nvPr/>
         </p:nvSpPr>
         <p:spPr>
           <a:xfrm>
-            <a:off x="20794690" y="15901416"/>
+            <a:off x="20794690" y="16404336"/>
             <a:ext cx="777240" cy="566928"/>
           </a:xfrm>
           <a:prstGeom prst="rect">
@@ -6851,13 +6893,13 @@
       </p:sp>
       <p:sp>
         <p:nvSpPr>
-          <p:cNvPr id="83" name="TextBox 82"/>
+          <p:cNvPr id="84" name="TextBox 83"/>
           <p:cNvSpPr txBox="1"/>
           <p:nvPr/>
         </p:nvSpPr>
         <p:spPr>
           <a:xfrm>
-            <a:off x="21571930" y="15901416"/>
+            <a:off x="21571930" y="16404336"/>
             <a:ext cx="2743200" cy="566928"/>
           </a:xfrm>
           <a:prstGeom prst="rect">
@@ -6893,13 +6935,13 @@
       </p:sp>
       <p:sp>
         <p:nvSpPr>
-          <p:cNvPr id="84" name="TextBox 83"/>
+          <p:cNvPr id="85" name="TextBox 84"/>
           <p:cNvSpPr txBox="1"/>
           <p:nvPr/>
         </p:nvSpPr>
         <p:spPr>
           <a:xfrm>
-            <a:off x="24315130" y="15846552"/>
+            <a:off x="24315130" y="16349472"/>
             <a:ext cx="2500267" cy="658368"/>
           </a:xfrm>
           <a:prstGeom prst="rect">
@@ -6953,13 +6995,13 @@
       </p:sp>
       <p:sp>
         <p:nvSpPr>
-          <p:cNvPr id="85" name="TextBox 84"/>
+          <p:cNvPr id="86" name="TextBox 85"/>
           <p:cNvSpPr txBox="1"/>
           <p:nvPr/>
         </p:nvSpPr>
         <p:spPr>
           <a:xfrm>
-            <a:off x="26815397" y="15846552"/>
+            <a:off x="26815397" y="16349472"/>
             <a:ext cx="2500267" cy="658368"/>
           </a:xfrm>
           <a:prstGeom prst="rect">
@@ -7013,13 +7055,13 @@
       </p:sp>
       <p:sp>
         <p:nvSpPr>
-          <p:cNvPr id="86" name="Rectangle 85"/>
+          <p:cNvPr id="87" name="Rectangle 86"/>
           <p:cNvSpPr/>
           <p:nvPr/>
         </p:nvSpPr>
         <p:spPr>
           <a:xfrm>
-            <a:off x="20794690" y="16541496"/>
+            <a:off x="20794690" y="17044416"/>
             <a:ext cx="8520974" cy="10160"/>
           </a:xfrm>
           <a:prstGeom prst="rect">
@@ -7057,13 +7099,13 @@
       </p:sp>
       <p:sp>
         <p:nvSpPr>
-          <p:cNvPr id="87" name="TextBox 86"/>
+          <p:cNvPr id="88" name="TextBox 87"/>
           <p:cNvSpPr txBox="1"/>
           <p:nvPr/>
         </p:nvSpPr>
         <p:spPr>
           <a:xfrm>
-            <a:off x="20794690" y="16651224"/>
+            <a:off x="20794690" y="17154144"/>
             <a:ext cx="777240" cy="566928"/>
           </a:xfrm>
           <a:prstGeom prst="rect">
@@ -7099,13 +7141,13 @@
       </p:sp>
       <p:sp>
         <p:nvSpPr>
-          <p:cNvPr id="88" name="TextBox 87"/>
+          <p:cNvPr id="89" name="TextBox 88"/>
           <p:cNvSpPr txBox="1"/>
           <p:nvPr/>
         </p:nvSpPr>
         <p:spPr>
           <a:xfrm>
-            <a:off x="21571930" y="16651224"/>
+            <a:off x="21571930" y="17154144"/>
             <a:ext cx="2743200" cy="566928"/>
           </a:xfrm>
           <a:prstGeom prst="rect">
@@ -7141,13 +7183,13 @@
       </p:sp>
       <p:sp>
         <p:nvSpPr>
-          <p:cNvPr id="89" name="TextBox 88"/>
+          <p:cNvPr id="90" name="TextBox 89"/>
           <p:cNvSpPr txBox="1"/>
           <p:nvPr/>
         </p:nvSpPr>
         <p:spPr>
           <a:xfrm>
-            <a:off x="24315130" y="16596360"/>
+            <a:off x="24315130" y="17099280"/>
             <a:ext cx="2500267" cy="658368"/>
           </a:xfrm>
           <a:prstGeom prst="rect">
@@ -7201,13 +7243,13 @@
       </p:sp>
       <p:sp>
         <p:nvSpPr>
-          <p:cNvPr id="90" name="TextBox 89"/>
+          <p:cNvPr id="91" name="TextBox 90"/>
           <p:cNvSpPr txBox="1"/>
           <p:nvPr/>
         </p:nvSpPr>
         <p:spPr>
           <a:xfrm>
-            <a:off x="26815397" y="16596360"/>
+            <a:off x="26815397" y="17099280"/>
             <a:ext cx="2500267" cy="658368"/>
           </a:xfrm>
           <a:prstGeom prst="rect">
@@ -7261,13 +7303,13 @@
       </p:sp>
       <p:sp>
         <p:nvSpPr>
-          <p:cNvPr id="91" name="Rectangle 90"/>
+          <p:cNvPr id="92" name="Rectangle 91"/>
           <p:cNvSpPr/>
           <p:nvPr/>
         </p:nvSpPr>
         <p:spPr>
           <a:xfrm>
-            <a:off x="20794690" y="17291304"/>
+            <a:off x="20794690" y="17794224"/>
             <a:ext cx="8520974" cy="10160"/>
           </a:xfrm>
           <a:prstGeom prst="rect">
@@ -7305,13 +7347,13 @@
       </p:sp>
       <p:sp>
         <p:nvSpPr>
-          <p:cNvPr id="92" name="TextBox 91"/>
+          <p:cNvPr id="93" name="TextBox 92"/>
           <p:cNvSpPr txBox="1"/>
           <p:nvPr/>
         </p:nvSpPr>
         <p:spPr>
           <a:xfrm>
-            <a:off x="20794690" y="17401032"/>
+            <a:off x="20794690" y="17903952"/>
             <a:ext cx="777240" cy="566928"/>
           </a:xfrm>
           <a:prstGeom prst="rect">
@@ -7347,13 +7389,13 @@
       </p:sp>
       <p:sp>
         <p:nvSpPr>
-          <p:cNvPr id="93" name="TextBox 92"/>
+          <p:cNvPr id="94" name="TextBox 93"/>
           <p:cNvSpPr txBox="1"/>
           <p:nvPr/>
         </p:nvSpPr>
         <p:spPr>
           <a:xfrm>
-            <a:off x="21571930" y="17401032"/>
+            <a:off x="21571930" y="17903952"/>
             <a:ext cx="2743200" cy="566928"/>
           </a:xfrm>
           <a:prstGeom prst="rect">
@@ -7389,13 +7431,13 @@
       </p:sp>
       <p:sp>
         <p:nvSpPr>
-          <p:cNvPr id="94" name="TextBox 93"/>
+          <p:cNvPr id="95" name="TextBox 94"/>
           <p:cNvSpPr txBox="1"/>
           <p:nvPr/>
         </p:nvSpPr>
         <p:spPr>
           <a:xfrm>
-            <a:off x="24315130" y="17346168"/>
+            <a:off x="24315130" y="17849088"/>
             <a:ext cx="2500267" cy="658368"/>
           </a:xfrm>
           <a:prstGeom prst="rect">
@@ -7449,13 +7491,13 @@
       </p:sp>
       <p:sp>
         <p:nvSpPr>
-          <p:cNvPr id="95" name="TextBox 94"/>
+          <p:cNvPr id="96" name="TextBox 95"/>
           <p:cNvSpPr txBox="1"/>
           <p:nvPr/>
         </p:nvSpPr>
         <p:spPr>
           <a:xfrm>
-            <a:off x="26815397" y="17346168"/>
+            <a:off x="26815397" y="17849088"/>
             <a:ext cx="2500267" cy="658368"/>
           </a:xfrm>
           <a:prstGeom prst="rect">
@@ -7509,13 +7551,13 @@
       </p:sp>
       <p:sp>
         <p:nvSpPr>
-          <p:cNvPr id="96" name="Rectangle 95"/>
+          <p:cNvPr id="97" name="Rectangle 96"/>
           <p:cNvSpPr/>
           <p:nvPr/>
         </p:nvSpPr>
         <p:spPr>
           <a:xfrm>
-            <a:off x="20794690" y="18041112"/>
+            <a:off x="20794690" y="18544032"/>
             <a:ext cx="8520974" cy="10160"/>
           </a:xfrm>
           <a:prstGeom prst="rect">
@@ -7553,13 +7595,13 @@
       </p:sp>
       <p:sp>
         <p:nvSpPr>
-          <p:cNvPr id="97" name="TextBox 96"/>
+          <p:cNvPr id="98" name="TextBox 97"/>
           <p:cNvSpPr txBox="1"/>
           <p:nvPr/>
         </p:nvSpPr>
         <p:spPr>
           <a:xfrm>
-            <a:off x="20794690" y="18150840"/>
+            <a:off x="20794690" y="18653760"/>
             <a:ext cx="777240" cy="566928"/>
           </a:xfrm>
           <a:prstGeom prst="rect">
@@ -7595,13 +7637,13 @@
       </p:sp>
       <p:sp>
         <p:nvSpPr>
-          <p:cNvPr id="98" name="TextBox 97"/>
+          <p:cNvPr id="99" name="TextBox 98"/>
           <p:cNvSpPr txBox="1"/>
           <p:nvPr/>
         </p:nvSpPr>
         <p:spPr>
           <a:xfrm>
-            <a:off x="21571930" y="18150840"/>
+            <a:off x="21571930" y="18653760"/>
             <a:ext cx="2743200" cy="566928"/>
           </a:xfrm>
           <a:prstGeom prst="rect">
@@ -7637,13 +7679,13 @@
       </p:sp>
       <p:sp>
         <p:nvSpPr>
-          <p:cNvPr id="99" name="TextBox 98"/>
+          <p:cNvPr id="100" name="TextBox 99"/>
           <p:cNvSpPr txBox="1"/>
           <p:nvPr/>
         </p:nvSpPr>
         <p:spPr>
           <a:xfrm>
-            <a:off x="24315130" y="18095976"/>
+            <a:off x="24315130" y="18598896"/>
             <a:ext cx="2500267" cy="658368"/>
           </a:xfrm>
           <a:prstGeom prst="rect">
@@ -7697,13 +7739,13 @@
       </p:sp>
       <p:sp>
         <p:nvSpPr>
-          <p:cNvPr id="100" name="TextBox 99"/>
+          <p:cNvPr id="101" name="TextBox 100"/>
           <p:cNvSpPr txBox="1"/>
           <p:nvPr/>
         </p:nvSpPr>
         <p:spPr>
           <a:xfrm>
-            <a:off x="26815397" y="18095976"/>
+            <a:off x="26815397" y="18598896"/>
             <a:ext cx="2500267" cy="658368"/>
           </a:xfrm>
           <a:prstGeom prst="rect">
@@ -7757,13 +7799,13 @@
       </p:sp>
       <p:sp>
         <p:nvSpPr>
-          <p:cNvPr id="101" name="Rectangle 100"/>
+          <p:cNvPr id="102" name="Rectangle 101"/>
           <p:cNvSpPr/>
           <p:nvPr/>
         </p:nvSpPr>
         <p:spPr>
           <a:xfrm>
-            <a:off x="20794690" y="18790920"/>
+            <a:off x="20794690" y="19293840"/>
             <a:ext cx="8520974" cy="10160"/>
           </a:xfrm>
           <a:prstGeom prst="rect">
@@ -7801,13 +7843,13 @@
       </p:sp>
       <p:sp>
         <p:nvSpPr>
-          <p:cNvPr id="102" name="TextBox 101"/>
+          <p:cNvPr id="103" name="TextBox 102"/>
           <p:cNvSpPr txBox="1"/>
           <p:nvPr/>
         </p:nvSpPr>
         <p:spPr>
           <a:xfrm>
-            <a:off x="20794690" y="18900648"/>
+            <a:off x="20794690" y="19403568"/>
             <a:ext cx="777240" cy="566928"/>
           </a:xfrm>
           <a:prstGeom prst="rect">
@@ -7843,13 +7885,13 @@
       </p:sp>
       <p:sp>
         <p:nvSpPr>
-          <p:cNvPr id="103" name="TextBox 102"/>
+          <p:cNvPr id="104" name="TextBox 103"/>
           <p:cNvSpPr txBox="1"/>
           <p:nvPr/>
         </p:nvSpPr>
         <p:spPr>
           <a:xfrm>
-            <a:off x="21571930" y="18900648"/>
+            <a:off x="21571930" y="19403568"/>
             <a:ext cx="2743200" cy="566928"/>
           </a:xfrm>
           <a:prstGeom prst="rect">
@@ -7885,13 +7927,13 @@
       </p:sp>
       <p:sp>
         <p:nvSpPr>
-          <p:cNvPr id="104" name="TextBox 103"/>
+          <p:cNvPr id="105" name="TextBox 104"/>
           <p:cNvSpPr txBox="1"/>
           <p:nvPr/>
         </p:nvSpPr>
         <p:spPr>
           <a:xfrm>
-            <a:off x="24315130" y="18845784"/>
+            <a:off x="24315130" y="19348704"/>
             <a:ext cx="2500267" cy="658368"/>
           </a:xfrm>
           <a:prstGeom prst="rect">
@@ -7945,13 +7987,13 @@
       </p:sp>
       <p:sp>
         <p:nvSpPr>
-          <p:cNvPr id="105" name="TextBox 104"/>
+          <p:cNvPr id="106" name="TextBox 105"/>
           <p:cNvSpPr txBox="1"/>
           <p:nvPr/>
         </p:nvSpPr>
         <p:spPr>
           <a:xfrm>
-            <a:off x="26815397" y="18845784"/>
+            <a:off x="26815397" y="19348704"/>
             <a:ext cx="2500267" cy="658368"/>
           </a:xfrm>
           <a:prstGeom prst="rect">
@@ -8005,13 +8047,13 @@
       </p:sp>
       <p:sp>
         <p:nvSpPr>
-          <p:cNvPr id="106" name="Rectangle 105"/>
+          <p:cNvPr id="107" name="Rectangle 106"/>
           <p:cNvSpPr/>
           <p:nvPr/>
         </p:nvSpPr>
         <p:spPr>
           <a:xfrm>
-            <a:off x="20794690" y="19540728"/>
+            <a:off x="20794690" y="20043648"/>
             <a:ext cx="8520974" cy="10160"/>
           </a:xfrm>
           <a:prstGeom prst="rect">
@@ -8049,13 +8091,13 @@
       </p:sp>
       <p:sp>
         <p:nvSpPr>
-          <p:cNvPr id="107" name="TextBox 106"/>
+          <p:cNvPr id="108" name="TextBox 107"/>
           <p:cNvSpPr txBox="1"/>
           <p:nvPr/>
         </p:nvSpPr>
         <p:spPr>
           <a:xfrm>
-            <a:off x="20794690" y="19869912"/>
+            <a:off x="20794690" y="20372832"/>
             <a:ext cx="8520974" cy="1463040"/>
           </a:xfrm>
           <a:prstGeom prst="rect">
@@ -8100,7 +8142,7 @@
       </p:sp>
       <p:pic>
         <p:nvPicPr>
-          <p:cNvPr id="108" name="Picture 107" descr="asset_fig3c.png"/>
+          <p:cNvPr id="109" name="Picture 108" descr="asset_fig3c.png"/>
           <p:cNvPicPr>
             <a:picLocks noChangeAspect="1"/>
           </p:cNvPicPr>
@@ -8114,7 +8156,7 @@
         </p:blipFill>
         <p:spPr>
           <a:xfrm>
-            <a:off x="20794690" y="21561552"/>
+            <a:off x="20794690" y="22064472"/>
             <a:ext cx="8520974" cy="6563834"/>
           </a:xfrm>
           <a:prstGeom prst="rect">
@@ -8124,13 +8166,13 @@
       </p:pic>
       <p:sp>
         <p:nvSpPr>
-          <p:cNvPr id="109" name="TextBox 108"/>
+          <p:cNvPr id="110" name="TextBox 109"/>
           <p:cNvSpPr txBox="1"/>
           <p:nvPr/>
         </p:nvSpPr>
         <p:spPr>
           <a:xfrm>
-            <a:off x="20794690" y="28308266"/>
+            <a:off x="20794690" y="28811186"/>
             <a:ext cx="8520974" cy="822960"/>
           </a:xfrm>
           <a:prstGeom prst="rect">
@@ -8184,7 +8226,7 @@
       </p:sp>
       <p:sp>
         <p:nvSpPr>
-          <p:cNvPr id="110" name="Rectangle 109"/>
+          <p:cNvPr id="111" name="Rectangle 110"/>
           <p:cNvSpPr/>
           <p:nvPr/>
         </p:nvSpPr>
@@ -8228,7 +8270,7 @@
       </p:sp>
       <p:sp>
         <p:nvSpPr>
-          <p:cNvPr id="111" name="Rectangle 110"/>
+          <p:cNvPr id="112" name="Rectangle 111"/>
           <p:cNvSpPr/>
           <p:nvPr/>
         </p:nvSpPr>
@@ -8272,7 +8314,7 @@
       </p:sp>
       <p:sp>
         <p:nvSpPr>
-          <p:cNvPr id="112" name="Rectangle 111"/>
+          <p:cNvPr id="113" name="Rectangle 112"/>
           <p:cNvSpPr/>
           <p:nvPr/>
         </p:nvSpPr>
@@ -8316,7 +8358,7 @@
       </p:sp>
       <p:sp>
         <p:nvSpPr>
-          <p:cNvPr id="113" name="TextBox 112"/>
+          <p:cNvPr id="114" name="TextBox 113"/>
           <p:cNvSpPr txBox="1"/>
           <p:nvPr/>
         </p:nvSpPr>
@@ -8358,7 +8400,7 @@
       </p:sp>
       <p:sp>
         <p:nvSpPr>
-          <p:cNvPr id="114" name="Rectangle 113"/>
+          <p:cNvPr id="115" name="Rectangle 114"/>
           <p:cNvSpPr/>
           <p:nvPr/>
         </p:nvSpPr>
@@ -8402,7 +8444,7 @@
       </p:sp>
       <p:pic>
         <p:nvPicPr>
-          <p:cNvPr id="115" name="Picture 114" descr="asset_fig3b.png"/>
+          <p:cNvPr id="116" name="Picture 115" descr="asset_fig3b.png"/>
           <p:cNvPicPr>
             <a:picLocks noChangeAspect="1"/>
           </p:cNvPicPr>
@@ -8426,7 +8468,7 @@
       </p:pic>
       <p:sp>
         <p:nvSpPr>
-          <p:cNvPr id="116" name="TextBox 115"/>
+          <p:cNvPr id="117" name="TextBox 116"/>
           <p:cNvSpPr txBox="1"/>
           <p:nvPr/>
         </p:nvSpPr>
@@ -8468,7 +8510,7 @@
       </p:sp>
       <p:sp>
         <p:nvSpPr>
-          <p:cNvPr id="117" name="TextBox 116"/>
+          <p:cNvPr id="118" name="TextBox 117"/>
           <p:cNvSpPr txBox="1"/>
           <p:nvPr/>
         </p:nvSpPr>
@@ -8528,7 +8570,7 @@
       </p:sp>
       <p:sp>
         <p:nvSpPr>
-          <p:cNvPr id="118" name="TextBox 117"/>
+          <p:cNvPr id="119" name="TextBox 118"/>
           <p:cNvSpPr txBox="1"/>
           <p:nvPr/>
         </p:nvSpPr>
@@ -8570,7 +8612,7 @@
       </p:sp>
       <p:sp>
         <p:nvSpPr>
-          <p:cNvPr id="119" name="Rectangle 118"/>
+          <p:cNvPr id="120" name="Rectangle 119"/>
           <p:cNvSpPr/>
           <p:nvPr/>
         </p:nvSpPr>
@@ -8614,7 +8656,7 @@
       </p:sp>
       <p:sp>
         <p:nvSpPr>
-          <p:cNvPr id="120" name="TextBox 119"/>
+          <p:cNvPr id="121" name="TextBox 120"/>
           <p:cNvSpPr txBox="1"/>
           <p:nvPr/>
         </p:nvSpPr>
@@ -8656,7 +8698,7 @@
       </p:sp>
       <p:sp>
         <p:nvSpPr>
-          <p:cNvPr id="121" name="Rectangle 120"/>
+          <p:cNvPr id="122" name="Rectangle 121"/>
           <p:cNvSpPr/>
           <p:nvPr/>
         </p:nvSpPr>
@@ -8702,7 +8744,7 @@
       </p:sp>
       <p:sp>
         <p:nvSpPr>
-          <p:cNvPr id="122" name="Rectangle 121"/>
+          <p:cNvPr id="123" name="Rectangle 122"/>
           <p:cNvSpPr/>
           <p:nvPr/>
         </p:nvSpPr>
@@ -8746,7 +8788,7 @@
       </p:sp>
       <p:sp>
         <p:nvSpPr>
-          <p:cNvPr id="123" name="TextBox 122"/>
+          <p:cNvPr id="124" name="TextBox 123"/>
           <p:cNvSpPr txBox="1"/>
           <p:nvPr/>
         </p:nvSpPr>
@@ -8788,7 +8830,7 @@
       </p:sp>
       <p:sp>
         <p:nvSpPr>
-          <p:cNvPr id="124" name="TextBox 123"/>
+          <p:cNvPr id="125" name="TextBox 124"/>
           <p:cNvSpPr txBox="1"/>
           <p:nvPr/>
         </p:nvSpPr>
@@ -8830,7 +8872,7 @@
       </p:sp>
       <p:sp>
         <p:nvSpPr>
-          <p:cNvPr id="125" name="Rectangle 124"/>
+          <p:cNvPr id="126" name="Rectangle 125"/>
           <p:cNvSpPr/>
           <p:nvPr/>
         </p:nvSpPr>
@@ -8876,7 +8918,7 @@
       </p:sp>
       <p:sp>
         <p:nvSpPr>
-          <p:cNvPr id="126" name="Rectangle 125"/>
+          <p:cNvPr id="127" name="Rectangle 126"/>
           <p:cNvSpPr/>
           <p:nvPr/>
         </p:nvSpPr>
@@ -8920,7 +8962,7 @@
       </p:sp>
       <p:sp>
         <p:nvSpPr>
-          <p:cNvPr id="127" name="TextBox 126"/>
+          <p:cNvPr id="128" name="TextBox 127"/>
           <p:cNvSpPr txBox="1"/>
           <p:nvPr/>
         </p:nvSpPr>
@@ -8962,7 +9004,7 @@
       </p:sp>
       <p:sp>
         <p:nvSpPr>
-          <p:cNvPr id="128" name="TextBox 127"/>
+          <p:cNvPr id="129" name="TextBox 128"/>
           <p:cNvSpPr txBox="1"/>
           <p:nvPr/>
         </p:nvSpPr>
@@ -9004,7 +9046,7 @@
       </p:sp>
       <p:sp>
         <p:nvSpPr>
-          <p:cNvPr id="129" name="Rectangle 128"/>
+          <p:cNvPr id="130" name="Rectangle 129"/>
           <p:cNvSpPr/>
           <p:nvPr/>
         </p:nvSpPr>
@@ -9050,7 +9092,7 @@
       </p:sp>
       <p:sp>
         <p:nvSpPr>
-          <p:cNvPr id="130" name="Rectangle 129"/>
+          <p:cNvPr id="131" name="Rectangle 130"/>
           <p:cNvSpPr/>
           <p:nvPr/>
         </p:nvSpPr>
@@ -9094,7 +9136,7 @@
       </p:sp>
       <p:sp>
         <p:nvSpPr>
-          <p:cNvPr id="131" name="TextBox 130"/>
+          <p:cNvPr id="132" name="TextBox 131"/>
           <p:cNvSpPr txBox="1"/>
           <p:nvPr/>
         </p:nvSpPr>
@@ -9136,7 +9178,7 @@
       </p:sp>
       <p:sp>
         <p:nvSpPr>
-          <p:cNvPr id="132" name="TextBox 131"/>
+          <p:cNvPr id="133" name="TextBox 132"/>
           <p:cNvSpPr txBox="1"/>
           <p:nvPr/>
         </p:nvSpPr>
@@ -9178,7 +9220,7 @@
       </p:sp>
       <p:sp>
         <p:nvSpPr>
-          <p:cNvPr id="133" name="Rectangle 132"/>
+          <p:cNvPr id="134" name="Rectangle 133"/>
           <p:cNvSpPr/>
           <p:nvPr/>
         </p:nvSpPr>
@@ -9224,7 +9266,7 @@
       </p:sp>
       <p:sp>
         <p:nvSpPr>
-          <p:cNvPr id="134" name="Rectangle 133"/>
+          <p:cNvPr id="135" name="Rectangle 134"/>
           <p:cNvSpPr/>
           <p:nvPr/>
         </p:nvSpPr>
@@ -9268,7 +9310,7 @@
       </p:sp>
       <p:sp>
         <p:nvSpPr>
-          <p:cNvPr id="135" name="TextBox 134"/>
+          <p:cNvPr id="136" name="TextBox 135"/>
           <p:cNvSpPr txBox="1"/>
           <p:nvPr/>
         </p:nvSpPr>
@@ -9310,7 +9352,7 @@
       </p:sp>
       <p:sp>
         <p:nvSpPr>
-          <p:cNvPr id="136" name="TextBox 135"/>
+          <p:cNvPr id="137" name="TextBox 136"/>
           <p:cNvSpPr txBox="1"/>
           <p:nvPr/>
         </p:nvSpPr>
@@ -9352,7 +9394,7 @@
       </p:sp>
       <p:sp>
         <p:nvSpPr>
-          <p:cNvPr id="137" name="TextBox 136"/>
+          <p:cNvPr id="138" name="TextBox 137"/>
           <p:cNvSpPr txBox="1"/>
           <p:nvPr/>
         </p:nvSpPr>
@@ -9432,7 +9474,7 @@
       </p:sp>
       <p:sp>
         <p:nvSpPr>
-          <p:cNvPr id="138" name="Rectangle 137"/>
+          <p:cNvPr id="139" name="Rectangle 138"/>
           <p:cNvSpPr/>
           <p:nvPr/>
         </p:nvSpPr>
@@ -9478,7 +9520,7 @@
       </p:sp>
       <p:sp>
         <p:nvSpPr>
-          <p:cNvPr id="139" name="Rectangle 138"/>
+          <p:cNvPr id="140" name="Rectangle 139"/>
           <p:cNvSpPr/>
           <p:nvPr/>
         </p:nvSpPr>
@@ -9522,7 +9564,7 @@
       </p:sp>
       <p:sp>
         <p:nvSpPr>
-          <p:cNvPr id="140" name="TextBox 139"/>
+          <p:cNvPr id="141" name="TextBox 140"/>
           <p:cNvSpPr txBox="1"/>
           <p:nvPr/>
         </p:nvSpPr>
@@ -9564,7 +9606,7 @@
       </p:sp>
       <p:sp>
         <p:nvSpPr>
-          <p:cNvPr id="141" name="TextBox 140"/>
+          <p:cNvPr id="142" name="TextBox 141"/>
           <p:cNvSpPr txBox="1"/>
           <p:nvPr/>
         </p:nvSpPr>
@@ -9606,7 +9648,7 @@
       </p:sp>
       <p:sp>
         <p:nvSpPr>
-          <p:cNvPr id="142" name="Rectangle 141"/>
+          <p:cNvPr id="143" name="Rectangle 142"/>
           <p:cNvSpPr/>
           <p:nvPr/>
         </p:nvSpPr>
@@ -9650,7 +9692,7 @@
       </p:sp>
       <p:sp>
         <p:nvSpPr>
-          <p:cNvPr id="143" name="TextBox 142"/>
+          <p:cNvPr id="144" name="TextBox 143"/>
           <p:cNvSpPr txBox="1"/>
           <p:nvPr/>
         </p:nvSpPr>
@@ -9692,7 +9734,7 @@
       </p:sp>
       <p:sp>
         <p:nvSpPr>
-          <p:cNvPr id="144" name="Rectangle 143"/>
+          <p:cNvPr id="145" name="Rectangle 144"/>
           <p:cNvSpPr/>
           <p:nvPr/>
         </p:nvSpPr>
@@ -9736,7 +9778,7 @@
       </p:sp>
       <p:sp>
         <p:nvSpPr>
-          <p:cNvPr id="145" name="TextBox 144"/>
+          <p:cNvPr id="146" name="TextBox 145"/>
           <p:cNvSpPr txBox="1"/>
           <p:nvPr/>
         </p:nvSpPr>
@@ -9778,7 +9820,7 @@
       </p:sp>
       <p:sp>
         <p:nvSpPr>
-          <p:cNvPr id="146" name="Rectangle 145"/>
+          <p:cNvPr id="147" name="Rectangle 146"/>
           <p:cNvSpPr/>
           <p:nvPr/>
         </p:nvSpPr>
@@ -9822,7 +9864,7 @@
       </p:sp>
       <p:sp>
         <p:nvSpPr>
-          <p:cNvPr id="147" name="TextBox 146"/>
+          <p:cNvPr id="148" name="TextBox 147"/>
           <p:cNvSpPr txBox="1"/>
           <p:nvPr/>
         </p:nvSpPr>
@@ -9864,7 +9906,7 @@
       </p:sp>
       <p:sp>
         <p:nvSpPr>
-          <p:cNvPr id="148" name="Rectangle 147"/>
+          <p:cNvPr id="149" name="Rectangle 148"/>
           <p:cNvSpPr/>
           <p:nvPr/>
         </p:nvSpPr>
@@ -9908,7 +9950,7 @@
       </p:sp>
       <p:sp>
         <p:nvSpPr>
-          <p:cNvPr id="149" name="TextBox 148"/>
+          <p:cNvPr id="150" name="TextBox 149"/>
           <p:cNvSpPr txBox="1"/>
           <p:nvPr/>
         </p:nvSpPr>
@@ -9950,7 +9992,7 @@
       </p:sp>
       <p:sp>
         <p:nvSpPr>
-          <p:cNvPr id="150" name="Rectangle 149"/>
+          <p:cNvPr id="151" name="Rectangle 150"/>
           <p:cNvSpPr/>
           <p:nvPr/>
         </p:nvSpPr>
@@ -9994,7 +10036,7 @@
       </p:sp>
       <p:sp>
         <p:nvSpPr>
-          <p:cNvPr id="151" name="TextBox 150"/>
+          <p:cNvPr id="152" name="TextBox 151"/>
           <p:cNvSpPr txBox="1"/>
           <p:nvPr/>
         </p:nvSpPr>

</xml_diff>

<commit_message>
fix(poster): stop the QPS panel running under the row-2 cards
Placed at full column width the Pareto figure stood 7.2 in tall and
ended at y = 31.3, while row 2 begins at 29.9 -- the takeaway card,
drawn later, covered its lower fifth and its caption entirely. The panel
is now sized from the room actually left in the column and centred:
5.28 x 4.07 in, ending at 27.9 with the caption clear at 28.97, inside
the 29.05 row boundary.

Auditing the other five columns the same way turned up one more, benign
but wrong: the closing paragraph of the method column declared a 4.0 in
text box for ~2.6 in of text, so its frame crossed into row 2 even
though nothing rendered there. Declared height now matches the content.

All six columns verified within their boundaries; 151 shapes, none
off-page.
</commit_message>
<xml_diff>
--- a/poster/PMC_CIKM2026_poster.pptx
+++ b/poster/PMC_CIKM2026_poster.pptx
@@ -5408,7 +5408,7 @@
         <p:spPr>
           <a:xfrm>
             <a:off x="10381183" y="23687532"/>
-            <a:ext cx="9499107" cy="3657600"/>
+            <a:ext cx="9499107" cy="2651760"/>
           </a:xfrm>
           <a:prstGeom prst="rect">
             <a:avLst/>
@@ -8156,8 +8156,8 @@
         </p:blipFill>
         <p:spPr>
           <a:xfrm>
-            <a:off x="20794690" y="22064472"/>
-            <a:ext cx="8520974" cy="6563834"/>
+            <a:off x="22639537" y="21790152"/>
+            <a:ext cx="4831280" cy="3721608"/>
           </a:xfrm>
           <a:prstGeom prst="rect">
             <a:avLst/>
@@ -8172,8 +8172,8 @@
         </p:nvSpPr>
         <p:spPr>
           <a:xfrm>
-            <a:off x="20794690" y="28811186"/>
-            <a:ext cx="8520974" cy="822960"/>
+            <a:off x="20794690" y="25621488"/>
+            <a:ext cx="8520974" cy="868680"/>
           </a:xfrm>
           <a:prstGeom prst="rect">
             <a:avLst/>
@@ -8186,7 +8186,7 @@
           </a:bodyPr>
           <a:lstStyle/>
           <a:p>
-            <a:pPr algn="l">
+            <a:pPr algn="ctr">
               <a:lnSpc>
                 <a:spcPct val="115000"/>
               </a:lnSpc>

</xml_diff>

<commit_message>
feat(poster): enlarge the QPS panel by 1.9x
Fitting the Pareto figure to the leftover space left it 5.28 x 4.07 in --
inside its column, but too small to read the axes at poster distance.
Reclaiming 1.5 in from the elements above it -- table row pitch 0.82 ->
0.76, the lead-in above the figure 1.55 -> 1.15, caption box 0.95 ->
0.72, and small trims to the callout and bar spacings -- takes it to
7.22 x 5.56 in, 1.9x the area, without touching any of the text sizes.

All six columns re-verified inside their boundaries; the figure now
spans y 22.57 to 28.13 against the 29.05 row-1 limit, caption clear.
</commit_message>
<xml_diff>
--- a/poster/PMC_CIKM2026_poster.pptx
+++ b/poster/PMC_CIKM2026_poster.pptx
@@ -5624,7 +5624,7 @@
         </p:nvSpPr>
         <p:spPr>
           <a:xfrm>
-            <a:off x="20794690" y="8961120"/>
+            <a:off x="20794690" y="8796528"/>
             <a:ext cx="8520974" cy="548640"/>
           </a:xfrm>
           <a:prstGeom prst="rect">
@@ -5666,7 +5666,7 @@
         </p:nvSpPr>
         <p:spPr>
           <a:xfrm>
-            <a:off x="20794690" y="9692640"/>
+            <a:off x="20794690" y="9436608"/>
             <a:ext cx="8520974" cy="548640"/>
           </a:xfrm>
           <a:prstGeom prst="rect">
@@ -5708,7 +5708,7 @@
         </p:nvSpPr>
         <p:spPr>
           <a:xfrm>
-            <a:off x="20794690" y="10378440"/>
+            <a:off x="20794690" y="10122408"/>
             <a:ext cx="6692174" cy="731520"/>
           </a:xfrm>
           <a:prstGeom prst="rect">
@@ -5754,7 +5754,7 @@
         </p:nvSpPr>
         <p:spPr>
           <a:xfrm>
-            <a:off x="20794690" y="10378440"/>
+            <a:off x="20794690" y="10122408"/>
             <a:ext cx="5054229" cy="731520"/>
           </a:xfrm>
           <a:prstGeom prst="rect">
@@ -5798,7 +5798,7 @@
         </p:nvSpPr>
         <p:spPr>
           <a:xfrm>
-            <a:off x="20977570" y="10378440"/>
+            <a:off x="20977570" y="10122408"/>
             <a:ext cx="6372134" cy="731520"/>
           </a:xfrm>
           <a:prstGeom prst="rect">
@@ -5840,7 +5840,7 @@
         </p:nvSpPr>
         <p:spPr>
           <a:xfrm>
-            <a:off x="27651456" y="10378440"/>
+            <a:off x="27651456" y="10122408"/>
             <a:ext cx="1645920" cy="731520"/>
           </a:xfrm>
           <a:prstGeom prst="rect">
@@ -5882,7 +5882,7 @@
         </p:nvSpPr>
         <p:spPr>
           <a:xfrm>
-            <a:off x="20794690" y="11274552"/>
+            <a:off x="20794690" y="10963656"/>
             <a:ext cx="6692174" cy="731520"/>
           </a:xfrm>
           <a:prstGeom prst="rect">
@@ -5928,7 +5928,7 @@
         </p:nvSpPr>
         <p:spPr>
           <a:xfrm>
-            <a:off x="20794690" y="11274552"/>
+            <a:off x="20794690" y="10963656"/>
             <a:ext cx="6692174" cy="731520"/>
           </a:xfrm>
           <a:prstGeom prst="rect">
@@ -5972,7 +5972,7 @@
         </p:nvSpPr>
         <p:spPr>
           <a:xfrm>
-            <a:off x="20977570" y="11274552"/>
+            <a:off x="20977570" y="10963656"/>
             <a:ext cx="6372134" cy="731520"/>
           </a:xfrm>
           <a:prstGeom prst="rect">
@@ -6014,7 +6014,7 @@
         </p:nvSpPr>
         <p:spPr>
           <a:xfrm>
-            <a:off x="27651456" y="11274552"/>
+            <a:off x="27651456" y="10963656"/>
             <a:ext cx="1645920" cy="731520"/>
           </a:xfrm>
           <a:prstGeom prst="rect">
@@ -6056,7 +6056,7 @@
         </p:nvSpPr>
         <p:spPr>
           <a:xfrm>
-            <a:off x="20794690" y="12298680"/>
+            <a:off x="20794690" y="11896344"/>
             <a:ext cx="8520974" cy="548640"/>
           </a:xfrm>
           <a:prstGeom prst="rect">
@@ -6107,7 +6107,7 @@
         </p:nvSpPr>
         <p:spPr>
           <a:xfrm>
-            <a:off x="20794690" y="13304520"/>
+            <a:off x="20794690" y="12902184"/>
             <a:ext cx="8520974" cy="685800"/>
           </a:xfrm>
           <a:prstGeom prst="rect">
@@ -6149,7 +6149,7 @@
         </p:nvSpPr>
         <p:spPr>
           <a:xfrm>
-            <a:off x="20794690" y="14081760"/>
+            <a:off x="20794690" y="13679424"/>
             <a:ext cx="777240" cy="548640"/>
           </a:xfrm>
           <a:prstGeom prst="rect">
@@ -6191,7 +6191,7 @@
         </p:nvSpPr>
         <p:spPr>
           <a:xfrm>
-            <a:off x="21571930" y="14081760"/>
+            <a:off x="21571930" y="13679424"/>
             <a:ext cx="2743200" cy="548640"/>
           </a:xfrm>
           <a:prstGeom prst="rect">
@@ -6233,7 +6233,7 @@
         </p:nvSpPr>
         <p:spPr>
           <a:xfrm>
-            <a:off x="24315130" y="14081760"/>
+            <a:off x="24315130" y="13679424"/>
             <a:ext cx="2500267" cy="548640"/>
           </a:xfrm>
           <a:prstGeom prst="rect">
@@ -6275,7 +6275,7 @@
         </p:nvSpPr>
         <p:spPr>
           <a:xfrm>
-            <a:off x="26815397" y="14081760"/>
+            <a:off x="26815397" y="13679424"/>
             <a:ext cx="2500267" cy="548640"/>
           </a:xfrm>
           <a:prstGeom prst="rect">
@@ -6317,7 +6317,7 @@
         </p:nvSpPr>
         <p:spPr>
           <a:xfrm>
-            <a:off x="20794690" y="14703552"/>
+            <a:off x="20794690" y="14301216"/>
             <a:ext cx="8520974" cy="20320"/>
           </a:xfrm>
           <a:prstGeom prst="rect">
@@ -6361,7 +6361,7 @@
         </p:nvSpPr>
         <p:spPr>
           <a:xfrm>
-            <a:off x="20794690" y="14904720"/>
+            <a:off x="20794690" y="14502384"/>
             <a:ext cx="777240" cy="566928"/>
           </a:xfrm>
           <a:prstGeom prst="rect">
@@ -6403,7 +6403,7 @@
         </p:nvSpPr>
         <p:spPr>
           <a:xfrm>
-            <a:off x="21571930" y="14904720"/>
+            <a:off x="21571930" y="14502384"/>
             <a:ext cx="2743200" cy="566928"/>
           </a:xfrm>
           <a:prstGeom prst="rect">
@@ -6445,7 +6445,7 @@
         </p:nvSpPr>
         <p:spPr>
           <a:xfrm>
-            <a:off x="24315130" y="14849856"/>
+            <a:off x="24315130" y="14447520"/>
             <a:ext cx="2500267" cy="658368"/>
           </a:xfrm>
           <a:prstGeom prst="rect">
@@ -6505,7 +6505,7 @@
         </p:nvSpPr>
         <p:spPr>
           <a:xfrm>
-            <a:off x="26815397" y="14849856"/>
+            <a:off x="26815397" y="14447520"/>
             <a:ext cx="2500267" cy="658368"/>
           </a:xfrm>
           <a:prstGeom prst="rect">
@@ -6565,7 +6565,7 @@
         </p:nvSpPr>
         <p:spPr>
           <a:xfrm>
-            <a:off x="20794690" y="15544800"/>
+            <a:off x="20794690" y="15087600"/>
             <a:ext cx="8520974" cy="10160"/>
           </a:xfrm>
           <a:prstGeom prst="rect">
@@ -6609,7 +6609,7 @@
         </p:nvSpPr>
         <p:spPr>
           <a:xfrm>
-            <a:off x="20794690" y="15654528"/>
+            <a:off x="20794690" y="15197328"/>
             <a:ext cx="777240" cy="566928"/>
           </a:xfrm>
           <a:prstGeom prst="rect">
@@ -6651,7 +6651,7 @@
         </p:nvSpPr>
         <p:spPr>
           <a:xfrm>
-            <a:off x="21571930" y="15654528"/>
+            <a:off x="21571930" y="15197328"/>
             <a:ext cx="2743200" cy="566928"/>
           </a:xfrm>
           <a:prstGeom prst="rect">
@@ -6693,7 +6693,7 @@
         </p:nvSpPr>
         <p:spPr>
           <a:xfrm>
-            <a:off x="24315130" y="15599664"/>
+            <a:off x="24315130" y="15142464"/>
             <a:ext cx="2500267" cy="658368"/>
           </a:xfrm>
           <a:prstGeom prst="rect">
@@ -6753,7 +6753,7 @@
         </p:nvSpPr>
         <p:spPr>
           <a:xfrm>
-            <a:off x="26815397" y="15599664"/>
+            <a:off x="26815397" y="15142464"/>
             <a:ext cx="2500267" cy="658368"/>
           </a:xfrm>
           <a:prstGeom prst="rect">
@@ -6813,7 +6813,7 @@
         </p:nvSpPr>
         <p:spPr>
           <a:xfrm>
-            <a:off x="20794690" y="16294608"/>
+            <a:off x="20794690" y="15782544"/>
             <a:ext cx="8520974" cy="10160"/>
           </a:xfrm>
           <a:prstGeom prst="rect">
@@ -6857,7 +6857,7 @@
         </p:nvSpPr>
         <p:spPr>
           <a:xfrm>
-            <a:off x="20794690" y="16404336"/>
+            <a:off x="20794690" y="15892272"/>
             <a:ext cx="777240" cy="566928"/>
           </a:xfrm>
           <a:prstGeom prst="rect">
@@ -6899,7 +6899,7 @@
         </p:nvSpPr>
         <p:spPr>
           <a:xfrm>
-            <a:off x="21571930" y="16404336"/>
+            <a:off x="21571930" y="15892272"/>
             <a:ext cx="2743200" cy="566928"/>
           </a:xfrm>
           <a:prstGeom prst="rect">
@@ -6941,7 +6941,7 @@
         </p:nvSpPr>
         <p:spPr>
           <a:xfrm>
-            <a:off x="24315130" y="16349472"/>
+            <a:off x="24315130" y="15837408"/>
             <a:ext cx="2500267" cy="658368"/>
           </a:xfrm>
           <a:prstGeom prst="rect">
@@ -7001,7 +7001,7 @@
         </p:nvSpPr>
         <p:spPr>
           <a:xfrm>
-            <a:off x="26815397" y="16349472"/>
+            <a:off x="26815397" y="15837408"/>
             <a:ext cx="2500267" cy="658368"/>
           </a:xfrm>
           <a:prstGeom prst="rect">
@@ -7061,7 +7061,7 @@
         </p:nvSpPr>
         <p:spPr>
           <a:xfrm>
-            <a:off x="20794690" y="17044416"/>
+            <a:off x="20794690" y="16477488"/>
             <a:ext cx="8520974" cy="10160"/>
           </a:xfrm>
           <a:prstGeom prst="rect">
@@ -7105,7 +7105,7 @@
         </p:nvSpPr>
         <p:spPr>
           <a:xfrm>
-            <a:off x="20794690" y="17154144"/>
+            <a:off x="20794690" y="16587216"/>
             <a:ext cx="777240" cy="566928"/>
           </a:xfrm>
           <a:prstGeom prst="rect">
@@ -7147,7 +7147,7 @@
         </p:nvSpPr>
         <p:spPr>
           <a:xfrm>
-            <a:off x="21571930" y="17154144"/>
+            <a:off x="21571930" y="16587216"/>
             <a:ext cx="2743200" cy="566928"/>
           </a:xfrm>
           <a:prstGeom prst="rect">
@@ -7189,7 +7189,7 @@
         </p:nvSpPr>
         <p:spPr>
           <a:xfrm>
-            <a:off x="24315130" y="17099280"/>
+            <a:off x="24315130" y="16532352"/>
             <a:ext cx="2500267" cy="658368"/>
           </a:xfrm>
           <a:prstGeom prst="rect">
@@ -7249,7 +7249,7 @@
         </p:nvSpPr>
         <p:spPr>
           <a:xfrm>
-            <a:off x="26815397" y="17099280"/>
+            <a:off x="26815397" y="16532352"/>
             <a:ext cx="2500267" cy="658368"/>
           </a:xfrm>
           <a:prstGeom prst="rect">
@@ -7309,7 +7309,7 @@
         </p:nvSpPr>
         <p:spPr>
           <a:xfrm>
-            <a:off x="20794690" y="17794224"/>
+            <a:off x="20794690" y="17172432"/>
             <a:ext cx="8520974" cy="10160"/>
           </a:xfrm>
           <a:prstGeom prst="rect">
@@ -7353,7 +7353,7 @@
         </p:nvSpPr>
         <p:spPr>
           <a:xfrm>
-            <a:off x="20794690" y="17903952"/>
+            <a:off x="20794690" y="17282160"/>
             <a:ext cx="777240" cy="566928"/>
           </a:xfrm>
           <a:prstGeom prst="rect">
@@ -7395,7 +7395,7 @@
         </p:nvSpPr>
         <p:spPr>
           <a:xfrm>
-            <a:off x="21571930" y="17903952"/>
+            <a:off x="21571930" y="17282160"/>
             <a:ext cx="2743200" cy="566928"/>
           </a:xfrm>
           <a:prstGeom prst="rect">
@@ -7437,7 +7437,7 @@
         </p:nvSpPr>
         <p:spPr>
           <a:xfrm>
-            <a:off x="24315130" y="17849088"/>
+            <a:off x="24315130" y="17227296"/>
             <a:ext cx="2500267" cy="658368"/>
           </a:xfrm>
           <a:prstGeom prst="rect">
@@ -7497,7 +7497,7 @@
         </p:nvSpPr>
         <p:spPr>
           <a:xfrm>
-            <a:off x="26815397" y="17849088"/>
+            <a:off x="26815397" y="17227296"/>
             <a:ext cx="2500267" cy="658368"/>
           </a:xfrm>
           <a:prstGeom prst="rect">
@@ -7557,7 +7557,7 @@
         </p:nvSpPr>
         <p:spPr>
           <a:xfrm>
-            <a:off x="20794690" y="18544032"/>
+            <a:off x="20794690" y="17867376"/>
             <a:ext cx="8520974" cy="10160"/>
           </a:xfrm>
           <a:prstGeom prst="rect">
@@ -7601,7 +7601,7 @@
         </p:nvSpPr>
         <p:spPr>
           <a:xfrm>
-            <a:off x="20794690" y="18653760"/>
+            <a:off x="20794690" y="17977104"/>
             <a:ext cx="777240" cy="566928"/>
           </a:xfrm>
           <a:prstGeom prst="rect">
@@ -7643,7 +7643,7 @@
         </p:nvSpPr>
         <p:spPr>
           <a:xfrm>
-            <a:off x="21571930" y="18653760"/>
+            <a:off x="21571930" y="17977104"/>
             <a:ext cx="2743200" cy="566928"/>
           </a:xfrm>
           <a:prstGeom prst="rect">
@@ -7685,7 +7685,7 @@
         </p:nvSpPr>
         <p:spPr>
           <a:xfrm>
-            <a:off x="24315130" y="18598896"/>
+            <a:off x="24315130" y="17922240"/>
             <a:ext cx="2500267" cy="658368"/>
           </a:xfrm>
           <a:prstGeom prst="rect">
@@ -7745,7 +7745,7 @@
         </p:nvSpPr>
         <p:spPr>
           <a:xfrm>
-            <a:off x="26815397" y="18598896"/>
+            <a:off x="26815397" y="17922240"/>
             <a:ext cx="2500267" cy="658368"/>
           </a:xfrm>
           <a:prstGeom prst="rect">
@@ -7805,7 +7805,7 @@
         </p:nvSpPr>
         <p:spPr>
           <a:xfrm>
-            <a:off x="20794690" y="19293840"/>
+            <a:off x="20794690" y="18562320"/>
             <a:ext cx="8520974" cy="10160"/>
           </a:xfrm>
           <a:prstGeom prst="rect">
@@ -7849,7 +7849,7 @@
         </p:nvSpPr>
         <p:spPr>
           <a:xfrm>
-            <a:off x="20794690" y="19403568"/>
+            <a:off x="20794690" y="18672048"/>
             <a:ext cx="777240" cy="566928"/>
           </a:xfrm>
           <a:prstGeom prst="rect">
@@ -7891,7 +7891,7 @@
         </p:nvSpPr>
         <p:spPr>
           <a:xfrm>
-            <a:off x="21571930" y="19403568"/>
+            <a:off x="21571930" y="18672048"/>
             <a:ext cx="2743200" cy="566928"/>
           </a:xfrm>
           <a:prstGeom prst="rect">
@@ -7933,7 +7933,7 @@
         </p:nvSpPr>
         <p:spPr>
           <a:xfrm>
-            <a:off x="24315130" y="19348704"/>
+            <a:off x="24315130" y="18617184"/>
             <a:ext cx="2500267" cy="658368"/>
           </a:xfrm>
           <a:prstGeom prst="rect">
@@ -7993,7 +7993,7 @@
         </p:nvSpPr>
         <p:spPr>
           <a:xfrm>
-            <a:off x="26815397" y="19348704"/>
+            <a:off x="26815397" y="18617184"/>
             <a:ext cx="2500267" cy="658368"/>
           </a:xfrm>
           <a:prstGeom prst="rect">
@@ -8053,7 +8053,7 @@
         </p:nvSpPr>
         <p:spPr>
           <a:xfrm>
-            <a:off x="20794690" y="20043648"/>
+            <a:off x="20794690" y="19257264"/>
             <a:ext cx="8520974" cy="10160"/>
           </a:xfrm>
           <a:prstGeom prst="rect">
@@ -8097,7 +8097,7 @@
         </p:nvSpPr>
         <p:spPr>
           <a:xfrm>
-            <a:off x="20794690" y="20372832"/>
+            <a:off x="20794690" y="19586448"/>
             <a:ext cx="8520974" cy="1463040"/>
           </a:xfrm>
           <a:prstGeom prst="rect">
@@ -8156,8 +8156,8 @@
         </p:blipFill>
         <p:spPr>
           <a:xfrm>
-            <a:off x="22639537" y="21790152"/>
-            <a:ext cx="4831280" cy="3721608"/>
+            <a:off x="21755187" y="20638008"/>
+            <a:ext cx="6599979" cy="5084064"/>
           </a:xfrm>
           <a:prstGeom prst="rect">
             <a:avLst/>
@@ -8172,8 +8172,8 @@
         </p:nvSpPr>
         <p:spPr>
           <a:xfrm>
-            <a:off x="20794690" y="25621488"/>
-            <a:ext cx="8520974" cy="868680"/>
+            <a:off x="20794690" y="25831800"/>
+            <a:ext cx="8520974" cy="658368"/>
           </a:xfrm>
           <a:prstGeom prst="rect">
             <a:avLst/>

</xml_diff>

<commit_message>
fix(poster): add grouped author emails to the header band
{sehoon787, junicus, jsy}@korea.ac.kr — italic gray, below the
department line.
</commit_message>
<xml_diff>
--- a/poster/PMC_CIKM2026_poster.pptx
+++ b/poster/PMC_CIKM2026_poster.pptx
@@ -3386,7 +3386,49 @@
       </p:sp>
       <p:sp>
         <p:nvSpPr>
-          <p:cNvPr id="10" name="Rectangle 9"/>
+          <p:cNvPr id="10" name="TextBox 9"/>
+          <p:cNvSpPr txBox="1"/>
+          <p:nvPr/>
+        </p:nvSpPr>
+        <p:spPr>
+          <a:xfrm>
+            <a:off x="777240" y="3834993"/>
+            <a:ext cx="20491704" cy="371855"/>
+          </a:xfrm>
+          <a:prstGeom prst="rect">
+            <a:avLst/>
+          </a:prstGeom>
+          <a:noFill/>
+        </p:spPr>
+        <p:txBody>
+          <a:bodyPr wrap="square" lIns="0" rIns="0" tIns="0" bIns="0">
+            <a:spAutoFit/>
+          </a:bodyPr>
+          <a:lstStyle/>
+          <a:p>
+            <a:pPr algn="l">
+              <a:lnSpc>
+                <a:spcPct val="122000"/>
+              </a:lnSpc>
+              <a:spcAft>
+                <a:spcPts val="0"/>
+              </a:spcAft>
+            </a:pPr>
+            <a:r>
+              <a:rPr sz="2000" b="0" i="1">
+                <a:solidFill>
+                  <a:srgbClr val="6F6F6F"/>
+                </a:solidFill>
+                <a:latin typeface="Times New Roman"/>
+              </a:rPr>
+              <a:t>{sehoon787, junicus, jsy}@korea.ac.kr</a:t>
+            </a:r>
+          </a:p>
+        </p:txBody>
+      </p:sp>
+      <p:sp>
+        <p:nvSpPr>
+          <p:cNvPr id="11" name="Rectangle 10"/>
           <p:cNvSpPr/>
           <p:nvPr/>
         </p:nvSpPr>
@@ -3430,7 +3472,7 @@
       </p:sp>
       <p:sp>
         <p:nvSpPr>
-          <p:cNvPr id="11" name="Rectangle 10"/>
+          <p:cNvPr id="12" name="Rectangle 11"/>
           <p:cNvSpPr/>
           <p:nvPr/>
         </p:nvSpPr>
@@ -3476,7 +3518,7 @@
       </p:sp>
       <p:sp>
         <p:nvSpPr>
-          <p:cNvPr id="12" name="TextBox 11"/>
+          <p:cNvPr id="13" name="TextBox 12"/>
           <p:cNvSpPr txBox="1"/>
           <p:nvPr/>
         </p:nvSpPr>
@@ -3527,7 +3569,7 @@
       </p:sp>
       <p:sp>
         <p:nvSpPr>
-          <p:cNvPr id="13" name="Rectangle 12"/>
+          <p:cNvPr id="14" name="Rectangle 13"/>
           <p:cNvSpPr/>
           <p:nvPr/>
         </p:nvSpPr>
@@ -3571,7 +3613,7 @@
       </p:sp>
       <p:sp>
         <p:nvSpPr>
-          <p:cNvPr id="14" name="Rectangle 13"/>
+          <p:cNvPr id="15" name="Rectangle 14"/>
           <p:cNvSpPr/>
           <p:nvPr/>
         </p:nvSpPr>
@@ -3615,7 +3657,7 @@
       </p:sp>
       <p:sp>
         <p:nvSpPr>
-          <p:cNvPr id="15" name="TextBox 14"/>
+          <p:cNvPr id="16" name="TextBox 15"/>
           <p:cNvSpPr txBox="1"/>
           <p:nvPr/>
         </p:nvSpPr>
@@ -3657,7 +3699,7 @@
       </p:sp>
       <p:sp>
         <p:nvSpPr>
-          <p:cNvPr id="16" name="Rectangle 15"/>
+          <p:cNvPr id="17" name="Rectangle 16"/>
           <p:cNvSpPr/>
           <p:nvPr/>
         </p:nvSpPr>
@@ -3701,7 +3743,7 @@
       </p:sp>
       <p:sp>
         <p:nvSpPr>
-          <p:cNvPr id="17" name="TextBox 16"/>
+          <p:cNvPr id="18" name="TextBox 17"/>
           <p:cNvSpPr txBox="1"/>
           <p:nvPr/>
         </p:nvSpPr>
@@ -3743,7 +3785,7 @@
       </p:sp>
       <p:sp>
         <p:nvSpPr>
-          <p:cNvPr id="18" name="Rectangle 17"/>
+          <p:cNvPr id="19" name="Rectangle 18"/>
           <p:cNvSpPr/>
           <p:nvPr/>
         </p:nvSpPr>
@@ -3787,7 +3829,7 @@
       </p:sp>
       <p:sp>
         <p:nvSpPr>
-          <p:cNvPr id="19" name="TextBox 18"/>
+          <p:cNvPr id="20" name="TextBox 19"/>
           <p:cNvSpPr txBox="1"/>
           <p:nvPr/>
         </p:nvSpPr>
@@ -3838,7 +3880,7 @@
       </p:sp>
       <p:sp>
         <p:nvSpPr>
-          <p:cNvPr id="20" name="Rectangle 19"/>
+          <p:cNvPr id="21" name="Rectangle 20"/>
           <p:cNvSpPr/>
           <p:nvPr/>
         </p:nvSpPr>
@@ -3882,7 +3924,7 @@
       </p:sp>
       <p:sp>
         <p:nvSpPr>
-          <p:cNvPr id="21" name="TextBox 20"/>
+          <p:cNvPr id="22" name="TextBox 21"/>
           <p:cNvSpPr txBox="1"/>
           <p:nvPr/>
         </p:nvSpPr>
@@ -3933,7 +3975,7 @@
       </p:sp>
       <p:sp>
         <p:nvSpPr>
-          <p:cNvPr id="22" name="Rectangle 21"/>
+          <p:cNvPr id="23" name="Rectangle 22"/>
           <p:cNvSpPr/>
           <p:nvPr/>
         </p:nvSpPr>
@@ -3977,7 +4019,7 @@
       </p:sp>
       <p:sp>
         <p:nvSpPr>
-          <p:cNvPr id="23" name="TextBox 22"/>
+          <p:cNvPr id="24" name="TextBox 23"/>
           <p:cNvSpPr txBox="1"/>
           <p:nvPr/>
         </p:nvSpPr>
@@ -4037,7 +4079,7 @@
       </p:sp>
       <p:sp>
         <p:nvSpPr>
-          <p:cNvPr id="24" name="TextBox 23"/>
+          <p:cNvPr id="25" name="TextBox 24"/>
           <p:cNvSpPr txBox="1"/>
           <p:nvPr/>
         </p:nvSpPr>
@@ -4079,7 +4121,7 @@
       </p:sp>
       <p:sp>
         <p:nvSpPr>
-          <p:cNvPr id="25" name="Rectangle 24"/>
+          <p:cNvPr id="26" name="Rectangle 25"/>
           <p:cNvSpPr/>
           <p:nvPr/>
         </p:nvSpPr>
@@ -4123,7 +4165,7 @@
       </p:sp>
       <p:sp>
         <p:nvSpPr>
-          <p:cNvPr id="26" name="TextBox 25"/>
+          <p:cNvPr id="27" name="TextBox 26"/>
           <p:cNvSpPr txBox="1"/>
           <p:nvPr/>
         </p:nvSpPr>
@@ -4219,7 +4261,7 @@
       </p:sp>
       <p:pic>
         <p:nvPicPr>
-          <p:cNvPr id="27" name="Picture 26" descr="asset_fig1.png"/>
+          <p:cNvPr id="28" name="Picture 27" descr="asset_fig1.png"/>
           <p:cNvPicPr>
             <a:picLocks noChangeAspect="1"/>
           </p:cNvPicPr>
@@ -4243,7 +4285,7 @@
       </p:pic>
       <p:sp>
         <p:nvSpPr>
-          <p:cNvPr id="28" name="TextBox 27"/>
+          <p:cNvPr id="29" name="TextBox 28"/>
           <p:cNvSpPr txBox="1"/>
           <p:nvPr/>
         </p:nvSpPr>
@@ -4285,7 +4327,7 @@
       </p:sp>
       <p:sp>
         <p:nvSpPr>
-          <p:cNvPr id="29" name="TextBox 28"/>
+          <p:cNvPr id="30" name="TextBox 29"/>
           <p:cNvSpPr txBox="1"/>
           <p:nvPr/>
         </p:nvSpPr>
@@ -4327,7 +4369,7 @@
       </p:sp>
       <p:sp>
         <p:nvSpPr>
-          <p:cNvPr id="30" name="Rectangle 29"/>
+          <p:cNvPr id="31" name="Rectangle 30"/>
           <p:cNvSpPr/>
           <p:nvPr/>
         </p:nvSpPr>
@@ -4371,7 +4413,7 @@
       </p:sp>
       <p:sp>
         <p:nvSpPr>
-          <p:cNvPr id="31" name="TextBox 30"/>
+          <p:cNvPr id="32" name="TextBox 31"/>
           <p:cNvSpPr txBox="1"/>
           <p:nvPr/>
         </p:nvSpPr>
@@ -4422,7 +4464,7 @@
       </p:sp>
       <p:sp>
         <p:nvSpPr>
-          <p:cNvPr id="32" name="Rectangle 31"/>
+          <p:cNvPr id="33" name="Rectangle 32"/>
           <p:cNvSpPr/>
           <p:nvPr/>
         </p:nvSpPr>
@@ -4466,7 +4508,7 @@
       </p:sp>
       <p:sp>
         <p:nvSpPr>
-          <p:cNvPr id="33" name="TextBox 32"/>
+          <p:cNvPr id="34" name="TextBox 33"/>
           <p:cNvSpPr txBox="1"/>
           <p:nvPr/>
         </p:nvSpPr>
@@ -4517,7 +4559,7 @@
       </p:sp>
       <p:sp>
         <p:nvSpPr>
-          <p:cNvPr id="34" name="Rectangle 33"/>
+          <p:cNvPr id="35" name="Rectangle 34"/>
           <p:cNvSpPr/>
           <p:nvPr/>
         </p:nvSpPr>
@@ -4563,7 +4605,7 @@
       </p:sp>
       <p:sp>
         <p:nvSpPr>
-          <p:cNvPr id="35" name="TextBox 34"/>
+          <p:cNvPr id="36" name="TextBox 35"/>
           <p:cNvSpPr txBox="1"/>
           <p:nvPr/>
         </p:nvSpPr>
@@ -4662,7 +4704,7 @@
       </p:sp>
       <p:sp>
         <p:nvSpPr>
-          <p:cNvPr id="36" name="TextBox 35"/>
+          <p:cNvPr id="37" name="TextBox 36"/>
           <p:cNvSpPr txBox="1"/>
           <p:nvPr/>
         </p:nvSpPr>
@@ -4713,7 +4755,7 @@
       </p:sp>
       <p:sp>
         <p:nvSpPr>
-          <p:cNvPr id="37" name="TextBox 36"/>
+          <p:cNvPr id="38" name="TextBox 37"/>
           <p:cNvSpPr txBox="1"/>
           <p:nvPr/>
         </p:nvSpPr>
@@ -4755,7 +4797,7 @@
       </p:sp>
       <p:sp>
         <p:nvSpPr>
-          <p:cNvPr id="38" name="Rectangle 37"/>
+          <p:cNvPr id="39" name="Rectangle 38"/>
           <p:cNvSpPr/>
           <p:nvPr/>
         </p:nvSpPr>
@@ -4799,7 +4841,7 @@
       </p:sp>
       <p:sp>
         <p:nvSpPr>
-          <p:cNvPr id="39" name="TextBox 38"/>
+          <p:cNvPr id="40" name="TextBox 39"/>
           <p:cNvSpPr txBox="1"/>
           <p:nvPr/>
         </p:nvSpPr>
@@ -4841,7 +4883,7 @@
       </p:sp>
       <p:sp>
         <p:nvSpPr>
-          <p:cNvPr id="40" name="TextBox 39"/>
+          <p:cNvPr id="41" name="TextBox 40"/>
           <p:cNvSpPr txBox="1"/>
           <p:nvPr/>
         </p:nvSpPr>
@@ -4876,7 +4918,7 @@
       </p:sp>
       <p:sp>
         <p:nvSpPr>
-          <p:cNvPr id="41" name="TextBox 40"/>
+          <p:cNvPr id="42" name="TextBox 41"/>
           <p:cNvSpPr txBox="1"/>
           <p:nvPr/>
         </p:nvSpPr>
@@ -4911,7 +4953,7 @@
       </p:sp>
       <p:sp>
         <p:nvSpPr>
-          <p:cNvPr id="42" name="TextBox 41"/>
+          <p:cNvPr id="43" name="TextBox 42"/>
           <p:cNvSpPr txBox="1"/>
           <p:nvPr/>
         </p:nvSpPr>
@@ -4946,7 +4988,7 @@
       </p:sp>
       <p:sp>
         <p:nvSpPr>
-          <p:cNvPr id="43" name="Rectangle 42"/>
+          <p:cNvPr id="44" name="Rectangle 43"/>
           <p:cNvSpPr/>
           <p:nvPr/>
         </p:nvSpPr>
@@ -4990,7 +5032,7 @@
       </p:sp>
       <p:sp>
         <p:nvSpPr>
-          <p:cNvPr id="44" name="TextBox 43"/>
+          <p:cNvPr id="45" name="TextBox 44"/>
           <p:cNvSpPr txBox="1"/>
           <p:nvPr/>
         </p:nvSpPr>
@@ -5025,7 +5067,7 @@
       </p:sp>
       <p:sp>
         <p:nvSpPr>
-          <p:cNvPr id="45" name="TextBox 44"/>
+          <p:cNvPr id="46" name="TextBox 45"/>
           <p:cNvSpPr txBox="1"/>
           <p:nvPr/>
         </p:nvSpPr>
@@ -5069,7 +5111,7 @@
       </p:sp>
       <p:sp>
         <p:nvSpPr>
-          <p:cNvPr id="46" name="TextBox 45"/>
+          <p:cNvPr id="47" name="TextBox 46"/>
           <p:cNvSpPr txBox="1"/>
           <p:nvPr/>
         </p:nvSpPr>
@@ -5113,7 +5155,7 @@
       </p:sp>
       <p:sp>
         <p:nvSpPr>
-          <p:cNvPr id="47" name="Rectangle 46"/>
+          <p:cNvPr id="48" name="Rectangle 47"/>
           <p:cNvSpPr/>
           <p:nvPr/>
         </p:nvSpPr>
@@ -5157,7 +5199,7 @@
       </p:sp>
       <p:sp>
         <p:nvSpPr>
-          <p:cNvPr id="48" name="TextBox 47"/>
+          <p:cNvPr id="49" name="TextBox 48"/>
           <p:cNvSpPr txBox="1"/>
           <p:nvPr/>
         </p:nvSpPr>
@@ -5192,7 +5234,7 @@
       </p:sp>
       <p:sp>
         <p:nvSpPr>
-          <p:cNvPr id="49" name="TextBox 48"/>
+          <p:cNvPr id="50" name="TextBox 49"/>
           <p:cNvSpPr txBox="1"/>
           <p:nvPr/>
         </p:nvSpPr>
@@ -5236,7 +5278,7 @@
       </p:sp>
       <p:sp>
         <p:nvSpPr>
-          <p:cNvPr id="50" name="TextBox 49"/>
+          <p:cNvPr id="51" name="TextBox 50"/>
           <p:cNvSpPr txBox="1"/>
           <p:nvPr/>
         </p:nvSpPr>
@@ -5280,7 +5322,7 @@
       </p:sp>
       <p:sp>
         <p:nvSpPr>
-          <p:cNvPr id="51" name="Rectangle 50"/>
+          <p:cNvPr id="52" name="Rectangle 51"/>
           <p:cNvSpPr/>
           <p:nvPr/>
         </p:nvSpPr>
@@ -5324,7 +5366,7 @@
       </p:sp>
       <p:sp>
         <p:nvSpPr>
-          <p:cNvPr id="52" name="TextBox 51"/>
+          <p:cNvPr id="53" name="TextBox 52"/>
           <p:cNvSpPr txBox="1"/>
           <p:nvPr/>
         </p:nvSpPr>
@@ -5359,7 +5401,7 @@
       </p:sp>
       <p:sp>
         <p:nvSpPr>
-          <p:cNvPr id="53" name="TextBox 52"/>
+          <p:cNvPr id="54" name="TextBox 53"/>
           <p:cNvSpPr txBox="1"/>
           <p:nvPr/>
         </p:nvSpPr>
@@ -5403,7 +5445,7 @@
       </p:sp>
       <p:sp>
         <p:nvSpPr>
-          <p:cNvPr id="54" name="TextBox 53"/>
+          <p:cNvPr id="55" name="TextBox 54"/>
           <p:cNvSpPr txBox="1"/>
           <p:nvPr/>
         </p:nvSpPr>
@@ -5447,7 +5489,7 @@
       </p:sp>
       <p:sp>
         <p:nvSpPr>
-          <p:cNvPr id="55" name="Rectangle 54"/>
+          <p:cNvPr id="56" name="Rectangle 55"/>
           <p:cNvSpPr/>
           <p:nvPr/>
         </p:nvSpPr>
@@ -5491,7 +5533,7 @@
       </p:sp>
       <p:sp>
         <p:nvSpPr>
-          <p:cNvPr id="56" name="TextBox 55"/>
+          <p:cNvPr id="57" name="TextBox 56"/>
           <p:cNvSpPr txBox="1"/>
           <p:nvPr/>
         </p:nvSpPr>
@@ -5526,7 +5568,7 @@
       </p:sp>
       <p:sp>
         <p:nvSpPr>
-          <p:cNvPr id="57" name="TextBox 56"/>
+          <p:cNvPr id="58" name="TextBox 57"/>
           <p:cNvSpPr txBox="1"/>
           <p:nvPr/>
         </p:nvSpPr>
@@ -5570,7 +5612,7 @@
       </p:sp>
       <p:sp>
         <p:nvSpPr>
-          <p:cNvPr id="58" name="TextBox 57"/>
+          <p:cNvPr id="59" name="TextBox 58"/>
           <p:cNvSpPr txBox="1"/>
           <p:nvPr/>
         </p:nvSpPr>
@@ -5614,7 +5656,7 @@
       </p:sp>
       <p:sp>
         <p:nvSpPr>
-          <p:cNvPr id="59" name="Rectangle 58"/>
+          <p:cNvPr id="60" name="Rectangle 59"/>
           <p:cNvSpPr/>
           <p:nvPr/>
         </p:nvSpPr>
@@ -5658,7 +5700,7 @@
       </p:sp>
       <p:sp>
         <p:nvSpPr>
-          <p:cNvPr id="60" name="TextBox 59"/>
+          <p:cNvPr id="61" name="TextBox 60"/>
           <p:cNvSpPr txBox="1"/>
           <p:nvPr/>
         </p:nvSpPr>
@@ -5700,7 +5742,7 @@
       </p:sp>
       <p:sp>
         <p:nvSpPr>
-          <p:cNvPr id="61" name="TextBox 60"/>
+          <p:cNvPr id="62" name="TextBox 61"/>
           <p:cNvSpPr txBox="1"/>
           <p:nvPr/>
         </p:nvSpPr>
@@ -5742,7 +5784,7 @@
       </p:sp>
       <p:sp>
         <p:nvSpPr>
-          <p:cNvPr id="62" name="Rectangle 61"/>
+          <p:cNvPr id="63" name="Rectangle 62"/>
           <p:cNvSpPr/>
           <p:nvPr/>
         </p:nvSpPr>
@@ -5786,7 +5828,7 @@
       </p:sp>
       <p:sp>
         <p:nvSpPr>
-          <p:cNvPr id="63" name="Rectangle 62"/>
+          <p:cNvPr id="64" name="Rectangle 63"/>
           <p:cNvSpPr/>
           <p:nvPr/>
         </p:nvSpPr>
@@ -5830,7 +5872,7 @@
       </p:sp>
       <p:sp>
         <p:nvSpPr>
-          <p:cNvPr id="64" name="TextBox 63"/>
+          <p:cNvPr id="65" name="TextBox 64"/>
           <p:cNvSpPr txBox="1"/>
           <p:nvPr/>
         </p:nvSpPr>
@@ -5881,7 +5923,7 @@
       </p:sp>
       <p:sp>
         <p:nvSpPr>
-          <p:cNvPr id="65" name="Rectangle 64"/>
+          <p:cNvPr id="66" name="Rectangle 65"/>
           <p:cNvSpPr/>
           <p:nvPr/>
         </p:nvSpPr>
@@ -5925,7 +5967,7 @@
       </p:sp>
       <p:sp>
         <p:nvSpPr>
-          <p:cNvPr id="66" name="TextBox 65"/>
+          <p:cNvPr id="67" name="TextBox 66"/>
           <p:cNvSpPr txBox="1"/>
           <p:nvPr/>
         </p:nvSpPr>
@@ -5976,7 +6018,7 @@
       </p:sp>
       <p:sp>
         <p:nvSpPr>
-          <p:cNvPr id="67" name="Rectangle 66"/>
+          <p:cNvPr id="68" name="Rectangle 67"/>
           <p:cNvSpPr/>
           <p:nvPr/>
         </p:nvSpPr>
@@ -6020,7 +6062,7 @@
       </p:sp>
       <p:sp>
         <p:nvSpPr>
-          <p:cNvPr id="68" name="TextBox 67"/>
+          <p:cNvPr id="69" name="TextBox 68"/>
           <p:cNvSpPr txBox="1"/>
           <p:nvPr/>
         </p:nvSpPr>
@@ -6071,7 +6113,7 @@
       </p:sp>
       <p:sp>
         <p:nvSpPr>
-          <p:cNvPr id="69" name="TextBox 68"/>
+          <p:cNvPr id="70" name="TextBox 69"/>
           <p:cNvSpPr txBox="1"/>
           <p:nvPr/>
         </p:nvSpPr>
@@ -6131,7 +6173,7 @@
       </p:sp>
       <p:sp>
         <p:nvSpPr>
-          <p:cNvPr id="70" name="TextBox 69"/>
+          <p:cNvPr id="71" name="TextBox 70"/>
           <p:cNvSpPr txBox="1"/>
           <p:nvPr/>
         </p:nvSpPr>
@@ -6173,7 +6215,7 @@
       </p:sp>
       <p:sp>
         <p:nvSpPr>
-          <p:cNvPr id="71" name="Rectangle 70"/>
+          <p:cNvPr id="72" name="Rectangle 71"/>
           <p:cNvSpPr/>
           <p:nvPr/>
         </p:nvSpPr>
@@ -6217,7 +6259,7 @@
       </p:sp>
       <p:sp>
         <p:nvSpPr>
-          <p:cNvPr id="72" name="Rectangle 71"/>
+          <p:cNvPr id="73" name="Rectangle 72"/>
           <p:cNvSpPr/>
           <p:nvPr/>
         </p:nvSpPr>
@@ -6261,7 +6303,7 @@
       </p:sp>
       <p:sp>
         <p:nvSpPr>
-          <p:cNvPr id="73" name="TextBox 72"/>
+          <p:cNvPr id="74" name="TextBox 73"/>
           <p:cNvSpPr txBox="1"/>
           <p:nvPr/>
         </p:nvSpPr>
@@ -6303,7 +6345,7 @@
       </p:sp>
       <p:sp>
         <p:nvSpPr>
-          <p:cNvPr id="74" name="Rectangle 73"/>
+          <p:cNvPr id="75" name="Rectangle 74"/>
           <p:cNvSpPr/>
           <p:nvPr/>
         </p:nvSpPr>
@@ -6347,7 +6389,7 @@
       </p:sp>
       <p:sp>
         <p:nvSpPr>
-          <p:cNvPr id="75" name="TextBox 74"/>
+          <p:cNvPr id="76" name="TextBox 75"/>
           <p:cNvSpPr txBox="1"/>
           <p:nvPr/>
         </p:nvSpPr>
@@ -6389,7 +6431,7 @@
       </p:sp>
       <p:sp>
         <p:nvSpPr>
-          <p:cNvPr id="76" name="Rectangle 75"/>
+          <p:cNvPr id="77" name="Rectangle 76"/>
           <p:cNvSpPr/>
           <p:nvPr/>
         </p:nvSpPr>
@@ -6433,7 +6475,7 @@
       </p:sp>
       <p:sp>
         <p:nvSpPr>
-          <p:cNvPr id="77" name="TextBox 76"/>
+          <p:cNvPr id="78" name="TextBox 77"/>
           <p:cNvSpPr txBox="1"/>
           <p:nvPr/>
         </p:nvSpPr>
@@ -6475,7 +6517,7 @@
       </p:sp>
       <p:sp>
         <p:nvSpPr>
-          <p:cNvPr id="78" name="TextBox 77"/>
+          <p:cNvPr id="79" name="TextBox 78"/>
           <p:cNvSpPr txBox="1"/>
           <p:nvPr/>
         </p:nvSpPr>
@@ -6517,7 +6559,7 @@
       </p:sp>
       <p:sp>
         <p:nvSpPr>
-          <p:cNvPr id="79" name="Rectangle 78"/>
+          <p:cNvPr id="80" name="Rectangle 79"/>
           <p:cNvSpPr/>
           <p:nvPr/>
         </p:nvSpPr>
@@ -6561,7 +6603,7 @@
       </p:sp>
       <p:sp>
         <p:nvSpPr>
-          <p:cNvPr id="80" name="TextBox 79"/>
+          <p:cNvPr id="81" name="TextBox 80"/>
           <p:cNvSpPr txBox="1"/>
           <p:nvPr/>
         </p:nvSpPr>
@@ -6612,7 +6654,7 @@
       </p:sp>
       <p:sp>
         <p:nvSpPr>
-          <p:cNvPr id="81" name="TextBox 80"/>
+          <p:cNvPr id="82" name="TextBox 81"/>
           <p:cNvSpPr txBox="1"/>
           <p:nvPr/>
         </p:nvSpPr>
@@ -6654,7 +6696,7 @@
       </p:sp>
       <p:sp>
         <p:nvSpPr>
-          <p:cNvPr id="82" name="TextBox 81"/>
+          <p:cNvPr id="83" name="TextBox 82"/>
           <p:cNvSpPr txBox="1"/>
           <p:nvPr/>
         </p:nvSpPr>
@@ -6732,7 +6774,7 @@
       </p:sp>
       <p:sp>
         <p:nvSpPr>
-          <p:cNvPr id="83" name="Rectangle 82"/>
+          <p:cNvPr id="84" name="Rectangle 83"/>
           <p:cNvSpPr/>
           <p:nvPr/>
         </p:nvSpPr>
@@ -6776,7 +6818,7 @@
       </p:sp>
       <p:sp>
         <p:nvSpPr>
-          <p:cNvPr id="84" name="Down Arrow 83"/>
+          <p:cNvPr id="85" name="Down Arrow 84"/>
           <p:cNvSpPr/>
           <p:nvPr/>
         </p:nvSpPr>
@@ -6820,7 +6862,7 @@
       </p:sp>
       <p:sp>
         <p:nvSpPr>
-          <p:cNvPr id="85" name="TextBox 84"/>
+          <p:cNvPr id="86" name="TextBox 85"/>
           <p:cNvSpPr txBox="1"/>
           <p:nvPr/>
         </p:nvSpPr>
@@ -6871,7 +6913,7 @@
       </p:sp>
       <p:sp>
         <p:nvSpPr>
-          <p:cNvPr id="86" name="TextBox 85"/>
+          <p:cNvPr id="87" name="TextBox 86"/>
           <p:cNvSpPr txBox="1"/>
           <p:nvPr/>
         </p:nvSpPr>
@@ -6913,7 +6955,7 @@
       </p:sp>
       <p:sp>
         <p:nvSpPr>
-          <p:cNvPr id="87" name="TextBox 86"/>
+          <p:cNvPr id="88" name="TextBox 87"/>
           <p:cNvSpPr txBox="1"/>
           <p:nvPr/>
         </p:nvSpPr>
@@ -6964,7 +7006,7 @@
       </p:sp>
       <p:sp>
         <p:nvSpPr>
-          <p:cNvPr id="88" name="Rectangle 87"/>
+          <p:cNvPr id="89" name="Rectangle 88"/>
           <p:cNvSpPr/>
           <p:nvPr/>
         </p:nvSpPr>
@@ -7008,7 +7050,7 @@
       </p:sp>
       <p:sp>
         <p:nvSpPr>
-          <p:cNvPr id="89" name="Down Arrow 88"/>
+          <p:cNvPr id="90" name="Down Arrow 89"/>
           <p:cNvSpPr/>
           <p:nvPr/>
         </p:nvSpPr>
@@ -7052,7 +7094,7 @@
       </p:sp>
       <p:sp>
         <p:nvSpPr>
-          <p:cNvPr id="90" name="TextBox 89"/>
+          <p:cNvPr id="91" name="TextBox 90"/>
           <p:cNvSpPr txBox="1"/>
           <p:nvPr/>
         </p:nvSpPr>
@@ -7103,7 +7145,7 @@
       </p:sp>
       <p:sp>
         <p:nvSpPr>
-          <p:cNvPr id="91" name="TextBox 90"/>
+          <p:cNvPr id="92" name="TextBox 91"/>
           <p:cNvSpPr txBox="1"/>
           <p:nvPr/>
         </p:nvSpPr>
@@ -7145,7 +7187,7 @@
       </p:sp>
       <p:sp>
         <p:nvSpPr>
-          <p:cNvPr id="92" name="TextBox 91"/>
+          <p:cNvPr id="93" name="TextBox 92"/>
           <p:cNvSpPr txBox="1"/>
           <p:nvPr/>
         </p:nvSpPr>
@@ -7196,7 +7238,7 @@
       </p:sp>
       <p:sp>
         <p:nvSpPr>
-          <p:cNvPr id="93" name="Rectangle 92"/>
+          <p:cNvPr id="94" name="Rectangle 93"/>
           <p:cNvSpPr/>
           <p:nvPr/>
         </p:nvSpPr>
@@ -7240,7 +7282,7 @@
       </p:sp>
       <p:sp>
         <p:nvSpPr>
-          <p:cNvPr id="94" name="Rectangle 93"/>
+          <p:cNvPr id="95" name="Rectangle 94"/>
           <p:cNvSpPr/>
           <p:nvPr/>
         </p:nvSpPr>
@@ -7284,7 +7326,7 @@
       </p:sp>
       <p:sp>
         <p:nvSpPr>
-          <p:cNvPr id="95" name="TextBox 94"/>
+          <p:cNvPr id="96" name="TextBox 95"/>
           <p:cNvSpPr txBox="1"/>
           <p:nvPr/>
         </p:nvSpPr>
@@ -7345,7 +7387,7 @@
       </p:sp>
       <p:sp>
         <p:nvSpPr>
-          <p:cNvPr id="96" name="TextBox 95"/>
+          <p:cNvPr id="97" name="TextBox 96"/>
           <p:cNvSpPr txBox="1"/>
           <p:nvPr/>
         </p:nvSpPr>
@@ -7387,7 +7429,7 @@
       </p:sp>
       <p:sp>
         <p:nvSpPr>
-          <p:cNvPr id="97" name="TextBox 96"/>
+          <p:cNvPr id="98" name="TextBox 97"/>
           <p:cNvSpPr txBox="1"/>
           <p:nvPr/>
         </p:nvSpPr>
@@ -7429,7 +7471,7 @@
       </p:sp>
       <p:sp>
         <p:nvSpPr>
-          <p:cNvPr id="98" name="Rectangle 97"/>
+          <p:cNvPr id="99" name="Rectangle 98"/>
           <p:cNvSpPr/>
           <p:nvPr/>
         </p:nvSpPr>
@@ -7473,7 +7515,7 @@
       </p:sp>
       <p:pic>
         <p:nvPicPr>
-          <p:cNvPr id="99" name="Picture 98" descr="asset_fig3b.png"/>
+          <p:cNvPr id="100" name="Picture 99" descr="asset_fig3b.png"/>
           <p:cNvPicPr>
             <a:picLocks noChangeAspect="1"/>
           </p:cNvPicPr>
@@ -7497,7 +7539,7 @@
       </p:pic>
       <p:sp>
         <p:nvSpPr>
-          <p:cNvPr id="100" name="TextBox 99"/>
+          <p:cNvPr id="101" name="TextBox 100"/>
           <p:cNvSpPr txBox="1"/>
           <p:nvPr/>
         </p:nvSpPr>
@@ -7539,7 +7581,7 @@
       </p:sp>
       <p:sp>
         <p:nvSpPr>
-          <p:cNvPr id="101" name="TextBox 100"/>
+          <p:cNvPr id="102" name="TextBox 101"/>
           <p:cNvSpPr txBox="1"/>
           <p:nvPr/>
         </p:nvSpPr>
@@ -7581,7 +7623,7 @@
       </p:sp>
       <p:sp>
         <p:nvSpPr>
-          <p:cNvPr id="102" name="TextBox 101"/>
+          <p:cNvPr id="103" name="TextBox 102"/>
           <p:cNvSpPr txBox="1"/>
           <p:nvPr/>
         </p:nvSpPr>
@@ -7623,7 +7665,7 @@
       </p:sp>
       <p:sp>
         <p:nvSpPr>
-          <p:cNvPr id="103" name="Rectangle 102"/>
+          <p:cNvPr id="104" name="Rectangle 103"/>
           <p:cNvSpPr/>
           <p:nvPr/>
         </p:nvSpPr>
@@ -7667,7 +7709,7 @@
       </p:sp>
       <p:sp>
         <p:nvSpPr>
-          <p:cNvPr id="104" name="TextBox 103"/>
+          <p:cNvPr id="105" name="TextBox 104"/>
           <p:cNvSpPr txBox="1"/>
           <p:nvPr/>
         </p:nvSpPr>
@@ -7709,7 +7751,7 @@
       </p:sp>
       <p:sp>
         <p:nvSpPr>
-          <p:cNvPr id="105" name="TextBox 104"/>
+          <p:cNvPr id="106" name="TextBox 105"/>
           <p:cNvSpPr txBox="1"/>
           <p:nvPr/>
         </p:nvSpPr>
@@ -7744,7 +7786,7 @@
       </p:sp>
       <p:sp>
         <p:nvSpPr>
-          <p:cNvPr id="106" name="TextBox 105"/>
+          <p:cNvPr id="107" name="TextBox 106"/>
           <p:cNvSpPr txBox="1"/>
           <p:nvPr/>
         </p:nvSpPr>
@@ -7779,7 +7821,7 @@
       </p:sp>
       <p:sp>
         <p:nvSpPr>
-          <p:cNvPr id="107" name="TextBox 106"/>
+          <p:cNvPr id="108" name="TextBox 107"/>
           <p:cNvSpPr txBox="1"/>
           <p:nvPr/>
         </p:nvSpPr>
@@ -7814,7 +7856,7 @@
       </p:sp>
       <p:sp>
         <p:nvSpPr>
-          <p:cNvPr id="108" name="Rectangle 107"/>
+          <p:cNvPr id="109" name="Rectangle 108"/>
           <p:cNvSpPr/>
           <p:nvPr/>
         </p:nvSpPr>
@@ -7858,7 +7900,7 @@
       </p:sp>
       <p:sp>
         <p:nvSpPr>
-          <p:cNvPr id="109" name="TextBox 108"/>
+          <p:cNvPr id="110" name="TextBox 109"/>
           <p:cNvSpPr txBox="1"/>
           <p:nvPr/>
         </p:nvSpPr>
@@ -7893,7 +7935,7 @@
       </p:sp>
       <p:sp>
         <p:nvSpPr>
-          <p:cNvPr id="110" name="TextBox 109"/>
+          <p:cNvPr id="111" name="TextBox 110"/>
           <p:cNvSpPr txBox="1"/>
           <p:nvPr/>
         </p:nvSpPr>
@@ -7946,7 +7988,7 @@
       </p:sp>
       <p:sp>
         <p:nvSpPr>
-          <p:cNvPr id="111" name="TextBox 110"/>
+          <p:cNvPr id="112" name="TextBox 111"/>
           <p:cNvSpPr txBox="1"/>
           <p:nvPr/>
         </p:nvSpPr>
@@ -7999,7 +8041,7 @@
       </p:sp>
       <p:sp>
         <p:nvSpPr>
-          <p:cNvPr id="112" name="Rectangle 111"/>
+          <p:cNvPr id="113" name="Rectangle 112"/>
           <p:cNvSpPr/>
           <p:nvPr/>
         </p:nvSpPr>
@@ -8043,7 +8085,7 @@
       </p:sp>
       <p:sp>
         <p:nvSpPr>
-          <p:cNvPr id="113" name="TextBox 112"/>
+          <p:cNvPr id="114" name="TextBox 113"/>
           <p:cNvSpPr txBox="1"/>
           <p:nvPr/>
         </p:nvSpPr>
@@ -8078,7 +8120,7 @@
       </p:sp>
       <p:sp>
         <p:nvSpPr>
-          <p:cNvPr id="114" name="TextBox 113"/>
+          <p:cNvPr id="115" name="TextBox 114"/>
           <p:cNvSpPr txBox="1"/>
           <p:nvPr/>
         </p:nvSpPr>
@@ -8131,7 +8173,7 @@
       </p:sp>
       <p:sp>
         <p:nvSpPr>
-          <p:cNvPr id="115" name="TextBox 114"/>
+          <p:cNvPr id="116" name="TextBox 115"/>
           <p:cNvSpPr txBox="1"/>
           <p:nvPr/>
         </p:nvSpPr>
@@ -8184,7 +8226,7 @@
       </p:sp>
       <p:sp>
         <p:nvSpPr>
-          <p:cNvPr id="116" name="Rectangle 115"/>
+          <p:cNvPr id="117" name="Rectangle 116"/>
           <p:cNvSpPr/>
           <p:nvPr/>
         </p:nvSpPr>
@@ -8228,7 +8270,7 @@
       </p:sp>
       <p:sp>
         <p:nvSpPr>
-          <p:cNvPr id="117" name="TextBox 116"/>
+          <p:cNvPr id="118" name="TextBox 117"/>
           <p:cNvSpPr txBox="1"/>
           <p:nvPr/>
         </p:nvSpPr>
@@ -8263,7 +8305,7 @@
       </p:sp>
       <p:sp>
         <p:nvSpPr>
-          <p:cNvPr id="118" name="TextBox 117"/>
+          <p:cNvPr id="119" name="TextBox 118"/>
           <p:cNvSpPr txBox="1"/>
           <p:nvPr/>
         </p:nvSpPr>
@@ -8316,7 +8358,7 @@
       </p:sp>
       <p:sp>
         <p:nvSpPr>
-          <p:cNvPr id="119" name="TextBox 118"/>
+          <p:cNvPr id="120" name="TextBox 119"/>
           <p:cNvSpPr txBox="1"/>
           <p:nvPr/>
         </p:nvSpPr>
@@ -8369,7 +8411,7 @@
       </p:sp>
       <p:sp>
         <p:nvSpPr>
-          <p:cNvPr id="120" name="Rectangle 119"/>
+          <p:cNvPr id="121" name="Rectangle 120"/>
           <p:cNvSpPr/>
           <p:nvPr/>
         </p:nvSpPr>
@@ -8413,7 +8455,7 @@
       </p:sp>
       <p:sp>
         <p:nvSpPr>
-          <p:cNvPr id="121" name="TextBox 120"/>
+          <p:cNvPr id="122" name="TextBox 121"/>
           <p:cNvSpPr txBox="1"/>
           <p:nvPr/>
         </p:nvSpPr>
@@ -8448,7 +8490,7 @@
       </p:sp>
       <p:sp>
         <p:nvSpPr>
-          <p:cNvPr id="122" name="TextBox 121"/>
+          <p:cNvPr id="123" name="TextBox 122"/>
           <p:cNvSpPr txBox="1"/>
           <p:nvPr/>
         </p:nvSpPr>
@@ -8501,7 +8543,7 @@
       </p:sp>
       <p:sp>
         <p:nvSpPr>
-          <p:cNvPr id="123" name="TextBox 122"/>
+          <p:cNvPr id="124" name="TextBox 123"/>
           <p:cNvSpPr txBox="1"/>
           <p:nvPr/>
         </p:nvSpPr>
@@ -8554,7 +8596,7 @@
       </p:sp>
       <p:sp>
         <p:nvSpPr>
-          <p:cNvPr id="124" name="Rectangle 123"/>
+          <p:cNvPr id="125" name="Rectangle 124"/>
           <p:cNvSpPr/>
           <p:nvPr/>
         </p:nvSpPr>
@@ -8598,7 +8640,7 @@
       </p:sp>
       <p:sp>
         <p:nvSpPr>
-          <p:cNvPr id="125" name="TextBox 124"/>
+          <p:cNvPr id="126" name="TextBox 125"/>
           <p:cNvSpPr txBox="1"/>
           <p:nvPr/>
         </p:nvSpPr>
@@ -8640,7 +8682,7 @@
       </p:sp>
       <p:sp>
         <p:nvSpPr>
-          <p:cNvPr id="126" name="TextBox 125"/>
+          <p:cNvPr id="127" name="TextBox 126"/>
           <p:cNvSpPr txBox="1"/>
           <p:nvPr/>
         </p:nvSpPr>
@@ -8682,7 +8724,7 @@
       </p:sp>
       <p:sp>
         <p:nvSpPr>
-          <p:cNvPr id="127" name="Rectangle 126"/>
+          <p:cNvPr id="128" name="Rectangle 127"/>
           <p:cNvSpPr/>
           <p:nvPr/>
         </p:nvSpPr>
@@ -8726,7 +8768,7 @@
       </p:sp>
       <p:sp>
         <p:nvSpPr>
-          <p:cNvPr id="128" name="TextBox 127"/>
+          <p:cNvPr id="129" name="TextBox 128"/>
           <p:cNvSpPr txBox="1"/>
           <p:nvPr/>
         </p:nvSpPr>
@@ -8768,7 +8810,7 @@
       </p:sp>
       <p:sp>
         <p:nvSpPr>
-          <p:cNvPr id="129" name="TextBox 128"/>
+          <p:cNvPr id="130" name="TextBox 129"/>
           <p:cNvSpPr txBox="1"/>
           <p:nvPr/>
         </p:nvSpPr>
@@ -8810,7 +8852,7 @@
       </p:sp>
       <p:sp>
         <p:nvSpPr>
-          <p:cNvPr id="130" name="Rectangle 129"/>
+          <p:cNvPr id="131" name="Rectangle 130"/>
           <p:cNvSpPr/>
           <p:nvPr/>
         </p:nvSpPr>
@@ -8854,7 +8896,7 @@
       </p:sp>
       <p:sp>
         <p:nvSpPr>
-          <p:cNvPr id="131" name="TextBox 130"/>
+          <p:cNvPr id="132" name="TextBox 131"/>
           <p:cNvSpPr txBox="1"/>
           <p:nvPr/>
         </p:nvSpPr>
@@ -8905,7 +8947,7 @@
       </p:sp>
       <p:sp>
         <p:nvSpPr>
-          <p:cNvPr id="132" name="TextBox 131"/>
+          <p:cNvPr id="133" name="TextBox 132"/>
           <p:cNvSpPr txBox="1"/>
           <p:nvPr/>
         </p:nvSpPr>
@@ -8947,7 +8989,7 @@
       </p:sp>
       <p:sp>
         <p:nvSpPr>
-          <p:cNvPr id="133" name="TextBox 132"/>
+          <p:cNvPr id="134" name="TextBox 133"/>
           <p:cNvSpPr txBox="1"/>
           <p:nvPr/>
         </p:nvSpPr>
@@ -8989,7 +9031,7 @@
       </p:sp>
       <p:sp>
         <p:nvSpPr>
-          <p:cNvPr id="134" name="Rectangle 133"/>
+          <p:cNvPr id="135" name="Rectangle 134"/>
           <p:cNvSpPr/>
           <p:nvPr/>
         </p:nvSpPr>
@@ -9035,7 +9077,7 @@
       </p:sp>
       <p:sp>
         <p:nvSpPr>
-          <p:cNvPr id="135" name="Rectangle 134"/>
+          <p:cNvPr id="136" name="Rectangle 135"/>
           <p:cNvSpPr/>
           <p:nvPr/>
         </p:nvSpPr>
@@ -9079,7 +9121,7 @@
       </p:sp>
       <p:sp>
         <p:nvSpPr>
-          <p:cNvPr id="136" name="TextBox 135"/>
+          <p:cNvPr id="137" name="TextBox 136"/>
           <p:cNvSpPr txBox="1"/>
           <p:nvPr/>
         </p:nvSpPr>
@@ -9114,7 +9156,7 @@
       </p:sp>
       <p:sp>
         <p:nvSpPr>
-          <p:cNvPr id="137" name="TextBox 136"/>
+          <p:cNvPr id="138" name="TextBox 137"/>
           <p:cNvSpPr txBox="1"/>
           <p:nvPr/>
         </p:nvSpPr>
@@ -9149,7 +9191,7 @@
       </p:sp>
       <p:sp>
         <p:nvSpPr>
-          <p:cNvPr id="138" name="Rectangle 137"/>
+          <p:cNvPr id="139" name="Rectangle 138"/>
           <p:cNvSpPr/>
           <p:nvPr/>
         </p:nvSpPr>
@@ -9195,7 +9237,7 @@
       </p:sp>
       <p:sp>
         <p:nvSpPr>
-          <p:cNvPr id="139" name="Rectangle 138"/>
+          <p:cNvPr id="140" name="Rectangle 139"/>
           <p:cNvSpPr/>
           <p:nvPr/>
         </p:nvSpPr>
@@ -9239,7 +9281,7 @@
       </p:sp>
       <p:sp>
         <p:nvSpPr>
-          <p:cNvPr id="140" name="TextBox 139"/>
+          <p:cNvPr id="141" name="TextBox 140"/>
           <p:cNvSpPr txBox="1"/>
           <p:nvPr/>
         </p:nvSpPr>
@@ -9274,7 +9316,7 @@
       </p:sp>
       <p:sp>
         <p:nvSpPr>
-          <p:cNvPr id="141" name="TextBox 140"/>
+          <p:cNvPr id="142" name="TextBox 141"/>
           <p:cNvSpPr txBox="1"/>
           <p:nvPr/>
         </p:nvSpPr>
@@ -9309,7 +9351,7 @@
       </p:sp>
       <p:sp>
         <p:nvSpPr>
-          <p:cNvPr id="142" name="TextBox 141"/>
+          <p:cNvPr id="143" name="TextBox 142"/>
           <p:cNvSpPr txBox="1"/>
           <p:nvPr/>
         </p:nvSpPr>
@@ -9360,7 +9402,7 @@
       </p:sp>
       <p:sp>
         <p:nvSpPr>
-          <p:cNvPr id="143" name="TextBox 142"/>
+          <p:cNvPr id="144" name="TextBox 143"/>
           <p:cNvSpPr txBox="1"/>
           <p:nvPr/>
         </p:nvSpPr>
@@ -9402,7 +9444,7 @@
       </p:sp>
       <p:sp>
         <p:nvSpPr>
-          <p:cNvPr id="144" name="TextBox 143"/>
+          <p:cNvPr id="145" name="TextBox 144"/>
           <p:cNvSpPr txBox="1"/>
           <p:nvPr/>
         </p:nvSpPr>
@@ -9437,7 +9479,7 @@
       </p:sp>
       <p:sp>
         <p:nvSpPr>
-          <p:cNvPr id="145" name="TextBox 144"/>
+          <p:cNvPr id="146" name="TextBox 145"/>
           <p:cNvSpPr txBox="1"/>
           <p:nvPr/>
         </p:nvSpPr>
@@ -9472,7 +9514,7 @@
       </p:sp>
       <p:sp>
         <p:nvSpPr>
-          <p:cNvPr id="146" name="TextBox 145"/>
+          <p:cNvPr id="147" name="TextBox 146"/>
           <p:cNvSpPr txBox="1"/>
           <p:nvPr/>
         </p:nvSpPr>
@@ -9507,7 +9549,7 @@
       </p:sp>
       <p:sp>
         <p:nvSpPr>
-          <p:cNvPr id="147" name="TextBox 146"/>
+          <p:cNvPr id="148" name="TextBox 147"/>
           <p:cNvSpPr txBox="1"/>
           <p:nvPr/>
         </p:nvSpPr>
@@ -9542,7 +9584,7 @@
       </p:sp>
       <p:sp>
         <p:nvSpPr>
-          <p:cNvPr id="148" name="Rectangle 147"/>
+          <p:cNvPr id="149" name="Rectangle 148"/>
           <p:cNvSpPr/>
           <p:nvPr/>
         </p:nvSpPr>
@@ -9586,7 +9628,7 @@
       </p:sp>
       <p:sp>
         <p:nvSpPr>
-          <p:cNvPr id="149" name="TextBox 148"/>
+          <p:cNvPr id="150" name="TextBox 149"/>
           <p:cNvSpPr txBox="1"/>
           <p:nvPr/>
         </p:nvSpPr>
@@ -9621,7 +9663,7 @@
       </p:sp>
       <p:sp>
         <p:nvSpPr>
-          <p:cNvPr id="150" name="TextBox 149"/>
+          <p:cNvPr id="151" name="TextBox 150"/>
           <p:cNvSpPr txBox="1"/>
           <p:nvPr/>
         </p:nvSpPr>
@@ -9656,7 +9698,7 @@
       </p:sp>
       <p:sp>
         <p:nvSpPr>
-          <p:cNvPr id="151" name="TextBox 150"/>
+          <p:cNvPr id="152" name="TextBox 151"/>
           <p:cNvSpPr txBox="1"/>
           <p:nvPr/>
         </p:nvSpPr>
@@ -9709,7 +9751,7 @@
       </p:sp>
       <p:sp>
         <p:nvSpPr>
-          <p:cNvPr id="152" name="TextBox 151"/>
+          <p:cNvPr id="153" name="TextBox 152"/>
           <p:cNvSpPr txBox="1"/>
           <p:nvPr/>
         </p:nvSpPr>
@@ -9762,7 +9804,7 @@
       </p:sp>
       <p:sp>
         <p:nvSpPr>
-          <p:cNvPr id="153" name="Rectangle 152"/>
+          <p:cNvPr id="154" name="Rectangle 153"/>
           <p:cNvSpPr/>
           <p:nvPr/>
         </p:nvSpPr>
@@ -9806,7 +9848,7 @@
       </p:sp>
       <p:sp>
         <p:nvSpPr>
-          <p:cNvPr id="154" name="TextBox 153"/>
+          <p:cNvPr id="155" name="TextBox 154"/>
           <p:cNvSpPr txBox="1"/>
           <p:nvPr/>
         </p:nvSpPr>
@@ -9841,7 +9883,7 @@
       </p:sp>
       <p:sp>
         <p:nvSpPr>
-          <p:cNvPr id="155" name="TextBox 154"/>
+          <p:cNvPr id="156" name="TextBox 155"/>
           <p:cNvSpPr txBox="1"/>
           <p:nvPr/>
         </p:nvSpPr>
@@ -9876,7 +9918,7 @@
       </p:sp>
       <p:sp>
         <p:nvSpPr>
-          <p:cNvPr id="156" name="TextBox 155"/>
+          <p:cNvPr id="157" name="TextBox 156"/>
           <p:cNvSpPr txBox="1"/>
           <p:nvPr/>
         </p:nvSpPr>
@@ -9929,7 +9971,7 @@
       </p:sp>
       <p:sp>
         <p:nvSpPr>
-          <p:cNvPr id="157" name="TextBox 156"/>
+          <p:cNvPr id="158" name="TextBox 157"/>
           <p:cNvSpPr txBox="1"/>
           <p:nvPr/>
         </p:nvSpPr>
@@ -9982,7 +10024,7 @@
       </p:sp>
       <p:sp>
         <p:nvSpPr>
-          <p:cNvPr id="158" name="Rectangle 157"/>
+          <p:cNvPr id="159" name="Rectangle 158"/>
           <p:cNvSpPr/>
           <p:nvPr/>
         </p:nvSpPr>
@@ -10026,7 +10068,7 @@
       </p:sp>
       <p:sp>
         <p:nvSpPr>
-          <p:cNvPr id="159" name="TextBox 158"/>
+          <p:cNvPr id="160" name="TextBox 159"/>
           <p:cNvSpPr txBox="1"/>
           <p:nvPr/>
         </p:nvSpPr>
@@ -10061,7 +10103,7 @@
       </p:sp>
       <p:sp>
         <p:nvSpPr>
-          <p:cNvPr id="160" name="TextBox 159"/>
+          <p:cNvPr id="161" name="TextBox 160"/>
           <p:cNvSpPr txBox="1"/>
           <p:nvPr/>
         </p:nvSpPr>
@@ -10096,7 +10138,7 @@
       </p:sp>
       <p:sp>
         <p:nvSpPr>
-          <p:cNvPr id="161" name="TextBox 160"/>
+          <p:cNvPr id="162" name="TextBox 161"/>
           <p:cNvSpPr txBox="1"/>
           <p:nvPr/>
         </p:nvSpPr>
@@ -10149,7 +10191,7 @@
       </p:sp>
       <p:sp>
         <p:nvSpPr>
-          <p:cNvPr id="162" name="TextBox 161"/>
+          <p:cNvPr id="163" name="TextBox 162"/>
           <p:cNvSpPr txBox="1"/>
           <p:nvPr/>
         </p:nvSpPr>
@@ -10202,7 +10244,7 @@
       </p:sp>
       <p:sp>
         <p:nvSpPr>
-          <p:cNvPr id="163" name="Rectangle 162"/>
+          <p:cNvPr id="164" name="Rectangle 163"/>
           <p:cNvSpPr/>
           <p:nvPr/>
         </p:nvSpPr>
@@ -10246,7 +10288,7 @@
       </p:sp>
       <p:sp>
         <p:nvSpPr>
-          <p:cNvPr id="164" name="TextBox 163"/>
+          <p:cNvPr id="165" name="TextBox 164"/>
           <p:cNvSpPr txBox="1"/>
           <p:nvPr/>
         </p:nvSpPr>
@@ -10281,7 +10323,7 @@
       </p:sp>
       <p:sp>
         <p:nvSpPr>
-          <p:cNvPr id="165" name="TextBox 164"/>
+          <p:cNvPr id="166" name="TextBox 165"/>
           <p:cNvSpPr txBox="1"/>
           <p:nvPr/>
         </p:nvSpPr>
@@ -10316,7 +10358,7 @@
       </p:sp>
       <p:sp>
         <p:nvSpPr>
-          <p:cNvPr id="166" name="TextBox 165"/>
+          <p:cNvPr id="167" name="TextBox 166"/>
           <p:cNvSpPr txBox="1"/>
           <p:nvPr/>
         </p:nvSpPr>
@@ -10369,7 +10411,7 @@
       </p:sp>
       <p:sp>
         <p:nvSpPr>
-          <p:cNvPr id="167" name="TextBox 166"/>
+          <p:cNvPr id="168" name="TextBox 167"/>
           <p:cNvSpPr txBox="1"/>
           <p:nvPr/>
         </p:nvSpPr>
@@ -10422,7 +10464,7 @@
       </p:sp>
       <p:sp>
         <p:nvSpPr>
-          <p:cNvPr id="168" name="Rectangle 167"/>
+          <p:cNvPr id="169" name="Rectangle 168"/>
           <p:cNvSpPr/>
           <p:nvPr/>
         </p:nvSpPr>
@@ -10466,7 +10508,7 @@
       </p:sp>
       <p:sp>
         <p:nvSpPr>
-          <p:cNvPr id="169" name="TextBox 168"/>
+          <p:cNvPr id="170" name="TextBox 169"/>
           <p:cNvSpPr txBox="1"/>
           <p:nvPr/>
         </p:nvSpPr>
@@ -10501,7 +10543,7 @@
       </p:sp>
       <p:sp>
         <p:nvSpPr>
-          <p:cNvPr id="170" name="TextBox 169"/>
+          <p:cNvPr id="171" name="TextBox 170"/>
           <p:cNvSpPr txBox="1"/>
           <p:nvPr/>
         </p:nvSpPr>
@@ -10536,7 +10578,7 @@
       </p:sp>
       <p:sp>
         <p:nvSpPr>
-          <p:cNvPr id="171" name="TextBox 170"/>
+          <p:cNvPr id="172" name="TextBox 171"/>
           <p:cNvSpPr txBox="1"/>
           <p:nvPr/>
         </p:nvSpPr>
@@ -10589,7 +10631,7 @@
       </p:sp>
       <p:sp>
         <p:nvSpPr>
-          <p:cNvPr id="172" name="TextBox 171"/>
+          <p:cNvPr id="173" name="TextBox 172"/>
           <p:cNvSpPr txBox="1"/>
           <p:nvPr/>
         </p:nvSpPr>
@@ -10642,7 +10684,7 @@
       </p:sp>
       <p:sp>
         <p:nvSpPr>
-          <p:cNvPr id="173" name="Rectangle 172"/>
+          <p:cNvPr id="174" name="Rectangle 173"/>
           <p:cNvSpPr/>
           <p:nvPr/>
         </p:nvSpPr>
@@ -10686,7 +10728,7 @@
       </p:sp>
       <p:sp>
         <p:nvSpPr>
-          <p:cNvPr id="174" name="TextBox 173"/>
+          <p:cNvPr id="175" name="TextBox 174"/>
           <p:cNvSpPr txBox="1"/>
           <p:nvPr/>
         </p:nvSpPr>
@@ -10721,7 +10763,7 @@
       </p:sp>
       <p:sp>
         <p:nvSpPr>
-          <p:cNvPr id="175" name="TextBox 174"/>
+          <p:cNvPr id="176" name="TextBox 175"/>
           <p:cNvSpPr txBox="1"/>
           <p:nvPr/>
         </p:nvSpPr>
@@ -10756,7 +10798,7 @@
       </p:sp>
       <p:sp>
         <p:nvSpPr>
-          <p:cNvPr id="176" name="TextBox 175"/>
+          <p:cNvPr id="177" name="TextBox 176"/>
           <p:cNvSpPr txBox="1"/>
           <p:nvPr/>
         </p:nvSpPr>
@@ -10809,7 +10851,7 @@
       </p:sp>
       <p:sp>
         <p:nvSpPr>
-          <p:cNvPr id="177" name="TextBox 176"/>
+          <p:cNvPr id="178" name="TextBox 177"/>
           <p:cNvSpPr txBox="1"/>
           <p:nvPr/>
         </p:nvSpPr>
@@ -10862,7 +10904,7 @@
       </p:sp>
       <p:sp>
         <p:nvSpPr>
-          <p:cNvPr id="178" name="Rectangle 177"/>
+          <p:cNvPr id="179" name="Rectangle 178"/>
           <p:cNvSpPr/>
           <p:nvPr/>
         </p:nvSpPr>
@@ -10906,7 +10948,7 @@
       </p:sp>
       <p:sp>
         <p:nvSpPr>
-          <p:cNvPr id="179" name="TextBox 178"/>
+          <p:cNvPr id="180" name="TextBox 179"/>
           <p:cNvSpPr txBox="1"/>
           <p:nvPr/>
         </p:nvSpPr>
@@ -10941,7 +10983,7 @@
       </p:sp>
       <p:sp>
         <p:nvSpPr>
-          <p:cNvPr id="180" name="TextBox 179"/>
+          <p:cNvPr id="181" name="TextBox 180"/>
           <p:cNvSpPr txBox="1"/>
           <p:nvPr/>
         </p:nvSpPr>
@@ -10976,7 +11018,7 @@
       </p:sp>
       <p:sp>
         <p:nvSpPr>
-          <p:cNvPr id="181" name="TextBox 180"/>
+          <p:cNvPr id="182" name="TextBox 181"/>
           <p:cNvSpPr txBox="1"/>
           <p:nvPr/>
         </p:nvSpPr>
@@ -11029,7 +11071,7 @@
       </p:sp>
       <p:sp>
         <p:nvSpPr>
-          <p:cNvPr id="182" name="TextBox 181"/>
+          <p:cNvPr id="183" name="TextBox 182"/>
           <p:cNvSpPr txBox="1"/>
           <p:nvPr/>
         </p:nvSpPr>
@@ -11082,7 +11124,7 @@
       </p:sp>
       <p:sp>
         <p:nvSpPr>
-          <p:cNvPr id="183" name="Rectangle 182"/>
+          <p:cNvPr id="184" name="Rectangle 183"/>
           <p:cNvSpPr/>
           <p:nvPr/>
         </p:nvSpPr>
@@ -11126,7 +11168,7 @@
       </p:sp>
       <p:sp>
         <p:nvSpPr>
-          <p:cNvPr id="184" name="TextBox 183"/>
+          <p:cNvPr id="185" name="TextBox 184"/>
           <p:cNvSpPr txBox="1"/>
           <p:nvPr/>
         </p:nvSpPr>
@@ -11177,7 +11219,7 @@
       </p:sp>
       <p:sp>
         <p:nvSpPr>
-          <p:cNvPr id="185" name="TextBox 184"/>
+          <p:cNvPr id="186" name="TextBox 185"/>
           <p:cNvSpPr txBox="1"/>
           <p:nvPr/>
         </p:nvSpPr>
@@ -11219,7 +11261,7 @@
       </p:sp>
       <p:sp>
         <p:nvSpPr>
-          <p:cNvPr id="186" name="Rectangle 185"/>
+          <p:cNvPr id="187" name="Rectangle 186"/>
           <p:cNvSpPr/>
           <p:nvPr/>
         </p:nvSpPr>
@@ -11263,7 +11305,7 @@
       </p:sp>
       <p:sp>
         <p:nvSpPr>
-          <p:cNvPr id="187" name="TextBox 186"/>
+          <p:cNvPr id="188" name="TextBox 187"/>
           <p:cNvSpPr txBox="1"/>
           <p:nvPr/>
         </p:nvSpPr>
@@ -11305,7 +11347,7 @@
       </p:sp>
       <p:sp>
         <p:nvSpPr>
-          <p:cNvPr id="188" name="Rectangle 187"/>
+          <p:cNvPr id="189" name="Rectangle 188"/>
           <p:cNvSpPr/>
           <p:nvPr/>
         </p:nvSpPr>
@@ -11351,7 +11393,7 @@
       </p:sp>
       <p:sp>
         <p:nvSpPr>
-          <p:cNvPr id="189" name="TextBox 188"/>
+          <p:cNvPr id="190" name="TextBox 189"/>
           <p:cNvSpPr txBox="1"/>
           <p:nvPr/>
         </p:nvSpPr>
@@ -11412,7 +11454,7 @@
       </p:sp>
       <p:sp>
         <p:nvSpPr>
-          <p:cNvPr id="190" name="TextBox 189"/>
+          <p:cNvPr id="191" name="TextBox 190"/>
           <p:cNvSpPr txBox="1"/>
           <p:nvPr/>
         </p:nvSpPr>
@@ -11454,7 +11496,7 @@
       </p:sp>
       <p:sp>
         <p:nvSpPr>
-          <p:cNvPr id="191" name="Rectangle 190"/>
+          <p:cNvPr id="192" name="Rectangle 191"/>
           <p:cNvSpPr/>
           <p:nvPr/>
         </p:nvSpPr>
@@ -11498,7 +11540,7 @@
       </p:sp>
       <p:sp>
         <p:nvSpPr>
-          <p:cNvPr id="192" name="TextBox 191"/>
+          <p:cNvPr id="193" name="TextBox 192"/>
           <p:cNvSpPr txBox="1"/>
           <p:nvPr/>
         </p:nvSpPr>
@@ -11540,7 +11582,7 @@
       </p:sp>
       <p:sp>
         <p:nvSpPr>
-          <p:cNvPr id="193" name="Rectangle 192"/>
+          <p:cNvPr id="194" name="Rectangle 193"/>
           <p:cNvSpPr/>
           <p:nvPr/>
         </p:nvSpPr>
@@ -11586,7 +11628,7 @@
       </p:sp>
       <p:sp>
         <p:nvSpPr>
-          <p:cNvPr id="194" name="Rectangle 193"/>
+          <p:cNvPr id="195" name="Rectangle 194"/>
           <p:cNvSpPr/>
           <p:nvPr/>
         </p:nvSpPr>
@@ -11630,7 +11672,7 @@
       </p:sp>
       <p:sp>
         <p:nvSpPr>
-          <p:cNvPr id="195" name="TextBox 194"/>
+          <p:cNvPr id="196" name="TextBox 195"/>
           <p:cNvSpPr txBox="1"/>
           <p:nvPr/>
         </p:nvSpPr>
@@ -11665,7 +11707,7 @@
       </p:sp>
       <p:sp>
         <p:nvSpPr>
-          <p:cNvPr id="196" name="TextBox 195"/>
+          <p:cNvPr id="197" name="TextBox 196"/>
           <p:cNvSpPr txBox="1"/>
           <p:nvPr/>
         </p:nvSpPr>
@@ -11700,7 +11742,7 @@
       </p:sp>
       <p:sp>
         <p:nvSpPr>
-          <p:cNvPr id="197" name="Rectangle 196"/>
+          <p:cNvPr id="198" name="Rectangle 197"/>
           <p:cNvSpPr/>
           <p:nvPr/>
         </p:nvSpPr>
@@ -11746,7 +11788,7 @@
       </p:sp>
       <p:sp>
         <p:nvSpPr>
-          <p:cNvPr id="198" name="Rectangle 197"/>
+          <p:cNvPr id="199" name="Rectangle 198"/>
           <p:cNvSpPr/>
           <p:nvPr/>
         </p:nvSpPr>
@@ -11790,7 +11832,7 @@
       </p:sp>
       <p:sp>
         <p:nvSpPr>
-          <p:cNvPr id="199" name="TextBox 198"/>
+          <p:cNvPr id="200" name="TextBox 199"/>
           <p:cNvSpPr txBox="1"/>
           <p:nvPr/>
         </p:nvSpPr>
@@ -11825,7 +11867,7 @@
       </p:sp>
       <p:sp>
         <p:nvSpPr>
-          <p:cNvPr id="200" name="TextBox 199"/>
+          <p:cNvPr id="201" name="TextBox 200"/>
           <p:cNvSpPr txBox="1"/>
           <p:nvPr/>
         </p:nvSpPr>
@@ -11860,7 +11902,7 @@
       </p:sp>
       <p:sp>
         <p:nvSpPr>
-          <p:cNvPr id="201" name="Rectangle 200"/>
+          <p:cNvPr id="202" name="Rectangle 201"/>
           <p:cNvSpPr/>
           <p:nvPr/>
         </p:nvSpPr>
@@ -11906,7 +11948,7 @@
       </p:sp>
       <p:sp>
         <p:nvSpPr>
-          <p:cNvPr id="202" name="Rectangle 201"/>
+          <p:cNvPr id="203" name="Rectangle 202"/>
           <p:cNvSpPr/>
           <p:nvPr/>
         </p:nvSpPr>
@@ -11950,7 +11992,7 @@
       </p:sp>
       <p:sp>
         <p:nvSpPr>
-          <p:cNvPr id="203" name="TextBox 202"/>
+          <p:cNvPr id="204" name="TextBox 203"/>
           <p:cNvSpPr txBox="1"/>
           <p:nvPr/>
         </p:nvSpPr>
@@ -11985,7 +12027,7 @@
       </p:sp>
       <p:sp>
         <p:nvSpPr>
-          <p:cNvPr id="204" name="TextBox 203"/>
+          <p:cNvPr id="205" name="TextBox 204"/>
           <p:cNvSpPr txBox="1"/>
           <p:nvPr/>
         </p:nvSpPr>
@@ -12020,7 +12062,7 @@
       </p:sp>
       <p:sp>
         <p:nvSpPr>
-          <p:cNvPr id="205" name="Rectangle 204"/>
+          <p:cNvPr id="206" name="Rectangle 205"/>
           <p:cNvSpPr/>
           <p:nvPr/>
         </p:nvSpPr>
@@ -12066,7 +12108,7 @@
       </p:sp>
       <p:sp>
         <p:nvSpPr>
-          <p:cNvPr id="206" name="Rectangle 205"/>
+          <p:cNvPr id="207" name="Rectangle 206"/>
           <p:cNvSpPr/>
           <p:nvPr/>
         </p:nvSpPr>
@@ -12110,7 +12152,7 @@
       </p:sp>
       <p:sp>
         <p:nvSpPr>
-          <p:cNvPr id="207" name="TextBox 206"/>
+          <p:cNvPr id="208" name="TextBox 207"/>
           <p:cNvSpPr txBox="1"/>
           <p:nvPr/>
         </p:nvSpPr>
@@ -12145,7 +12187,7 @@
       </p:sp>
       <p:sp>
         <p:nvSpPr>
-          <p:cNvPr id="208" name="TextBox 207"/>
+          <p:cNvPr id="209" name="TextBox 208"/>
           <p:cNvSpPr txBox="1"/>
           <p:nvPr/>
         </p:nvSpPr>
@@ -12180,7 +12222,7 @@
       </p:sp>
       <p:sp>
         <p:nvSpPr>
-          <p:cNvPr id="209" name="TextBox 208"/>
+          <p:cNvPr id="210" name="TextBox 209"/>
           <p:cNvSpPr txBox="1"/>
           <p:nvPr/>
         </p:nvSpPr>
@@ -12231,7 +12273,7 @@
       </p:sp>
       <p:sp>
         <p:nvSpPr>
-          <p:cNvPr id="210" name="TextBox 209"/>
+          <p:cNvPr id="211" name="TextBox 210"/>
           <p:cNvSpPr txBox="1"/>
           <p:nvPr/>
         </p:nvSpPr>
@@ -12273,7 +12315,7 @@
       </p:sp>
       <p:sp>
         <p:nvSpPr>
-          <p:cNvPr id="211" name="TextBox 210"/>
+          <p:cNvPr id="212" name="TextBox 211"/>
           <p:cNvSpPr txBox="1"/>
           <p:nvPr/>
         </p:nvSpPr>
@@ -12315,7 +12357,7 @@
       </p:sp>
       <p:sp>
         <p:nvSpPr>
-          <p:cNvPr id="212" name="Rectangle 211"/>
+          <p:cNvPr id="213" name="Rectangle 212"/>
           <p:cNvSpPr/>
           <p:nvPr/>
         </p:nvSpPr>
@@ -12359,7 +12401,7 @@
       </p:sp>
       <p:pic>
         <p:nvPicPr>
-          <p:cNvPr id="213" name="Picture 212" descr="asset_fig3c.png"/>
+          <p:cNvPr id="214" name="Picture 213" descr="asset_fig3c.png"/>
           <p:cNvPicPr>
             <a:picLocks noChangeAspect="1"/>
           </p:cNvPicPr>
@@ -12383,7 +12425,7 @@
       </p:pic>
       <p:sp>
         <p:nvSpPr>
-          <p:cNvPr id="214" name="TextBox 213"/>
+          <p:cNvPr id="215" name="TextBox 214"/>
           <p:cNvSpPr txBox="1"/>
           <p:nvPr/>
         </p:nvSpPr>
@@ -12425,7 +12467,7 @@
       </p:sp>
       <p:sp>
         <p:nvSpPr>
-          <p:cNvPr id="215" name="Rectangle 214"/>
+          <p:cNvPr id="216" name="Rectangle 215"/>
           <p:cNvSpPr/>
           <p:nvPr/>
         </p:nvSpPr>
@@ -12471,7 +12513,7 @@
       </p:sp>
       <p:sp>
         <p:nvSpPr>
-          <p:cNvPr id="216" name="TextBox 215"/>
+          <p:cNvPr id="217" name="TextBox 216"/>
           <p:cNvSpPr txBox="1"/>
           <p:nvPr/>
         </p:nvSpPr>
@@ -12551,7 +12593,7 @@
       </p:sp>
       <p:sp>
         <p:nvSpPr>
-          <p:cNvPr id="217" name="Rectangle 216"/>
+          <p:cNvPr id="218" name="Rectangle 217"/>
           <p:cNvSpPr/>
           <p:nvPr/>
         </p:nvSpPr>
@@ -12595,7 +12637,7 @@
       </p:sp>
       <p:sp>
         <p:nvSpPr>
-          <p:cNvPr id="218" name="Rectangle 217"/>
+          <p:cNvPr id="219" name="Rectangle 218"/>
           <p:cNvSpPr/>
           <p:nvPr/>
         </p:nvSpPr>
@@ -12639,7 +12681,7 @@
       </p:sp>
       <p:pic>
         <p:nvPicPr>
-          <p:cNvPr id="219" name="Picture 218" descr="asset_cikm.png"/>
+          <p:cNvPr id="220" name="Picture 219" descr="asset_cikm.png"/>
           <p:cNvPicPr>
             <a:picLocks noChangeAspect="1"/>
           </p:cNvPicPr>
@@ -12663,7 +12705,7 @@
       </p:pic>
       <p:sp>
         <p:nvSpPr>
-          <p:cNvPr id="220" name="TextBox 219"/>
+          <p:cNvPr id="221" name="TextBox 220"/>
           <p:cNvSpPr txBox="1"/>
           <p:nvPr/>
         </p:nvSpPr>
@@ -12705,7 +12747,7 @@
       </p:sp>
       <p:sp>
         <p:nvSpPr>
-          <p:cNvPr id="221" name="TextBox 220"/>
+          <p:cNvPr id="222" name="TextBox 221"/>
           <p:cNvSpPr txBox="1"/>
           <p:nvPr/>
         </p:nvSpPr>

</xml_diff>

<commit_message>
fix(poster): match equations to the paper, use paper Figure 3 in Results
- Eq.(2): drop the interpunct absent from the paper
- Eq.(4): "0 otherwise" per the paper's cases wording
- Add missing Eq.(5) cumulative gap-energy fraction
- Replace gap-vs-gain scatter (not in the paper) with Figure 3
  (alpha sweep / Selective PMC / QPS Pareto) + paper caption
</commit_message>
<xml_diff>
--- a/poster/PMC_CIKM2026_poster.pptx
+++ b/poster/PMC_CIKM2026_poster.pptx
@@ -4238,7 +4238,7 @@
                 </a:solidFill>
                 <a:latin typeface="Times New Roman"/>
               </a:rPr>
-              <a:t>(0) · |g</a:t>
+              <a:t>(0) |g</a:t>
             </a:r>
             <a:r>
               <a:rPr sz="2160" b="1" i="0" baseline="-25000">
@@ -5317,7 +5317,7 @@
                 </a:solidFill>
                 <a:latin typeface="Times New Roman"/>
               </a:rPr>
-              <a:t> ,  else  0 ;      x′</a:t>
+              <a:t> ,  0  otherwise ;      x′</a:t>
             </a:r>
             <a:r>
               <a:rPr sz="1800" b="1" i="0" baseline="-25000">
@@ -5384,7 +5384,163 @@
         </p:nvSpPr>
         <p:spPr>
           <a:xfrm>
-            <a:off x="777240" y="36462080"/>
+            <a:off x="777240" y="36608384"/>
+            <a:ext cx="14040612" cy="464820"/>
+          </a:xfrm>
+          <a:prstGeom prst="rect">
+            <a:avLst/>
+          </a:prstGeom>
+          <a:noFill/>
+        </p:spPr>
+        <p:txBody>
+          <a:bodyPr wrap="square" lIns="0" rIns="0" tIns="0" bIns="0">
+            <a:spAutoFit/>
+          </a:bodyPr>
+          <a:lstStyle/>
+          <a:p>
+            <a:pPr algn="ctr">
+              <a:lnSpc>
+                <a:spcPct val="122000"/>
+              </a:lnSpc>
+              <a:spcAft>
+                <a:spcPts val="0"/>
+              </a:spcAft>
+            </a:pPr>
+            <a:r>
+              <a:rPr sz="2500" b="1" i="0">
+                <a:solidFill>
+                  <a:srgbClr val="1F1F1F"/>
+                </a:solidFill>
+                <a:latin typeface="Times New Roman"/>
+              </a:rPr>
+              <a:t>E(P)  =  Σ</a:t>
+            </a:r>
+            <a:r>
+              <a:rPr sz="1800" b="1" i="0" baseline="-25000">
+                <a:solidFill>
+                  <a:srgbClr val="1F1F1F"/>
+                </a:solidFill>
+                <a:latin typeface="Times New Roman"/>
+              </a:rPr>
+              <a:t>i ∈ S(P)</a:t>
+            </a:r>
+            <a:r>
+              <a:rPr sz="2500" b="1" i="0">
+                <a:solidFill>
+                  <a:srgbClr val="1F1F1F"/>
+                </a:solidFill>
+                <a:latin typeface="Times New Roman"/>
+              </a:rPr>
+              <a:t> g</a:t>
+            </a:r>
+            <a:r>
+              <a:rPr sz="1800" b="1" i="0" baseline="-25000">
+                <a:solidFill>
+                  <a:srgbClr val="1F1F1F"/>
+                </a:solidFill>
+                <a:latin typeface="Times New Roman"/>
+              </a:rPr>
+              <a:t>i</a:t>
+            </a:r>
+            <a:r>
+              <a:rPr sz="2500" b="1" i="0">
+                <a:solidFill>
+                  <a:srgbClr val="1F1F1F"/>
+                </a:solidFill>
+                <a:latin typeface="Times New Roman"/>
+              </a:rPr>
+              <a:t>²  /  ‖g‖² ,      S(P) = { i : |g</a:t>
+            </a:r>
+            <a:r>
+              <a:rPr sz="1800" b="1" i="0" baseline="-25000">
+                <a:solidFill>
+                  <a:srgbClr val="1F1F1F"/>
+                </a:solidFill>
+                <a:latin typeface="Times New Roman"/>
+              </a:rPr>
+              <a:t>i</a:t>
+            </a:r>
+            <a:r>
+              <a:rPr sz="2500" b="1" i="0">
+                <a:solidFill>
+                  <a:srgbClr val="1F1F1F"/>
+                </a:solidFill>
+                <a:latin typeface="Times New Roman"/>
+              </a:rPr>
+              <a:t>| ≥ |g|</a:t>
+            </a:r>
+            <a:r>
+              <a:rPr sz="1800" b="1" i="0" baseline="-25000">
+                <a:solidFill>
+                  <a:srgbClr val="1F1F1F"/>
+                </a:solidFill>
+                <a:latin typeface="Times New Roman"/>
+              </a:rPr>
+              <a:t>(P)</a:t>
+            </a:r>
+            <a:r>
+              <a:rPr sz="2500" b="1" i="0">
+                <a:solidFill>
+                  <a:srgbClr val="1F1F1F"/>
+                </a:solidFill>
+                <a:latin typeface="Times New Roman"/>
+              </a:rPr>
+              <a:t> }</a:t>
+            </a:r>
+          </a:p>
+        </p:txBody>
+      </p:sp>
+      <p:sp>
+        <p:nvSpPr>
+          <p:cNvPr id="41" name="TextBox 40"/>
+          <p:cNvSpPr txBox="1"/>
+          <p:nvPr/>
+        </p:nvSpPr>
+        <p:spPr>
+          <a:xfrm>
+            <a:off x="777240" y="37073204"/>
+            <a:ext cx="14040612" cy="371855"/>
+          </a:xfrm>
+          <a:prstGeom prst="rect">
+            <a:avLst/>
+          </a:prstGeom>
+          <a:noFill/>
+        </p:spPr>
+        <p:txBody>
+          <a:bodyPr wrap="square" lIns="0" rIns="0" tIns="0" bIns="0">
+            <a:spAutoFit/>
+          </a:bodyPr>
+          <a:lstStyle/>
+          <a:p>
+            <a:pPr algn="ctr">
+              <a:lnSpc>
+                <a:spcPct val="122000"/>
+              </a:lnSpc>
+              <a:spcAft>
+                <a:spcPts val="0"/>
+              </a:spcAft>
+            </a:pPr>
+            <a:r>
+              <a:rPr sz="2000" b="0" i="1">
+                <a:solidFill>
+                  <a:srgbClr val="6F6F6F"/>
+                </a:solidFill>
+                <a:latin typeface="Times New Roman"/>
+              </a:rPr>
+              <a:t>cumulative gap energy captured by the selected dimensions</a:t>
+            </a:r>
+          </a:p>
+        </p:txBody>
+      </p:sp>
+      <p:sp>
+        <p:nvSpPr>
+          <p:cNvPr id="42" name="TextBox 41"/>
+          <p:cNvSpPr txBox="1"/>
+          <p:nvPr/>
+        </p:nvSpPr>
+        <p:spPr>
+          <a:xfrm>
+            <a:off x="777240" y="37609651"/>
             <a:ext cx="14040612" cy="1290624"/>
           </a:xfrm>
           <a:prstGeom prst="rect">
@@ -5438,7 +5594,7 @@
       </p:sp>
       <p:sp>
         <p:nvSpPr>
-          <p:cNvPr id="41" name="TextBox 40"/>
+          <p:cNvPr id="43" name="TextBox 42"/>
           <p:cNvSpPr txBox="1"/>
           <p:nvPr/>
         </p:nvSpPr>
@@ -5480,7 +5636,7 @@
       </p:sp>
       <p:sp>
         <p:nvSpPr>
-          <p:cNvPr id="42" name="Rectangle 41"/>
+          <p:cNvPr id="44" name="Rectangle 43"/>
           <p:cNvSpPr/>
           <p:nvPr/>
         </p:nvSpPr>
@@ -5524,7 +5680,7 @@
       </p:sp>
       <p:pic>
         <p:nvPicPr>
-          <p:cNvPr id="43" name="Picture 42" descr="asset_fig2ov.png"/>
+          <p:cNvPr id="45" name="Picture 44" descr="asset_fig2ov.png"/>
           <p:cNvPicPr>
             <a:picLocks noChangeAspect="1"/>
           </p:cNvPicPr>
@@ -5548,7 +5704,7 @@
       </p:pic>
       <p:sp>
         <p:nvSpPr>
-          <p:cNvPr id="44" name="TextBox 43"/>
+          <p:cNvPr id="46" name="TextBox 45"/>
           <p:cNvSpPr txBox="1"/>
           <p:nvPr/>
         </p:nvSpPr>
@@ -5662,7 +5818,7 @@
       </p:sp>
       <p:sp>
         <p:nvSpPr>
-          <p:cNvPr id="45" name="TextBox 44"/>
+          <p:cNvPr id="47" name="TextBox 46"/>
           <p:cNvSpPr txBox="1"/>
           <p:nvPr/>
         </p:nvSpPr>
@@ -5704,7 +5860,7 @@
       </p:sp>
       <p:sp>
         <p:nvSpPr>
-          <p:cNvPr id="46" name="Rectangle 45"/>
+          <p:cNvPr id="48" name="Rectangle 47"/>
           <p:cNvSpPr/>
           <p:nvPr/>
         </p:nvSpPr>
@@ -5748,7 +5904,7 @@
       </p:sp>
       <p:sp>
         <p:nvSpPr>
-          <p:cNvPr id="47" name="TextBox 46"/>
+          <p:cNvPr id="49" name="TextBox 48"/>
           <p:cNvSpPr txBox="1"/>
           <p:nvPr/>
         </p:nvSpPr>
@@ -5844,7 +6000,7 @@
       </p:sp>
       <p:sp>
         <p:nvSpPr>
-          <p:cNvPr id="48" name="TextBox 47"/>
+          <p:cNvPr id="50" name="TextBox 49"/>
           <p:cNvSpPr txBox="1"/>
           <p:nvPr/>
         </p:nvSpPr>
@@ -5895,7 +6051,7 @@
       </p:sp>
       <p:sp>
         <p:nvSpPr>
-          <p:cNvPr id="49" name="TextBox 48"/>
+          <p:cNvPr id="51" name="TextBox 50"/>
           <p:cNvSpPr txBox="1"/>
           <p:nvPr/>
         </p:nvSpPr>
@@ -5930,7 +6086,7 @@
       </p:sp>
       <p:sp>
         <p:nvSpPr>
-          <p:cNvPr id="50" name="TextBox 49"/>
+          <p:cNvPr id="52" name="TextBox 51"/>
           <p:cNvSpPr txBox="1"/>
           <p:nvPr/>
         </p:nvSpPr>
@@ -5965,7 +6121,7 @@
       </p:sp>
       <p:sp>
         <p:nvSpPr>
-          <p:cNvPr id="51" name="TextBox 50"/>
+          <p:cNvPr id="53" name="TextBox 52"/>
           <p:cNvSpPr txBox="1"/>
           <p:nvPr/>
         </p:nvSpPr>
@@ -6000,7 +6156,7 @@
       </p:sp>
       <p:sp>
         <p:nvSpPr>
-          <p:cNvPr id="52" name="TextBox 51"/>
+          <p:cNvPr id="54" name="TextBox 53"/>
           <p:cNvSpPr txBox="1"/>
           <p:nvPr/>
         </p:nvSpPr>
@@ -6035,7 +6191,7 @@
       </p:sp>
       <p:sp>
         <p:nvSpPr>
-          <p:cNvPr id="53" name="Rectangle 52"/>
+          <p:cNvPr id="55" name="Rectangle 54"/>
           <p:cNvSpPr/>
           <p:nvPr/>
         </p:nvSpPr>
@@ -6079,7 +6235,7 @@
       </p:sp>
       <p:sp>
         <p:nvSpPr>
-          <p:cNvPr id="54" name="TextBox 53"/>
+          <p:cNvPr id="56" name="TextBox 55"/>
           <p:cNvSpPr txBox="1"/>
           <p:nvPr/>
         </p:nvSpPr>
@@ -6114,7 +6270,7 @@
       </p:sp>
       <p:sp>
         <p:nvSpPr>
-          <p:cNvPr id="55" name="TextBox 54"/>
+          <p:cNvPr id="57" name="TextBox 56"/>
           <p:cNvSpPr txBox="1"/>
           <p:nvPr/>
         </p:nvSpPr>
@@ -6149,7 +6305,7 @@
       </p:sp>
       <p:sp>
         <p:nvSpPr>
-          <p:cNvPr id="56" name="TextBox 55"/>
+          <p:cNvPr id="58" name="TextBox 57"/>
           <p:cNvSpPr txBox="1"/>
           <p:nvPr/>
         </p:nvSpPr>
@@ -6202,7 +6358,7 @@
       </p:sp>
       <p:sp>
         <p:nvSpPr>
-          <p:cNvPr id="57" name="TextBox 56"/>
+          <p:cNvPr id="59" name="TextBox 58"/>
           <p:cNvSpPr txBox="1"/>
           <p:nvPr/>
         </p:nvSpPr>
@@ -6255,7 +6411,7 @@
       </p:sp>
       <p:sp>
         <p:nvSpPr>
-          <p:cNvPr id="58" name="Rectangle 57"/>
+          <p:cNvPr id="60" name="Rectangle 59"/>
           <p:cNvSpPr/>
           <p:nvPr/>
         </p:nvSpPr>
@@ -6299,7 +6455,7 @@
       </p:sp>
       <p:sp>
         <p:nvSpPr>
-          <p:cNvPr id="59" name="TextBox 58"/>
+          <p:cNvPr id="61" name="TextBox 60"/>
           <p:cNvSpPr txBox="1"/>
           <p:nvPr/>
         </p:nvSpPr>
@@ -6334,7 +6490,7 @@
       </p:sp>
       <p:sp>
         <p:nvSpPr>
-          <p:cNvPr id="60" name="TextBox 59"/>
+          <p:cNvPr id="62" name="TextBox 61"/>
           <p:cNvSpPr txBox="1"/>
           <p:nvPr/>
         </p:nvSpPr>
@@ -6369,7 +6525,7 @@
       </p:sp>
       <p:sp>
         <p:nvSpPr>
-          <p:cNvPr id="61" name="TextBox 60"/>
+          <p:cNvPr id="63" name="TextBox 62"/>
           <p:cNvSpPr txBox="1"/>
           <p:nvPr/>
         </p:nvSpPr>
@@ -6422,7 +6578,7 @@
       </p:sp>
       <p:sp>
         <p:nvSpPr>
-          <p:cNvPr id="62" name="TextBox 61"/>
+          <p:cNvPr id="64" name="TextBox 63"/>
           <p:cNvSpPr txBox="1"/>
           <p:nvPr/>
         </p:nvSpPr>
@@ -6475,7 +6631,7 @@
       </p:sp>
       <p:sp>
         <p:nvSpPr>
-          <p:cNvPr id="63" name="Rectangle 62"/>
+          <p:cNvPr id="65" name="Rectangle 64"/>
           <p:cNvSpPr/>
           <p:nvPr/>
         </p:nvSpPr>
@@ -6519,7 +6675,7 @@
       </p:sp>
       <p:sp>
         <p:nvSpPr>
-          <p:cNvPr id="64" name="TextBox 63"/>
+          <p:cNvPr id="66" name="TextBox 65"/>
           <p:cNvSpPr txBox="1"/>
           <p:nvPr/>
         </p:nvSpPr>
@@ -6554,7 +6710,7 @@
       </p:sp>
       <p:sp>
         <p:nvSpPr>
-          <p:cNvPr id="65" name="TextBox 64"/>
+          <p:cNvPr id="67" name="TextBox 66"/>
           <p:cNvSpPr txBox="1"/>
           <p:nvPr/>
         </p:nvSpPr>
@@ -6589,7 +6745,7 @@
       </p:sp>
       <p:sp>
         <p:nvSpPr>
-          <p:cNvPr id="66" name="TextBox 65"/>
+          <p:cNvPr id="68" name="TextBox 67"/>
           <p:cNvSpPr txBox="1"/>
           <p:nvPr/>
         </p:nvSpPr>
@@ -6642,7 +6798,7 @@
       </p:sp>
       <p:sp>
         <p:nvSpPr>
-          <p:cNvPr id="67" name="TextBox 66"/>
+          <p:cNvPr id="69" name="TextBox 68"/>
           <p:cNvSpPr txBox="1"/>
           <p:nvPr/>
         </p:nvSpPr>
@@ -6695,7 +6851,7 @@
       </p:sp>
       <p:sp>
         <p:nvSpPr>
-          <p:cNvPr id="68" name="Rectangle 67"/>
+          <p:cNvPr id="70" name="Rectangle 69"/>
           <p:cNvSpPr/>
           <p:nvPr/>
         </p:nvSpPr>
@@ -6739,7 +6895,7 @@
       </p:sp>
       <p:sp>
         <p:nvSpPr>
-          <p:cNvPr id="69" name="TextBox 68"/>
+          <p:cNvPr id="71" name="TextBox 70"/>
           <p:cNvSpPr txBox="1"/>
           <p:nvPr/>
         </p:nvSpPr>
@@ -6774,7 +6930,7 @@
       </p:sp>
       <p:sp>
         <p:nvSpPr>
-          <p:cNvPr id="70" name="TextBox 69"/>
+          <p:cNvPr id="72" name="TextBox 71"/>
           <p:cNvSpPr txBox="1"/>
           <p:nvPr/>
         </p:nvSpPr>
@@ -6809,7 +6965,7 @@
       </p:sp>
       <p:sp>
         <p:nvSpPr>
-          <p:cNvPr id="71" name="TextBox 70"/>
+          <p:cNvPr id="73" name="TextBox 72"/>
           <p:cNvSpPr txBox="1"/>
           <p:nvPr/>
         </p:nvSpPr>
@@ -6862,7 +7018,7 @@
       </p:sp>
       <p:sp>
         <p:nvSpPr>
-          <p:cNvPr id="72" name="TextBox 71"/>
+          <p:cNvPr id="74" name="TextBox 73"/>
           <p:cNvSpPr txBox="1"/>
           <p:nvPr/>
         </p:nvSpPr>
@@ -6915,7 +7071,7 @@
       </p:sp>
       <p:sp>
         <p:nvSpPr>
-          <p:cNvPr id="73" name="Rectangle 72"/>
+          <p:cNvPr id="75" name="Rectangle 74"/>
           <p:cNvSpPr/>
           <p:nvPr/>
         </p:nvSpPr>
@@ -6959,7 +7115,7 @@
       </p:sp>
       <p:sp>
         <p:nvSpPr>
-          <p:cNvPr id="74" name="TextBox 73"/>
+          <p:cNvPr id="76" name="TextBox 75"/>
           <p:cNvSpPr txBox="1"/>
           <p:nvPr/>
         </p:nvSpPr>
@@ -6994,7 +7150,7 @@
       </p:sp>
       <p:sp>
         <p:nvSpPr>
-          <p:cNvPr id="75" name="TextBox 74"/>
+          <p:cNvPr id="77" name="TextBox 76"/>
           <p:cNvSpPr txBox="1"/>
           <p:nvPr/>
         </p:nvSpPr>
@@ -7029,7 +7185,7 @@
       </p:sp>
       <p:sp>
         <p:nvSpPr>
-          <p:cNvPr id="76" name="TextBox 75"/>
+          <p:cNvPr id="78" name="TextBox 77"/>
           <p:cNvSpPr txBox="1"/>
           <p:nvPr/>
         </p:nvSpPr>
@@ -7082,7 +7238,7 @@
       </p:sp>
       <p:sp>
         <p:nvSpPr>
-          <p:cNvPr id="77" name="TextBox 76"/>
+          <p:cNvPr id="79" name="TextBox 78"/>
           <p:cNvSpPr txBox="1"/>
           <p:nvPr/>
         </p:nvSpPr>
@@ -7135,7 +7291,7 @@
       </p:sp>
       <p:sp>
         <p:nvSpPr>
-          <p:cNvPr id="78" name="Rectangle 77"/>
+          <p:cNvPr id="80" name="Rectangle 79"/>
           <p:cNvSpPr/>
           <p:nvPr/>
         </p:nvSpPr>
@@ -7179,7 +7335,7 @@
       </p:sp>
       <p:sp>
         <p:nvSpPr>
-          <p:cNvPr id="79" name="TextBox 78"/>
+          <p:cNvPr id="81" name="TextBox 80"/>
           <p:cNvSpPr txBox="1"/>
           <p:nvPr/>
         </p:nvSpPr>
@@ -7214,7 +7370,7 @@
       </p:sp>
       <p:sp>
         <p:nvSpPr>
-          <p:cNvPr id="80" name="TextBox 79"/>
+          <p:cNvPr id="82" name="TextBox 81"/>
           <p:cNvSpPr txBox="1"/>
           <p:nvPr/>
         </p:nvSpPr>
@@ -7249,7 +7405,7 @@
       </p:sp>
       <p:sp>
         <p:nvSpPr>
-          <p:cNvPr id="81" name="TextBox 80"/>
+          <p:cNvPr id="83" name="TextBox 82"/>
           <p:cNvSpPr txBox="1"/>
           <p:nvPr/>
         </p:nvSpPr>
@@ -7302,7 +7458,7 @@
       </p:sp>
       <p:sp>
         <p:nvSpPr>
-          <p:cNvPr id="82" name="TextBox 81"/>
+          <p:cNvPr id="84" name="TextBox 83"/>
           <p:cNvSpPr txBox="1"/>
           <p:nvPr/>
         </p:nvSpPr>
@@ -7355,7 +7511,7 @@
       </p:sp>
       <p:sp>
         <p:nvSpPr>
-          <p:cNvPr id="83" name="Rectangle 82"/>
+          <p:cNvPr id="85" name="Rectangle 84"/>
           <p:cNvSpPr/>
           <p:nvPr/>
         </p:nvSpPr>
@@ -7399,7 +7555,7 @@
       </p:sp>
       <p:sp>
         <p:nvSpPr>
-          <p:cNvPr id="84" name="TextBox 83"/>
+          <p:cNvPr id="86" name="TextBox 85"/>
           <p:cNvSpPr txBox="1"/>
           <p:nvPr/>
         </p:nvSpPr>
@@ -7434,7 +7590,7 @@
       </p:sp>
       <p:sp>
         <p:nvSpPr>
-          <p:cNvPr id="85" name="TextBox 84"/>
+          <p:cNvPr id="87" name="TextBox 86"/>
           <p:cNvSpPr txBox="1"/>
           <p:nvPr/>
         </p:nvSpPr>
@@ -7469,7 +7625,7 @@
       </p:sp>
       <p:sp>
         <p:nvSpPr>
-          <p:cNvPr id="86" name="TextBox 85"/>
+          <p:cNvPr id="88" name="TextBox 87"/>
           <p:cNvSpPr txBox="1"/>
           <p:nvPr/>
         </p:nvSpPr>
@@ -7522,7 +7678,7 @@
       </p:sp>
       <p:sp>
         <p:nvSpPr>
-          <p:cNvPr id="87" name="TextBox 86"/>
+          <p:cNvPr id="89" name="TextBox 88"/>
           <p:cNvSpPr txBox="1"/>
           <p:nvPr/>
         </p:nvSpPr>
@@ -7575,7 +7731,7 @@
       </p:sp>
       <p:sp>
         <p:nvSpPr>
-          <p:cNvPr id="88" name="Rectangle 87"/>
+          <p:cNvPr id="90" name="Rectangle 89"/>
           <p:cNvSpPr/>
           <p:nvPr/>
         </p:nvSpPr>
@@ -7619,7 +7775,7 @@
       </p:sp>
       <p:sp>
         <p:nvSpPr>
-          <p:cNvPr id="89" name="TextBox 88"/>
+          <p:cNvPr id="91" name="TextBox 90"/>
           <p:cNvSpPr txBox="1"/>
           <p:nvPr/>
         </p:nvSpPr>
@@ -7697,7 +7853,7 @@
       </p:sp>
       <p:pic>
         <p:nvPicPr>
-          <p:cNvPr id="90" name="Picture 89" descr="asset_gapgain.png"/>
+          <p:cNvPr id="92" name="Picture 91" descr="asset_fig3.png"/>
           <p:cNvPicPr>
             <a:picLocks noChangeAspect="1"/>
           </p:cNvPicPr>
@@ -7711,8 +7867,8 @@
         </p:blipFill>
         <p:spPr>
           <a:xfrm>
-            <a:off x="19108491" y="23357812"/>
-            <a:ext cx="6739493" cy="4477094"/>
+            <a:off x="15457932" y="23376100"/>
+            <a:ext cx="14040612" cy="3622757"/>
           </a:xfrm>
           <a:prstGeom prst="rect">
             <a:avLst/>
@@ -7721,14 +7877,14 @@
       </p:pic>
       <p:sp>
         <p:nvSpPr>
-          <p:cNvPr id="91" name="TextBox 90"/>
+          <p:cNvPr id="93" name="TextBox 92"/>
           <p:cNvSpPr txBox="1"/>
           <p:nvPr/>
         </p:nvSpPr>
         <p:spPr>
           <a:xfrm>
-            <a:off x="15457932" y="27908058"/>
-            <a:ext cx="14040612" cy="350520"/>
+            <a:off x="15457932" y="27072009"/>
+            <a:ext cx="14040612" cy="1051560"/>
           </a:xfrm>
           <a:prstGeom prst="rect">
             <a:avLst/>
@@ -7756,20 +7912,20 @@
                 </a:solidFill>
                 <a:latin typeface="Times New Roman"/>
               </a:rPr>
-              <a:t>ΔR@100 vs modality gap across every backbone and index — the gain tracks the gap.</a:t>
-            </a:r>
-          </a:p>
-        </p:txBody>
-      </p:sp>
-      <p:sp>
-        <p:nvSpPr>
-          <p:cNvPr id="92" name="TextBox 91"/>
+              <a:t>(a) R@100 vs shift strength α (α = 0: MeanShift, α = 1: full DB-side PMC): α = 1 is best or near-best, justifying the default. (b) Selective PMC: on concentrated-gap MSCOCO, top-P = 5% already reaches peak R@100; diffuse gaps require broader correction. (c) R@100–QPS Pareto: PMC dominates Vanilla across throughput levels.</a:t>
+            </a:r>
+          </a:p>
+        </p:txBody>
+      </p:sp>
+      <p:sp>
+        <p:nvSpPr>
+          <p:cNvPr id="94" name="TextBox 93"/>
           <p:cNvSpPr txBox="1"/>
           <p:nvPr/>
         </p:nvSpPr>
         <p:spPr>
           <a:xfrm>
-            <a:off x="15457932" y="28331730"/>
+            <a:off x="15457932" y="28196721"/>
             <a:ext cx="14040612" cy="560070"/>
           </a:xfrm>
           <a:prstGeom prst="rect">
@@ -7805,13 +7961,13 @@
       </p:sp>
       <p:sp>
         <p:nvSpPr>
-          <p:cNvPr id="93" name="Rectangle 92"/>
+          <p:cNvPr id="95" name="Rectangle 94"/>
           <p:cNvSpPr/>
           <p:nvPr/>
         </p:nvSpPr>
         <p:spPr>
           <a:xfrm>
-            <a:off x="15457932" y="28937520"/>
+            <a:off x="15457932" y="28802511"/>
             <a:ext cx="14040612" cy="31750"/>
           </a:xfrm>
           <a:prstGeom prst="rect">
@@ -7849,13 +8005,13 @@
       </p:sp>
       <p:sp>
         <p:nvSpPr>
-          <p:cNvPr id="94" name="TextBox 93"/>
+          <p:cNvPr id="96" name="TextBox 95"/>
           <p:cNvSpPr txBox="1"/>
           <p:nvPr/>
         </p:nvSpPr>
         <p:spPr>
           <a:xfrm>
-            <a:off x="15457932" y="29014990"/>
+            <a:off x="15457932" y="28879981"/>
             <a:ext cx="14040612" cy="427634"/>
           </a:xfrm>
           <a:prstGeom prst="rect">
@@ -7900,13 +8056,13 @@
       </p:sp>
       <p:sp>
         <p:nvSpPr>
-          <p:cNvPr id="95" name="TextBox 94"/>
+          <p:cNvPr id="97" name="TextBox 96"/>
           <p:cNvSpPr txBox="1"/>
           <p:nvPr/>
         </p:nvSpPr>
         <p:spPr>
           <a:xfrm>
-            <a:off x="15457932" y="29552352"/>
+            <a:off x="15457932" y="29417343"/>
             <a:ext cx="2926080" cy="438912"/>
           </a:xfrm>
           <a:prstGeom prst="rect">
@@ -7935,13 +8091,13 @@
       </p:sp>
       <p:sp>
         <p:nvSpPr>
-          <p:cNvPr id="96" name="TextBox 95"/>
+          <p:cNvPr id="98" name="TextBox 97"/>
           <p:cNvSpPr txBox="1"/>
           <p:nvPr/>
         </p:nvSpPr>
         <p:spPr>
           <a:xfrm>
-            <a:off x="18384012" y="29552352"/>
+            <a:off x="18384012" y="29417343"/>
             <a:ext cx="5557266" cy="438912"/>
           </a:xfrm>
           <a:prstGeom prst="rect">
@@ -7970,13 +8126,13 @@
       </p:sp>
       <p:sp>
         <p:nvSpPr>
-          <p:cNvPr id="97" name="TextBox 96"/>
+          <p:cNvPr id="99" name="TextBox 98"/>
           <p:cNvSpPr txBox="1"/>
           <p:nvPr/>
         </p:nvSpPr>
         <p:spPr>
           <a:xfrm>
-            <a:off x="23941278" y="29552352"/>
+            <a:off x="23941278" y="29417343"/>
             <a:ext cx="5557266" cy="438912"/>
           </a:xfrm>
           <a:prstGeom prst="rect">
@@ -8005,13 +8161,13 @@
       </p:sp>
       <p:sp>
         <p:nvSpPr>
-          <p:cNvPr id="98" name="Rectangle 97"/>
+          <p:cNvPr id="100" name="Rectangle 99"/>
           <p:cNvSpPr/>
           <p:nvPr/>
         </p:nvSpPr>
         <p:spPr>
           <a:xfrm>
-            <a:off x="15457932" y="30027840"/>
+            <a:off x="15457932" y="29892831"/>
             <a:ext cx="14040612" cy="19050"/>
           </a:xfrm>
           <a:prstGeom prst="rect">
@@ -8049,13 +8205,13 @@
       </p:sp>
       <p:sp>
         <p:nvSpPr>
-          <p:cNvPr id="99" name="TextBox 98"/>
+          <p:cNvPr id="101" name="TextBox 100"/>
           <p:cNvSpPr txBox="1"/>
           <p:nvPr/>
         </p:nvSpPr>
         <p:spPr>
           <a:xfrm>
-            <a:off x="15457932" y="30065178"/>
+            <a:off x="15457932" y="29930169"/>
             <a:ext cx="2926080" cy="457200"/>
           </a:xfrm>
           <a:prstGeom prst="rect">
@@ -8084,13 +8240,13 @@
       </p:sp>
       <p:sp>
         <p:nvSpPr>
-          <p:cNvPr id="100" name="TextBox 99"/>
+          <p:cNvPr id="102" name="TextBox 101"/>
           <p:cNvSpPr txBox="1"/>
           <p:nvPr/>
         </p:nvSpPr>
         <p:spPr>
           <a:xfrm>
-            <a:off x="18384012" y="30065178"/>
+            <a:off x="18384012" y="29930169"/>
             <a:ext cx="5557266" cy="457200"/>
           </a:xfrm>
           <a:prstGeom prst="rect">
@@ -8128,13 +8284,13 @@
       </p:sp>
       <p:sp>
         <p:nvSpPr>
-          <p:cNvPr id="101" name="TextBox 100"/>
+          <p:cNvPr id="103" name="TextBox 102"/>
           <p:cNvSpPr txBox="1"/>
           <p:nvPr/>
         </p:nvSpPr>
         <p:spPr>
           <a:xfrm>
-            <a:off x="23941278" y="30065178"/>
+            <a:off x="23941278" y="29930169"/>
             <a:ext cx="5557266" cy="457200"/>
           </a:xfrm>
           <a:prstGeom prst="rect">
@@ -8172,13 +8328,13 @@
       </p:sp>
       <p:sp>
         <p:nvSpPr>
-          <p:cNvPr id="102" name="Rectangle 101"/>
+          <p:cNvPr id="104" name="Rectangle 103"/>
           <p:cNvSpPr/>
           <p:nvPr/>
         </p:nvSpPr>
         <p:spPr>
           <a:xfrm>
-            <a:off x="15457932" y="30522378"/>
+            <a:off x="15457932" y="30387369"/>
             <a:ext cx="14040612" cy="10160"/>
           </a:xfrm>
           <a:prstGeom prst="rect">
@@ -8216,13 +8372,13 @@
       </p:sp>
       <p:sp>
         <p:nvSpPr>
-          <p:cNvPr id="103" name="TextBox 102"/>
+          <p:cNvPr id="105" name="TextBox 104"/>
           <p:cNvSpPr txBox="1"/>
           <p:nvPr/>
         </p:nvSpPr>
         <p:spPr>
           <a:xfrm>
-            <a:off x="15457932" y="30522378"/>
+            <a:off x="15457932" y="30387369"/>
             <a:ext cx="2926080" cy="457200"/>
           </a:xfrm>
           <a:prstGeom prst="rect">
@@ -8251,13 +8407,13 @@
       </p:sp>
       <p:sp>
         <p:nvSpPr>
-          <p:cNvPr id="104" name="TextBox 103"/>
+          <p:cNvPr id="106" name="TextBox 105"/>
           <p:cNvSpPr txBox="1"/>
           <p:nvPr/>
         </p:nvSpPr>
         <p:spPr>
           <a:xfrm>
-            <a:off x="18384012" y="30522378"/>
+            <a:off x="18384012" y="30387369"/>
             <a:ext cx="5557266" cy="457200"/>
           </a:xfrm>
           <a:prstGeom prst="rect">
@@ -8295,13 +8451,13 @@
       </p:sp>
       <p:sp>
         <p:nvSpPr>
-          <p:cNvPr id="105" name="TextBox 104"/>
+          <p:cNvPr id="107" name="TextBox 106"/>
           <p:cNvSpPr txBox="1"/>
           <p:nvPr/>
         </p:nvSpPr>
         <p:spPr>
           <a:xfrm>
-            <a:off x="23941278" y="30522378"/>
+            <a:off x="23941278" y="30387369"/>
             <a:ext cx="5557266" cy="457200"/>
           </a:xfrm>
           <a:prstGeom prst="rect">
@@ -8339,13 +8495,13 @@
       </p:sp>
       <p:sp>
         <p:nvSpPr>
-          <p:cNvPr id="106" name="Rectangle 105"/>
+          <p:cNvPr id="108" name="Rectangle 107"/>
           <p:cNvSpPr/>
           <p:nvPr/>
         </p:nvSpPr>
         <p:spPr>
           <a:xfrm>
-            <a:off x="15457932" y="30979578"/>
+            <a:off x="15457932" y="30844569"/>
             <a:ext cx="14040612" cy="10160"/>
           </a:xfrm>
           <a:prstGeom prst="rect">
@@ -8383,13 +8539,13 @@
       </p:sp>
       <p:sp>
         <p:nvSpPr>
-          <p:cNvPr id="107" name="TextBox 106"/>
+          <p:cNvPr id="109" name="TextBox 108"/>
           <p:cNvSpPr txBox="1"/>
           <p:nvPr/>
         </p:nvSpPr>
         <p:spPr>
           <a:xfrm>
-            <a:off x="15457932" y="30979578"/>
+            <a:off x="15457932" y="30844569"/>
             <a:ext cx="2926080" cy="457200"/>
           </a:xfrm>
           <a:prstGeom prst="rect">
@@ -8418,13 +8574,13 @@
       </p:sp>
       <p:sp>
         <p:nvSpPr>
-          <p:cNvPr id="108" name="TextBox 107"/>
+          <p:cNvPr id="110" name="TextBox 109"/>
           <p:cNvSpPr txBox="1"/>
           <p:nvPr/>
         </p:nvSpPr>
         <p:spPr>
           <a:xfrm>
-            <a:off x="18384012" y="30979578"/>
+            <a:off x="18384012" y="30844569"/>
             <a:ext cx="5557266" cy="457200"/>
           </a:xfrm>
           <a:prstGeom prst="rect">
@@ -8462,13 +8618,13 @@
       </p:sp>
       <p:sp>
         <p:nvSpPr>
-          <p:cNvPr id="109" name="TextBox 108"/>
+          <p:cNvPr id="111" name="TextBox 110"/>
           <p:cNvSpPr txBox="1"/>
           <p:nvPr/>
         </p:nvSpPr>
         <p:spPr>
           <a:xfrm>
-            <a:off x="23941278" y="30979578"/>
+            <a:off x="23941278" y="30844569"/>
             <a:ext cx="5557266" cy="457200"/>
           </a:xfrm>
           <a:prstGeom prst="rect">
@@ -8506,13 +8662,13 @@
       </p:sp>
       <p:sp>
         <p:nvSpPr>
-          <p:cNvPr id="110" name="Rectangle 109"/>
+          <p:cNvPr id="112" name="Rectangle 111"/>
           <p:cNvSpPr/>
           <p:nvPr/>
         </p:nvSpPr>
         <p:spPr>
           <a:xfrm>
-            <a:off x="15457932" y="31436778"/>
+            <a:off x="15457932" y="31301769"/>
             <a:ext cx="14040612" cy="10160"/>
           </a:xfrm>
           <a:prstGeom prst="rect">
@@ -8550,13 +8706,13 @@
       </p:sp>
       <p:sp>
         <p:nvSpPr>
-          <p:cNvPr id="111" name="TextBox 110"/>
+          <p:cNvPr id="113" name="TextBox 112"/>
           <p:cNvSpPr txBox="1"/>
           <p:nvPr/>
         </p:nvSpPr>
         <p:spPr>
           <a:xfrm>
-            <a:off x="15457932" y="31436778"/>
+            <a:off x="15457932" y="31301769"/>
             <a:ext cx="2926080" cy="457200"/>
           </a:xfrm>
           <a:prstGeom prst="rect">
@@ -8585,13 +8741,13 @@
       </p:sp>
       <p:sp>
         <p:nvSpPr>
-          <p:cNvPr id="112" name="TextBox 111"/>
+          <p:cNvPr id="114" name="TextBox 113"/>
           <p:cNvSpPr txBox="1"/>
           <p:nvPr/>
         </p:nvSpPr>
         <p:spPr>
           <a:xfrm>
-            <a:off x="18384012" y="31436778"/>
+            <a:off x="18384012" y="31301769"/>
             <a:ext cx="5557266" cy="457200"/>
           </a:xfrm>
           <a:prstGeom prst="rect">
@@ -8629,13 +8785,13 @@
       </p:sp>
       <p:sp>
         <p:nvSpPr>
-          <p:cNvPr id="113" name="TextBox 112"/>
+          <p:cNvPr id="115" name="TextBox 114"/>
           <p:cNvSpPr txBox="1"/>
           <p:nvPr/>
         </p:nvSpPr>
         <p:spPr>
           <a:xfrm>
-            <a:off x="23941278" y="31436778"/>
+            <a:off x="23941278" y="31301769"/>
             <a:ext cx="5557266" cy="457200"/>
           </a:xfrm>
           <a:prstGeom prst="rect">
@@ -8673,13 +8829,13 @@
       </p:sp>
       <p:sp>
         <p:nvSpPr>
-          <p:cNvPr id="114" name="Rectangle 113"/>
+          <p:cNvPr id="116" name="Rectangle 115"/>
           <p:cNvSpPr/>
           <p:nvPr/>
         </p:nvSpPr>
         <p:spPr>
           <a:xfrm>
-            <a:off x="15457932" y="31893978"/>
+            <a:off x="15457932" y="31758969"/>
             <a:ext cx="14040612" cy="10160"/>
           </a:xfrm>
           <a:prstGeom prst="rect">
@@ -8717,13 +8873,13 @@
       </p:sp>
       <p:sp>
         <p:nvSpPr>
-          <p:cNvPr id="115" name="TextBox 114"/>
+          <p:cNvPr id="117" name="TextBox 116"/>
           <p:cNvSpPr txBox="1"/>
           <p:nvPr/>
         </p:nvSpPr>
         <p:spPr>
           <a:xfrm>
-            <a:off x="15457932" y="32021994"/>
+            <a:off x="15457932" y="31886985"/>
             <a:ext cx="14040612" cy="1699666"/>
           </a:xfrm>
           <a:prstGeom prst="rect">
@@ -8759,13 +8915,13 @@
       </p:sp>
       <p:sp>
         <p:nvSpPr>
-          <p:cNvPr id="116" name="TextBox 115"/>
+          <p:cNvPr id="118" name="TextBox 117"/>
           <p:cNvSpPr txBox="1"/>
           <p:nvPr/>
         </p:nvSpPr>
         <p:spPr>
           <a:xfrm>
-            <a:off x="15457932" y="33886252"/>
+            <a:off x="15457932" y="33751243"/>
             <a:ext cx="14040612" cy="446227"/>
           </a:xfrm>
           <a:prstGeom prst="rect">
@@ -8810,13 +8966,13 @@
       </p:sp>
       <p:sp>
         <p:nvSpPr>
-          <p:cNvPr id="117" name="Rectangle 116"/>
+          <p:cNvPr id="119" name="Rectangle 118"/>
           <p:cNvSpPr/>
           <p:nvPr/>
         </p:nvSpPr>
         <p:spPr>
           <a:xfrm>
-            <a:off x="15457932" y="34460495"/>
+            <a:off x="15457932" y="34325486"/>
             <a:ext cx="12486132" cy="457200"/>
           </a:xfrm>
           <a:prstGeom prst="rect">
@@ -8856,13 +9012,13 @@
       </p:sp>
       <p:sp>
         <p:nvSpPr>
-          <p:cNvPr id="118" name="Rectangle 117"/>
+          <p:cNvPr id="120" name="Rectangle 119"/>
           <p:cNvSpPr/>
           <p:nvPr/>
         </p:nvSpPr>
         <p:spPr>
           <a:xfrm>
-            <a:off x="15457932" y="34460495"/>
+            <a:off x="15457932" y="34325486"/>
             <a:ext cx="8546657" cy="457200"/>
           </a:xfrm>
           <a:prstGeom prst="rect">
@@ -8900,13 +9056,13 @@
       </p:sp>
       <p:sp>
         <p:nvSpPr>
-          <p:cNvPr id="119" name="TextBox 118"/>
+          <p:cNvPr id="121" name="TextBox 120"/>
           <p:cNvSpPr txBox="1"/>
           <p:nvPr/>
         </p:nvSpPr>
         <p:spPr>
           <a:xfrm>
-            <a:off x="15622524" y="34460495"/>
+            <a:off x="15622524" y="34325486"/>
             <a:ext cx="12211812" cy="457200"/>
           </a:xfrm>
           <a:prstGeom prst="rect">
@@ -8935,13 +9091,13 @@
       </p:sp>
       <p:sp>
         <p:nvSpPr>
-          <p:cNvPr id="120" name="TextBox 119"/>
+          <p:cNvPr id="122" name="TextBox 121"/>
           <p:cNvSpPr txBox="1"/>
           <p:nvPr/>
         </p:nvSpPr>
         <p:spPr>
           <a:xfrm>
-            <a:off x="28072080" y="34460495"/>
+            <a:off x="28072080" y="34325486"/>
             <a:ext cx="1426464" cy="457200"/>
           </a:xfrm>
           <a:prstGeom prst="rect">
@@ -8970,13 +9126,13 @@
       </p:sp>
       <p:sp>
         <p:nvSpPr>
-          <p:cNvPr id="121" name="Rectangle 120"/>
+          <p:cNvPr id="123" name="Rectangle 122"/>
           <p:cNvSpPr/>
           <p:nvPr/>
         </p:nvSpPr>
         <p:spPr>
           <a:xfrm>
-            <a:off x="15457932" y="35009135"/>
+            <a:off x="15457932" y="34874126"/>
             <a:ext cx="12486132" cy="457200"/>
           </a:xfrm>
           <a:prstGeom prst="rect">
@@ -9016,13 +9172,13 @@
       </p:sp>
       <p:sp>
         <p:nvSpPr>
-          <p:cNvPr id="122" name="Rectangle 121"/>
+          <p:cNvPr id="124" name="Rectangle 123"/>
           <p:cNvSpPr/>
           <p:nvPr/>
         </p:nvSpPr>
         <p:spPr>
           <a:xfrm>
-            <a:off x="15457932" y="35009135"/>
+            <a:off x="15457932" y="34874126"/>
             <a:ext cx="6076139" cy="457200"/>
           </a:xfrm>
           <a:prstGeom prst="rect">
@@ -9060,13 +9216,13 @@
       </p:sp>
       <p:sp>
         <p:nvSpPr>
-          <p:cNvPr id="123" name="TextBox 122"/>
+          <p:cNvPr id="125" name="TextBox 124"/>
           <p:cNvSpPr txBox="1"/>
           <p:nvPr/>
         </p:nvSpPr>
         <p:spPr>
           <a:xfrm>
-            <a:off x="15622524" y="35009135"/>
+            <a:off x="15622524" y="34874126"/>
             <a:ext cx="12211812" cy="457200"/>
           </a:xfrm>
           <a:prstGeom prst="rect">
@@ -9095,13 +9251,13 @@
       </p:sp>
       <p:sp>
         <p:nvSpPr>
-          <p:cNvPr id="124" name="TextBox 123"/>
+          <p:cNvPr id="126" name="TextBox 125"/>
           <p:cNvSpPr txBox="1"/>
           <p:nvPr/>
         </p:nvSpPr>
         <p:spPr>
           <a:xfrm>
-            <a:off x="28072080" y="35009135"/>
+            <a:off x="28072080" y="34874126"/>
             <a:ext cx="1426464" cy="457200"/>
           </a:xfrm>
           <a:prstGeom prst="rect">
@@ -9130,13 +9286,13 @@
       </p:sp>
       <p:sp>
         <p:nvSpPr>
-          <p:cNvPr id="125" name="Rectangle 124"/>
+          <p:cNvPr id="127" name="Rectangle 126"/>
           <p:cNvSpPr/>
           <p:nvPr/>
         </p:nvSpPr>
         <p:spPr>
           <a:xfrm>
-            <a:off x="15457932" y="35557775"/>
+            <a:off x="15457932" y="35422766"/>
             <a:ext cx="12486132" cy="457200"/>
           </a:xfrm>
           <a:prstGeom prst="rect">
@@ -9176,13 +9332,13 @@
       </p:sp>
       <p:sp>
         <p:nvSpPr>
-          <p:cNvPr id="126" name="Rectangle 125"/>
+          <p:cNvPr id="128" name="Rectangle 127"/>
           <p:cNvSpPr/>
           <p:nvPr/>
         </p:nvSpPr>
         <p:spPr>
           <a:xfrm>
-            <a:off x="15457932" y="35557775"/>
+            <a:off x="15457932" y="35422766"/>
             <a:ext cx="9948843" cy="457200"/>
           </a:xfrm>
           <a:prstGeom prst="rect">
@@ -9220,13 +9376,13 @@
       </p:sp>
       <p:sp>
         <p:nvSpPr>
-          <p:cNvPr id="127" name="TextBox 126"/>
+          <p:cNvPr id="129" name="TextBox 128"/>
           <p:cNvSpPr txBox="1"/>
           <p:nvPr/>
         </p:nvSpPr>
         <p:spPr>
           <a:xfrm>
-            <a:off x="15622524" y="35557775"/>
+            <a:off x="15622524" y="35422766"/>
             <a:ext cx="12211812" cy="457200"/>
           </a:xfrm>
           <a:prstGeom prst="rect">
@@ -9255,13 +9411,13 @@
       </p:sp>
       <p:sp>
         <p:nvSpPr>
-          <p:cNvPr id="128" name="TextBox 127"/>
+          <p:cNvPr id="130" name="TextBox 129"/>
           <p:cNvSpPr txBox="1"/>
           <p:nvPr/>
         </p:nvSpPr>
         <p:spPr>
           <a:xfrm>
-            <a:off x="28072080" y="35557775"/>
+            <a:off x="28072080" y="35422766"/>
             <a:ext cx="1426464" cy="457200"/>
           </a:xfrm>
           <a:prstGeom prst="rect">
@@ -9290,13 +9446,13 @@
       </p:sp>
       <p:sp>
         <p:nvSpPr>
-          <p:cNvPr id="129" name="Rectangle 128"/>
+          <p:cNvPr id="131" name="Rectangle 130"/>
           <p:cNvSpPr/>
           <p:nvPr/>
         </p:nvSpPr>
         <p:spPr>
           <a:xfrm>
-            <a:off x="15457932" y="36106415"/>
+            <a:off x="15457932" y="35971406"/>
             <a:ext cx="12486132" cy="457200"/>
           </a:xfrm>
           <a:prstGeom prst="rect">
@@ -9336,13 +9492,13 @@
       </p:sp>
       <p:sp>
         <p:nvSpPr>
-          <p:cNvPr id="130" name="Rectangle 129"/>
+          <p:cNvPr id="132" name="Rectangle 131"/>
           <p:cNvSpPr/>
           <p:nvPr/>
         </p:nvSpPr>
         <p:spPr>
           <a:xfrm>
-            <a:off x="15457932" y="36106415"/>
+            <a:off x="15457932" y="35971406"/>
             <a:ext cx="12486132" cy="457200"/>
           </a:xfrm>
           <a:prstGeom prst="rect">
@@ -9380,13 +9536,13 @@
       </p:sp>
       <p:sp>
         <p:nvSpPr>
-          <p:cNvPr id="131" name="TextBox 130"/>
+          <p:cNvPr id="133" name="TextBox 132"/>
           <p:cNvSpPr txBox="1"/>
           <p:nvPr/>
         </p:nvSpPr>
         <p:spPr>
           <a:xfrm>
-            <a:off x="15622524" y="36106415"/>
+            <a:off x="15622524" y="35971406"/>
             <a:ext cx="12211812" cy="457200"/>
           </a:xfrm>
           <a:prstGeom prst="rect">
@@ -9415,13 +9571,13 @@
       </p:sp>
       <p:sp>
         <p:nvSpPr>
-          <p:cNvPr id="132" name="TextBox 131"/>
+          <p:cNvPr id="134" name="TextBox 133"/>
           <p:cNvSpPr txBox="1"/>
           <p:nvPr/>
         </p:nvSpPr>
         <p:spPr>
           <a:xfrm>
-            <a:off x="28072080" y="36106415"/>
+            <a:off x="28072080" y="35971406"/>
             <a:ext cx="1426464" cy="457200"/>
           </a:xfrm>
           <a:prstGeom prst="rect">
@@ -9450,13 +9606,13 @@
       </p:sp>
       <p:sp>
         <p:nvSpPr>
-          <p:cNvPr id="133" name="TextBox 132"/>
+          <p:cNvPr id="135" name="TextBox 134"/>
           <p:cNvSpPr txBox="1"/>
           <p:nvPr/>
         </p:nvSpPr>
         <p:spPr>
           <a:xfrm>
-            <a:off x="15457932" y="36709919"/>
+            <a:off x="15457932" y="36574910"/>
             <a:ext cx="14040612" cy="1290624"/>
           </a:xfrm>
           <a:prstGeom prst="rect">
@@ -9501,13 +9657,13 @@
       </p:sp>
       <p:sp>
         <p:nvSpPr>
-          <p:cNvPr id="134" name="Rectangle 133"/>
+          <p:cNvPr id="136" name="Rectangle 135"/>
           <p:cNvSpPr/>
           <p:nvPr/>
         </p:nvSpPr>
         <p:spPr>
           <a:xfrm>
-            <a:off x="15457932" y="38183423"/>
+            <a:off x="15457932" y="38048414"/>
             <a:ext cx="14040612" cy="2313228"/>
           </a:xfrm>
           <a:prstGeom prst="rect">
@@ -9545,13 +9701,13 @@
       </p:sp>
       <p:sp>
         <p:nvSpPr>
-          <p:cNvPr id="135" name="TextBox 134"/>
+          <p:cNvPr id="137" name="TextBox 136"/>
           <p:cNvSpPr txBox="1"/>
           <p:nvPr/>
         </p:nvSpPr>
         <p:spPr>
           <a:xfrm>
-            <a:off x="15695676" y="38421167"/>
+            <a:off x="15695676" y="38286158"/>
             <a:ext cx="13565124" cy="1837740"/>
           </a:xfrm>
           <a:prstGeom prst="rect">
@@ -9624,7 +9780,7 @@
       </p:sp>
       <p:sp>
         <p:nvSpPr>
-          <p:cNvPr id="136" name="Rectangle 135"/>
+          <p:cNvPr id="138" name="Rectangle 137"/>
           <p:cNvSpPr/>
           <p:nvPr/>
         </p:nvSpPr>
@@ -9668,7 +9824,7 @@
       </p:sp>
       <p:sp>
         <p:nvSpPr>
-          <p:cNvPr id="137" name="Rectangle 136"/>
+          <p:cNvPr id="139" name="Rectangle 138"/>
           <p:cNvSpPr/>
           <p:nvPr/>
         </p:nvSpPr>
@@ -9712,7 +9868,7 @@
       </p:sp>
       <p:pic>
         <p:nvPicPr>
-          <p:cNvPr id="138" name="Picture 137" descr="asset_cikm.png"/>
+          <p:cNvPr id="140" name="Picture 139" descr="asset_cikm.png"/>
           <p:cNvPicPr>
             <a:picLocks noChangeAspect="1"/>
           </p:cNvPicPr>
@@ -9736,7 +9892,7 @@
       </p:pic>
       <p:sp>
         <p:nvSpPr>
-          <p:cNvPr id="139" name="TextBox 138"/>
+          <p:cNvPr id="141" name="TextBox 140"/>
           <p:cNvSpPr txBox="1"/>
           <p:nvPr/>
         </p:nvSpPr>
@@ -9778,7 +9934,7 @@
       </p:sp>
       <p:sp>
         <p:nvSpPr>
-          <p:cNvPr id="140" name="TextBox 139"/>
+          <p:cNvPr id="142" name="TextBox 141"/>
           <p:cNvSpPr txBox="1"/>
           <p:nvPr/>
         </p:nvSpPr>

</xml_diff>

<commit_message>
feat(poster): add R@10 columns to the main results table
Two-level header (q->db / db->q, each R@10 + R@100); R@10 values
taken verbatim from the paper's R@10 table (Vanilla -> PMC).
</commit_message>
<xml_diff>
--- a/poster/PMC_CIKM2026_poster.pptx
+++ b/poster/PMC_CIKM2026_poster.pptx
@@ -6006,7 +6006,7 @@
         </p:nvSpPr>
         <p:spPr>
           <a:xfrm>
-            <a:off x="15457932" y="17505399"/>
+            <a:off x="15457932" y="17468823"/>
             <a:ext cx="14040612" cy="446227"/>
           </a:xfrm>
           <a:prstGeom prst="rect">
@@ -6044,7 +6044,7 @@
                 </a:solidFill>
                 <a:latin typeface="Times New Roman"/>
               </a:rPr>
-              <a:t>(R@100, Vanilla → PMC)</a:t>
+              <a:t>(Vanilla → PMC)</a:t>
             </a:r>
           </a:p>
         </p:txBody>
@@ -6057,8 +6057,8 @@
         </p:nvSpPr>
         <p:spPr>
           <a:xfrm>
-            <a:off x="15457932" y="18079642"/>
-            <a:ext cx="868680" cy="438912"/>
+            <a:off x="18841212" y="18024778"/>
+            <a:ext cx="5328666" cy="384048"/>
           </a:xfrm>
           <a:prstGeom prst="rect">
             <a:avLst/>
@@ -6071,9 +6071,79 @@
           </a:bodyPr>
           <a:lstStyle/>
           <a:p>
+            <a:pPr algn="ctr"/>
+            <a:r>
+              <a:rPr sz="2100" b="1" i="0">
+                <a:solidFill>
+                  <a:srgbClr val="6F6F6F"/>
+                </a:solidFill>
+                <a:latin typeface="Times New Roman"/>
+              </a:rPr>
+              <a:t>q→db</a:t>
+            </a:r>
+          </a:p>
+        </p:txBody>
+      </p:sp>
+      <p:sp>
+        <p:nvSpPr>
+          <p:cNvPr id="52" name="TextBox 51"/>
+          <p:cNvSpPr txBox="1"/>
+          <p:nvPr/>
+        </p:nvSpPr>
+        <p:spPr>
+          <a:xfrm>
+            <a:off x="24169878" y="18024778"/>
+            <a:ext cx="5328666" cy="384048"/>
+          </a:xfrm>
+          <a:prstGeom prst="rect">
+            <a:avLst/>
+          </a:prstGeom>
+          <a:noFill/>
+        </p:spPr>
+        <p:txBody>
+          <a:bodyPr wrap="none" anchor="ctr" lIns="0" rIns="0" tIns="0" bIns="0">
+            <a:spAutoFit/>
+          </a:bodyPr>
+          <a:lstStyle/>
+          <a:p>
+            <a:pPr algn="ctr"/>
+            <a:r>
+              <a:rPr sz="2100" b="1" i="0">
+                <a:solidFill>
+                  <a:srgbClr val="6F6F6F"/>
+                </a:solidFill>
+                <a:latin typeface="Times New Roman"/>
+              </a:rPr>
+              <a:t>db→q</a:t>
+            </a:r>
+          </a:p>
+        </p:txBody>
+      </p:sp>
+      <p:sp>
+        <p:nvSpPr>
+          <p:cNvPr id="53" name="TextBox 52"/>
+          <p:cNvSpPr txBox="1"/>
+          <p:nvPr/>
+        </p:nvSpPr>
+        <p:spPr>
+          <a:xfrm>
+            <a:off x="15457932" y="18427114"/>
+            <a:ext cx="777240" cy="384048"/>
+          </a:xfrm>
+          <a:prstGeom prst="rect">
+            <a:avLst/>
+          </a:prstGeom>
+          <a:noFill/>
+        </p:spPr>
+        <p:txBody>
+          <a:bodyPr wrap="none" anchor="ctr" lIns="0" rIns="0" tIns="0" bIns="0">
+            <a:spAutoFit/>
+          </a:bodyPr>
+          <a:lstStyle/>
+          <a:p>
             <a:pPr algn="l"/>
             <a:r>
-              <a:rPr sz="2100" b="1" i="0">
+              <a:rPr sz="2000" b="1" i="0">
                 <a:solidFill>
                   <a:srgbClr val="6F6F6F"/>
                 </a:solidFill>
@@ -6086,14 +6156,14 @@
       </p:sp>
       <p:sp>
         <p:nvSpPr>
-          <p:cNvPr id="52" name="TextBox 51"/>
-          <p:cNvSpPr txBox="1"/>
-          <p:nvPr/>
-        </p:nvSpPr>
-        <p:spPr>
-          <a:xfrm>
-            <a:off x="16326612" y="18079642"/>
-            <a:ext cx="3017520" cy="438912"/>
+          <p:cNvPr id="54" name="TextBox 53"/>
+          <p:cNvSpPr txBox="1"/>
+          <p:nvPr/>
+        </p:nvSpPr>
+        <p:spPr>
+          <a:xfrm>
+            <a:off x="16235172" y="18427114"/>
+            <a:ext cx="2606040" cy="384048"/>
           </a:xfrm>
           <a:prstGeom prst="rect">
             <a:avLst/>
@@ -6108,7 +6178,7 @@
           <a:p>
             <a:pPr algn="l"/>
             <a:r>
-              <a:rPr sz="2100" b="1" i="0">
+              <a:rPr sz="2000" b="1" i="0">
                 <a:solidFill>
                   <a:srgbClr val="6F6F6F"/>
                 </a:solidFill>
@@ -6121,14 +6191,14 @@
       </p:sp>
       <p:sp>
         <p:nvSpPr>
-          <p:cNvPr id="53" name="TextBox 52"/>
-          <p:cNvSpPr txBox="1"/>
-          <p:nvPr/>
-        </p:nvSpPr>
-        <p:spPr>
-          <a:xfrm>
-            <a:off x="19344132" y="18079642"/>
-            <a:ext cx="5077206" cy="438912"/>
+          <p:cNvPr id="55" name="TextBox 54"/>
+          <p:cNvSpPr txBox="1"/>
+          <p:nvPr/>
+        </p:nvSpPr>
+        <p:spPr>
+          <a:xfrm>
+            <a:off x="18841212" y="18427114"/>
+            <a:ext cx="1874519" cy="384048"/>
           </a:xfrm>
           <a:prstGeom prst="rect">
             <a:avLst/>
@@ -6143,27 +6213,27 @@
           <a:p>
             <a:pPr algn="r"/>
             <a:r>
-              <a:rPr sz="2100" b="1" i="0">
+              <a:rPr sz="2000" b="1" i="0">
                 <a:solidFill>
                   <a:srgbClr val="6F6F6F"/>
                 </a:solidFill>
                 <a:latin typeface="Times New Roman"/>
               </a:rPr>
-              <a:t>q→db</a:t>
-            </a:r>
-          </a:p>
-        </p:txBody>
-      </p:sp>
-      <p:sp>
-        <p:nvSpPr>
-          <p:cNvPr id="54" name="TextBox 53"/>
-          <p:cNvSpPr txBox="1"/>
-          <p:nvPr/>
-        </p:nvSpPr>
-        <p:spPr>
-          <a:xfrm>
-            <a:off x="24421338" y="18079642"/>
-            <a:ext cx="5077206" cy="438912"/>
+              <a:t>R@10</a:t>
+            </a:r>
+          </a:p>
+        </p:txBody>
+      </p:sp>
+      <p:sp>
+        <p:nvSpPr>
+          <p:cNvPr id="56" name="TextBox 55"/>
+          <p:cNvSpPr txBox="1"/>
+          <p:nvPr/>
+        </p:nvSpPr>
+        <p:spPr>
+          <a:xfrm>
+            <a:off x="20715731" y="18427114"/>
+            <a:ext cx="3454147" cy="384048"/>
           </a:xfrm>
           <a:prstGeom prst="rect">
             <a:avLst/>
@@ -6178,26 +6248,96 @@
           <a:p>
             <a:pPr algn="r"/>
             <a:r>
-              <a:rPr sz="2100" b="1" i="0">
+              <a:rPr sz="2000" b="1" i="0">
                 <a:solidFill>
                   <a:srgbClr val="6F6F6F"/>
                 </a:solidFill>
                 <a:latin typeface="Times New Roman"/>
               </a:rPr>
-              <a:t>db→q</a:t>
-            </a:r>
-          </a:p>
-        </p:txBody>
-      </p:sp>
-      <p:sp>
-        <p:nvSpPr>
-          <p:cNvPr id="55" name="Rectangle 54"/>
+              <a:t>R@100</a:t>
+            </a:r>
+          </a:p>
+        </p:txBody>
+      </p:sp>
+      <p:sp>
+        <p:nvSpPr>
+          <p:cNvPr id="57" name="TextBox 56"/>
+          <p:cNvSpPr txBox="1"/>
+          <p:nvPr/>
+        </p:nvSpPr>
+        <p:spPr>
+          <a:xfrm>
+            <a:off x="24169878" y="18427114"/>
+            <a:ext cx="1874519" cy="384048"/>
+          </a:xfrm>
+          <a:prstGeom prst="rect">
+            <a:avLst/>
+          </a:prstGeom>
+          <a:noFill/>
+        </p:spPr>
+        <p:txBody>
+          <a:bodyPr wrap="none" anchor="ctr" lIns="0" rIns="0" tIns="0" bIns="0">
+            <a:spAutoFit/>
+          </a:bodyPr>
+          <a:lstStyle/>
+          <a:p>
+            <a:pPr algn="r"/>
+            <a:r>
+              <a:rPr sz="2000" b="1" i="0">
+                <a:solidFill>
+                  <a:srgbClr val="6F6F6F"/>
+                </a:solidFill>
+                <a:latin typeface="Times New Roman"/>
+              </a:rPr>
+              <a:t>R@10</a:t>
+            </a:r>
+          </a:p>
+        </p:txBody>
+      </p:sp>
+      <p:sp>
+        <p:nvSpPr>
+          <p:cNvPr id="58" name="TextBox 57"/>
+          <p:cNvSpPr txBox="1"/>
+          <p:nvPr/>
+        </p:nvSpPr>
+        <p:spPr>
+          <a:xfrm>
+            <a:off x="26044397" y="18427114"/>
+            <a:ext cx="3454147" cy="384048"/>
+          </a:xfrm>
+          <a:prstGeom prst="rect">
+            <a:avLst/>
+          </a:prstGeom>
+          <a:noFill/>
+        </p:spPr>
+        <p:txBody>
+          <a:bodyPr wrap="none" anchor="ctr" lIns="0" rIns="0" tIns="0" bIns="0">
+            <a:spAutoFit/>
+          </a:bodyPr>
+          <a:lstStyle/>
+          <a:p>
+            <a:pPr algn="r"/>
+            <a:r>
+              <a:rPr sz="2000" b="1" i="0">
+                <a:solidFill>
+                  <a:srgbClr val="6F6F6F"/>
+                </a:solidFill>
+                <a:latin typeface="Times New Roman"/>
+              </a:rPr>
+              <a:t>R@100</a:t>
+            </a:r>
+          </a:p>
+        </p:txBody>
+      </p:sp>
+      <p:sp>
+        <p:nvSpPr>
+          <p:cNvPr id="59" name="Rectangle 58"/>
           <p:cNvSpPr/>
           <p:nvPr/>
         </p:nvSpPr>
         <p:spPr>
           <a:xfrm>
-            <a:off x="15457932" y="18555130"/>
+            <a:off x="15457932" y="18847738"/>
             <a:ext cx="14040612" cy="19050"/>
           </a:xfrm>
           <a:prstGeom prst="rect">
@@ -6235,14 +6375,14 @@
       </p:sp>
       <p:sp>
         <p:nvSpPr>
-          <p:cNvPr id="56" name="TextBox 55"/>
-          <p:cNvSpPr txBox="1"/>
-          <p:nvPr/>
-        </p:nvSpPr>
-        <p:spPr>
-          <a:xfrm>
-            <a:off x="15457932" y="18592468"/>
-            <a:ext cx="868680" cy="457200"/>
+          <p:cNvPr id="60" name="TextBox 59"/>
+          <p:cNvSpPr txBox="1"/>
+          <p:nvPr/>
+        </p:nvSpPr>
+        <p:spPr>
+          <a:xfrm>
+            <a:off x="15457932" y="18885076"/>
+            <a:ext cx="777240" cy="457200"/>
           </a:xfrm>
           <a:prstGeom prst="rect">
             <a:avLst/>
@@ -6257,7 +6397,7 @@
           <a:p>
             <a:pPr algn="l"/>
             <a:r>
-              <a:rPr sz="2300" b="1" i="0">
+              <a:rPr sz="2200" b="1" i="0">
                 <a:solidFill>
                   <a:srgbClr val="8B0029"/>
                 </a:solidFill>
@@ -6270,14 +6410,14 @@
       </p:sp>
       <p:sp>
         <p:nvSpPr>
-          <p:cNvPr id="57" name="TextBox 56"/>
-          <p:cNvSpPr txBox="1"/>
-          <p:nvPr/>
-        </p:nvSpPr>
-        <p:spPr>
-          <a:xfrm>
-            <a:off x="16326612" y="18592468"/>
-            <a:ext cx="3017520" cy="457200"/>
+          <p:cNvPr id="61" name="TextBox 60"/>
+          <p:cNvSpPr txBox="1"/>
+          <p:nvPr/>
+        </p:nvSpPr>
+        <p:spPr>
+          <a:xfrm>
+            <a:off x="16235172" y="18885076"/>
+            <a:ext cx="2606040" cy="457200"/>
           </a:xfrm>
           <a:prstGeom prst="rect">
             <a:avLst/>
@@ -6292,7 +6432,7 @@
           <a:p>
             <a:pPr algn="l"/>
             <a:r>
-              <a:rPr sz="2200" b="0" i="0">
+              <a:rPr sz="2100" b="0" i="0">
                 <a:solidFill>
                   <a:srgbClr val="1F1F1F"/>
                 </a:solidFill>
@@ -6305,14 +6445,14 @@
       </p:sp>
       <p:sp>
         <p:nvSpPr>
-          <p:cNvPr id="58" name="TextBox 57"/>
-          <p:cNvSpPr txBox="1"/>
-          <p:nvPr/>
-        </p:nvSpPr>
-        <p:spPr>
-          <a:xfrm>
-            <a:off x="19344132" y="18592468"/>
-            <a:ext cx="5077206" cy="457200"/>
+          <p:cNvPr id="62" name="TextBox 61"/>
+          <p:cNvSpPr txBox="1"/>
+          <p:nvPr/>
+        </p:nvSpPr>
+        <p:spPr>
+          <a:xfrm>
+            <a:off x="18841212" y="18885076"/>
+            <a:ext cx="1874519" cy="457200"/>
           </a:xfrm>
           <a:prstGeom prst="rect">
             <a:avLst/>
@@ -6327,16 +6467,60 @@
           <a:p>
             <a:pPr algn="r"/>
             <a:r>
-              <a:rPr sz="2000" b="0" i="0">
+              <a:rPr sz="1800" b="0" i="0">
                 <a:solidFill>
                   <a:srgbClr val="6F6F6F"/>
                 </a:solidFill>
                 <a:latin typeface="Times New Roman"/>
               </a:rPr>
+              <a:t>.36→</a:t>
+            </a:r>
+            <a:r>
+              <a:rPr sz="2100" b="1" i="0">
+                <a:solidFill>
+                  <a:srgbClr val="0D4DA3"/>
+                </a:solidFill>
+                <a:latin typeface="Times New Roman"/>
+              </a:rPr>
+              <a:t>.48</a:t>
+            </a:r>
+          </a:p>
+        </p:txBody>
+      </p:sp>
+      <p:sp>
+        <p:nvSpPr>
+          <p:cNvPr id="63" name="TextBox 62"/>
+          <p:cNvSpPr txBox="1"/>
+          <p:nvPr/>
+        </p:nvSpPr>
+        <p:spPr>
+          <a:xfrm>
+            <a:off x="20715731" y="18885076"/>
+            <a:ext cx="3454147" cy="457200"/>
+          </a:xfrm>
+          <a:prstGeom prst="rect">
+            <a:avLst/>
+          </a:prstGeom>
+          <a:noFill/>
+        </p:spPr>
+        <p:txBody>
+          <a:bodyPr wrap="none" anchor="ctr" lIns="0" rIns="0" tIns="0" bIns="0">
+            <a:spAutoFit/>
+          </a:bodyPr>
+          <a:lstStyle/>
+          <a:p>
+            <a:pPr algn="r"/>
+            <a:r>
+              <a:rPr sz="1800" b="0" i="0">
+                <a:solidFill>
+                  <a:srgbClr val="6F6F6F"/>
+                </a:solidFill>
+                <a:latin typeface="Times New Roman"/>
+              </a:rPr>
               <a:t>.55→</a:t>
             </a:r>
             <a:r>
-              <a:rPr sz="2300" b="1" i="0">
+              <a:rPr sz="2100" b="1" i="0">
                 <a:solidFill>
                   <a:srgbClr val="0D4DA3"/>
                 </a:solidFill>
@@ -6345,7 +6529,7 @@
               <a:t>.65</a:t>
             </a:r>
             <a:r>
-              <a:rPr sz="2000" b="1" i="0">
+              <a:rPr sz="1800" b="1" i="0">
                 <a:solidFill>
                   <a:srgbClr val="0D4DA3"/>
                 </a:solidFill>
@@ -6358,14 +6542,14 @@
       </p:sp>
       <p:sp>
         <p:nvSpPr>
-          <p:cNvPr id="59" name="TextBox 58"/>
-          <p:cNvSpPr txBox="1"/>
-          <p:nvPr/>
-        </p:nvSpPr>
-        <p:spPr>
-          <a:xfrm>
-            <a:off x="24421338" y="18592468"/>
-            <a:ext cx="5077206" cy="457200"/>
+          <p:cNvPr id="64" name="TextBox 63"/>
+          <p:cNvSpPr txBox="1"/>
+          <p:nvPr/>
+        </p:nvSpPr>
+        <p:spPr>
+          <a:xfrm>
+            <a:off x="24169878" y="18885076"/>
+            <a:ext cx="1874519" cy="457200"/>
           </a:xfrm>
           <a:prstGeom prst="rect">
             <a:avLst/>
@@ -6380,16 +6564,60 @@
           <a:p>
             <a:pPr algn="r"/>
             <a:r>
-              <a:rPr sz="2000" b="0" i="0">
+              <a:rPr sz="1800" b="0" i="0">
                 <a:solidFill>
                   <a:srgbClr val="6F6F6F"/>
                 </a:solidFill>
                 <a:latin typeface="Times New Roman"/>
               </a:rPr>
+              <a:t>.26→</a:t>
+            </a:r>
+            <a:r>
+              <a:rPr sz="2100" b="1" i="0">
+                <a:solidFill>
+                  <a:srgbClr val="0D4DA3"/>
+                </a:solidFill>
+                <a:latin typeface="Times New Roman"/>
+              </a:rPr>
+              <a:t>.44</a:t>
+            </a:r>
+          </a:p>
+        </p:txBody>
+      </p:sp>
+      <p:sp>
+        <p:nvSpPr>
+          <p:cNvPr id="65" name="TextBox 64"/>
+          <p:cNvSpPr txBox="1"/>
+          <p:nvPr/>
+        </p:nvSpPr>
+        <p:spPr>
+          <a:xfrm>
+            <a:off x="26044397" y="18885076"/>
+            <a:ext cx="3454147" cy="457200"/>
+          </a:xfrm>
+          <a:prstGeom prst="rect">
+            <a:avLst/>
+          </a:prstGeom>
+          <a:noFill/>
+        </p:spPr>
+        <p:txBody>
+          <a:bodyPr wrap="none" anchor="ctr" lIns="0" rIns="0" tIns="0" bIns="0">
+            <a:spAutoFit/>
+          </a:bodyPr>
+          <a:lstStyle/>
+          <a:p>
+            <a:pPr algn="r"/>
+            <a:r>
+              <a:rPr sz="1800" b="0" i="0">
+                <a:solidFill>
+                  <a:srgbClr val="6F6F6F"/>
+                </a:solidFill>
+                <a:latin typeface="Times New Roman"/>
+              </a:rPr>
               <a:t>.47→</a:t>
             </a:r>
             <a:r>
-              <a:rPr sz="2300" b="1" i="0">
+              <a:rPr sz="2100" b="1" i="0">
                 <a:solidFill>
                   <a:srgbClr val="0D4DA3"/>
                 </a:solidFill>
@@ -6398,7 +6626,7 @@
               <a:t>.63</a:t>
             </a:r>
             <a:r>
-              <a:rPr sz="2000" b="1" i="0">
+              <a:rPr sz="1800" b="1" i="0">
                 <a:solidFill>
                   <a:srgbClr val="0D4DA3"/>
                 </a:solidFill>
@@ -6411,13 +6639,13 @@
       </p:sp>
       <p:sp>
         <p:nvSpPr>
-          <p:cNvPr id="60" name="Rectangle 59"/>
+          <p:cNvPr id="66" name="Rectangle 65"/>
           <p:cNvSpPr/>
           <p:nvPr/>
         </p:nvSpPr>
         <p:spPr>
           <a:xfrm>
-            <a:off x="15457932" y="19049668"/>
+            <a:off x="15457932" y="19342276"/>
             <a:ext cx="14040612" cy="10160"/>
           </a:xfrm>
           <a:prstGeom prst="rect">
@@ -6455,14 +6683,14 @@
       </p:sp>
       <p:sp>
         <p:nvSpPr>
-          <p:cNvPr id="61" name="TextBox 60"/>
-          <p:cNvSpPr txBox="1"/>
-          <p:nvPr/>
-        </p:nvSpPr>
-        <p:spPr>
-          <a:xfrm>
-            <a:off x="15457932" y="19049668"/>
-            <a:ext cx="868680" cy="457200"/>
+          <p:cNvPr id="67" name="TextBox 66"/>
+          <p:cNvSpPr txBox="1"/>
+          <p:nvPr/>
+        </p:nvSpPr>
+        <p:spPr>
+          <a:xfrm>
+            <a:off x="15457932" y="19342276"/>
+            <a:ext cx="777240" cy="457200"/>
           </a:xfrm>
           <a:prstGeom prst="rect">
             <a:avLst/>
@@ -6477,7 +6705,7 @@
           <a:p>
             <a:pPr algn="l"/>
             <a:r>
-              <a:rPr sz="2300" b="1" i="0">
+              <a:rPr sz="2200" b="1" i="0">
                 <a:solidFill>
                   <a:srgbClr val="8B0029"/>
                 </a:solidFill>
@@ -6490,14 +6718,14 @@
       </p:sp>
       <p:sp>
         <p:nvSpPr>
-          <p:cNvPr id="62" name="TextBox 61"/>
-          <p:cNvSpPr txBox="1"/>
-          <p:nvPr/>
-        </p:nvSpPr>
-        <p:spPr>
-          <a:xfrm>
-            <a:off x="16326612" y="19049668"/>
-            <a:ext cx="3017520" cy="457200"/>
+          <p:cNvPr id="68" name="TextBox 67"/>
+          <p:cNvSpPr txBox="1"/>
+          <p:nvPr/>
+        </p:nvSpPr>
+        <p:spPr>
+          <a:xfrm>
+            <a:off x="16235172" y="19342276"/>
+            <a:ext cx="2606040" cy="457200"/>
           </a:xfrm>
           <a:prstGeom prst="rect">
             <a:avLst/>
@@ -6512,7 +6740,7 @@
           <a:p>
             <a:pPr algn="l"/>
             <a:r>
-              <a:rPr sz="2200" b="0" i="0">
+              <a:rPr sz="2100" b="0" i="0">
                 <a:solidFill>
                   <a:srgbClr val="1F1F1F"/>
                 </a:solidFill>
@@ -6525,14 +6753,14 @@
       </p:sp>
       <p:sp>
         <p:nvSpPr>
-          <p:cNvPr id="63" name="TextBox 62"/>
-          <p:cNvSpPr txBox="1"/>
-          <p:nvPr/>
-        </p:nvSpPr>
-        <p:spPr>
-          <a:xfrm>
-            <a:off x="19344132" y="19049668"/>
-            <a:ext cx="5077206" cy="457200"/>
+          <p:cNvPr id="69" name="TextBox 68"/>
+          <p:cNvSpPr txBox="1"/>
+          <p:nvPr/>
+        </p:nvSpPr>
+        <p:spPr>
+          <a:xfrm>
+            <a:off x="18841212" y="19342276"/>
+            <a:ext cx="1874519" cy="457200"/>
           </a:xfrm>
           <a:prstGeom prst="rect">
             <a:avLst/>
@@ -6547,16 +6775,60 @@
           <a:p>
             <a:pPr algn="r"/>
             <a:r>
-              <a:rPr sz="2000" b="0" i="0">
+              <a:rPr sz="1800" b="0" i="0">
                 <a:solidFill>
                   <a:srgbClr val="6F6F6F"/>
                 </a:solidFill>
                 <a:latin typeface="Times New Roman"/>
               </a:rPr>
+              <a:t>.40→</a:t>
+            </a:r>
+            <a:r>
+              <a:rPr sz="2100" b="1" i="0">
+                <a:solidFill>
+                  <a:srgbClr val="0D4DA3"/>
+                </a:solidFill>
+                <a:latin typeface="Times New Roman"/>
+              </a:rPr>
+              <a:t>.46</a:t>
+            </a:r>
+          </a:p>
+        </p:txBody>
+      </p:sp>
+      <p:sp>
+        <p:nvSpPr>
+          <p:cNvPr id="70" name="TextBox 69"/>
+          <p:cNvSpPr txBox="1"/>
+          <p:nvPr/>
+        </p:nvSpPr>
+        <p:spPr>
+          <a:xfrm>
+            <a:off x="20715731" y="19342276"/>
+            <a:ext cx="3454147" cy="457200"/>
+          </a:xfrm>
+          <a:prstGeom prst="rect">
+            <a:avLst/>
+          </a:prstGeom>
+          <a:noFill/>
+        </p:spPr>
+        <p:txBody>
+          <a:bodyPr wrap="none" anchor="ctr" lIns="0" rIns="0" tIns="0" bIns="0">
+            <a:spAutoFit/>
+          </a:bodyPr>
+          <a:lstStyle/>
+          <a:p>
+            <a:pPr algn="r"/>
+            <a:r>
+              <a:rPr sz="1800" b="0" i="0">
+                <a:solidFill>
+                  <a:srgbClr val="6F6F6F"/>
+                </a:solidFill>
+                <a:latin typeface="Times New Roman"/>
+              </a:rPr>
               <a:t>.58→</a:t>
             </a:r>
             <a:r>
-              <a:rPr sz="2300" b="1" i="0">
+              <a:rPr sz="2100" b="1" i="0">
                 <a:solidFill>
                   <a:srgbClr val="0D4DA3"/>
                 </a:solidFill>
@@ -6565,7 +6837,7 @@
               <a:t>.63</a:t>
             </a:r>
             <a:r>
-              <a:rPr sz="2000" b="1" i="0">
+              <a:rPr sz="1800" b="1" i="0">
                 <a:solidFill>
                   <a:srgbClr val="0D4DA3"/>
                 </a:solidFill>
@@ -6578,14 +6850,14 @@
       </p:sp>
       <p:sp>
         <p:nvSpPr>
-          <p:cNvPr id="64" name="TextBox 63"/>
-          <p:cNvSpPr txBox="1"/>
-          <p:nvPr/>
-        </p:nvSpPr>
-        <p:spPr>
-          <a:xfrm>
-            <a:off x="24421338" y="19049668"/>
-            <a:ext cx="5077206" cy="457200"/>
+          <p:cNvPr id="71" name="TextBox 70"/>
+          <p:cNvSpPr txBox="1"/>
+          <p:nvPr/>
+        </p:nvSpPr>
+        <p:spPr>
+          <a:xfrm>
+            <a:off x="24169878" y="19342276"/>
+            <a:ext cx="1874519" cy="457200"/>
           </a:xfrm>
           <a:prstGeom prst="rect">
             <a:avLst/>
@@ -6600,16 +6872,60 @@
           <a:p>
             <a:pPr algn="r"/>
             <a:r>
-              <a:rPr sz="2000" b="0" i="0">
+              <a:rPr sz="1800" b="0" i="0">
                 <a:solidFill>
                   <a:srgbClr val="6F6F6F"/>
                 </a:solidFill>
                 <a:latin typeface="Times New Roman"/>
               </a:rPr>
+              <a:t>.29→</a:t>
+            </a:r>
+            <a:r>
+              <a:rPr sz="2100" b="1" i="0">
+                <a:solidFill>
+                  <a:srgbClr val="0D4DA3"/>
+                </a:solidFill>
+                <a:latin typeface="Times New Roman"/>
+              </a:rPr>
+              <a:t>.39</a:t>
+            </a:r>
+          </a:p>
+        </p:txBody>
+      </p:sp>
+      <p:sp>
+        <p:nvSpPr>
+          <p:cNvPr id="72" name="TextBox 71"/>
+          <p:cNvSpPr txBox="1"/>
+          <p:nvPr/>
+        </p:nvSpPr>
+        <p:spPr>
+          <a:xfrm>
+            <a:off x="26044397" y="19342276"/>
+            <a:ext cx="3454147" cy="457200"/>
+          </a:xfrm>
+          <a:prstGeom prst="rect">
+            <a:avLst/>
+          </a:prstGeom>
+          <a:noFill/>
+        </p:spPr>
+        <p:txBody>
+          <a:bodyPr wrap="none" anchor="ctr" lIns="0" rIns="0" tIns="0" bIns="0">
+            <a:spAutoFit/>
+          </a:bodyPr>
+          <a:lstStyle/>
+          <a:p>
+            <a:pPr algn="r"/>
+            <a:r>
+              <a:rPr sz="1800" b="0" i="0">
+                <a:solidFill>
+                  <a:srgbClr val="6F6F6F"/>
+                </a:solidFill>
+                <a:latin typeface="Times New Roman"/>
+              </a:rPr>
               <a:t>.50→</a:t>
             </a:r>
             <a:r>
-              <a:rPr sz="2300" b="1" i="0">
+              <a:rPr sz="2100" b="1" i="0">
                 <a:solidFill>
                   <a:srgbClr val="0D4DA3"/>
                 </a:solidFill>
@@ -6618,7 +6934,7 @@
               <a:t>.60</a:t>
             </a:r>
             <a:r>
-              <a:rPr sz="2000" b="1" i="0">
+              <a:rPr sz="1800" b="1" i="0">
                 <a:solidFill>
                   <a:srgbClr val="0D4DA3"/>
                 </a:solidFill>
@@ -6631,13 +6947,13 @@
       </p:sp>
       <p:sp>
         <p:nvSpPr>
-          <p:cNvPr id="65" name="Rectangle 64"/>
+          <p:cNvPr id="73" name="Rectangle 72"/>
           <p:cNvSpPr/>
           <p:nvPr/>
         </p:nvSpPr>
         <p:spPr>
           <a:xfrm>
-            <a:off x="15457932" y="19506868"/>
+            <a:off x="15457932" y="19799476"/>
             <a:ext cx="14040612" cy="10160"/>
           </a:xfrm>
           <a:prstGeom prst="rect">
@@ -6675,14 +6991,14 @@
       </p:sp>
       <p:sp>
         <p:nvSpPr>
-          <p:cNvPr id="66" name="TextBox 65"/>
-          <p:cNvSpPr txBox="1"/>
-          <p:nvPr/>
-        </p:nvSpPr>
-        <p:spPr>
-          <a:xfrm>
-            <a:off x="15457932" y="19506868"/>
-            <a:ext cx="868680" cy="457200"/>
+          <p:cNvPr id="74" name="TextBox 73"/>
+          <p:cNvSpPr txBox="1"/>
+          <p:nvPr/>
+        </p:nvSpPr>
+        <p:spPr>
+          <a:xfrm>
+            <a:off x="15457932" y="19799476"/>
+            <a:ext cx="777240" cy="457200"/>
           </a:xfrm>
           <a:prstGeom prst="rect">
             <a:avLst/>
@@ -6697,7 +7013,7 @@
           <a:p>
             <a:pPr algn="l"/>
             <a:r>
-              <a:rPr sz="2300" b="1" i="0">
+              <a:rPr sz="2200" b="1" i="0">
                 <a:solidFill>
                   <a:srgbClr val="8B0029"/>
                 </a:solidFill>
@@ -6710,14 +7026,14 @@
       </p:sp>
       <p:sp>
         <p:nvSpPr>
-          <p:cNvPr id="67" name="TextBox 66"/>
-          <p:cNvSpPr txBox="1"/>
-          <p:nvPr/>
-        </p:nvSpPr>
-        <p:spPr>
-          <a:xfrm>
-            <a:off x="16326612" y="19506868"/>
-            <a:ext cx="3017520" cy="457200"/>
+          <p:cNvPr id="75" name="TextBox 74"/>
+          <p:cNvSpPr txBox="1"/>
+          <p:nvPr/>
+        </p:nvSpPr>
+        <p:spPr>
+          <a:xfrm>
+            <a:off x="16235172" y="19799476"/>
+            <a:ext cx="2606040" cy="457200"/>
           </a:xfrm>
           <a:prstGeom prst="rect">
             <a:avLst/>
@@ -6732,7 +7048,7 @@
           <a:p>
             <a:pPr algn="l"/>
             <a:r>
-              <a:rPr sz="2200" b="0" i="0">
+              <a:rPr sz="2100" b="0" i="0">
                 <a:solidFill>
                   <a:srgbClr val="1F1F1F"/>
                 </a:solidFill>
@@ -6745,14 +7061,14 @@
       </p:sp>
       <p:sp>
         <p:nvSpPr>
-          <p:cNvPr id="68" name="TextBox 67"/>
-          <p:cNvSpPr txBox="1"/>
-          <p:nvPr/>
-        </p:nvSpPr>
-        <p:spPr>
-          <a:xfrm>
-            <a:off x="19344132" y="19506868"/>
-            <a:ext cx="5077206" cy="457200"/>
+          <p:cNvPr id="76" name="TextBox 75"/>
+          <p:cNvSpPr txBox="1"/>
+          <p:nvPr/>
+        </p:nvSpPr>
+        <p:spPr>
+          <a:xfrm>
+            <a:off x="18841212" y="19799476"/>
+            <a:ext cx="1874519" cy="457200"/>
           </a:xfrm>
           <a:prstGeom prst="rect">
             <a:avLst/>
@@ -6767,16 +7083,60 @@
           <a:p>
             <a:pPr algn="r"/>
             <a:r>
-              <a:rPr sz="2000" b="0" i="0">
+              <a:rPr sz="1800" b="0" i="0">
                 <a:solidFill>
                   <a:srgbClr val="6F6F6F"/>
                 </a:solidFill>
                 <a:latin typeface="Times New Roman"/>
               </a:rPr>
+              <a:t>.31→</a:t>
+            </a:r>
+            <a:r>
+              <a:rPr sz="2100" b="1" i="0">
+                <a:solidFill>
+                  <a:srgbClr val="0D4DA3"/>
+                </a:solidFill>
+                <a:latin typeface="Times New Roman"/>
+              </a:rPr>
+              <a:t>.38</a:t>
+            </a:r>
+          </a:p>
+        </p:txBody>
+      </p:sp>
+      <p:sp>
+        <p:nvSpPr>
+          <p:cNvPr id="77" name="TextBox 76"/>
+          <p:cNvSpPr txBox="1"/>
+          <p:nvPr/>
+        </p:nvSpPr>
+        <p:spPr>
+          <a:xfrm>
+            <a:off x="20715731" y="19799476"/>
+            <a:ext cx="3454147" cy="457200"/>
+          </a:xfrm>
+          <a:prstGeom prst="rect">
+            <a:avLst/>
+          </a:prstGeom>
+          <a:noFill/>
+        </p:spPr>
+        <p:txBody>
+          <a:bodyPr wrap="none" anchor="ctr" lIns="0" rIns="0" tIns="0" bIns="0">
+            <a:spAutoFit/>
+          </a:bodyPr>
+          <a:lstStyle/>
+          <a:p>
+            <a:pPr algn="r"/>
+            <a:r>
+              <a:rPr sz="1800" b="0" i="0">
+                <a:solidFill>
+                  <a:srgbClr val="6F6F6F"/>
+                </a:solidFill>
+                <a:latin typeface="Times New Roman"/>
+              </a:rPr>
               <a:t>.41→</a:t>
             </a:r>
             <a:r>
-              <a:rPr sz="2300" b="1" i="0">
+              <a:rPr sz="2100" b="1" i="0">
                 <a:solidFill>
                   <a:srgbClr val="0D4DA3"/>
                 </a:solidFill>
@@ -6785,7 +7145,7 @@
               <a:t>.48</a:t>
             </a:r>
             <a:r>
-              <a:rPr sz="2000" b="1" i="0">
+              <a:rPr sz="1800" b="1" i="0">
                 <a:solidFill>
                   <a:srgbClr val="0D4DA3"/>
                 </a:solidFill>
@@ -6798,14 +7158,14 @@
       </p:sp>
       <p:sp>
         <p:nvSpPr>
-          <p:cNvPr id="69" name="TextBox 68"/>
-          <p:cNvSpPr txBox="1"/>
-          <p:nvPr/>
-        </p:nvSpPr>
-        <p:spPr>
-          <a:xfrm>
-            <a:off x="24421338" y="19506868"/>
-            <a:ext cx="5077206" cy="457200"/>
+          <p:cNvPr id="78" name="TextBox 77"/>
+          <p:cNvSpPr txBox="1"/>
+          <p:nvPr/>
+        </p:nvSpPr>
+        <p:spPr>
+          <a:xfrm>
+            <a:off x="24169878" y="19799476"/>
+            <a:ext cx="1874519" cy="457200"/>
           </a:xfrm>
           <a:prstGeom prst="rect">
             <a:avLst/>
@@ -6820,16 +7180,60 @@
           <a:p>
             <a:pPr algn="r"/>
             <a:r>
-              <a:rPr sz="2000" b="0" i="0">
+              <a:rPr sz="1800" b="0" i="0">
                 <a:solidFill>
                   <a:srgbClr val="6F6F6F"/>
                 </a:solidFill>
                 <a:latin typeface="Times New Roman"/>
               </a:rPr>
+              <a:t>.22→</a:t>
+            </a:r>
+            <a:r>
+              <a:rPr sz="2100" b="1" i="0">
+                <a:solidFill>
+                  <a:srgbClr val="0D4DA3"/>
+                </a:solidFill>
+                <a:latin typeface="Times New Roman"/>
+              </a:rPr>
+              <a:t>.38</a:t>
+            </a:r>
+          </a:p>
+        </p:txBody>
+      </p:sp>
+      <p:sp>
+        <p:nvSpPr>
+          <p:cNvPr id="79" name="TextBox 78"/>
+          <p:cNvSpPr txBox="1"/>
+          <p:nvPr/>
+        </p:nvSpPr>
+        <p:spPr>
+          <a:xfrm>
+            <a:off x="26044397" y="19799476"/>
+            <a:ext cx="3454147" cy="457200"/>
+          </a:xfrm>
+          <a:prstGeom prst="rect">
+            <a:avLst/>
+          </a:prstGeom>
+          <a:noFill/>
+        </p:spPr>
+        <p:txBody>
+          <a:bodyPr wrap="none" anchor="ctr" lIns="0" rIns="0" tIns="0" bIns="0">
+            <a:spAutoFit/>
+          </a:bodyPr>
+          <a:lstStyle/>
+          <a:p>
+            <a:pPr algn="r"/>
+            <a:r>
+              <a:rPr sz="1800" b="0" i="0">
+                <a:solidFill>
+                  <a:srgbClr val="6F6F6F"/>
+                </a:solidFill>
+                <a:latin typeface="Times New Roman"/>
+              </a:rPr>
               <a:t>.33→</a:t>
             </a:r>
             <a:r>
-              <a:rPr sz="2300" b="1" i="0">
+              <a:rPr sz="2100" b="1" i="0">
                 <a:solidFill>
                   <a:srgbClr val="0D4DA3"/>
                 </a:solidFill>
@@ -6838,7 +7242,7 @@
               <a:t>.48</a:t>
             </a:r>
             <a:r>
-              <a:rPr sz="2000" b="1" i="0">
+              <a:rPr sz="1800" b="1" i="0">
                 <a:solidFill>
                   <a:srgbClr val="0D4DA3"/>
                 </a:solidFill>
@@ -6851,13 +7255,13 @@
       </p:sp>
       <p:sp>
         <p:nvSpPr>
-          <p:cNvPr id="70" name="Rectangle 69"/>
+          <p:cNvPr id="80" name="Rectangle 79"/>
           <p:cNvSpPr/>
           <p:nvPr/>
         </p:nvSpPr>
         <p:spPr>
           <a:xfrm>
-            <a:off x="15457932" y="19964068"/>
+            <a:off x="15457932" y="20256676"/>
             <a:ext cx="14040612" cy="10160"/>
           </a:xfrm>
           <a:prstGeom prst="rect">
@@ -6895,14 +7299,14 @@
       </p:sp>
       <p:sp>
         <p:nvSpPr>
-          <p:cNvPr id="71" name="TextBox 70"/>
-          <p:cNvSpPr txBox="1"/>
-          <p:nvPr/>
-        </p:nvSpPr>
-        <p:spPr>
-          <a:xfrm>
-            <a:off x="15457932" y="19964068"/>
-            <a:ext cx="868680" cy="457200"/>
+          <p:cNvPr id="81" name="TextBox 80"/>
+          <p:cNvSpPr txBox="1"/>
+          <p:nvPr/>
+        </p:nvSpPr>
+        <p:spPr>
+          <a:xfrm>
+            <a:off x="15457932" y="20256676"/>
+            <a:ext cx="777240" cy="457200"/>
           </a:xfrm>
           <a:prstGeom prst="rect">
             <a:avLst/>
@@ -6917,7 +7321,7 @@
           <a:p>
             <a:pPr algn="l"/>
             <a:r>
-              <a:rPr sz="2300" b="1" i="0">
+              <a:rPr sz="2200" b="1" i="0">
                 <a:solidFill>
                   <a:srgbClr val="8B0029"/>
                 </a:solidFill>
@@ -6930,14 +7334,14 @@
       </p:sp>
       <p:sp>
         <p:nvSpPr>
-          <p:cNvPr id="72" name="TextBox 71"/>
-          <p:cNvSpPr txBox="1"/>
-          <p:nvPr/>
-        </p:nvSpPr>
-        <p:spPr>
-          <a:xfrm>
-            <a:off x="16326612" y="19964068"/>
-            <a:ext cx="3017520" cy="457200"/>
+          <p:cNvPr id="82" name="TextBox 81"/>
+          <p:cNvSpPr txBox="1"/>
+          <p:nvPr/>
+        </p:nvSpPr>
+        <p:spPr>
+          <a:xfrm>
+            <a:off x="16235172" y="20256676"/>
+            <a:ext cx="2606040" cy="457200"/>
           </a:xfrm>
           <a:prstGeom prst="rect">
             <a:avLst/>
@@ -6952,7 +7356,7 @@
           <a:p>
             <a:pPr algn="l"/>
             <a:r>
-              <a:rPr sz="2200" b="0" i="0">
+              <a:rPr sz="2100" b="0" i="0">
                 <a:solidFill>
                   <a:srgbClr val="1F1F1F"/>
                 </a:solidFill>
@@ -6965,14 +7369,14 @@
       </p:sp>
       <p:sp>
         <p:nvSpPr>
-          <p:cNvPr id="73" name="TextBox 72"/>
-          <p:cNvSpPr txBox="1"/>
-          <p:nvPr/>
-        </p:nvSpPr>
-        <p:spPr>
-          <a:xfrm>
-            <a:off x="19344132" y="19964068"/>
-            <a:ext cx="5077206" cy="457200"/>
+          <p:cNvPr id="83" name="TextBox 82"/>
+          <p:cNvSpPr txBox="1"/>
+          <p:nvPr/>
+        </p:nvSpPr>
+        <p:spPr>
+          <a:xfrm>
+            <a:off x="18841212" y="20256676"/>
+            <a:ext cx="1874519" cy="457200"/>
           </a:xfrm>
           <a:prstGeom prst="rect">
             <a:avLst/>
@@ -6987,16 +7391,60 @@
           <a:p>
             <a:pPr algn="r"/>
             <a:r>
-              <a:rPr sz="2000" b="0" i="0">
+              <a:rPr sz="1800" b="0" i="0">
                 <a:solidFill>
                   <a:srgbClr val="6F6F6F"/>
                 </a:solidFill>
                 <a:latin typeface="Times New Roman"/>
               </a:rPr>
+              <a:t>.075→</a:t>
+            </a:r>
+            <a:r>
+              <a:rPr sz="2100" b="1" i="0">
+                <a:solidFill>
+                  <a:srgbClr val="0D4DA3"/>
+                </a:solidFill>
+                <a:latin typeface="Times New Roman"/>
+              </a:rPr>
+              <a:t>.086</a:t>
+            </a:r>
+          </a:p>
+        </p:txBody>
+      </p:sp>
+      <p:sp>
+        <p:nvSpPr>
+          <p:cNvPr id="84" name="TextBox 83"/>
+          <p:cNvSpPr txBox="1"/>
+          <p:nvPr/>
+        </p:nvSpPr>
+        <p:spPr>
+          <a:xfrm>
+            <a:off x="20715731" y="20256676"/>
+            <a:ext cx="3454147" cy="457200"/>
+          </a:xfrm>
+          <a:prstGeom prst="rect">
+            <a:avLst/>
+          </a:prstGeom>
+          <a:noFill/>
+        </p:spPr>
+        <p:txBody>
+          <a:bodyPr wrap="none" anchor="ctr" lIns="0" rIns="0" tIns="0" bIns="0">
+            <a:spAutoFit/>
+          </a:bodyPr>
+          <a:lstStyle/>
+          <a:p>
+            <a:pPr algn="r"/>
+            <a:r>
+              <a:rPr sz="1800" b="0" i="0">
+                <a:solidFill>
+                  <a:srgbClr val="6F6F6F"/>
+                </a:solidFill>
+                <a:latin typeface="Times New Roman"/>
+              </a:rPr>
               <a:t>.108→</a:t>
             </a:r>
             <a:r>
-              <a:rPr sz="2300" b="1" i="0">
+              <a:rPr sz="2100" b="1" i="0">
                 <a:solidFill>
                   <a:srgbClr val="0D4DA3"/>
                 </a:solidFill>
@@ -7005,7 +7453,7 @@
               <a:t>.143</a:t>
             </a:r>
             <a:r>
-              <a:rPr sz="2000" b="1" i="0">
+              <a:rPr sz="1800" b="1" i="0">
                 <a:solidFill>
                   <a:srgbClr val="0D4DA3"/>
                 </a:solidFill>
@@ -7018,14 +7466,14 @@
       </p:sp>
       <p:sp>
         <p:nvSpPr>
-          <p:cNvPr id="74" name="TextBox 73"/>
-          <p:cNvSpPr txBox="1"/>
-          <p:nvPr/>
-        </p:nvSpPr>
-        <p:spPr>
-          <a:xfrm>
-            <a:off x="24421338" y="19964068"/>
-            <a:ext cx="5077206" cy="457200"/>
+          <p:cNvPr id="85" name="TextBox 84"/>
+          <p:cNvSpPr txBox="1"/>
+          <p:nvPr/>
+        </p:nvSpPr>
+        <p:spPr>
+          <a:xfrm>
+            <a:off x="24169878" y="20256676"/>
+            <a:ext cx="1874519" cy="457200"/>
           </a:xfrm>
           <a:prstGeom prst="rect">
             <a:avLst/>
@@ -7040,16 +7488,60 @@
           <a:p>
             <a:pPr algn="r"/>
             <a:r>
-              <a:rPr sz="2000" b="0" i="0">
+              <a:rPr sz="1800" b="0" i="0">
                 <a:solidFill>
                   <a:srgbClr val="6F6F6F"/>
                 </a:solidFill>
                 <a:latin typeface="Times New Roman"/>
               </a:rPr>
+              <a:t>.035→</a:t>
+            </a:r>
+            <a:r>
+              <a:rPr sz="2100" b="1" i="0">
+                <a:solidFill>
+                  <a:srgbClr val="0D4DA3"/>
+                </a:solidFill>
+                <a:latin typeface="Times New Roman"/>
+              </a:rPr>
+              <a:t>.048</a:t>
+            </a:r>
+          </a:p>
+        </p:txBody>
+      </p:sp>
+      <p:sp>
+        <p:nvSpPr>
+          <p:cNvPr id="86" name="TextBox 85"/>
+          <p:cNvSpPr txBox="1"/>
+          <p:nvPr/>
+        </p:nvSpPr>
+        <p:spPr>
+          <a:xfrm>
+            <a:off x="26044397" y="20256676"/>
+            <a:ext cx="3454147" cy="457200"/>
+          </a:xfrm>
+          <a:prstGeom prst="rect">
+            <a:avLst/>
+          </a:prstGeom>
+          <a:noFill/>
+        </p:spPr>
+        <p:txBody>
+          <a:bodyPr wrap="none" anchor="ctr" lIns="0" rIns="0" tIns="0" bIns="0">
+            <a:spAutoFit/>
+          </a:bodyPr>
+          <a:lstStyle/>
+          <a:p>
+            <a:pPr algn="r"/>
+            <a:r>
+              <a:rPr sz="1800" b="0" i="0">
+                <a:solidFill>
+                  <a:srgbClr val="6F6F6F"/>
+                </a:solidFill>
+                <a:latin typeface="Times New Roman"/>
+              </a:rPr>
               <a:t>.069→</a:t>
             </a:r>
             <a:r>
-              <a:rPr sz="2300" b="1" i="0">
+              <a:rPr sz="2100" b="1" i="0">
                 <a:solidFill>
                   <a:srgbClr val="0D4DA3"/>
                 </a:solidFill>
@@ -7058,7 +7550,7 @@
               <a:t>.073</a:t>
             </a:r>
             <a:r>
-              <a:rPr sz="2000" b="1" i="0">
+              <a:rPr sz="1800" b="1" i="0">
                 <a:solidFill>
                   <a:srgbClr val="0D4DA3"/>
                 </a:solidFill>
@@ -7071,13 +7563,13 @@
       </p:sp>
       <p:sp>
         <p:nvSpPr>
-          <p:cNvPr id="75" name="Rectangle 74"/>
+          <p:cNvPr id="87" name="Rectangle 86"/>
           <p:cNvSpPr/>
           <p:nvPr/>
         </p:nvSpPr>
         <p:spPr>
           <a:xfrm>
-            <a:off x="15457932" y="20421268"/>
+            <a:off x="15457932" y="20713876"/>
             <a:ext cx="14040612" cy="10160"/>
           </a:xfrm>
           <a:prstGeom prst="rect">
@@ -7115,14 +7607,14 @@
       </p:sp>
       <p:sp>
         <p:nvSpPr>
-          <p:cNvPr id="76" name="TextBox 75"/>
-          <p:cNvSpPr txBox="1"/>
-          <p:nvPr/>
-        </p:nvSpPr>
-        <p:spPr>
-          <a:xfrm>
-            <a:off x="15457932" y="20421268"/>
-            <a:ext cx="868680" cy="457200"/>
+          <p:cNvPr id="88" name="TextBox 87"/>
+          <p:cNvSpPr txBox="1"/>
+          <p:nvPr/>
+        </p:nvSpPr>
+        <p:spPr>
+          <a:xfrm>
+            <a:off x="15457932" y="20713876"/>
+            <a:ext cx="777240" cy="457200"/>
           </a:xfrm>
           <a:prstGeom prst="rect">
             <a:avLst/>
@@ -7137,7 +7629,7 @@
           <a:p>
             <a:pPr algn="l"/>
             <a:r>
-              <a:rPr sz="2300" b="1" i="0">
+              <a:rPr sz="2200" b="1" i="0">
                 <a:solidFill>
                   <a:srgbClr val="8B0029"/>
                 </a:solidFill>
@@ -7150,14 +7642,14 @@
       </p:sp>
       <p:sp>
         <p:nvSpPr>
-          <p:cNvPr id="77" name="TextBox 76"/>
-          <p:cNvSpPr txBox="1"/>
-          <p:nvPr/>
-        </p:nvSpPr>
-        <p:spPr>
-          <a:xfrm>
-            <a:off x="16326612" y="20421268"/>
-            <a:ext cx="3017520" cy="457200"/>
+          <p:cNvPr id="89" name="TextBox 88"/>
+          <p:cNvSpPr txBox="1"/>
+          <p:nvPr/>
+        </p:nvSpPr>
+        <p:spPr>
+          <a:xfrm>
+            <a:off x="16235172" y="20713876"/>
+            <a:ext cx="2606040" cy="457200"/>
           </a:xfrm>
           <a:prstGeom prst="rect">
             <a:avLst/>
@@ -7172,7 +7664,7 @@
           <a:p>
             <a:pPr algn="l"/>
             <a:r>
-              <a:rPr sz="2200" b="0" i="0">
+              <a:rPr sz="2100" b="0" i="0">
                 <a:solidFill>
                   <a:srgbClr val="1F1F1F"/>
                 </a:solidFill>
@@ -7185,14 +7677,14 @@
       </p:sp>
       <p:sp>
         <p:nvSpPr>
-          <p:cNvPr id="78" name="TextBox 77"/>
-          <p:cNvSpPr txBox="1"/>
-          <p:nvPr/>
-        </p:nvSpPr>
-        <p:spPr>
-          <a:xfrm>
-            <a:off x="19344132" y="20421268"/>
-            <a:ext cx="5077206" cy="457200"/>
+          <p:cNvPr id="90" name="TextBox 89"/>
+          <p:cNvSpPr txBox="1"/>
+          <p:nvPr/>
+        </p:nvSpPr>
+        <p:spPr>
+          <a:xfrm>
+            <a:off x="18841212" y="20713876"/>
+            <a:ext cx="1874519" cy="457200"/>
           </a:xfrm>
           <a:prstGeom prst="rect">
             <a:avLst/>
@@ -7207,16 +7699,60 @@
           <a:p>
             <a:pPr algn="r"/>
             <a:r>
-              <a:rPr sz="2000" b="0" i="0">
+              <a:rPr sz="1800" b="0" i="0">
                 <a:solidFill>
                   <a:srgbClr val="6F6F6F"/>
                 </a:solidFill>
                 <a:latin typeface="Times New Roman"/>
               </a:rPr>
+              <a:t>.55→</a:t>
+            </a:r>
+            <a:r>
+              <a:rPr sz="2100" b="1" i="0">
+                <a:solidFill>
+                  <a:srgbClr val="0D4DA3"/>
+                </a:solidFill>
+                <a:latin typeface="Times New Roman"/>
+              </a:rPr>
+              <a:t>.63</a:t>
+            </a:r>
+          </a:p>
+        </p:txBody>
+      </p:sp>
+      <p:sp>
+        <p:nvSpPr>
+          <p:cNvPr id="91" name="TextBox 90"/>
+          <p:cNvSpPr txBox="1"/>
+          <p:nvPr/>
+        </p:nvSpPr>
+        <p:spPr>
+          <a:xfrm>
+            <a:off x="20715731" y="20713876"/>
+            <a:ext cx="3454147" cy="457200"/>
+          </a:xfrm>
+          <a:prstGeom prst="rect">
+            <a:avLst/>
+          </a:prstGeom>
+          <a:noFill/>
+        </p:spPr>
+        <p:txBody>
+          <a:bodyPr wrap="none" anchor="ctr" lIns="0" rIns="0" tIns="0" bIns="0">
+            <a:spAutoFit/>
+          </a:bodyPr>
+          <a:lstStyle/>
+          <a:p>
+            <a:pPr algn="r"/>
+            <a:r>
+              <a:rPr sz="1800" b="0" i="0">
+                <a:solidFill>
+                  <a:srgbClr val="6F6F6F"/>
+                </a:solidFill>
+                <a:latin typeface="Times New Roman"/>
+              </a:rPr>
               <a:t>.67→</a:t>
             </a:r>
             <a:r>
-              <a:rPr sz="2300" b="1" i="0">
+              <a:rPr sz="2100" b="1" i="0">
                 <a:solidFill>
                   <a:srgbClr val="0D4DA3"/>
                 </a:solidFill>
@@ -7225,7 +7761,7 @@
               <a:t>.75</a:t>
             </a:r>
             <a:r>
-              <a:rPr sz="2000" b="1" i="0">
+              <a:rPr sz="1800" b="1" i="0">
                 <a:solidFill>
                   <a:srgbClr val="0D4DA3"/>
                 </a:solidFill>
@@ -7238,14 +7774,14 @@
       </p:sp>
       <p:sp>
         <p:nvSpPr>
-          <p:cNvPr id="79" name="TextBox 78"/>
-          <p:cNvSpPr txBox="1"/>
-          <p:nvPr/>
-        </p:nvSpPr>
-        <p:spPr>
-          <a:xfrm>
-            <a:off x="24421338" y="20421268"/>
-            <a:ext cx="5077206" cy="457200"/>
+          <p:cNvPr id="92" name="TextBox 91"/>
+          <p:cNvSpPr txBox="1"/>
+          <p:nvPr/>
+        </p:nvSpPr>
+        <p:spPr>
+          <a:xfrm>
+            <a:off x="24169878" y="20713876"/>
+            <a:ext cx="1874519" cy="457200"/>
           </a:xfrm>
           <a:prstGeom prst="rect">
             <a:avLst/>
@@ -7260,16 +7796,60 @@
           <a:p>
             <a:pPr algn="r"/>
             <a:r>
-              <a:rPr sz="2000" b="0" i="0">
+              <a:rPr sz="1800" b="0" i="0">
                 <a:solidFill>
                   <a:srgbClr val="6F6F6F"/>
                 </a:solidFill>
                 <a:latin typeface="Times New Roman"/>
               </a:rPr>
+              <a:t>.57→</a:t>
+            </a:r>
+            <a:r>
+              <a:rPr sz="2100" b="1" i="0">
+                <a:solidFill>
+                  <a:srgbClr val="0D4DA3"/>
+                </a:solidFill>
+                <a:latin typeface="Times New Roman"/>
+              </a:rPr>
+              <a:t>.64</a:t>
+            </a:r>
+          </a:p>
+        </p:txBody>
+      </p:sp>
+      <p:sp>
+        <p:nvSpPr>
+          <p:cNvPr id="93" name="TextBox 92"/>
+          <p:cNvSpPr txBox="1"/>
+          <p:nvPr/>
+        </p:nvSpPr>
+        <p:spPr>
+          <a:xfrm>
+            <a:off x="26044397" y="20713876"/>
+            <a:ext cx="3454147" cy="457200"/>
+          </a:xfrm>
+          <a:prstGeom prst="rect">
+            <a:avLst/>
+          </a:prstGeom>
+          <a:noFill/>
+        </p:spPr>
+        <p:txBody>
+          <a:bodyPr wrap="none" anchor="ctr" lIns="0" rIns="0" tIns="0" bIns="0">
+            <a:spAutoFit/>
+          </a:bodyPr>
+          <a:lstStyle/>
+          <a:p>
+            <a:pPr algn="r"/>
+            <a:r>
+              <a:rPr sz="1800" b="0" i="0">
+                <a:solidFill>
+                  <a:srgbClr val="6F6F6F"/>
+                </a:solidFill>
+                <a:latin typeface="Times New Roman"/>
+              </a:rPr>
               <a:t>.71→</a:t>
             </a:r>
             <a:r>
-              <a:rPr sz="2300" b="1" i="0">
+              <a:rPr sz="2100" b="1" i="0">
                 <a:solidFill>
                   <a:srgbClr val="0D4DA3"/>
                 </a:solidFill>
@@ -7278,7 +7858,7 @@
               <a:t>.75</a:t>
             </a:r>
             <a:r>
-              <a:rPr sz="2000" b="1" i="0">
+              <a:rPr sz="1800" b="1" i="0">
                 <a:solidFill>
                   <a:srgbClr val="0D4DA3"/>
                 </a:solidFill>
@@ -7291,13 +7871,13 @@
       </p:sp>
       <p:sp>
         <p:nvSpPr>
-          <p:cNvPr id="80" name="Rectangle 79"/>
+          <p:cNvPr id="94" name="Rectangle 93"/>
           <p:cNvSpPr/>
           <p:nvPr/>
         </p:nvSpPr>
         <p:spPr>
           <a:xfrm>
-            <a:off x="15457932" y="20878468"/>
+            <a:off x="15457932" y="21171076"/>
             <a:ext cx="14040612" cy="10160"/>
           </a:xfrm>
           <a:prstGeom prst="rect">
@@ -7335,14 +7915,14 @@
       </p:sp>
       <p:sp>
         <p:nvSpPr>
-          <p:cNvPr id="81" name="TextBox 80"/>
-          <p:cNvSpPr txBox="1"/>
-          <p:nvPr/>
-        </p:nvSpPr>
-        <p:spPr>
-          <a:xfrm>
-            <a:off x="15457932" y="20878468"/>
-            <a:ext cx="868680" cy="457200"/>
+          <p:cNvPr id="95" name="TextBox 94"/>
+          <p:cNvSpPr txBox="1"/>
+          <p:nvPr/>
+        </p:nvSpPr>
+        <p:spPr>
+          <a:xfrm>
+            <a:off x="15457932" y="21171076"/>
+            <a:ext cx="777240" cy="457200"/>
           </a:xfrm>
           <a:prstGeom prst="rect">
             <a:avLst/>
@@ -7357,7 +7937,7 @@
           <a:p>
             <a:pPr algn="l"/>
             <a:r>
-              <a:rPr sz="2300" b="1" i="0">
+              <a:rPr sz="2200" b="1" i="0">
                 <a:solidFill>
                   <a:srgbClr val="8B0029"/>
                 </a:solidFill>
@@ -7370,14 +7950,14 @@
       </p:sp>
       <p:sp>
         <p:nvSpPr>
-          <p:cNvPr id="82" name="TextBox 81"/>
-          <p:cNvSpPr txBox="1"/>
-          <p:nvPr/>
-        </p:nvSpPr>
-        <p:spPr>
-          <a:xfrm>
-            <a:off x="16326612" y="20878468"/>
-            <a:ext cx="3017520" cy="457200"/>
+          <p:cNvPr id="96" name="TextBox 95"/>
+          <p:cNvSpPr txBox="1"/>
+          <p:nvPr/>
+        </p:nvSpPr>
+        <p:spPr>
+          <a:xfrm>
+            <a:off x="16235172" y="21171076"/>
+            <a:ext cx="2606040" cy="457200"/>
           </a:xfrm>
           <a:prstGeom prst="rect">
             <a:avLst/>
@@ -7392,7 +7972,7 @@
           <a:p>
             <a:pPr algn="l"/>
             <a:r>
-              <a:rPr sz="2200" b="0" i="0">
+              <a:rPr sz="2100" b="0" i="0">
                 <a:solidFill>
                   <a:srgbClr val="1F1F1F"/>
                 </a:solidFill>
@@ -7405,14 +7985,14 @@
       </p:sp>
       <p:sp>
         <p:nvSpPr>
-          <p:cNvPr id="83" name="TextBox 82"/>
-          <p:cNvSpPr txBox="1"/>
-          <p:nvPr/>
-        </p:nvSpPr>
-        <p:spPr>
-          <a:xfrm>
-            <a:off x="19344132" y="20878468"/>
-            <a:ext cx="5077206" cy="457200"/>
+          <p:cNvPr id="97" name="TextBox 96"/>
+          <p:cNvSpPr txBox="1"/>
+          <p:nvPr/>
+        </p:nvSpPr>
+        <p:spPr>
+          <a:xfrm>
+            <a:off x="18841212" y="21171076"/>
+            <a:ext cx="1874519" cy="457200"/>
           </a:xfrm>
           <a:prstGeom prst="rect">
             <a:avLst/>
@@ -7427,16 +8007,60 @@
           <a:p>
             <a:pPr algn="r"/>
             <a:r>
-              <a:rPr sz="2000" b="0" i="0">
+              <a:rPr sz="1800" b="0" i="0">
                 <a:solidFill>
                   <a:srgbClr val="6F6F6F"/>
                 </a:solidFill>
                 <a:latin typeface="Times New Roman"/>
               </a:rPr>
+              <a:t>.59→</a:t>
+            </a:r>
+            <a:r>
+              <a:rPr sz="2100" b="1" i="0">
+                <a:solidFill>
+                  <a:srgbClr val="0D4DA3"/>
+                </a:solidFill>
+                <a:latin typeface="Times New Roman"/>
+              </a:rPr>
+              <a:t>.60</a:t>
+            </a:r>
+          </a:p>
+        </p:txBody>
+      </p:sp>
+      <p:sp>
+        <p:nvSpPr>
+          <p:cNvPr id="98" name="TextBox 97"/>
+          <p:cNvSpPr txBox="1"/>
+          <p:nvPr/>
+        </p:nvSpPr>
+        <p:spPr>
+          <a:xfrm>
+            <a:off x="20715731" y="21171076"/>
+            <a:ext cx="3454147" cy="457200"/>
+          </a:xfrm>
+          <a:prstGeom prst="rect">
+            <a:avLst/>
+          </a:prstGeom>
+          <a:noFill/>
+        </p:spPr>
+        <p:txBody>
+          <a:bodyPr wrap="none" anchor="ctr" lIns="0" rIns="0" tIns="0" bIns="0">
+            <a:spAutoFit/>
+          </a:bodyPr>
+          <a:lstStyle/>
+          <a:p>
+            <a:pPr algn="r"/>
+            <a:r>
+              <a:rPr sz="1800" b="0" i="0">
+                <a:solidFill>
+                  <a:srgbClr val="6F6F6F"/>
+                </a:solidFill>
+                <a:latin typeface="Times New Roman"/>
+              </a:rPr>
               <a:t>.72→</a:t>
             </a:r>
             <a:r>
-              <a:rPr sz="2300" b="1" i="0">
+              <a:rPr sz="2100" b="1" i="0">
                 <a:solidFill>
                   <a:srgbClr val="0D4DA3"/>
                 </a:solidFill>
@@ -7445,7 +8069,7 @@
               <a:t>.73</a:t>
             </a:r>
             <a:r>
-              <a:rPr sz="2000" b="1" i="0">
+              <a:rPr sz="1800" b="1" i="0">
                 <a:solidFill>
                   <a:srgbClr val="0D4DA3"/>
                 </a:solidFill>
@@ -7458,14 +8082,14 @@
       </p:sp>
       <p:sp>
         <p:nvSpPr>
-          <p:cNvPr id="84" name="TextBox 83"/>
-          <p:cNvSpPr txBox="1"/>
-          <p:nvPr/>
-        </p:nvSpPr>
-        <p:spPr>
-          <a:xfrm>
-            <a:off x="24421338" y="20878468"/>
-            <a:ext cx="5077206" cy="457200"/>
+          <p:cNvPr id="99" name="TextBox 98"/>
+          <p:cNvSpPr txBox="1"/>
+          <p:nvPr/>
+        </p:nvSpPr>
+        <p:spPr>
+          <a:xfrm>
+            <a:off x="24169878" y="21171076"/>
+            <a:ext cx="1874519" cy="457200"/>
           </a:xfrm>
           <a:prstGeom prst="rect">
             <a:avLst/>
@@ -7480,16 +8104,60 @@
           <a:p>
             <a:pPr algn="r"/>
             <a:r>
-              <a:rPr sz="2000" b="0" i="0">
+              <a:rPr sz="1800" b="0" i="0">
                 <a:solidFill>
                   <a:srgbClr val="6F6F6F"/>
                 </a:solidFill>
                 <a:latin typeface="Times New Roman"/>
               </a:rPr>
+              <a:t>.48→</a:t>
+            </a:r>
+            <a:r>
+              <a:rPr sz="2100" b="1" i="0">
+                <a:solidFill>
+                  <a:srgbClr val="0D4DA3"/>
+                </a:solidFill>
+                <a:latin typeface="Times New Roman"/>
+              </a:rPr>
+              <a:t>.54</a:t>
+            </a:r>
+          </a:p>
+        </p:txBody>
+      </p:sp>
+      <p:sp>
+        <p:nvSpPr>
+          <p:cNvPr id="100" name="TextBox 99"/>
+          <p:cNvSpPr txBox="1"/>
+          <p:nvPr/>
+        </p:nvSpPr>
+        <p:spPr>
+          <a:xfrm>
+            <a:off x="26044397" y="21171076"/>
+            <a:ext cx="3454147" cy="457200"/>
+          </a:xfrm>
+          <a:prstGeom prst="rect">
+            <a:avLst/>
+          </a:prstGeom>
+          <a:noFill/>
+        </p:spPr>
+        <p:txBody>
+          <a:bodyPr wrap="none" anchor="ctr" lIns="0" rIns="0" tIns="0" bIns="0">
+            <a:spAutoFit/>
+          </a:bodyPr>
+          <a:lstStyle/>
+          <a:p>
+            <a:pPr algn="r"/>
+            <a:r>
+              <a:rPr sz="1800" b="0" i="0">
+                <a:solidFill>
+                  <a:srgbClr val="6F6F6F"/>
+                </a:solidFill>
+                <a:latin typeface="Times New Roman"/>
+              </a:rPr>
               <a:t>.62→</a:t>
             </a:r>
             <a:r>
-              <a:rPr sz="2300" b="1" i="0">
+              <a:rPr sz="2100" b="1" i="0">
                 <a:solidFill>
                   <a:srgbClr val="0D4DA3"/>
                 </a:solidFill>
@@ -7498,7 +8166,7 @@
               <a:t>.69</a:t>
             </a:r>
             <a:r>
-              <a:rPr sz="2000" b="1" i="0">
+              <a:rPr sz="1800" b="1" i="0">
                 <a:solidFill>
                   <a:srgbClr val="0D4DA3"/>
                 </a:solidFill>
@@ -7511,13 +8179,13 @@
       </p:sp>
       <p:sp>
         <p:nvSpPr>
-          <p:cNvPr id="85" name="Rectangle 84"/>
+          <p:cNvPr id="101" name="Rectangle 100"/>
           <p:cNvSpPr/>
           <p:nvPr/>
         </p:nvSpPr>
         <p:spPr>
           <a:xfrm>
-            <a:off x="15457932" y="21335668"/>
+            <a:off x="15457932" y="21628276"/>
             <a:ext cx="14040612" cy="10160"/>
           </a:xfrm>
           <a:prstGeom prst="rect">
@@ -7555,14 +8223,14 @@
       </p:sp>
       <p:sp>
         <p:nvSpPr>
-          <p:cNvPr id="86" name="TextBox 85"/>
-          <p:cNvSpPr txBox="1"/>
-          <p:nvPr/>
-        </p:nvSpPr>
-        <p:spPr>
-          <a:xfrm>
-            <a:off x="15457932" y="21335668"/>
-            <a:ext cx="868680" cy="457200"/>
+          <p:cNvPr id="102" name="TextBox 101"/>
+          <p:cNvSpPr txBox="1"/>
+          <p:nvPr/>
+        </p:nvSpPr>
+        <p:spPr>
+          <a:xfrm>
+            <a:off x="15457932" y="21628276"/>
+            <a:ext cx="777240" cy="457200"/>
           </a:xfrm>
           <a:prstGeom prst="rect">
             <a:avLst/>
@@ -7577,7 +8245,7 @@
           <a:p>
             <a:pPr algn="l"/>
             <a:r>
-              <a:rPr sz="2300" b="1" i="0">
+              <a:rPr sz="2200" b="1" i="0">
                 <a:solidFill>
                   <a:srgbClr val="8B0029"/>
                 </a:solidFill>
@@ -7590,14 +8258,14 @@
       </p:sp>
       <p:sp>
         <p:nvSpPr>
-          <p:cNvPr id="87" name="TextBox 86"/>
-          <p:cNvSpPr txBox="1"/>
-          <p:nvPr/>
-        </p:nvSpPr>
-        <p:spPr>
-          <a:xfrm>
-            <a:off x="16326612" y="21335668"/>
-            <a:ext cx="3017520" cy="457200"/>
+          <p:cNvPr id="103" name="TextBox 102"/>
+          <p:cNvSpPr txBox="1"/>
+          <p:nvPr/>
+        </p:nvSpPr>
+        <p:spPr>
+          <a:xfrm>
+            <a:off x="16235172" y="21628276"/>
+            <a:ext cx="2606040" cy="457200"/>
           </a:xfrm>
           <a:prstGeom prst="rect">
             <a:avLst/>
@@ -7612,7 +8280,7 @@
           <a:p>
             <a:pPr algn="l"/>
             <a:r>
-              <a:rPr sz="2200" b="0" i="0">
+              <a:rPr sz="2100" b="0" i="0">
                 <a:solidFill>
                   <a:srgbClr val="1F1F1F"/>
                 </a:solidFill>
@@ -7625,14 +8293,14 @@
       </p:sp>
       <p:sp>
         <p:nvSpPr>
-          <p:cNvPr id="88" name="TextBox 87"/>
-          <p:cNvSpPr txBox="1"/>
-          <p:nvPr/>
-        </p:nvSpPr>
-        <p:spPr>
-          <a:xfrm>
-            <a:off x="19344132" y="21335668"/>
-            <a:ext cx="5077206" cy="457200"/>
+          <p:cNvPr id="104" name="TextBox 103"/>
+          <p:cNvSpPr txBox="1"/>
+          <p:nvPr/>
+        </p:nvSpPr>
+        <p:spPr>
+          <a:xfrm>
+            <a:off x="18841212" y="21628276"/>
+            <a:ext cx="1874519" cy="457200"/>
           </a:xfrm>
           <a:prstGeom prst="rect">
             <a:avLst/>
@@ -7647,16 +8315,60 @@
           <a:p>
             <a:pPr algn="r"/>
             <a:r>
-              <a:rPr sz="2000" b="0" i="0">
+              <a:rPr sz="1800" b="0" i="0">
                 <a:solidFill>
                   <a:srgbClr val="6F6F6F"/>
                 </a:solidFill>
                 <a:latin typeface="Times New Roman"/>
               </a:rPr>
+              <a:t>.39→</a:t>
+            </a:r>
+            <a:r>
+              <a:rPr sz="2100" b="1" i="0">
+                <a:solidFill>
+                  <a:srgbClr val="0D4DA3"/>
+                </a:solidFill>
+                <a:latin typeface="Times New Roman"/>
+              </a:rPr>
+              <a:t>.44</a:t>
+            </a:r>
+          </a:p>
+        </p:txBody>
+      </p:sp>
+      <p:sp>
+        <p:nvSpPr>
+          <p:cNvPr id="105" name="TextBox 104"/>
+          <p:cNvSpPr txBox="1"/>
+          <p:nvPr/>
+        </p:nvSpPr>
+        <p:spPr>
+          <a:xfrm>
+            <a:off x="20715731" y="21628276"/>
+            <a:ext cx="3454147" cy="457200"/>
+          </a:xfrm>
+          <a:prstGeom prst="rect">
+            <a:avLst/>
+          </a:prstGeom>
+          <a:noFill/>
+        </p:spPr>
+        <p:txBody>
+          <a:bodyPr wrap="none" anchor="ctr" lIns="0" rIns="0" tIns="0" bIns="0">
+            <a:spAutoFit/>
+          </a:bodyPr>
+          <a:lstStyle/>
+          <a:p>
+            <a:pPr algn="r"/>
+            <a:r>
+              <a:rPr sz="1800" b="0" i="0">
+                <a:solidFill>
+                  <a:srgbClr val="6F6F6F"/>
+                </a:solidFill>
+                <a:latin typeface="Times New Roman"/>
+              </a:rPr>
               <a:t>.75→</a:t>
             </a:r>
             <a:r>
-              <a:rPr sz="2300" b="1" i="0">
+              <a:rPr sz="2100" b="1" i="0">
                 <a:solidFill>
                   <a:srgbClr val="0D4DA3"/>
                 </a:solidFill>
@@ -7665,7 +8377,7 @@
               <a:t>.78</a:t>
             </a:r>
             <a:r>
-              <a:rPr sz="2000" b="1" i="0">
+              <a:rPr sz="1800" b="1" i="0">
                 <a:solidFill>
                   <a:srgbClr val="0D4DA3"/>
                 </a:solidFill>
@@ -7678,14 +8390,14 @@
       </p:sp>
       <p:sp>
         <p:nvSpPr>
-          <p:cNvPr id="89" name="TextBox 88"/>
-          <p:cNvSpPr txBox="1"/>
-          <p:nvPr/>
-        </p:nvSpPr>
-        <p:spPr>
-          <a:xfrm>
-            <a:off x="24421338" y="21335668"/>
-            <a:ext cx="5077206" cy="457200"/>
+          <p:cNvPr id="106" name="TextBox 105"/>
+          <p:cNvSpPr txBox="1"/>
+          <p:nvPr/>
+        </p:nvSpPr>
+        <p:spPr>
+          <a:xfrm>
+            <a:off x="24169878" y="21628276"/>
+            <a:ext cx="1874519" cy="457200"/>
           </a:xfrm>
           <a:prstGeom prst="rect">
             <a:avLst/>
@@ -7700,16 +8412,60 @@
           <a:p>
             <a:pPr algn="r"/>
             <a:r>
-              <a:rPr sz="2000" b="0" i="0">
+              <a:rPr sz="1800" b="0" i="0">
                 <a:solidFill>
                   <a:srgbClr val="6F6F6F"/>
                 </a:solidFill>
                 <a:latin typeface="Times New Roman"/>
               </a:rPr>
+              <a:t>.44→</a:t>
+            </a:r>
+            <a:r>
+              <a:rPr sz="2100" b="1" i="0">
+                <a:solidFill>
+                  <a:srgbClr val="0D4DA3"/>
+                </a:solidFill>
+                <a:latin typeface="Times New Roman"/>
+              </a:rPr>
+              <a:t>.48</a:t>
+            </a:r>
+          </a:p>
+        </p:txBody>
+      </p:sp>
+      <p:sp>
+        <p:nvSpPr>
+          <p:cNvPr id="107" name="TextBox 106"/>
+          <p:cNvSpPr txBox="1"/>
+          <p:nvPr/>
+        </p:nvSpPr>
+        <p:spPr>
+          <a:xfrm>
+            <a:off x="26044397" y="21628276"/>
+            <a:ext cx="3454147" cy="457200"/>
+          </a:xfrm>
+          <a:prstGeom prst="rect">
+            <a:avLst/>
+          </a:prstGeom>
+          <a:noFill/>
+        </p:spPr>
+        <p:txBody>
+          <a:bodyPr wrap="none" anchor="ctr" lIns="0" rIns="0" tIns="0" bIns="0">
+            <a:spAutoFit/>
+          </a:bodyPr>
+          <a:lstStyle/>
+          <a:p>
+            <a:pPr algn="r"/>
+            <a:r>
+              <a:rPr sz="1800" b="0" i="0">
+                <a:solidFill>
+                  <a:srgbClr val="6F6F6F"/>
+                </a:solidFill>
+                <a:latin typeface="Times New Roman"/>
+              </a:rPr>
               <a:t>.83→</a:t>
             </a:r>
             <a:r>
-              <a:rPr sz="2300" b="1" i="0">
+              <a:rPr sz="2100" b="1" i="0">
                 <a:solidFill>
                   <a:srgbClr val="0D4DA3"/>
                 </a:solidFill>
@@ -7718,7 +8474,7 @@
               <a:t>.83</a:t>
             </a:r>
             <a:r>
-              <a:rPr sz="2000" b="1" i="0">
+              <a:rPr sz="1800" b="1" i="0">
                 <a:solidFill>
                   <a:srgbClr val="0D4DA3"/>
                 </a:solidFill>
@@ -7731,13 +8487,13 @@
       </p:sp>
       <p:sp>
         <p:nvSpPr>
-          <p:cNvPr id="90" name="Rectangle 89"/>
+          <p:cNvPr id="108" name="Rectangle 107"/>
           <p:cNvSpPr/>
           <p:nvPr/>
         </p:nvSpPr>
         <p:spPr>
           <a:xfrm>
-            <a:off x="15457932" y="21792868"/>
+            <a:off x="15457932" y="22085476"/>
             <a:ext cx="14040612" cy="10160"/>
           </a:xfrm>
           <a:prstGeom prst="rect">
@@ -7775,13 +8531,13 @@
       </p:sp>
       <p:sp>
         <p:nvSpPr>
-          <p:cNvPr id="91" name="TextBox 90"/>
-          <p:cNvSpPr txBox="1"/>
-          <p:nvPr/>
-        </p:nvSpPr>
-        <p:spPr>
-          <a:xfrm>
-            <a:off x="15457932" y="21939172"/>
+          <p:cNvPr id="109" name="TextBox 108"/>
+          <p:cNvSpPr txBox="1"/>
+          <p:nvPr/>
+        </p:nvSpPr>
+        <p:spPr>
+          <a:xfrm>
+            <a:off x="15457932" y="22231780"/>
             <a:ext cx="14040612" cy="1290624"/>
           </a:xfrm>
           <a:prstGeom prst="rect">
@@ -7853,7 +8609,7 @@
       </p:sp>
       <p:pic>
         <p:nvPicPr>
-          <p:cNvPr id="92" name="Picture 91" descr="asset_fig3.png"/>
+          <p:cNvPr id="110" name="Picture 109" descr="asset_fig3.png"/>
           <p:cNvPicPr>
             <a:picLocks noChangeAspect="1"/>
           </p:cNvPicPr>
@@ -7867,7 +8623,7 @@
         </p:blipFill>
         <p:spPr>
           <a:xfrm>
-            <a:off x="15457932" y="23376100"/>
+            <a:off x="15457932" y="23668708"/>
             <a:ext cx="14040612" cy="3622757"/>
           </a:xfrm>
           <a:prstGeom prst="rect">
@@ -7877,13 +8633,13 @@
       </p:pic>
       <p:sp>
         <p:nvSpPr>
-          <p:cNvPr id="93" name="TextBox 92"/>
-          <p:cNvSpPr txBox="1"/>
-          <p:nvPr/>
-        </p:nvSpPr>
-        <p:spPr>
-          <a:xfrm>
-            <a:off x="15457932" y="27072009"/>
+          <p:cNvPr id="111" name="TextBox 110"/>
+          <p:cNvSpPr txBox="1"/>
+          <p:nvPr/>
+        </p:nvSpPr>
+        <p:spPr>
+          <a:xfrm>
+            <a:off x="15457932" y="27364617"/>
             <a:ext cx="14040612" cy="1051560"/>
           </a:xfrm>
           <a:prstGeom prst="rect">
@@ -7919,13 +8675,13 @@
       </p:sp>
       <p:sp>
         <p:nvSpPr>
-          <p:cNvPr id="94" name="TextBox 93"/>
-          <p:cNvSpPr txBox="1"/>
-          <p:nvPr/>
-        </p:nvSpPr>
-        <p:spPr>
-          <a:xfrm>
-            <a:off x="15457932" y="28196721"/>
+          <p:cNvPr id="112" name="TextBox 111"/>
+          <p:cNvSpPr txBox="1"/>
+          <p:nvPr/>
+        </p:nvSpPr>
+        <p:spPr>
+          <a:xfrm>
+            <a:off x="15457932" y="28489329"/>
             <a:ext cx="14040612" cy="560070"/>
           </a:xfrm>
           <a:prstGeom prst="rect">
@@ -7961,13 +8717,13 @@
       </p:sp>
       <p:sp>
         <p:nvSpPr>
-          <p:cNvPr id="95" name="Rectangle 94"/>
+          <p:cNvPr id="113" name="Rectangle 112"/>
           <p:cNvSpPr/>
           <p:nvPr/>
         </p:nvSpPr>
         <p:spPr>
           <a:xfrm>
-            <a:off x="15457932" y="28802511"/>
+            <a:off x="15457932" y="29095119"/>
             <a:ext cx="14040612" cy="31750"/>
           </a:xfrm>
           <a:prstGeom prst="rect">
@@ -8005,13 +8761,13 @@
       </p:sp>
       <p:sp>
         <p:nvSpPr>
-          <p:cNvPr id="96" name="TextBox 95"/>
-          <p:cNvSpPr txBox="1"/>
-          <p:nvPr/>
-        </p:nvSpPr>
-        <p:spPr>
-          <a:xfrm>
-            <a:off x="15457932" y="28879981"/>
+          <p:cNvPr id="114" name="TextBox 113"/>
+          <p:cNvSpPr txBox="1"/>
+          <p:nvPr/>
+        </p:nvSpPr>
+        <p:spPr>
+          <a:xfrm>
+            <a:off x="15457932" y="29172589"/>
             <a:ext cx="14040612" cy="427634"/>
           </a:xfrm>
           <a:prstGeom prst="rect">
@@ -8056,13 +8812,13 @@
       </p:sp>
       <p:sp>
         <p:nvSpPr>
-          <p:cNvPr id="97" name="TextBox 96"/>
-          <p:cNvSpPr txBox="1"/>
-          <p:nvPr/>
-        </p:nvSpPr>
-        <p:spPr>
-          <a:xfrm>
-            <a:off x="15457932" y="29417343"/>
+          <p:cNvPr id="115" name="TextBox 114"/>
+          <p:cNvSpPr txBox="1"/>
+          <p:nvPr/>
+        </p:nvSpPr>
+        <p:spPr>
+          <a:xfrm>
+            <a:off x="15457932" y="29709951"/>
             <a:ext cx="2926080" cy="438912"/>
           </a:xfrm>
           <a:prstGeom prst="rect">
@@ -8091,13 +8847,13 @@
       </p:sp>
       <p:sp>
         <p:nvSpPr>
-          <p:cNvPr id="98" name="TextBox 97"/>
-          <p:cNvSpPr txBox="1"/>
-          <p:nvPr/>
-        </p:nvSpPr>
-        <p:spPr>
-          <a:xfrm>
-            <a:off x="18384012" y="29417343"/>
+          <p:cNvPr id="116" name="TextBox 115"/>
+          <p:cNvSpPr txBox="1"/>
+          <p:nvPr/>
+        </p:nvSpPr>
+        <p:spPr>
+          <a:xfrm>
+            <a:off x="18384012" y="29709951"/>
             <a:ext cx="5557266" cy="438912"/>
           </a:xfrm>
           <a:prstGeom prst="rect">
@@ -8126,13 +8882,13 @@
       </p:sp>
       <p:sp>
         <p:nvSpPr>
-          <p:cNvPr id="99" name="TextBox 98"/>
-          <p:cNvSpPr txBox="1"/>
-          <p:nvPr/>
-        </p:nvSpPr>
-        <p:spPr>
-          <a:xfrm>
-            <a:off x="23941278" y="29417343"/>
+          <p:cNvPr id="117" name="TextBox 116"/>
+          <p:cNvSpPr txBox="1"/>
+          <p:nvPr/>
+        </p:nvSpPr>
+        <p:spPr>
+          <a:xfrm>
+            <a:off x="23941278" y="29709951"/>
             <a:ext cx="5557266" cy="438912"/>
           </a:xfrm>
           <a:prstGeom prst="rect">
@@ -8161,13 +8917,13 @@
       </p:sp>
       <p:sp>
         <p:nvSpPr>
-          <p:cNvPr id="100" name="Rectangle 99"/>
+          <p:cNvPr id="118" name="Rectangle 117"/>
           <p:cNvSpPr/>
           <p:nvPr/>
         </p:nvSpPr>
         <p:spPr>
           <a:xfrm>
-            <a:off x="15457932" y="29892831"/>
+            <a:off x="15457932" y="30185439"/>
             <a:ext cx="14040612" cy="19050"/>
           </a:xfrm>
           <a:prstGeom prst="rect">
@@ -8205,13 +8961,13 @@
       </p:sp>
       <p:sp>
         <p:nvSpPr>
-          <p:cNvPr id="101" name="TextBox 100"/>
-          <p:cNvSpPr txBox="1"/>
-          <p:nvPr/>
-        </p:nvSpPr>
-        <p:spPr>
-          <a:xfrm>
-            <a:off x="15457932" y="29930169"/>
+          <p:cNvPr id="119" name="TextBox 118"/>
+          <p:cNvSpPr txBox="1"/>
+          <p:nvPr/>
+        </p:nvSpPr>
+        <p:spPr>
+          <a:xfrm>
+            <a:off x="15457932" y="30222777"/>
             <a:ext cx="2926080" cy="457200"/>
           </a:xfrm>
           <a:prstGeom prst="rect">
@@ -8240,13 +8996,13 @@
       </p:sp>
       <p:sp>
         <p:nvSpPr>
-          <p:cNvPr id="102" name="TextBox 101"/>
-          <p:cNvSpPr txBox="1"/>
-          <p:nvPr/>
-        </p:nvSpPr>
-        <p:spPr>
-          <a:xfrm>
-            <a:off x="18384012" y="29930169"/>
+          <p:cNvPr id="120" name="TextBox 119"/>
+          <p:cNvSpPr txBox="1"/>
+          <p:nvPr/>
+        </p:nvSpPr>
+        <p:spPr>
+          <a:xfrm>
+            <a:off x="18384012" y="30222777"/>
             <a:ext cx="5557266" cy="457200"/>
           </a:xfrm>
           <a:prstGeom prst="rect">
@@ -8284,13 +9040,13 @@
       </p:sp>
       <p:sp>
         <p:nvSpPr>
-          <p:cNvPr id="103" name="TextBox 102"/>
-          <p:cNvSpPr txBox="1"/>
-          <p:nvPr/>
-        </p:nvSpPr>
-        <p:spPr>
-          <a:xfrm>
-            <a:off x="23941278" y="29930169"/>
+          <p:cNvPr id="121" name="TextBox 120"/>
+          <p:cNvSpPr txBox="1"/>
+          <p:nvPr/>
+        </p:nvSpPr>
+        <p:spPr>
+          <a:xfrm>
+            <a:off x="23941278" y="30222777"/>
             <a:ext cx="5557266" cy="457200"/>
           </a:xfrm>
           <a:prstGeom prst="rect">
@@ -8328,13 +9084,13 @@
       </p:sp>
       <p:sp>
         <p:nvSpPr>
-          <p:cNvPr id="104" name="Rectangle 103"/>
+          <p:cNvPr id="122" name="Rectangle 121"/>
           <p:cNvSpPr/>
           <p:nvPr/>
         </p:nvSpPr>
         <p:spPr>
           <a:xfrm>
-            <a:off x="15457932" y="30387369"/>
+            <a:off x="15457932" y="30679977"/>
             <a:ext cx="14040612" cy="10160"/>
           </a:xfrm>
           <a:prstGeom prst="rect">
@@ -8372,13 +9128,13 @@
       </p:sp>
       <p:sp>
         <p:nvSpPr>
-          <p:cNvPr id="105" name="TextBox 104"/>
-          <p:cNvSpPr txBox="1"/>
-          <p:nvPr/>
-        </p:nvSpPr>
-        <p:spPr>
-          <a:xfrm>
-            <a:off x="15457932" y="30387369"/>
+          <p:cNvPr id="123" name="TextBox 122"/>
+          <p:cNvSpPr txBox="1"/>
+          <p:nvPr/>
+        </p:nvSpPr>
+        <p:spPr>
+          <a:xfrm>
+            <a:off x="15457932" y="30679977"/>
             <a:ext cx="2926080" cy="457200"/>
           </a:xfrm>
           <a:prstGeom prst="rect">
@@ -8407,13 +9163,13 @@
       </p:sp>
       <p:sp>
         <p:nvSpPr>
-          <p:cNvPr id="106" name="TextBox 105"/>
-          <p:cNvSpPr txBox="1"/>
-          <p:nvPr/>
-        </p:nvSpPr>
-        <p:spPr>
-          <a:xfrm>
-            <a:off x="18384012" y="30387369"/>
+          <p:cNvPr id="124" name="TextBox 123"/>
+          <p:cNvSpPr txBox="1"/>
+          <p:nvPr/>
+        </p:nvSpPr>
+        <p:spPr>
+          <a:xfrm>
+            <a:off x="18384012" y="30679977"/>
             <a:ext cx="5557266" cy="457200"/>
           </a:xfrm>
           <a:prstGeom prst="rect">
@@ -8451,13 +9207,13 @@
       </p:sp>
       <p:sp>
         <p:nvSpPr>
-          <p:cNvPr id="107" name="TextBox 106"/>
-          <p:cNvSpPr txBox="1"/>
-          <p:nvPr/>
-        </p:nvSpPr>
-        <p:spPr>
-          <a:xfrm>
-            <a:off x="23941278" y="30387369"/>
+          <p:cNvPr id="125" name="TextBox 124"/>
+          <p:cNvSpPr txBox="1"/>
+          <p:nvPr/>
+        </p:nvSpPr>
+        <p:spPr>
+          <a:xfrm>
+            <a:off x="23941278" y="30679977"/>
             <a:ext cx="5557266" cy="457200"/>
           </a:xfrm>
           <a:prstGeom prst="rect">
@@ -8495,13 +9251,13 @@
       </p:sp>
       <p:sp>
         <p:nvSpPr>
-          <p:cNvPr id="108" name="Rectangle 107"/>
+          <p:cNvPr id="126" name="Rectangle 125"/>
           <p:cNvSpPr/>
           <p:nvPr/>
         </p:nvSpPr>
         <p:spPr>
           <a:xfrm>
-            <a:off x="15457932" y="30844569"/>
+            <a:off x="15457932" y="31137177"/>
             <a:ext cx="14040612" cy="10160"/>
           </a:xfrm>
           <a:prstGeom prst="rect">
@@ -8539,13 +9295,13 @@
       </p:sp>
       <p:sp>
         <p:nvSpPr>
-          <p:cNvPr id="109" name="TextBox 108"/>
-          <p:cNvSpPr txBox="1"/>
-          <p:nvPr/>
-        </p:nvSpPr>
-        <p:spPr>
-          <a:xfrm>
-            <a:off x="15457932" y="30844569"/>
+          <p:cNvPr id="127" name="TextBox 126"/>
+          <p:cNvSpPr txBox="1"/>
+          <p:nvPr/>
+        </p:nvSpPr>
+        <p:spPr>
+          <a:xfrm>
+            <a:off x="15457932" y="31137177"/>
             <a:ext cx="2926080" cy="457200"/>
           </a:xfrm>
           <a:prstGeom prst="rect">
@@ -8574,13 +9330,13 @@
       </p:sp>
       <p:sp>
         <p:nvSpPr>
-          <p:cNvPr id="110" name="TextBox 109"/>
-          <p:cNvSpPr txBox="1"/>
-          <p:nvPr/>
-        </p:nvSpPr>
-        <p:spPr>
-          <a:xfrm>
-            <a:off x="18384012" y="30844569"/>
+          <p:cNvPr id="128" name="TextBox 127"/>
+          <p:cNvSpPr txBox="1"/>
+          <p:nvPr/>
+        </p:nvSpPr>
+        <p:spPr>
+          <a:xfrm>
+            <a:off x="18384012" y="31137177"/>
             <a:ext cx="5557266" cy="457200"/>
           </a:xfrm>
           <a:prstGeom prst="rect">
@@ -8618,13 +9374,13 @@
       </p:sp>
       <p:sp>
         <p:nvSpPr>
-          <p:cNvPr id="111" name="TextBox 110"/>
-          <p:cNvSpPr txBox="1"/>
-          <p:nvPr/>
-        </p:nvSpPr>
-        <p:spPr>
-          <a:xfrm>
-            <a:off x="23941278" y="30844569"/>
+          <p:cNvPr id="129" name="TextBox 128"/>
+          <p:cNvSpPr txBox="1"/>
+          <p:nvPr/>
+        </p:nvSpPr>
+        <p:spPr>
+          <a:xfrm>
+            <a:off x="23941278" y="31137177"/>
             <a:ext cx="5557266" cy="457200"/>
           </a:xfrm>
           <a:prstGeom prst="rect">
@@ -8662,13 +9418,13 @@
       </p:sp>
       <p:sp>
         <p:nvSpPr>
-          <p:cNvPr id="112" name="Rectangle 111"/>
+          <p:cNvPr id="130" name="Rectangle 129"/>
           <p:cNvSpPr/>
           <p:nvPr/>
         </p:nvSpPr>
         <p:spPr>
           <a:xfrm>
-            <a:off x="15457932" y="31301769"/>
+            <a:off x="15457932" y="31594377"/>
             <a:ext cx="14040612" cy="10160"/>
           </a:xfrm>
           <a:prstGeom prst="rect">
@@ -8706,13 +9462,13 @@
       </p:sp>
       <p:sp>
         <p:nvSpPr>
-          <p:cNvPr id="113" name="TextBox 112"/>
-          <p:cNvSpPr txBox="1"/>
-          <p:nvPr/>
-        </p:nvSpPr>
-        <p:spPr>
-          <a:xfrm>
-            <a:off x="15457932" y="31301769"/>
+          <p:cNvPr id="131" name="TextBox 130"/>
+          <p:cNvSpPr txBox="1"/>
+          <p:nvPr/>
+        </p:nvSpPr>
+        <p:spPr>
+          <a:xfrm>
+            <a:off x="15457932" y="31594377"/>
             <a:ext cx="2926080" cy="457200"/>
           </a:xfrm>
           <a:prstGeom prst="rect">
@@ -8741,13 +9497,13 @@
       </p:sp>
       <p:sp>
         <p:nvSpPr>
-          <p:cNvPr id="114" name="TextBox 113"/>
-          <p:cNvSpPr txBox="1"/>
-          <p:nvPr/>
-        </p:nvSpPr>
-        <p:spPr>
-          <a:xfrm>
-            <a:off x="18384012" y="31301769"/>
+          <p:cNvPr id="132" name="TextBox 131"/>
+          <p:cNvSpPr txBox="1"/>
+          <p:nvPr/>
+        </p:nvSpPr>
+        <p:spPr>
+          <a:xfrm>
+            <a:off x="18384012" y="31594377"/>
             <a:ext cx="5557266" cy="457200"/>
           </a:xfrm>
           <a:prstGeom prst="rect">
@@ -8785,13 +9541,13 @@
       </p:sp>
       <p:sp>
         <p:nvSpPr>
-          <p:cNvPr id="115" name="TextBox 114"/>
-          <p:cNvSpPr txBox="1"/>
-          <p:nvPr/>
-        </p:nvSpPr>
-        <p:spPr>
-          <a:xfrm>
-            <a:off x="23941278" y="31301769"/>
+          <p:cNvPr id="133" name="TextBox 132"/>
+          <p:cNvSpPr txBox="1"/>
+          <p:nvPr/>
+        </p:nvSpPr>
+        <p:spPr>
+          <a:xfrm>
+            <a:off x="23941278" y="31594377"/>
             <a:ext cx="5557266" cy="457200"/>
           </a:xfrm>
           <a:prstGeom prst="rect">
@@ -8829,13 +9585,13 @@
       </p:sp>
       <p:sp>
         <p:nvSpPr>
-          <p:cNvPr id="116" name="Rectangle 115"/>
+          <p:cNvPr id="134" name="Rectangle 133"/>
           <p:cNvSpPr/>
           <p:nvPr/>
         </p:nvSpPr>
         <p:spPr>
           <a:xfrm>
-            <a:off x="15457932" y="31758969"/>
+            <a:off x="15457932" y="32051577"/>
             <a:ext cx="14040612" cy="10160"/>
           </a:xfrm>
           <a:prstGeom prst="rect">
@@ -8873,13 +9629,13 @@
       </p:sp>
       <p:sp>
         <p:nvSpPr>
-          <p:cNvPr id="117" name="TextBox 116"/>
-          <p:cNvSpPr txBox="1"/>
-          <p:nvPr/>
-        </p:nvSpPr>
-        <p:spPr>
-          <a:xfrm>
-            <a:off x="15457932" y="31886985"/>
+          <p:cNvPr id="135" name="TextBox 134"/>
+          <p:cNvSpPr txBox="1"/>
+          <p:nvPr/>
+        </p:nvSpPr>
+        <p:spPr>
+          <a:xfrm>
+            <a:off x="15457932" y="32179593"/>
             <a:ext cx="14040612" cy="1699666"/>
           </a:xfrm>
           <a:prstGeom prst="rect">
@@ -8915,13 +9671,13 @@
       </p:sp>
       <p:sp>
         <p:nvSpPr>
-          <p:cNvPr id="118" name="TextBox 117"/>
-          <p:cNvSpPr txBox="1"/>
-          <p:nvPr/>
-        </p:nvSpPr>
-        <p:spPr>
-          <a:xfrm>
-            <a:off x="15457932" y="33751243"/>
+          <p:cNvPr id="136" name="TextBox 135"/>
+          <p:cNvSpPr txBox="1"/>
+          <p:nvPr/>
+        </p:nvSpPr>
+        <p:spPr>
+          <a:xfrm>
+            <a:off x="15457932" y="33988987"/>
             <a:ext cx="14040612" cy="446227"/>
           </a:xfrm>
           <a:prstGeom prst="rect">
@@ -8966,13 +9722,13 @@
       </p:sp>
       <p:sp>
         <p:nvSpPr>
-          <p:cNvPr id="119" name="Rectangle 118"/>
+          <p:cNvPr id="137" name="Rectangle 136"/>
           <p:cNvSpPr/>
           <p:nvPr/>
         </p:nvSpPr>
         <p:spPr>
           <a:xfrm>
-            <a:off x="15457932" y="34325486"/>
+            <a:off x="15457932" y="34563230"/>
             <a:ext cx="12486132" cy="457200"/>
           </a:xfrm>
           <a:prstGeom prst="rect">
@@ -9012,13 +9768,13 @@
       </p:sp>
       <p:sp>
         <p:nvSpPr>
-          <p:cNvPr id="120" name="Rectangle 119"/>
+          <p:cNvPr id="138" name="Rectangle 137"/>
           <p:cNvSpPr/>
           <p:nvPr/>
         </p:nvSpPr>
         <p:spPr>
           <a:xfrm>
-            <a:off x="15457932" y="34325486"/>
+            <a:off x="15457932" y="34563230"/>
             <a:ext cx="8546657" cy="457200"/>
           </a:xfrm>
           <a:prstGeom prst="rect">
@@ -9056,13 +9812,13 @@
       </p:sp>
       <p:sp>
         <p:nvSpPr>
-          <p:cNvPr id="121" name="TextBox 120"/>
-          <p:cNvSpPr txBox="1"/>
-          <p:nvPr/>
-        </p:nvSpPr>
-        <p:spPr>
-          <a:xfrm>
-            <a:off x="15622524" y="34325486"/>
+          <p:cNvPr id="139" name="TextBox 138"/>
+          <p:cNvSpPr txBox="1"/>
+          <p:nvPr/>
+        </p:nvSpPr>
+        <p:spPr>
+          <a:xfrm>
+            <a:off x="15622524" y="34563230"/>
             <a:ext cx="12211812" cy="457200"/>
           </a:xfrm>
           <a:prstGeom prst="rect">
@@ -9091,13 +9847,13 @@
       </p:sp>
       <p:sp>
         <p:nvSpPr>
-          <p:cNvPr id="122" name="TextBox 121"/>
-          <p:cNvSpPr txBox="1"/>
-          <p:nvPr/>
-        </p:nvSpPr>
-        <p:spPr>
-          <a:xfrm>
-            <a:off x="28072080" y="34325486"/>
+          <p:cNvPr id="140" name="TextBox 139"/>
+          <p:cNvSpPr txBox="1"/>
+          <p:nvPr/>
+        </p:nvSpPr>
+        <p:spPr>
+          <a:xfrm>
+            <a:off x="28072080" y="34563230"/>
             <a:ext cx="1426464" cy="457200"/>
           </a:xfrm>
           <a:prstGeom prst="rect">
@@ -9126,13 +9882,13 @@
       </p:sp>
       <p:sp>
         <p:nvSpPr>
-          <p:cNvPr id="123" name="Rectangle 122"/>
+          <p:cNvPr id="141" name="Rectangle 140"/>
           <p:cNvSpPr/>
           <p:nvPr/>
         </p:nvSpPr>
         <p:spPr>
           <a:xfrm>
-            <a:off x="15457932" y="34874126"/>
+            <a:off x="15457932" y="35111870"/>
             <a:ext cx="12486132" cy="457200"/>
           </a:xfrm>
           <a:prstGeom prst="rect">
@@ -9172,13 +9928,13 @@
       </p:sp>
       <p:sp>
         <p:nvSpPr>
-          <p:cNvPr id="124" name="Rectangle 123"/>
+          <p:cNvPr id="142" name="Rectangle 141"/>
           <p:cNvSpPr/>
           <p:nvPr/>
         </p:nvSpPr>
         <p:spPr>
           <a:xfrm>
-            <a:off x="15457932" y="34874126"/>
+            <a:off x="15457932" y="35111870"/>
             <a:ext cx="6076139" cy="457200"/>
           </a:xfrm>
           <a:prstGeom prst="rect">
@@ -9216,13 +9972,13 @@
       </p:sp>
       <p:sp>
         <p:nvSpPr>
-          <p:cNvPr id="125" name="TextBox 124"/>
-          <p:cNvSpPr txBox="1"/>
-          <p:nvPr/>
-        </p:nvSpPr>
-        <p:spPr>
-          <a:xfrm>
-            <a:off x="15622524" y="34874126"/>
+          <p:cNvPr id="143" name="TextBox 142"/>
+          <p:cNvSpPr txBox="1"/>
+          <p:nvPr/>
+        </p:nvSpPr>
+        <p:spPr>
+          <a:xfrm>
+            <a:off x="15622524" y="35111870"/>
             <a:ext cx="12211812" cy="457200"/>
           </a:xfrm>
           <a:prstGeom prst="rect">
@@ -9251,13 +10007,13 @@
       </p:sp>
       <p:sp>
         <p:nvSpPr>
-          <p:cNvPr id="126" name="TextBox 125"/>
-          <p:cNvSpPr txBox="1"/>
-          <p:nvPr/>
-        </p:nvSpPr>
-        <p:spPr>
-          <a:xfrm>
-            <a:off x="28072080" y="34874126"/>
+          <p:cNvPr id="144" name="TextBox 143"/>
+          <p:cNvSpPr txBox="1"/>
+          <p:nvPr/>
+        </p:nvSpPr>
+        <p:spPr>
+          <a:xfrm>
+            <a:off x="28072080" y="35111870"/>
             <a:ext cx="1426464" cy="457200"/>
           </a:xfrm>
           <a:prstGeom prst="rect">
@@ -9286,13 +10042,13 @@
       </p:sp>
       <p:sp>
         <p:nvSpPr>
-          <p:cNvPr id="127" name="Rectangle 126"/>
+          <p:cNvPr id="145" name="Rectangle 144"/>
           <p:cNvSpPr/>
           <p:nvPr/>
         </p:nvSpPr>
         <p:spPr>
           <a:xfrm>
-            <a:off x="15457932" y="35422766"/>
+            <a:off x="15457932" y="35660510"/>
             <a:ext cx="12486132" cy="457200"/>
           </a:xfrm>
           <a:prstGeom prst="rect">
@@ -9332,13 +10088,13 @@
       </p:sp>
       <p:sp>
         <p:nvSpPr>
-          <p:cNvPr id="128" name="Rectangle 127"/>
+          <p:cNvPr id="146" name="Rectangle 145"/>
           <p:cNvSpPr/>
           <p:nvPr/>
         </p:nvSpPr>
         <p:spPr>
           <a:xfrm>
-            <a:off x="15457932" y="35422766"/>
+            <a:off x="15457932" y="35660510"/>
             <a:ext cx="9948843" cy="457200"/>
           </a:xfrm>
           <a:prstGeom prst="rect">
@@ -9376,13 +10132,13 @@
       </p:sp>
       <p:sp>
         <p:nvSpPr>
-          <p:cNvPr id="129" name="TextBox 128"/>
-          <p:cNvSpPr txBox="1"/>
-          <p:nvPr/>
-        </p:nvSpPr>
-        <p:spPr>
-          <a:xfrm>
-            <a:off x="15622524" y="35422766"/>
+          <p:cNvPr id="147" name="TextBox 146"/>
+          <p:cNvSpPr txBox="1"/>
+          <p:nvPr/>
+        </p:nvSpPr>
+        <p:spPr>
+          <a:xfrm>
+            <a:off x="15622524" y="35660510"/>
             <a:ext cx="12211812" cy="457200"/>
           </a:xfrm>
           <a:prstGeom prst="rect">
@@ -9411,13 +10167,13 @@
       </p:sp>
       <p:sp>
         <p:nvSpPr>
-          <p:cNvPr id="130" name="TextBox 129"/>
-          <p:cNvSpPr txBox="1"/>
-          <p:nvPr/>
-        </p:nvSpPr>
-        <p:spPr>
-          <a:xfrm>
-            <a:off x="28072080" y="35422766"/>
+          <p:cNvPr id="148" name="TextBox 147"/>
+          <p:cNvSpPr txBox="1"/>
+          <p:nvPr/>
+        </p:nvSpPr>
+        <p:spPr>
+          <a:xfrm>
+            <a:off x="28072080" y="35660510"/>
             <a:ext cx="1426464" cy="457200"/>
           </a:xfrm>
           <a:prstGeom prst="rect">
@@ -9446,13 +10202,13 @@
       </p:sp>
       <p:sp>
         <p:nvSpPr>
-          <p:cNvPr id="131" name="Rectangle 130"/>
+          <p:cNvPr id="149" name="Rectangle 148"/>
           <p:cNvSpPr/>
           <p:nvPr/>
         </p:nvSpPr>
         <p:spPr>
           <a:xfrm>
-            <a:off x="15457932" y="35971406"/>
+            <a:off x="15457932" y="36209150"/>
             <a:ext cx="12486132" cy="457200"/>
           </a:xfrm>
           <a:prstGeom prst="rect">
@@ -9492,13 +10248,13 @@
       </p:sp>
       <p:sp>
         <p:nvSpPr>
-          <p:cNvPr id="132" name="Rectangle 131"/>
+          <p:cNvPr id="150" name="Rectangle 149"/>
           <p:cNvSpPr/>
           <p:nvPr/>
         </p:nvSpPr>
         <p:spPr>
           <a:xfrm>
-            <a:off x="15457932" y="35971406"/>
+            <a:off x="15457932" y="36209150"/>
             <a:ext cx="12486132" cy="457200"/>
           </a:xfrm>
           <a:prstGeom prst="rect">
@@ -9536,13 +10292,13 @@
       </p:sp>
       <p:sp>
         <p:nvSpPr>
-          <p:cNvPr id="133" name="TextBox 132"/>
-          <p:cNvSpPr txBox="1"/>
-          <p:nvPr/>
-        </p:nvSpPr>
-        <p:spPr>
-          <a:xfrm>
-            <a:off x="15622524" y="35971406"/>
+          <p:cNvPr id="151" name="TextBox 150"/>
+          <p:cNvSpPr txBox="1"/>
+          <p:nvPr/>
+        </p:nvSpPr>
+        <p:spPr>
+          <a:xfrm>
+            <a:off x="15622524" y="36209150"/>
             <a:ext cx="12211812" cy="457200"/>
           </a:xfrm>
           <a:prstGeom prst="rect">
@@ -9571,13 +10327,13 @@
       </p:sp>
       <p:sp>
         <p:nvSpPr>
-          <p:cNvPr id="134" name="TextBox 133"/>
-          <p:cNvSpPr txBox="1"/>
-          <p:nvPr/>
-        </p:nvSpPr>
-        <p:spPr>
-          <a:xfrm>
-            <a:off x="28072080" y="35971406"/>
+          <p:cNvPr id="152" name="TextBox 151"/>
+          <p:cNvSpPr txBox="1"/>
+          <p:nvPr/>
+        </p:nvSpPr>
+        <p:spPr>
+          <a:xfrm>
+            <a:off x="28072080" y="36209150"/>
             <a:ext cx="1426464" cy="457200"/>
           </a:xfrm>
           <a:prstGeom prst="rect">
@@ -9606,13 +10362,13 @@
       </p:sp>
       <p:sp>
         <p:nvSpPr>
-          <p:cNvPr id="135" name="TextBox 134"/>
-          <p:cNvSpPr txBox="1"/>
-          <p:nvPr/>
-        </p:nvSpPr>
-        <p:spPr>
-          <a:xfrm>
-            <a:off x="15457932" y="36574910"/>
+          <p:cNvPr id="153" name="TextBox 152"/>
+          <p:cNvSpPr txBox="1"/>
+          <p:nvPr/>
+        </p:nvSpPr>
+        <p:spPr>
+          <a:xfrm>
+            <a:off x="15457932" y="36812654"/>
             <a:ext cx="14040612" cy="1290624"/>
           </a:xfrm>
           <a:prstGeom prst="rect">
@@ -9657,13 +10413,13 @@
       </p:sp>
       <p:sp>
         <p:nvSpPr>
-          <p:cNvPr id="136" name="Rectangle 135"/>
+          <p:cNvPr id="154" name="Rectangle 153"/>
           <p:cNvSpPr/>
           <p:nvPr/>
         </p:nvSpPr>
         <p:spPr>
           <a:xfrm>
-            <a:off x="15457932" y="38048414"/>
+            <a:off x="15457932" y="38286158"/>
             <a:ext cx="14040612" cy="2313228"/>
           </a:xfrm>
           <a:prstGeom prst="rect">
@@ -9701,13 +10457,13 @@
       </p:sp>
       <p:sp>
         <p:nvSpPr>
-          <p:cNvPr id="137" name="TextBox 136"/>
-          <p:cNvSpPr txBox="1"/>
-          <p:nvPr/>
-        </p:nvSpPr>
-        <p:spPr>
-          <a:xfrm>
-            <a:off x="15695676" y="38286158"/>
+          <p:cNvPr id="155" name="TextBox 154"/>
+          <p:cNvSpPr txBox="1"/>
+          <p:nvPr/>
+        </p:nvSpPr>
+        <p:spPr>
+          <a:xfrm>
+            <a:off x="15695676" y="38523902"/>
             <a:ext cx="13565124" cy="1837740"/>
           </a:xfrm>
           <a:prstGeom prst="rect">
@@ -9780,7 +10536,7 @@
       </p:sp>
       <p:sp>
         <p:nvSpPr>
-          <p:cNvPr id="138" name="Rectangle 137"/>
+          <p:cNvPr id="156" name="Rectangle 155"/>
           <p:cNvSpPr/>
           <p:nvPr/>
         </p:nvSpPr>
@@ -9824,7 +10580,7 @@
       </p:sp>
       <p:sp>
         <p:nvSpPr>
-          <p:cNvPr id="139" name="Rectangle 138"/>
+          <p:cNvPr id="157" name="Rectangle 156"/>
           <p:cNvSpPr/>
           <p:nvPr/>
         </p:nvSpPr>
@@ -9868,7 +10624,7 @@
       </p:sp>
       <p:pic>
         <p:nvPicPr>
-          <p:cNvPr id="140" name="Picture 139" descr="asset_cikm.png"/>
+          <p:cNvPr id="158" name="Picture 157" descr="asset_cikm.png"/>
           <p:cNvPicPr>
             <a:picLocks noChangeAspect="1"/>
           </p:cNvPicPr>
@@ -9892,7 +10648,7 @@
       </p:pic>
       <p:sp>
         <p:nvSpPr>
-          <p:cNvPr id="141" name="TextBox 140"/>
+          <p:cNvPr id="159" name="TextBox 158"/>
           <p:cNvSpPr txBox="1"/>
           <p:nvPr/>
         </p:nvSpPr>
@@ -9934,7 +10690,7 @@
       </p:sp>
       <p:sp>
         <p:nvSpPr>
-          <p:cNvPr id="142" name="TextBox 141"/>
+          <p:cNvPr id="160" name="TextBox 159"/>
           <p:cNvSpPr txBox="1"/>
           <p:nvPr/>
         </p:nvSpPr>

</xml_diff>

<commit_message>
fix(poster): bind group headers to their sub-columns, add R@10 deltas
Underline rules tie q->db / db->q headers to their R@10+R@100 pairs;
all four numeric columns now share the van->pmc +d% format.
</commit_message>
<xml_diff>
--- a/poster/PMC_CIKM2026_poster.pptx
+++ b/poster/PMC_CIKM2026_poster.pptx
@@ -6057,8 +6057,8 @@
         </p:nvSpPr>
         <p:spPr>
           <a:xfrm>
-            <a:off x="18841212" y="18024778"/>
-            <a:ext cx="5328666" cy="384048"/>
+            <a:off x="18521172" y="18024778"/>
+            <a:ext cx="5488686" cy="365760"/>
           </a:xfrm>
           <a:prstGeom prst="rect">
             <a:avLst/>
@@ -6075,25 +6075,183 @@
             <a:r>
               <a:rPr sz="2100" b="1" i="0">
                 <a:solidFill>
+                  <a:srgbClr val="1F1F1F"/>
+                </a:solidFill>
+                <a:latin typeface="Times New Roman"/>
+              </a:rPr>
+              <a:t>q→db</a:t>
+            </a:r>
+          </a:p>
+        </p:txBody>
+      </p:sp>
+      <p:sp>
+        <p:nvSpPr>
+          <p:cNvPr id="52" name="Rectangle 51"/>
+          <p:cNvSpPr/>
+          <p:nvPr/>
+        </p:nvSpPr>
+        <p:spPr>
+          <a:xfrm>
+            <a:off x="18795492" y="18408826"/>
+            <a:ext cx="4940046" cy="15240"/>
+          </a:xfrm>
+          <a:prstGeom prst="rect">
+            <a:avLst/>
+          </a:prstGeom>
+          <a:solidFill>
+            <a:srgbClr val="6F6F6F"/>
+          </a:solidFill>
+          <a:ln>
+            <a:noFill/>
+          </a:ln>
+          <a:effectLst/>
+        </p:spPr>
+        <p:style>
+          <a:lnRef idx="1">
+            <a:schemeClr val="accent1"/>
+          </a:lnRef>
+          <a:fillRef idx="3">
+            <a:schemeClr val="accent1"/>
+          </a:fillRef>
+          <a:effectRef idx="2">
+            <a:schemeClr val="accent1"/>
+          </a:effectRef>
+          <a:fontRef idx="minor">
+            <a:schemeClr val="lt1"/>
+          </a:fontRef>
+        </p:style>
+        <p:txBody>
+          <a:bodyPr rtlCol="0" anchor="ctr"/>
+          <a:lstStyle/>
+          <a:p>
+            <a:pPr algn="ctr"/>
+          </a:p>
+        </p:txBody>
+      </p:sp>
+      <p:sp>
+        <p:nvSpPr>
+          <p:cNvPr id="53" name="TextBox 52"/>
+          <p:cNvSpPr txBox="1"/>
+          <p:nvPr/>
+        </p:nvSpPr>
+        <p:spPr>
+          <a:xfrm>
+            <a:off x="24009858" y="18024778"/>
+            <a:ext cx="5488686" cy="365760"/>
+          </a:xfrm>
+          <a:prstGeom prst="rect">
+            <a:avLst/>
+          </a:prstGeom>
+          <a:noFill/>
+        </p:spPr>
+        <p:txBody>
+          <a:bodyPr wrap="none" anchor="ctr" lIns="0" rIns="0" tIns="0" bIns="0">
+            <a:spAutoFit/>
+          </a:bodyPr>
+          <a:lstStyle/>
+          <a:p>
+            <a:pPr algn="ctr"/>
+            <a:r>
+              <a:rPr sz="2100" b="1" i="0">
+                <a:solidFill>
+                  <a:srgbClr val="1F1F1F"/>
+                </a:solidFill>
+                <a:latin typeface="Times New Roman"/>
+              </a:rPr>
+              <a:t>db→q</a:t>
+            </a:r>
+          </a:p>
+        </p:txBody>
+      </p:sp>
+      <p:sp>
+        <p:nvSpPr>
+          <p:cNvPr id="54" name="Rectangle 53"/>
+          <p:cNvSpPr/>
+          <p:nvPr/>
+        </p:nvSpPr>
+        <p:spPr>
+          <a:xfrm>
+            <a:off x="24284178" y="18408826"/>
+            <a:ext cx="4940046" cy="15240"/>
+          </a:xfrm>
+          <a:prstGeom prst="rect">
+            <a:avLst/>
+          </a:prstGeom>
+          <a:solidFill>
+            <a:srgbClr val="6F6F6F"/>
+          </a:solidFill>
+          <a:ln>
+            <a:noFill/>
+          </a:ln>
+          <a:effectLst/>
+        </p:spPr>
+        <p:style>
+          <a:lnRef idx="1">
+            <a:schemeClr val="accent1"/>
+          </a:lnRef>
+          <a:fillRef idx="3">
+            <a:schemeClr val="accent1"/>
+          </a:fillRef>
+          <a:effectRef idx="2">
+            <a:schemeClr val="accent1"/>
+          </a:effectRef>
+          <a:fontRef idx="minor">
+            <a:schemeClr val="lt1"/>
+          </a:fontRef>
+        </p:style>
+        <p:txBody>
+          <a:bodyPr rtlCol="0" anchor="ctr"/>
+          <a:lstStyle/>
+          <a:p>
+            <a:pPr algn="ctr"/>
+          </a:p>
+        </p:txBody>
+      </p:sp>
+      <p:sp>
+        <p:nvSpPr>
+          <p:cNvPr id="55" name="TextBox 54"/>
+          <p:cNvSpPr txBox="1"/>
+          <p:nvPr/>
+        </p:nvSpPr>
+        <p:spPr>
+          <a:xfrm>
+            <a:off x="15457932" y="18445402"/>
+            <a:ext cx="685800" cy="365760"/>
+          </a:xfrm>
+          <a:prstGeom prst="rect">
+            <a:avLst/>
+          </a:prstGeom>
+          <a:noFill/>
+        </p:spPr>
+        <p:txBody>
+          <a:bodyPr wrap="none" anchor="ctr" lIns="0" rIns="0" tIns="0" bIns="0">
+            <a:spAutoFit/>
+          </a:bodyPr>
+          <a:lstStyle/>
+          <a:p>
+            <a:pPr algn="l"/>
+            <a:r>
+              <a:rPr sz="2000" b="1" i="0">
+                <a:solidFill>
                   <a:srgbClr val="6F6F6F"/>
                 </a:solidFill>
                 <a:latin typeface="Times New Roman"/>
               </a:rPr>
-              <a:t>q→db</a:t>
-            </a:r>
-          </a:p>
-        </p:txBody>
-      </p:sp>
-      <p:sp>
-        <p:nvSpPr>
-          <p:cNvPr id="52" name="TextBox 51"/>
-          <p:cNvSpPr txBox="1"/>
-          <p:nvPr/>
-        </p:nvSpPr>
-        <p:spPr>
-          <a:xfrm>
-            <a:off x="24169878" y="18024778"/>
-            <a:ext cx="5328666" cy="384048"/>
+              <a:t>‖g‖</a:t>
+            </a:r>
+          </a:p>
+        </p:txBody>
+      </p:sp>
+      <p:sp>
+        <p:nvSpPr>
+          <p:cNvPr id="56" name="TextBox 55"/>
+          <p:cNvSpPr txBox="1"/>
+          <p:nvPr/>
+        </p:nvSpPr>
+        <p:spPr>
+          <a:xfrm>
+            <a:off x="16143732" y="18445402"/>
+            <a:ext cx="2377440" cy="365760"/>
           </a:xfrm>
           <a:prstGeom prst="rect">
             <a:avLst/>
@@ -6106,29 +6264,29 @@
           </a:bodyPr>
           <a:lstStyle/>
           <a:p>
-            <a:pPr algn="ctr"/>
-            <a:r>
-              <a:rPr sz="2100" b="1" i="0">
+            <a:pPr algn="l"/>
+            <a:r>
+              <a:rPr sz="2000" b="1" i="0">
                 <a:solidFill>
                   <a:srgbClr val="6F6F6F"/>
                 </a:solidFill>
                 <a:latin typeface="Times New Roman"/>
               </a:rPr>
-              <a:t>db→q</a:t>
-            </a:r>
-          </a:p>
-        </p:txBody>
-      </p:sp>
-      <p:sp>
-        <p:nvSpPr>
-          <p:cNvPr id="53" name="TextBox 52"/>
-          <p:cNvSpPr txBox="1"/>
-          <p:nvPr/>
-        </p:nvSpPr>
-        <p:spPr>
-          <a:xfrm>
-            <a:off x="15457932" y="18427114"/>
-            <a:ext cx="777240" cy="384048"/>
+              <a:t>Dataset · Enc.</a:t>
+            </a:r>
+          </a:p>
+        </p:txBody>
+      </p:sp>
+      <p:sp>
+        <p:nvSpPr>
+          <p:cNvPr id="57" name="TextBox 56"/>
+          <p:cNvSpPr txBox="1"/>
+          <p:nvPr/>
+        </p:nvSpPr>
+        <p:spPr>
+          <a:xfrm>
+            <a:off x="18521172" y="18445402"/>
+            <a:ext cx="2423160" cy="365760"/>
           </a:xfrm>
           <a:prstGeom prst="rect">
             <a:avLst/>
@@ -6141,7 +6299,7 @@
           </a:bodyPr>
           <a:lstStyle/>
           <a:p>
-            <a:pPr algn="l"/>
+            <a:pPr algn="r"/>
             <a:r>
               <a:rPr sz="2000" b="1" i="0">
                 <a:solidFill>
@@ -6149,21 +6307,21 @@
                 </a:solidFill>
                 <a:latin typeface="Times New Roman"/>
               </a:rPr>
-              <a:t>‖g‖</a:t>
-            </a:r>
-          </a:p>
-        </p:txBody>
-      </p:sp>
-      <p:sp>
-        <p:nvSpPr>
-          <p:cNvPr id="54" name="TextBox 53"/>
-          <p:cNvSpPr txBox="1"/>
-          <p:nvPr/>
-        </p:nvSpPr>
-        <p:spPr>
-          <a:xfrm>
-            <a:off x="16235172" y="18427114"/>
-            <a:ext cx="2606040" cy="384048"/>
+              <a:t>R@10</a:t>
+            </a:r>
+          </a:p>
+        </p:txBody>
+      </p:sp>
+      <p:sp>
+        <p:nvSpPr>
+          <p:cNvPr id="58" name="TextBox 57"/>
+          <p:cNvSpPr txBox="1"/>
+          <p:nvPr/>
+        </p:nvSpPr>
+        <p:spPr>
+          <a:xfrm>
+            <a:off x="20944332" y="18445402"/>
+            <a:ext cx="3065526" cy="365760"/>
           </a:xfrm>
           <a:prstGeom prst="rect">
             <a:avLst/>
@@ -6176,7 +6334,7 @@
           </a:bodyPr>
           <a:lstStyle/>
           <a:p>
-            <a:pPr algn="l"/>
+            <a:pPr algn="r"/>
             <a:r>
               <a:rPr sz="2000" b="1" i="0">
                 <a:solidFill>
@@ -6184,21 +6342,21 @@
                 </a:solidFill>
                 <a:latin typeface="Times New Roman"/>
               </a:rPr>
-              <a:t>Dataset · Enc.</a:t>
-            </a:r>
-          </a:p>
-        </p:txBody>
-      </p:sp>
-      <p:sp>
-        <p:nvSpPr>
-          <p:cNvPr id="55" name="TextBox 54"/>
-          <p:cNvSpPr txBox="1"/>
-          <p:nvPr/>
-        </p:nvSpPr>
-        <p:spPr>
-          <a:xfrm>
-            <a:off x="18841212" y="18427114"/>
-            <a:ext cx="1874519" cy="384048"/>
+              <a:t>R@100</a:t>
+            </a:r>
+          </a:p>
+        </p:txBody>
+      </p:sp>
+      <p:sp>
+        <p:nvSpPr>
+          <p:cNvPr id="59" name="TextBox 58"/>
+          <p:cNvSpPr txBox="1"/>
+          <p:nvPr/>
+        </p:nvSpPr>
+        <p:spPr>
+          <a:xfrm>
+            <a:off x="24009858" y="18445402"/>
+            <a:ext cx="2423160" cy="365760"/>
           </a:xfrm>
           <a:prstGeom prst="rect">
             <a:avLst/>
@@ -6226,14 +6384,14 @@
       </p:sp>
       <p:sp>
         <p:nvSpPr>
-          <p:cNvPr id="56" name="TextBox 55"/>
-          <p:cNvSpPr txBox="1"/>
-          <p:nvPr/>
-        </p:nvSpPr>
-        <p:spPr>
-          <a:xfrm>
-            <a:off x="20715731" y="18427114"/>
-            <a:ext cx="3454147" cy="384048"/>
+          <p:cNvPr id="60" name="TextBox 59"/>
+          <p:cNvSpPr txBox="1"/>
+          <p:nvPr/>
+        </p:nvSpPr>
+        <p:spPr>
+          <a:xfrm>
+            <a:off x="26433018" y="18445402"/>
+            <a:ext cx="3065526" cy="365760"/>
           </a:xfrm>
           <a:prstGeom prst="rect">
             <a:avLst/>
@@ -6261,77 +6419,7 @@
       </p:sp>
       <p:sp>
         <p:nvSpPr>
-          <p:cNvPr id="57" name="TextBox 56"/>
-          <p:cNvSpPr txBox="1"/>
-          <p:nvPr/>
-        </p:nvSpPr>
-        <p:spPr>
-          <a:xfrm>
-            <a:off x="24169878" y="18427114"/>
-            <a:ext cx="1874519" cy="384048"/>
-          </a:xfrm>
-          <a:prstGeom prst="rect">
-            <a:avLst/>
-          </a:prstGeom>
-          <a:noFill/>
-        </p:spPr>
-        <p:txBody>
-          <a:bodyPr wrap="none" anchor="ctr" lIns="0" rIns="0" tIns="0" bIns="0">
-            <a:spAutoFit/>
-          </a:bodyPr>
-          <a:lstStyle/>
-          <a:p>
-            <a:pPr algn="r"/>
-            <a:r>
-              <a:rPr sz="2000" b="1" i="0">
-                <a:solidFill>
-                  <a:srgbClr val="6F6F6F"/>
-                </a:solidFill>
-                <a:latin typeface="Times New Roman"/>
-              </a:rPr>
-              <a:t>R@10</a:t>
-            </a:r>
-          </a:p>
-        </p:txBody>
-      </p:sp>
-      <p:sp>
-        <p:nvSpPr>
-          <p:cNvPr id="58" name="TextBox 57"/>
-          <p:cNvSpPr txBox="1"/>
-          <p:nvPr/>
-        </p:nvSpPr>
-        <p:spPr>
-          <a:xfrm>
-            <a:off x="26044397" y="18427114"/>
-            <a:ext cx="3454147" cy="384048"/>
-          </a:xfrm>
-          <a:prstGeom prst="rect">
-            <a:avLst/>
-          </a:prstGeom>
-          <a:noFill/>
-        </p:spPr>
-        <p:txBody>
-          <a:bodyPr wrap="none" anchor="ctr" lIns="0" rIns="0" tIns="0" bIns="0">
-            <a:spAutoFit/>
-          </a:bodyPr>
-          <a:lstStyle/>
-          <a:p>
-            <a:pPr algn="r"/>
-            <a:r>
-              <a:rPr sz="2000" b="1" i="0">
-                <a:solidFill>
-                  <a:srgbClr val="6F6F6F"/>
-                </a:solidFill>
-                <a:latin typeface="Times New Roman"/>
-              </a:rPr>
-              <a:t>R@100</a:t>
-            </a:r>
-          </a:p>
-        </p:txBody>
-      </p:sp>
-      <p:sp>
-        <p:nvSpPr>
-          <p:cNvPr id="59" name="Rectangle 58"/>
+          <p:cNvPr id="61" name="Rectangle 60"/>
           <p:cNvSpPr/>
           <p:nvPr/>
         </p:nvSpPr>
@@ -6375,14 +6463,14 @@
       </p:sp>
       <p:sp>
         <p:nvSpPr>
-          <p:cNvPr id="60" name="TextBox 59"/>
+          <p:cNvPr id="62" name="TextBox 61"/>
           <p:cNvSpPr txBox="1"/>
           <p:nvPr/>
         </p:nvSpPr>
         <p:spPr>
           <a:xfrm>
             <a:off x="15457932" y="18885076"/>
-            <a:ext cx="777240" cy="457200"/>
+            <a:ext cx="685800" cy="457200"/>
           </a:xfrm>
           <a:prstGeom prst="rect">
             <a:avLst/>
@@ -6410,14 +6498,14 @@
       </p:sp>
       <p:sp>
         <p:nvSpPr>
-          <p:cNvPr id="61" name="TextBox 60"/>
-          <p:cNvSpPr txBox="1"/>
-          <p:nvPr/>
-        </p:nvSpPr>
-        <p:spPr>
-          <a:xfrm>
-            <a:off x="16235172" y="18885076"/>
-            <a:ext cx="2606040" cy="457200"/>
+          <p:cNvPr id="63" name="TextBox 62"/>
+          <p:cNvSpPr txBox="1"/>
+          <p:nvPr/>
+        </p:nvSpPr>
+        <p:spPr>
+          <a:xfrm>
+            <a:off x="16143732" y="18885076"/>
+            <a:ext cx="2377440" cy="457200"/>
           </a:xfrm>
           <a:prstGeom prst="rect">
             <a:avLst/>
@@ -6445,14 +6533,14 @@
       </p:sp>
       <p:sp>
         <p:nvSpPr>
-          <p:cNvPr id="62" name="TextBox 61"/>
-          <p:cNvSpPr txBox="1"/>
-          <p:nvPr/>
-        </p:nvSpPr>
-        <p:spPr>
-          <a:xfrm>
-            <a:off x="18841212" y="18885076"/>
-            <a:ext cx="1874519" cy="457200"/>
+          <p:cNvPr id="64" name="TextBox 63"/>
+          <p:cNvSpPr txBox="1"/>
+          <p:nvPr/>
+        </p:nvSpPr>
+        <p:spPr>
+          <a:xfrm>
+            <a:off x="18521172" y="18885076"/>
+            <a:ext cx="2423160" cy="457200"/>
           </a:xfrm>
           <a:prstGeom prst="rect">
             <a:avLst/>
@@ -6467,7 +6555,7 @@
           <a:p>
             <a:pPr algn="r"/>
             <a:r>
-              <a:rPr sz="1800" b="0" i="0">
+              <a:rPr sz="1700" b="0" i="0">
                 <a:solidFill>
                   <a:srgbClr val="6F6F6F"/>
                 </a:solidFill>
@@ -6476,7 +6564,7 @@
               <a:t>.36→</a:t>
             </a:r>
             <a:r>
-              <a:rPr sz="2100" b="1" i="0">
+              <a:rPr sz="2000" b="1" i="0">
                 <a:solidFill>
                   <a:srgbClr val="0D4DA3"/>
                 </a:solidFill>
@@ -6484,19 +6572,28 @@
               </a:rPr>
               <a:t>.48</a:t>
             </a:r>
-          </a:p>
-        </p:txBody>
-      </p:sp>
-      <p:sp>
-        <p:nvSpPr>
-          <p:cNvPr id="63" name="TextBox 62"/>
-          <p:cNvSpPr txBox="1"/>
-          <p:nvPr/>
-        </p:nvSpPr>
-        <p:spPr>
-          <a:xfrm>
-            <a:off x="20715731" y="18885076"/>
-            <a:ext cx="3454147" cy="457200"/>
+            <a:r>
+              <a:rPr sz="1700" b="1" i="0">
+                <a:solidFill>
+                  <a:srgbClr val="0D4DA3"/>
+                </a:solidFill>
+                <a:latin typeface="Times New Roman"/>
+              </a:rPr>
+              <a:t> +33%</a:t>
+            </a:r>
+          </a:p>
+        </p:txBody>
+      </p:sp>
+      <p:sp>
+        <p:nvSpPr>
+          <p:cNvPr id="65" name="TextBox 64"/>
+          <p:cNvSpPr txBox="1"/>
+          <p:nvPr/>
+        </p:nvSpPr>
+        <p:spPr>
+          <a:xfrm>
+            <a:off x="20944332" y="18885076"/>
+            <a:ext cx="3065526" cy="457200"/>
           </a:xfrm>
           <a:prstGeom prst="rect">
             <a:avLst/>
@@ -6511,7 +6608,7 @@
           <a:p>
             <a:pPr algn="r"/>
             <a:r>
-              <a:rPr sz="1800" b="0" i="0">
+              <a:rPr sz="1700" b="0" i="0">
                 <a:solidFill>
                   <a:srgbClr val="6F6F6F"/>
                 </a:solidFill>
@@ -6520,7 +6617,7 @@
               <a:t>.55→</a:t>
             </a:r>
             <a:r>
-              <a:rPr sz="2100" b="1" i="0">
+              <a:rPr sz="2000" b="1" i="0">
                 <a:solidFill>
                   <a:srgbClr val="0D4DA3"/>
                 </a:solidFill>
@@ -6529,7 +6626,7 @@
               <a:t>.65</a:t>
             </a:r>
             <a:r>
-              <a:rPr sz="1800" b="1" i="0">
+              <a:rPr sz="1700" b="1" i="0">
                 <a:solidFill>
                   <a:srgbClr val="0D4DA3"/>
                 </a:solidFill>
@@ -6542,14 +6639,14 @@
       </p:sp>
       <p:sp>
         <p:nvSpPr>
-          <p:cNvPr id="64" name="TextBox 63"/>
-          <p:cNvSpPr txBox="1"/>
-          <p:nvPr/>
-        </p:nvSpPr>
-        <p:spPr>
-          <a:xfrm>
-            <a:off x="24169878" y="18885076"/>
-            <a:ext cx="1874519" cy="457200"/>
+          <p:cNvPr id="66" name="TextBox 65"/>
+          <p:cNvSpPr txBox="1"/>
+          <p:nvPr/>
+        </p:nvSpPr>
+        <p:spPr>
+          <a:xfrm>
+            <a:off x="24009858" y="18885076"/>
+            <a:ext cx="2423160" cy="457200"/>
           </a:xfrm>
           <a:prstGeom prst="rect">
             <a:avLst/>
@@ -6564,7 +6661,7 @@
           <a:p>
             <a:pPr algn="r"/>
             <a:r>
-              <a:rPr sz="1800" b="0" i="0">
+              <a:rPr sz="1700" b="0" i="0">
                 <a:solidFill>
                   <a:srgbClr val="6F6F6F"/>
                 </a:solidFill>
@@ -6573,7 +6670,7 @@
               <a:t>.26→</a:t>
             </a:r>
             <a:r>
-              <a:rPr sz="2100" b="1" i="0">
+              <a:rPr sz="2000" b="1" i="0">
                 <a:solidFill>
                   <a:srgbClr val="0D4DA3"/>
                 </a:solidFill>
@@ -6581,19 +6678,28 @@
               </a:rPr>
               <a:t>.44</a:t>
             </a:r>
-          </a:p>
-        </p:txBody>
-      </p:sp>
-      <p:sp>
-        <p:nvSpPr>
-          <p:cNvPr id="65" name="TextBox 64"/>
-          <p:cNvSpPr txBox="1"/>
-          <p:nvPr/>
-        </p:nvSpPr>
-        <p:spPr>
-          <a:xfrm>
-            <a:off x="26044397" y="18885076"/>
-            <a:ext cx="3454147" cy="457200"/>
+            <a:r>
+              <a:rPr sz="1700" b="1" i="0">
+                <a:solidFill>
+                  <a:srgbClr val="0D4DA3"/>
+                </a:solidFill>
+                <a:latin typeface="Times New Roman"/>
+              </a:rPr>
+              <a:t> +69%</a:t>
+            </a:r>
+          </a:p>
+        </p:txBody>
+      </p:sp>
+      <p:sp>
+        <p:nvSpPr>
+          <p:cNvPr id="67" name="TextBox 66"/>
+          <p:cNvSpPr txBox="1"/>
+          <p:nvPr/>
+        </p:nvSpPr>
+        <p:spPr>
+          <a:xfrm>
+            <a:off x="26433018" y="18885076"/>
+            <a:ext cx="3065526" cy="457200"/>
           </a:xfrm>
           <a:prstGeom prst="rect">
             <a:avLst/>
@@ -6608,7 +6714,7 @@
           <a:p>
             <a:pPr algn="r"/>
             <a:r>
-              <a:rPr sz="1800" b="0" i="0">
+              <a:rPr sz="1700" b="0" i="0">
                 <a:solidFill>
                   <a:srgbClr val="6F6F6F"/>
                 </a:solidFill>
@@ -6617,7 +6723,7 @@
               <a:t>.47→</a:t>
             </a:r>
             <a:r>
-              <a:rPr sz="2100" b="1" i="0">
+              <a:rPr sz="2000" b="1" i="0">
                 <a:solidFill>
                   <a:srgbClr val="0D4DA3"/>
                 </a:solidFill>
@@ -6626,7 +6732,7 @@
               <a:t>.63</a:t>
             </a:r>
             <a:r>
-              <a:rPr sz="1800" b="1" i="0">
+              <a:rPr sz="1700" b="1" i="0">
                 <a:solidFill>
                   <a:srgbClr val="0D4DA3"/>
                 </a:solidFill>
@@ -6639,7 +6745,7 @@
       </p:sp>
       <p:sp>
         <p:nvSpPr>
-          <p:cNvPr id="66" name="Rectangle 65"/>
+          <p:cNvPr id="68" name="Rectangle 67"/>
           <p:cNvSpPr/>
           <p:nvPr/>
         </p:nvSpPr>
@@ -6683,14 +6789,14 @@
       </p:sp>
       <p:sp>
         <p:nvSpPr>
-          <p:cNvPr id="67" name="TextBox 66"/>
+          <p:cNvPr id="69" name="TextBox 68"/>
           <p:cNvSpPr txBox="1"/>
           <p:nvPr/>
         </p:nvSpPr>
         <p:spPr>
           <a:xfrm>
             <a:off x="15457932" y="19342276"/>
-            <a:ext cx="777240" cy="457200"/>
+            <a:ext cx="685800" cy="457200"/>
           </a:xfrm>
           <a:prstGeom prst="rect">
             <a:avLst/>
@@ -6718,14 +6824,14 @@
       </p:sp>
       <p:sp>
         <p:nvSpPr>
-          <p:cNvPr id="68" name="TextBox 67"/>
-          <p:cNvSpPr txBox="1"/>
-          <p:nvPr/>
-        </p:nvSpPr>
-        <p:spPr>
-          <a:xfrm>
-            <a:off x="16235172" y="19342276"/>
-            <a:ext cx="2606040" cy="457200"/>
+          <p:cNvPr id="70" name="TextBox 69"/>
+          <p:cNvSpPr txBox="1"/>
+          <p:nvPr/>
+        </p:nvSpPr>
+        <p:spPr>
+          <a:xfrm>
+            <a:off x="16143732" y="19342276"/>
+            <a:ext cx="2377440" cy="457200"/>
           </a:xfrm>
           <a:prstGeom prst="rect">
             <a:avLst/>
@@ -6753,14 +6859,14 @@
       </p:sp>
       <p:sp>
         <p:nvSpPr>
-          <p:cNvPr id="69" name="TextBox 68"/>
-          <p:cNvSpPr txBox="1"/>
-          <p:nvPr/>
-        </p:nvSpPr>
-        <p:spPr>
-          <a:xfrm>
-            <a:off x="18841212" y="19342276"/>
-            <a:ext cx="1874519" cy="457200"/>
+          <p:cNvPr id="71" name="TextBox 70"/>
+          <p:cNvSpPr txBox="1"/>
+          <p:nvPr/>
+        </p:nvSpPr>
+        <p:spPr>
+          <a:xfrm>
+            <a:off x="18521172" y="19342276"/>
+            <a:ext cx="2423160" cy="457200"/>
           </a:xfrm>
           <a:prstGeom prst="rect">
             <a:avLst/>
@@ -6775,7 +6881,7 @@
           <a:p>
             <a:pPr algn="r"/>
             <a:r>
-              <a:rPr sz="1800" b="0" i="0">
+              <a:rPr sz="1700" b="0" i="0">
                 <a:solidFill>
                   <a:srgbClr val="6F6F6F"/>
                 </a:solidFill>
@@ -6784,7 +6890,7 @@
               <a:t>.40→</a:t>
             </a:r>
             <a:r>
-              <a:rPr sz="2100" b="1" i="0">
+              <a:rPr sz="2000" b="1" i="0">
                 <a:solidFill>
                   <a:srgbClr val="0D4DA3"/>
                 </a:solidFill>
@@ -6792,19 +6898,28 @@
               </a:rPr>
               <a:t>.46</a:t>
             </a:r>
-          </a:p>
-        </p:txBody>
-      </p:sp>
-      <p:sp>
-        <p:nvSpPr>
-          <p:cNvPr id="70" name="TextBox 69"/>
-          <p:cNvSpPr txBox="1"/>
-          <p:nvPr/>
-        </p:nvSpPr>
-        <p:spPr>
-          <a:xfrm>
-            <a:off x="20715731" y="19342276"/>
-            <a:ext cx="3454147" cy="457200"/>
+            <a:r>
+              <a:rPr sz="1700" b="1" i="0">
+                <a:solidFill>
+                  <a:srgbClr val="0D4DA3"/>
+                </a:solidFill>
+                <a:latin typeface="Times New Roman"/>
+              </a:rPr>
+              <a:t> +15%</a:t>
+            </a:r>
+          </a:p>
+        </p:txBody>
+      </p:sp>
+      <p:sp>
+        <p:nvSpPr>
+          <p:cNvPr id="72" name="TextBox 71"/>
+          <p:cNvSpPr txBox="1"/>
+          <p:nvPr/>
+        </p:nvSpPr>
+        <p:spPr>
+          <a:xfrm>
+            <a:off x="20944332" y="19342276"/>
+            <a:ext cx="3065526" cy="457200"/>
           </a:xfrm>
           <a:prstGeom prst="rect">
             <a:avLst/>
@@ -6819,7 +6934,7 @@
           <a:p>
             <a:pPr algn="r"/>
             <a:r>
-              <a:rPr sz="1800" b="0" i="0">
+              <a:rPr sz="1700" b="0" i="0">
                 <a:solidFill>
                   <a:srgbClr val="6F6F6F"/>
                 </a:solidFill>
@@ -6828,7 +6943,7 @@
               <a:t>.58→</a:t>
             </a:r>
             <a:r>
-              <a:rPr sz="2100" b="1" i="0">
+              <a:rPr sz="2000" b="1" i="0">
                 <a:solidFill>
                   <a:srgbClr val="0D4DA3"/>
                 </a:solidFill>
@@ -6837,7 +6952,7 @@
               <a:t>.63</a:t>
             </a:r>
             <a:r>
-              <a:rPr sz="1800" b="1" i="0">
+              <a:rPr sz="1700" b="1" i="0">
                 <a:solidFill>
                   <a:srgbClr val="0D4DA3"/>
                 </a:solidFill>
@@ -6850,14 +6965,14 @@
       </p:sp>
       <p:sp>
         <p:nvSpPr>
-          <p:cNvPr id="71" name="TextBox 70"/>
-          <p:cNvSpPr txBox="1"/>
-          <p:nvPr/>
-        </p:nvSpPr>
-        <p:spPr>
-          <a:xfrm>
-            <a:off x="24169878" y="19342276"/>
-            <a:ext cx="1874519" cy="457200"/>
+          <p:cNvPr id="73" name="TextBox 72"/>
+          <p:cNvSpPr txBox="1"/>
+          <p:nvPr/>
+        </p:nvSpPr>
+        <p:spPr>
+          <a:xfrm>
+            <a:off x="24009858" y="19342276"/>
+            <a:ext cx="2423160" cy="457200"/>
           </a:xfrm>
           <a:prstGeom prst="rect">
             <a:avLst/>
@@ -6872,7 +6987,7 @@
           <a:p>
             <a:pPr algn="r"/>
             <a:r>
-              <a:rPr sz="1800" b="0" i="0">
+              <a:rPr sz="1700" b="0" i="0">
                 <a:solidFill>
                   <a:srgbClr val="6F6F6F"/>
                 </a:solidFill>
@@ -6881,7 +6996,7 @@
               <a:t>.29→</a:t>
             </a:r>
             <a:r>
-              <a:rPr sz="2100" b="1" i="0">
+              <a:rPr sz="2000" b="1" i="0">
                 <a:solidFill>
                   <a:srgbClr val="0D4DA3"/>
                 </a:solidFill>
@@ -6889,19 +7004,28 @@
               </a:rPr>
               <a:t>.39</a:t>
             </a:r>
-          </a:p>
-        </p:txBody>
-      </p:sp>
-      <p:sp>
-        <p:nvSpPr>
-          <p:cNvPr id="72" name="TextBox 71"/>
-          <p:cNvSpPr txBox="1"/>
-          <p:nvPr/>
-        </p:nvSpPr>
-        <p:spPr>
-          <a:xfrm>
-            <a:off x="26044397" y="19342276"/>
-            <a:ext cx="3454147" cy="457200"/>
+            <a:r>
+              <a:rPr sz="1700" b="1" i="0">
+                <a:solidFill>
+                  <a:srgbClr val="0D4DA3"/>
+                </a:solidFill>
+                <a:latin typeface="Times New Roman"/>
+              </a:rPr>
+              <a:t> +34%</a:t>
+            </a:r>
+          </a:p>
+        </p:txBody>
+      </p:sp>
+      <p:sp>
+        <p:nvSpPr>
+          <p:cNvPr id="74" name="TextBox 73"/>
+          <p:cNvSpPr txBox="1"/>
+          <p:nvPr/>
+        </p:nvSpPr>
+        <p:spPr>
+          <a:xfrm>
+            <a:off x="26433018" y="19342276"/>
+            <a:ext cx="3065526" cy="457200"/>
           </a:xfrm>
           <a:prstGeom prst="rect">
             <a:avLst/>
@@ -6916,7 +7040,7 @@
           <a:p>
             <a:pPr algn="r"/>
             <a:r>
-              <a:rPr sz="1800" b="0" i="0">
+              <a:rPr sz="1700" b="0" i="0">
                 <a:solidFill>
                   <a:srgbClr val="6F6F6F"/>
                 </a:solidFill>
@@ -6925,7 +7049,7 @@
               <a:t>.50→</a:t>
             </a:r>
             <a:r>
-              <a:rPr sz="2100" b="1" i="0">
+              <a:rPr sz="2000" b="1" i="0">
                 <a:solidFill>
                   <a:srgbClr val="0D4DA3"/>
                 </a:solidFill>
@@ -6934,7 +7058,7 @@
               <a:t>.60</a:t>
             </a:r>
             <a:r>
-              <a:rPr sz="1800" b="1" i="0">
+              <a:rPr sz="1700" b="1" i="0">
                 <a:solidFill>
                   <a:srgbClr val="0D4DA3"/>
                 </a:solidFill>
@@ -6947,7 +7071,7 @@
       </p:sp>
       <p:sp>
         <p:nvSpPr>
-          <p:cNvPr id="73" name="Rectangle 72"/>
+          <p:cNvPr id="75" name="Rectangle 74"/>
           <p:cNvSpPr/>
           <p:nvPr/>
         </p:nvSpPr>
@@ -6991,14 +7115,14 @@
       </p:sp>
       <p:sp>
         <p:nvSpPr>
-          <p:cNvPr id="74" name="TextBox 73"/>
+          <p:cNvPr id="76" name="TextBox 75"/>
           <p:cNvSpPr txBox="1"/>
           <p:nvPr/>
         </p:nvSpPr>
         <p:spPr>
           <a:xfrm>
             <a:off x="15457932" y="19799476"/>
-            <a:ext cx="777240" cy="457200"/>
+            <a:ext cx="685800" cy="457200"/>
           </a:xfrm>
           <a:prstGeom prst="rect">
             <a:avLst/>
@@ -7026,14 +7150,14 @@
       </p:sp>
       <p:sp>
         <p:nvSpPr>
-          <p:cNvPr id="75" name="TextBox 74"/>
-          <p:cNvSpPr txBox="1"/>
-          <p:nvPr/>
-        </p:nvSpPr>
-        <p:spPr>
-          <a:xfrm>
-            <a:off x="16235172" y="19799476"/>
-            <a:ext cx="2606040" cy="457200"/>
+          <p:cNvPr id="77" name="TextBox 76"/>
+          <p:cNvSpPr txBox="1"/>
+          <p:nvPr/>
+        </p:nvSpPr>
+        <p:spPr>
+          <a:xfrm>
+            <a:off x="16143732" y="19799476"/>
+            <a:ext cx="2377440" cy="457200"/>
           </a:xfrm>
           <a:prstGeom prst="rect">
             <a:avLst/>
@@ -7061,14 +7185,14 @@
       </p:sp>
       <p:sp>
         <p:nvSpPr>
-          <p:cNvPr id="76" name="TextBox 75"/>
-          <p:cNvSpPr txBox="1"/>
-          <p:nvPr/>
-        </p:nvSpPr>
-        <p:spPr>
-          <a:xfrm>
-            <a:off x="18841212" y="19799476"/>
-            <a:ext cx="1874519" cy="457200"/>
+          <p:cNvPr id="78" name="TextBox 77"/>
+          <p:cNvSpPr txBox="1"/>
+          <p:nvPr/>
+        </p:nvSpPr>
+        <p:spPr>
+          <a:xfrm>
+            <a:off x="18521172" y="19799476"/>
+            <a:ext cx="2423160" cy="457200"/>
           </a:xfrm>
           <a:prstGeom prst="rect">
             <a:avLst/>
@@ -7083,7 +7207,7 @@
           <a:p>
             <a:pPr algn="r"/>
             <a:r>
-              <a:rPr sz="1800" b="0" i="0">
+              <a:rPr sz="1700" b="0" i="0">
                 <a:solidFill>
                   <a:srgbClr val="6F6F6F"/>
                 </a:solidFill>
@@ -7092,7 +7216,7 @@
               <a:t>.31→</a:t>
             </a:r>
             <a:r>
-              <a:rPr sz="2100" b="1" i="0">
+              <a:rPr sz="2000" b="1" i="0">
                 <a:solidFill>
                   <a:srgbClr val="0D4DA3"/>
                 </a:solidFill>
@@ -7100,19 +7224,28 @@
               </a:rPr>
               <a:t>.38</a:t>
             </a:r>
-          </a:p>
-        </p:txBody>
-      </p:sp>
-      <p:sp>
-        <p:nvSpPr>
-          <p:cNvPr id="77" name="TextBox 76"/>
-          <p:cNvSpPr txBox="1"/>
-          <p:nvPr/>
-        </p:nvSpPr>
-        <p:spPr>
-          <a:xfrm>
-            <a:off x="20715731" y="19799476"/>
-            <a:ext cx="3454147" cy="457200"/>
+            <a:r>
+              <a:rPr sz="1700" b="1" i="0">
+                <a:solidFill>
+                  <a:srgbClr val="0D4DA3"/>
+                </a:solidFill>
+                <a:latin typeface="Times New Roman"/>
+              </a:rPr>
+              <a:t> +23%</a:t>
+            </a:r>
+          </a:p>
+        </p:txBody>
+      </p:sp>
+      <p:sp>
+        <p:nvSpPr>
+          <p:cNvPr id="79" name="TextBox 78"/>
+          <p:cNvSpPr txBox="1"/>
+          <p:nvPr/>
+        </p:nvSpPr>
+        <p:spPr>
+          <a:xfrm>
+            <a:off x="20944332" y="19799476"/>
+            <a:ext cx="3065526" cy="457200"/>
           </a:xfrm>
           <a:prstGeom prst="rect">
             <a:avLst/>
@@ -7127,7 +7260,7 @@
           <a:p>
             <a:pPr algn="r"/>
             <a:r>
-              <a:rPr sz="1800" b="0" i="0">
+              <a:rPr sz="1700" b="0" i="0">
                 <a:solidFill>
                   <a:srgbClr val="6F6F6F"/>
                 </a:solidFill>
@@ -7136,7 +7269,7 @@
               <a:t>.41→</a:t>
             </a:r>
             <a:r>
-              <a:rPr sz="2100" b="1" i="0">
+              <a:rPr sz="2000" b="1" i="0">
                 <a:solidFill>
                   <a:srgbClr val="0D4DA3"/>
                 </a:solidFill>
@@ -7145,7 +7278,7 @@
               <a:t>.48</a:t>
             </a:r>
             <a:r>
-              <a:rPr sz="1800" b="1" i="0">
+              <a:rPr sz="1700" b="1" i="0">
                 <a:solidFill>
                   <a:srgbClr val="0D4DA3"/>
                 </a:solidFill>
@@ -7158,14 +7291,14 @@
       </p:sp>
       <p:sp>
         <p:nvSpPr>
-          <p:cNvPr id="78" name="TextBox 77"/>
-          <p:cNvSpPr txBox="1"/>
-          <p:nvPr/>
-        </p:nvSpPr>
-        <p:spPr>
-          <a:xfrm>
-            <a:off x="24169878" y="19799476"/>
-            <a:ext cx="1874519" cy="457200"/>
+          <p:cNvPr id="80" name="TextBox 79"/>
+          <p:cNvSpPr txBox="1"/>
+          <p:nvPr/>
+        </p:nvSpPr>
+        <p:spPr>
+          <a:xfrm>
+            <a:off x="24009858" y="19799476"/>
+            <a:ext cx="2423160" cy="457200"/>
           </a:xfrm>
           <a:prstGeom prst="rect">
             <a:avLst/>
@@ -7180,7 +7313,7 @@
           <a:p>
             <a:pPr algn="r"/>
             <a:r>
-              <a:rPr sz="1800" b="0" i="0">
+              <a:rPr sz="1700" b="0" i="0">
                 <a:solidFill>
                   <a:srgbClr val="6F6F6F"/>
                 </a:solidFill>
@@ -7189,7 +7322,7 @@
               <a:t>.22→</a:t>
             </a:r>
             <a:r>
-              <a:rPr sz="2100" b="1" i="0">
+              <a:rPr sz="2000" b="1" i="0">
                 <a:solidFill>
                   <a:srgbClr val="0D4DA3"/>
                 </a:solidFill>
@@ -7197,19 +7330,28 @@
               </a:rPr>
               <a:t>.38</a:t>
             </a:r>
-          </a:p>
-        </p:txBody>
-      </p:sp>
-      <p:sp>
-        <p:nvSpPr>
-          <p:cNvPr id="79" name="TextBox 78"/>
-          <p:cNvSpPr txBox="1"/>
-          <p:nvPr/>
-        </p:nvSpPr>
-        <p:spPr>
-          <a:xfrm>
-            <a:off x="26044397" y="19799476"/>
-            <a:ext cx="3454147" cy="457200"/>
+            <a:r>
+              <a:rPr sz="1700" b="1" i="0">
+                <a:solidFill>
+                  <a:srgbClr val="0D4DA3"/>
+                </a:solidFill>
+                <a:latin typeface="Times New Roman"/>
+              </a:rPr>
+              <a:t> +73%</a:t>
+            </a:r>
+          </a:p>
+        </p:txBody>
+      </p:sp>
+      <p:sp>
+        <p:nvSpPr>
+          <p:cNvPr id="81" name="TextBox 80"/>
+          <p:cNvSpPr txBox="1"/>
+          <p:nvPr/>
+        </p:nvSpPr>
+        <p:spPr>
+          <a:xfrm>
+            <a:off x="26433018" y="19799476"/>
+            <a:ext cx="3065526" cy="457200"/>
           </a:xfrm>
           <a:prstGeom prst="rect">
             <a:avLst/>
@@ -7224,7 +7366,7 @@
           <a:p>
             <a:pPr algn="r"/>
             <a:r>
-              <a:rPr sz="1800" b="0" i="0">
+              <a:rPr sz="1700" b="0" i="0">
                 <a:solidFill>
                   <a:srgbClr val="6F6F6F"/>
                 </a:solidFill>
@@ -7233,7 +7375,7 @@
               <a:t>.33→</a:t>
             </a:r>
             <a:r>
-              <a:rPr sz="2100" b="1" i="0">
+              <a:rPr sz="2000" b="1" i="0">
                 <a:solidFill>
                   <a:srgbClr val="0D4DA3"/>
                 </a:solidFill>
@@ -7242,7 +7384,7 @@
               <a:t>.48</a:t>
             </a:r>
             <a:r>
-              <a:rPr sz="1800" b="1" i="0">
+              <a:rPr sz="1700" b="1" i="0">
                 <a:solidFill>
                   <a:srgbClr val="0D4DA3"/>
                 </a:solidFill>
@@ -7255,7 +7397,7 @@
       </p:sp>
       <p:sp>
         <p:nvSpPr>
-          <p:cNvPr id="80" name="Rectangle 79"/>
+          <p:cNvPr id="82" name="Rectangle 81"/>
           <p:cNvSpPr/>
           <p:nvPr/>
         </p:nvSpPr>
@@ -7299,14 +7441,14 @@
       </p:sp>
       <p:sp>
         <p:nvSpPr>
-          <p:cNvPr id="81" name="TextBox 80"/>
+          <p:cNvPr id="83" name="TextBox 82"/>
           <p:cNvSpPr txBox="1"/>
           <p:nvPr/>
         </p:nvSpPr>
         <p:spPr>
           <a:xfrm>
             <a:off x="15457932" y="20256676"/>
-            <a:ext cx="777240" cy="457200"/>
+            <a:ext cx="685800" cy="457200"/>
           </a:xfrm>
           <a:prstGeom prst="rect">
             <a:avLst/>
@@ -7334,14 +7476,14 @@
       </p:sp>
       <p:sp>
         <p:nvSpPr>
-          <p:cNvPr id="82" name="TextBox 81"/>
-          <p:cNvSpPr txBox="1"/>
-          <p:nvPr/>
-        </p:nvSpPr>
-        <p:spPr>
-          <a:xfrm>
-            <a:off x="16235172" y="20256676"/>
-            <a:ext cx="2606040" cy="457200"/>
+          <p:cNvPr id="84" name="TextBox 83"/>
+          <p:cNvSpPr txBox="1"/>
+          <p:nvPr/>
+        </p:nvSpPr>
+        <p:spPr>
+          <a:xfrm>
+            <a:off x="16143732" y="20256676"/>
+            <a:ext cx="2377440" cy="457200"/>
           </a:xfrm>
           <a:prstGeom prst="rect">
             <a:avLst/>
@@ -7369,14 +7511,14 @@
       </p:sp>
       <p:sp>
         <p:nvSpPr>
-          <p:cNvPr id="83" name="TextBox 82"/>
-          <p:cNvSpPr txBox="1"/>
-          <p:nvPr/>
-        </p:nvSpPr>
-        <p:spPr>
-          <a:xfrm>
-            <a:off x="18841212" y="20256676"/>
-            <a:ext cx="1874519" cy="457200"/>
+          <p:cNvPr id="85" name="TextBox 84"/>
+          <p:cNvSpPr txBox="1"/>
+          <p:nvPr/>
+        </p:nvSpPr>
+        <p:spPr>
+          <a:xfrm>
+            <a:off x="18521172" y="20256676"/>
+            <a:ext cx="2423160" cy="457200"/>
           </a:xfrm>
           <a:prstGeom prst="rect">
             <a:avLst/>
@@ -7391,7 +7533,7 @@
           <a:p>
             <a:pPr algn="r"/>
             <a:r>
-              <a:rPr sz="1800" b="0" i="0">
+              <a:rPr sz="1700" b="0" i="0">
                 <a:solidFill>
                   <a:srgbClr val="6F6F6F"/>
                 </a:solidFill>
@@ -7400,7 +7542,7 @@
               <a:t>.075→</a:t>
             </a:r>
             <a:r>
-              <a:rPr sz="2100" b="1" i="0">
+              <a:rPr sz="2000" b="1" i="0">
                 <a:solidFill>
                   <a:srgbClr val="0D4DA3"/>
                 </a:solidFill>
@@ -7408,19 +7550,28 @@
               </a:rPr>
               <a:t>.086</a:t>
             </a:r>
-          </a:p>
-        </p:txBody>
-      </p:sp>
-      <p:sp>
-        <p:nvSpPr>
-          <p:cNvPr id="84" name="TextBox 83"/>
-          <p:cNvSpPr txBox="1"/>
-          <p:nvPr/>
-        </p:nvSpPr>
-        <p:spPr>
-          <a:xfrm>
-            <a:off x="20715731" y="20256676"/>
-            <a:ext cx="3454147" cy="457200"/>
+            <a:r>
+              <a:rPr sz="1700" b="1" i="0">
+                <a:solidFill>
+                  <a:srgbClr val="0D4DA3"/>
+                </a:solidFill>
+                <a:latin typeface="Times New Roman"/>
+              </a:rPr>
+              <a:t> +15%</a:t>
+            </a:r>
+          </a:p>
+        </p:txBody>
+      </p:sp>
+      <p:sp>
+        <p:nvSpPr>
+          <p:cNvPr id="86" name="TextBox 85"/>
+          <p:cNvSpPr txBox="1"/>
+          <p:nvPr/>
+        </p:nvSpPr>
+        <p:spPr>
+          <a:xfrm>
+            <a:off x="20944332" y="20256676"/>
+            <a:ext cx="3065526" cy="457200"/>
           </a:xfrm>
           <a:prstGeom prst="rect">
             <a:avLst/>
@@ -7435,7 +7586,7 @@
           <a:p>
             <a:pPr algn="r"/>
             <a:r>
-              <a:rPr sz="1800" b="0" i="0">
+              <a:rPr sz="1700" b="0" i="0">
                 <a:solidFill>
                   <a:srgbClr val="6F6F6F"/>
                 </a:solidFill>
@@ -7444,7 +7595,7 @@
               <a:t>.108→</a:t>
             </a:r>
             <a:r>
-              <a:rPr sz="2100" b="1" i="0">
+              <a:rPr sz="2000" b="1" i="0">
                 <a:solidFill>
                   <a:srgbClr val="0D4DA3"/>
                 </a:solidFill>
@@ -7453,7 +7604,7 @@
               <a:t>.143</a:t>
             </a:r>
             <a:r>
-              <a:rPr sz="1800" b="1" i="0">
+              <a:rPr sz="1700" b="1" i="0">
                 <a:solidFill>
                   <a:srgbClr val="0D4DA3"/>
                 </a:solidFill>
@@ -7466,14 +7617,14 @@
       </p:sp>
       <p:sp>
         <p:nvSpPr>
-          <p:cNvPr id="85" name="TextBox 84"/>
-          <p:cNvSpPr txBox="1"/>
-          <p:nvPr/>
-        </p:nvSpPr>
-        <p:spPr>
-          <a:xfrm>
-            <a:off x="24169878" y="20256676"/>
-            <a:ext cx="1874519" cy="457200"/>
+          <p:cNvPr id="87" name="TextBox 86"/>
+          <p:cNvSpPr txBox="1"/>
+          <p:nvPr/>
+        </p:nvSpPr>
+        <p:spPr>
+          <a:xfrm>
+            <a:off x="24009858" y="20256676"/>
+            <a:ext cx="2423160" cy="457200"/>
           </a:xfrm>
           <a:prstGeom prst="rect">
             <a:avLst/>
@@ -7488,7 +7639,7 @@
           <a:p>
             <a:pPr algn="r"/>
             <a:r>
-              <a:rPr sz="1800" b="0" i="0">
+              <a:rPr sz="1700" b="0" i="0">
                 <a:solidFill>
                   <a:srgbClr val="6F6F6F"/>
                 </a:solidFill>
@@ -7497,7 +7648,7 @@
               <a:t>.035→</a:t>
             </a:r>
             <a:r>
-              <a:rPr sz="2100" b="1" i="0">
+              <a:rPr sz="2000" b="1" i="0">
                 <a:solidFill>
                   <a:srgbClr val="0D4DA3"/>
                 </a:solidFill>
@@ -7505,19 +7656,28 @@
               </a:rPr>
               <a:t>.048</a:t>
             </a:r>
-          </a:p>
-        </p:txBody>
-      </p:sp>
-      <p:sp>
-        <p:nvSpPr>
-          <p:cNvPr id="86" name="TextBox 85"/>
-          <p:cNvSpPr txBox="1"/>
-          <p:nvPr/>
-        </p:nvSpPr>
-        <p:spPr>
-          <a:xfrm>
-            <a:off x="26044397" y="20256676"/>
-            <a:ext cx="3454147" cy="457200"/>
+            <a:r>
+              <a:rPr sz="1700" b="1" i="0">
+                <a:solidFill>
+                  <a:srgbClr val="0D4DA3"/>
+                </a:solidFill>
+                <a:latin typeface="Times New Roman"/>
+              </a:rPr>
+              <a:t> +37%</a:t>
+            </a:r>
+          </a:p>
+        </p:txBody>
+      </p:sp>
+      <p:sp>
+        <p:nvSpPr>
+          <p:cNvPr id="88" name="TextBox 87"/>
+          <p:cNvSpPr txBox="1"/>
+          <p:nvPr/>
+        </p:nvSpPr>
+        <p:spPr>
+          <a:xfrm>
+            <a:off x="26433018" y="20256676"/>
+            <a:ext cx="3065526" cy="457200"/>
           </a:xfrm>
           <a:prstGeom prst="rect">
             <a:avLst/>
@@ -7532,7 +7692,7 @@
           <a:p>
             <a:pPr algn="r"/>
             <a:r>
-              <a:rPr sz="1800" b="0" i="0">
+              <a:rPr sz="1700" b="0" i="0">
                 <a:solidFill>
                   <a:srgbClr val="6F6F6F"/>
                 </a:solidFill>
@@ -7541,7 +7701,7 @@
               <a:t>.069→</a:t>
             </a:r>
             <a:r>
-              <a:rPr sz="2100" b="1" i="0">
+              <a:rPr sz="2000" b="1" i="0">
                 <a:solidFill>
                   <a:srgbClr val="0D4DA3"/>
                 </a:solidFill>
@@ -7550,7 +7710,7 @@
               <a:t>.073</a:t>
             </a:r>
             <a:r>
-              <a:rPr sz="1800" b="1" i="0">
+              <a:rPr sz="1700" b="1" i="0">
                 <a:solidFill>
                   <a:srgbClr val="0D4DA3"/>
                 </a:solidFill>
@@ -7563,7 +7723,7 @@
       </p:sp>
       <p:sp>
         <p:nvSpPr>
-          <p:cNvPr id="87" name="Rectangle 86"/>
+          <p:cNvPr id="89" name="Rectangle 88"/>
           <p:cNvSpPr/>
           <p:nvPr/>
         </p:nvSpPr>
@@ -7607,14 +7767,14 @@
       </p:sp>
       <p:sp>
         <p:nvSpPr>
-          <p:cNvPr id="88" name="TextBox 87"/>
+          <p:cNvPr id="90" name="TextBox 89"/>
           <p:cNvSpPr txBox="1"/>
           <p:nvPr/>
         </p:nvSpPr>
         <p:spPr>
           <a:xfrm>
             <a:off x="15457932" y="20713876"/>
-            <a:ext cx="777240" cy="457200"/>
+            <a:ext cx="685800" cy="457200"/>
           </a:xfrm>
           <a:prstGeom prst="rect">
             <a:avLst/>
@@ -7642,14 +7802,14 @@
       </p:sp>
       <p:sp>
         <p:nvSpPr>
-          <p:cNvPr id="89" name="TextBox 88"/>
-          <p:cNvSpPr txBox="1"/>
-          <p:nvPr/>
-        </p:nvSpPr>
-        <p:spPr>
-          <a:xfrm>
-            <a:off x="16235172" y="20713876"/>
-            <a:ext cx="2606040" cy="457200"/>
+          <p:cNvPr id="91" name="TextBox 90"/>
+          <p:cNvSpPr txBox="1"/>
+          <p:nvPr/>
+        </p:nvSpPr>
+        <p:spPr>
+          <a:xfrm>
+            <a:off x="16143732" y="20713876"/>
+            <a:ext cx="2377440" cy="457200"/>
           </a:xfrm>
           <a:prstGeom prst="rect">
             <a:avLst/>
@@ -7677,14 +7837,14 @@
       </p:sp>
       <p:sp>
         <p:nvSpPr>
-          <p:cNvPr id="90" name="TextBox 89"/>
-          <p:cNvSpPr txBox="1"/>
-          <p:nvPr/>
-        </p:nvSpPr>
-        <p:spPr>
-          <a:xfrm>
-            <a:off x="18841212" y="20713876"/>
-            <a:ext cx="1874519" cy="457200"/>
+          <p:cNvPr id="92" name="TextBox 91"/>
+          <p:cNvSpPr txBox="1"/>
+          <p:nvPr/>
+        </p:nvSpPr>
+        <p:spPr>
+          <a:xfrm>
+            <a:off x="18521172" y="20713876"/>
+            <a:ext cx="2423160" cy="457200"/>
           </a:xfrm>
           <a:prstGeom prst="rect">
             <a:avLst/>
@@ -7699,7 +7859,7 @@
           <a:p>
             <a:pPr algn="r"/>
             <a:r>
-              <a:rPr sz="1800" b="0" i="0">
+              <a:rPr sz="1700" b="0" i="0">
                 <a:solidFill>
                   <a:srgbClr val="6F6F6F"/>
                 </a:solidFill>
@@ -7708,7 +7868,7 @@
               <a:t>.55→</a:t>
             </a:r>
             <a:r>
-              <a:rPr sz="2100" b="1" i="0">
+              <a:rPr sz="2000" b="1" i="0">
                 <a:solidFill>
                   <a:srgbClr val="0D4DA3"/>
                 </a:solidFill>
@@ -7716,19 +7876,28 @@
               </a:rPr>
               <a:t>.63</a:t>
             </a:r>
-          </a:p>
-        </p:txBody>
-      </p:sp>
-      <p:sp>
-        <p:nvSpPr>
-          <p:cNvPr id="91" name="TextBox 90"/>
-          <p:cNvSpPr txBox="1"/>
-          <p:nvPr/>
-        </p:nvSpPr>
-        <p:spPr>
-          <a:xfrm>
-            <a:off x="20715731" y="20713876"/>
-            <a:ext cx="3454147" cy="457200"/>
+            <a:r>
+              <a:rPr sz="1700" b="1" i="0">
+                <a:solidFill>
+                  <a:srgbClr val="0D4DA3"/>
+                </a:solidFill>
+                <a:latin typeface="Times New Roman"/>
+              </a:rPr>
+              <a:t> +15%</a:t>
+            </a:r>
+          </a:p>
+        </p:txBody>
+      </p:sp>
+      <p:sp>
+        <p:nvSpPr>
+          <p:cNvPr id="93" name="TextBox 92"/>
+          <p:cNvSpPr txBox="1"/>
+          <p:nvPr/>
+        </p:nvSpPr>
+        <p:spPr>
+          <a:xfrm>
+            <a:off x="20944332" y="20713876"/>
+            <a:ext cx="3065526" cy="457200"/>
           </a:xfrm>
           <a:prstGeom prst="rect">
             <a:avLst/>
@@ -7743,7 +7912,7 @@
           <a:p>
             <a:pPr algn="r"/>
             <a:r>
-              <a:rPr sz="1800" b="0" i="0">
+              <a:rPr sz="1700" b="0" i="0">
                 <a:solidFill>
                   <a:srgbClr val="6F6F6F"/>
                 </a:solidFill>
@@ -7752,7 +7921,7 @@
               <a:t>.67→</a:t>
             </a:r>
             <a:r>
-              <a:rPr sz="2100" b="1" i="0">
+              <a:rPr sz="2000" b="1" i="0">
                 <a:solidFill>
                   <a:srgbClr val="0D4DA3"/>
                 </a:solidFill>
@@ -7761,7 +7930,7 @@
               <a:t>.75</a:t>
             </a:r>
             <a:r>
-              <a:rPr sz="1800" b="1" i="0">
+              <a:rPr sz="1700" b="1" i="0">
                 <a:solidFill>
                   <a:srgbClr val="0D4DA3"/>
                 </a:solidFill>
@@ -7774,14 +7943,14 @@
       </p:sp>
       <p:sp>
         <p:nvSpPr>
-          <p:cNvPr id="92" name="TextBox 91"/>
-          <p:cNvSpPr txBox="1"/>
-          <p:nvPr/>
-        </p:nvSpPr>
-        <p:spPr>
-          <a:xfrm>
-            <a:off x="24169878" y="20713876"/>
-            <a:ext cx="1874519" cy="457200"/>
+          <p:cNvPr id="94" name="TextBox 93"/>
+          <p:cNvSpPr txBox="1"/>
+          <p:nvPr/>
+        </p:nvSpPr>
+        <p:spPr>
+          <a:xfrm>
+            <a:off x="24009858" y="20713876"/>
+            <a:ext cx="2423160" cy="457200"/>
           </a:xfrm>
           <a:prstGeom prst="rect">
             <a:avLst/>
@@ -7796,7 +7965,7 @@
           <a:p>
             <a:pPr algn="r"/>
             <a:r>
-              <a:rPr sz="1800" b="0" i="0">
+              <a:rPr sz="1700" b="0" i="0">
                 <a:solidFill>
                   <a:srgbClr val="6F6F6F"/>
                 </a:solidFill>
@@ -7805,7 +7974,7 @@
               <a:t>.57→</a:t>
             </a:r>
             <a:r>
-              <a:rPr sz="2100" b="1" i="0">
+              <a:rPr sz="2000" b="1" i="0">
                 <a:solidFill>
                   <a:srgbClr val="0D4DA3"/>
                 </a:solidFill>
@@ -7813,19 +7982,28 @@
               </a:rPr>
               <a:t>.64</a:t>
             </a:r>
-          </a:p>
-        </p:txBody>
-      </p:sp>
-      <p:sp>
-        <p:nvSpPr>
-          <p:cNvPr id="93" name="TextBox 92"/>
-          <p:cNvSpPr txBox="1"/>
-          <p:nvPr/>
-        </p:nvSpPr>
-        <p:spPr>
-          <a:xfrm>
-            <a:off x="26044397" y="20713876"/>
-            <a:ext cx="3454147" cy="457200"/>
+            <a:r>
+              <a:rPr sz="1700" b="1" i="0">
+                <a:solidFill>
+                  <a:srgbClr val="0D4DA3"/>
+                </a:solidFill>
+                <a:latin typeface="Times New Roman"/>
+              </a:rPr>
+              <a:t> +12%</a:t>
+            </a:r>
+          </a:p>
+        </p:txBody>
+      </p:sp>
+      <p:sp>
+        <p:nvSpPr>
+          <p:cNvPr id="95" name="TextBox 94"/>
+          <p:cNvSpPr txBox="1"/>
+          <p:nvPr/>
+        </p:nvSpPr>
+        <p:spPr>
+          <a:xfrm>
+            <a:off x="26433018" y="20713876"/>
+            <a:ext cx="3065526" cy="457200"/>
           </a:xfrm>
           <a:prstGeom prst="rect">
             <a:avLst/>
@@ -7840,7 +8018,7 @@
           <a:p>
             <a:pPr algn="r"/>
             <a:r>
-              <a:rPr sz="1800" b="0" i="0">
+              <a:rPr sz="1700" b="0" i="0">
                 <a:solidFill>
                   <a:srgbClr val="6F6F6F"/>
                 </a:solidFill>
@@ -7849,7 +8027,7 @@
               <a:t>.71→</a:t>
             </a:r>
             <a:r>
-              <a:rPr sz="2100" b="1" i="0">
+              <a:rPr sz="2000" b="1" i="0">
                 <a:solidFill>
                   <a:srgbClr val="0D4DA3"/>
                 </a:solidFill>
@@ -7858,7 +8036,7 @@
               <a:t>.75</a:t>
             </a:r>
             <a:r>
-              <a:rPr sz="1800" b="1" i="0">
+              <a:rPr sz="1700" b="1" i="0">
                 <a:solidFill>
                   <a:srgbClr val="0D4DA3"/>
                 </a:solidFill>
@@ -7871,7 +8049,7 @@
       </p:sp>
       <p:sp>
         <p:nvSpPr>
-          <p:cNvPr id="94" name="Rectangle 93"/>
+          <p:cNvPr id="96" name="Rectangle 95"/>
           <p:cNvSpPr/>
           <p:nvPr/>
         </p:nvSpPr>
@@ -7915,14 +8093,14 @@
       </p:sp>
       <p:sp>
         <p:nvSpPr>
-          <p:cNvPr id="95" name="TextBox 94"/>
+          <p:cNvPr id="97" name="TextBox 96"/>
           <p:cNvSpPr txBox="1"/>
           <p:nvPr/>
         </p:nvSpPr>
         <p:spPr>
           <a:xfrm>
             <a:off x="15457932" y="21171076"/>
-            <a:ext cx="777240" cy="457200"/>
+            <a:ext cx="685800" cy="457200"/>
           </a:xfrm>
           <a:prstGeom prst="rect">
             <a:avLst/>
@@ -7950,14 +8128,14 @@
       </p:sp>
       <p:sp>
         <p:nvSpPr>
-          <p:cNvPr id="96" name="TextBox 95"/>
-          <p:cNvSpPr txBox="1"/>
-          <p:nvPr/>
-        </p:nvSpPr>
-        <p:spPr>
-          <a:xfrm>
-            <a:off x="16235172" y="21171076"/>
-            <a:ext cx="2606040" cy="457200"/>
+          <p:cNvPr id="98" name="TextBox 97"/>
+          <p:cNvSpPr txBox="1"/>
+          <p:nvPr/>
+        </p:nvSpPr>
+        <p:spPr>
+          <a:xfrm>
+            <a:off x="16143732" y="21171076"/>
+            <a:ext cx="2377440" cy="457200"/>
           </a:xfrm>
           <a:prstGeom prst="rect">
             <a:avLst/>
@@ -7985,14 +8163,14 @@
       </p:sp>
       <p:sp>
         <p:nvSpPr>
-          <p:cNvPr id="97" name="TextBox 96"/>
-          <p:cNvSpPr txBox="1"/>
-          <p:nvPr/>
-        </p:nvSpPr>
-        <p:spPr>
-          <a:xfrm>
-            <a:off x="18841212" y="21171076"/>
-            <a:ext cx="1874519" cy="457200"/>
+          <p:cNvPr id="99" name="TextBox 98"/>
+          <p:cNvSpPr txBox="1"/>
+          <p:nvPr/>
+        </p:nvSpPr>
+        <p:spPr>
+          <a:xfrm>
+            <a:off x="18521172" y="21171076"/>
+            <a:ext cx="2423160" cy="457200"/>
           </a:xfrm>
           <a:prstGeom prst="rect">
             <a:avLst/>
@@ -8007,7 +8185,7 @@
           <a:p>
             <a:pPr algn="r"/>
             <a:r>
-              <a:rPr sz="1800" b="0" i="0">
+              <a:rPr sz="1700" b="0" i="0">
                 <a:solidFill>
                   <a:srgbClr val="6F6F6F"/>
                 </a:solidFill>
@@ -8016,7 +8194,7 @@
               <a:t>.59→</a:t>
             </a:r>
             <a:r>
-              <a:rPr sz="2100" b="1" i="0">
+              <a:rPr sz="2000" b="1" i="0">
                 <a:solidFill>
                   <a:srgbClr val="0D4DA3"/>
                 </a:solidFill>
@@ -8024,19 +8202,28 @@
               </a:rPr>
               <a:t>.60</a:t>
             </a:r>
-          </a:p>
-        </p:txBody>
-      </p:sp>
-      <p:sp>
-        <p:nvSpPr>
-          <p:cNvPr id="98" name="TextBox 97"/>
-          <p:cNvSpPr txBox="1"/>
-          <p:nvPr/>
-        </p:nvSpPr>
-        <p:spPr>
-          <a:xfrm>
-            <a:off x="20715731" y="21171076"/>
-            <a:ext cx="3454147" cy="457200"/>
+            <a:r>
+              <a:rPr sz="1700" b="1" i="0">
+                <a:solidFill>
+                  <a:srgbClr val="0D4DA3"/>
+                </a:solidFill>
+                <a:latin typeface="Times New Roman"/>
+              </a:rPr>
+              <a:t> +2%</a:t>
+            </a:r>
+          </a:p>
+        </p:txBody>
+      </p:sp>
+      <p:sp>
+        <p:nvSpPr>
+          <p:cNvPr id="100" name="TextBox 99"/>
+          <p:cNvSpPr txBox="1"/>
+          <p:nvPr/>
+        </p:nvSpPr>
+        <p:spPr>
+          <a:xfrm>
+            <a:off x="20944332" y="21171076"/>
+            <a:ext cx="3065526" cy="457200"/>
           </a:xfrm>
           <a:prstGeom prst="rect">
             <a:avLst/>
@@ -8051,7 +8238,7 @@
           <a:p>
             <a:pPr algn="r"/>
             <a:r>
-              <a:rPr sz="1800" b="0" i="0">
+              <a:rPr sz="1700" b="0" i="0">
                 <a:solidFill>
                   <a:srgbClr val="6F6F6F"/>
                 </a:solidFill>
@@ -8060,7 +8247,7 @@
               <a:t>.72→</a:t>
             </a:r>
             <a:r>
-              <a:rPr sz="2100" b="1" i="0">
+              <a:rPr sz="2000" b="1" i="0">
                 <a:solidFill>
                   <a:srgbClr val="0D4DA3"/>
                 </a:solidFill>
@@ -8069,7 +8256,7 @@
               <a:t>.73</a:t>
             </a:r>
             <a:r>
-              <a:rPr sz="1800" b="1" i="0">
+              <a:rPr sz="1700" b="1" i="0">
                 <a:solidFill>
                   <a:srgbClr val="0D4DA3"/>
                 </a:solidFill>
@@ -8082,14 +8269,14 @@
       </p:sp>
       <p:sp>
         <p:nvSpPr>
-          <p:cNvPr id="99" name="TextBox 98"/>
-          <p:cNvSpPr txBox="1"/>
-          <p:nvPr/>
-        </p:nvSpPr>
-        <p:spPr>
-          <a:xfrm>
-            <a:off x="24169878" y="21171076"/>
-            <a:ext cx="1874519" cy="457200"/>
+          <p:cNvPr id="101" name="TextBox 100"/>
+          <p:cNvSpPr txBox="1"/>
+          <p:nvPr/>
+        </p:nvSpPr>
+        <p:spPr>
+          <a:xfrm>
+            <a:off x="24009858" y="21171076"/>
+            <a:ext cx="2423160" cy="457200"/>
           </a:xfrm>
           <a:prstGeom prst="rect">
             <a:avLst/>
@@ -8104,7 +8291,7 @@
           <a:p>
             <a:pPr algn="r"/>
             <a:r>
-              <a:rPr sz="1800" b="0" i="0">
+              <a:rPr sz="1700" b="0" i="0">
                 <a:solidFill>
                   <a:srgbClr val="6F6F6F"/>
                 </a:solidFill>
@@ -8113,7 +8300,7 @@
               <a:t>.48→</a:t>
             </a:r>
             <a:r>
-              <a:rPr sz="2100" b="1" i="0">
+              <a:rPr sz="2000" b="1" i="0">
                 <a:solidFill>
                   <a:srgbClr val="0D4DA3"/>
                 </a:solidFill>
@@ -8121,19 +8308,28 @@
               </a:rPr>
               <a:t>.54</a:t>
             </a:r>
-          </a:p>
-        </p:txBody>
-      </p:sp>
-      <p:sp>
-        <p:nvSpPr>
-          <p:cNvPr id="100" name="TextBox 99"/>
-          <p:cNvSpPr txBox="1"/>
-          <p:nvPr/>
-        </p:nvSpPr>
-        <p:spPr>
-          <a:xfrm>
-            <a:off x="26044397" y="21171076"/>
-            <a:ext cx="3454147" cy="457200"/>
+            <a:r>
+              <a:rPr sz="1700" b="1" i="0">
+                <a:solidFill>
+                  <a:srgbClr val="0D4DA3"/>
+                </a:solidFill>
+                <a:latin typeface="Times New Roman"/>
+              </a:rPr>
+              <a:t> +13%</a:t>
+            </a:r>
+          </a:p>
+        </p:txBody>
+      </p:sp>
+      <p:sp>
+        <p:nvSpPr>
+          <p:cNvPr id="102" name="TextBox 101"/>
+          <p:cNvSpPr txBox="1"/>
+          <p:nvPr/>
+        </p:nvSpPr>
+        <p:spPr>
+          <a:xfrm>
+            <a:off x="26433018" y="21171076"/>
+            <a:ext cx="3065526" cy="457200"/>
           </a:xfrm>
           <a:prstGeom prst="rect">
             <a:avLst/>
@@ -8148,7 +8344,7 @@
           <a:p>
             <a:pPr algn="r"/>
             <a:r>
-              <a:rPr sz="1800" b="0" i="0">
+              <a:rPr sz="1700" b="0" i="0">
                 <a:solidFill>
                   <a:srgbClr val="6F6F6F"/>
                 </a:solidFill>
@@ -8157,7 +8353,7 @@
               <a:t>.62→</a:t>
             </a:r>
             <a:r>
-              <a:rPr sz="2100" b="1" i="0">
+              <a:rPr sz="2000" b="1" i="0">
                 <a:solidFill>
                   <a:srgbClr val="0D4DA3"/>
                 </a:solidFill>
@@ -8166,7 +8362,7 @@
               <a:t>.69</a:t>
             </a:r>
             <a:r>
-              <a:rPr sz="1800" b="1" i="0">
+              <a:rPr sz="1700" b="1" i="0">
                 <a:solidFill>
                   <a:srgbClr val="0D4DA3"/>
                 </a:solidFill>
@@ -8179,7 +8375,7 @@
       </p:sp>
       <p:sp>
         <p:nvSpPr>
-          <p:cNvPr id="101" name="Rectangle 100"/>
+          <p:cNvPr id="103" name="Rectangle 102"/>
           <p:cNvSpPr/>
           <p:nvPr/>
         </p:nvSpPr>
@@ -8223,14 +8419,14 @@
       </p:sp>
       <p:sp>
         <p:nvSpPr>
-          <p:cNvPr id="102" name="TextBox 101"/>
+          <p:cNvPr id="104" name="TextBox 103"/>
           <p:cNvSpPr txBox="1"/>
           <p:nvPr/>
         </p:nvSpPr>
         <p:spPr>
           <a:xfrm>
             <a:off x="15457932" y="21628276"/>
-            <a:ext cx="777240" cy="457200"/>
+            <a:ext cx="685800" cy="457200"/>
           </a:xfrm>
           <a:prstGeom prst="rect">
             <a:avLst/>
@@ -8258,14 +8454,14 @@
       </p:sp>
       <p:sp>
         <p:nvSpPr>
-          <p:cNvPr id="103" name="TextBox 102"/>
-          <p:cNvSpPr txBox="1"/>
-          <p:nvPr/>
-        </p:nvSpPr>
-        <p:spPr>
-          <a:xfrm>
-            <a:off x="16235172" y="21628276"/>
-            <a:ext cx="2606040" cy="457200"/>
+          <p:cNvPr id="105" name="TextBox 104"/>
+          <p:cNvSpPr txBox="1"/>
+          <p:nvPr/>
+        </p:nvSpPr>
+        <p:spPr>
+          <a:xfrm>
+            <a:off x="16143732" y="21628276"/>
+            <a:ext cx="2377440" cy="457200"/>
           </a:xfrm>
           <a:prstGeom prst="rect">
             <a:avLst/>
@@ -8293,14 +8489,14 @@
       </p:sp>
       <p:sp>
         <p:nvSpPr>
-          <p:cNvPr id="104" name="TextBox 103"/>
-          <p:cNvSpPr txBox="1"/>
-          <p:nvPr/>
-        </p:nvSpPr>
-        <p:spPr>
-          <a:xfrm>
-            <a:off x="18841212" y="21628276"/>
-            <a:ext cx="1874519" cy="457200"/>
+          <p:cNvPr id="106" name="TextBox 105"/>
+          <p:cNvSpPr txBox="1"/>
+          <p:nvPr/>
+        </p:nvSpPr>
+        <p:spPr>
+          <a:xfrm>
+            <a:off x="18521172" y="21628276"/>
+            <a:ext cx="2423160" cy="457200"/>
           </a:xfrm>
           <a:prstGeom prst="rect">
             <a:avLst/>
@@ -8315,7 +8511,7 @@
           <a:p>
             <a:pPr algn="r"/>
             <a:r>
-              <a:rPr sz="1800" b="0" i="0">
+              <a:rPr sz="1700" b="0" i="0">
                 <a:solidFill>
                   <a:srgbClr val="6F6F6F"/>
                 </a:solidFill>
@@ -8324,7 +8520,7 @@
               <a:t>.39→</a:t>
             </a:r>
             <a:r>
-              <a:rPr sz="2100" b="1" i="0">
+              <a:rPr sz="2000" b="1" i="0">
                 <a:solidFill>
                   <a:srgbClr val="0D4DA3"/>
                 </a:solidFill>
@@ -8332,19 +8528,28 @@
               </a:rPr>
               <a:t>.44</a:t>
             </a:r>
-          </a:p>
-        </p:txBody>
-      </p:sp>
-      <p:sp>
-        <p:nvSpPr>
-          <p:cNvPr id="105" name="TextBox 104"/>
-          <p:cNvSpPr txBox="1"/>
-          <p:nvPr/>
-        </p:nvSpPr>
-        <p:spPr>
-          <a:xfrm>
-            <a:off x="20715731" y="21628276"/>
-            <a:ext cx="3454147" cy="457200"/>
+            <a:r>
+              <a:rPr sz="1700" b="1" i="0">
+                <a:solidFill>
+                  <a:srgbClr val="0D4DA3"/>
+                </a:solidFill>
+                <a:latin typeface="Times New Roman"/>
+              </a:rPr>
+              <a:t> +13%</a:t>
+            </a:r>
+          </a:p>
+        </p:txBody>
+      </p:sp>
+      <p:sp>
+        <p:nvSpPr>
+          <p:cNvPr id="107" name="TextBox 106"/>
+          <p:cNvSpPr txBox="1"/>
+          <p:nvPr/>
+        </p:nvSpPr>
+        <p:spPr>
+          <a:xfrm>
+            <a:off x="20944332" y="21628276"/>
+            <a:ext cx="3065526" cy="457200"/>
           </a:xfrm>
           <a:prstGeom prst="rect">
             <a:avLst/>
@@ -8359,7 +8564,7 @@
           <a:p>
             <a:pPr algn="r"/>
             <a:r>
-              <a:rPr sz="1800" b="0" i="0">
+              <a:rPr sz="1700" b="0" i="0">
                 <a:solidFill>
                   <a:srgbClr val="6F6F6F"/>
                 </a:solidFill>
@@ -8368,7 +8573,7 @@
               <a:t>.75→</a:t>
             </a:r>
             <a:r>
-              <a:rPr sz="2100" b="1" i="0">
+              <a:rPr sz="2000" b="1" i="0">
                 <a:solidFill>
                   <a:srgbClr val="0D4DA3"/>
                 </a:solidFill>
@@ -8377,7 +8582,7 @@
               <a:t>.78</a:t>
             </a:r>
             <a:r>
-              <a:rPr sz="1800" b="1" i="0">
+              <a:rPr sz="1700" b="1" i="0">
                 <a:solidFill>
                   <a:srgbClr val="0D4DA3"/>
                 </a:solidFill>
@@ -8390,14 +8595,14 @@
       </p:sp>
       <p:sp>
         <p:nvSpPr>
-          <p:cNvPr id="106" name="TextBox 105"/>
-          <p:cNvSpPr txBox="1"/>
-          <p:nvPr/>
-        </p:nvSpPr>
-        <p:spPr>
-          <a:xfrm>
-            <a:off x="24169878" y="21628276"/>
-            <a:ext cx="1874519" cy="457200"/>
+          <p:cNvPr id="108" name="TextBox 107"/>
+          <p:cNvSpPr txBox="1"/>
+          <p:nvPr/>
+        </p:nvSpPr>
+        <p:spPr>
+          <a:xfrm>
+            <a:off x="24009858" y="21628276"/>
+            <a:ext cx="2423160" cy="457200"/>
           </a:xfrm>
           <a:prstGeom prst="rect">
             <a:avLst/>
@@ -8412,7 +8617,7 @@
           <a:p>
             <a:pPr algn="r"/>
             <a:r>
-              <a:rPr sz="1800" b="0" i="0">
+              <a:rPr sz="1700" b="0" i="0">
                 <a:solidFill>
                   <a:srgbClr val="6F6F6F"/>
                 </a:solidFill>
@@ -8421,7 +8626,7 @@
               <a:t>.44→</a:t>
             </a:r>
             <a:r>
-              <a:rPr sz="2100" b="1" i="0">
+              <a:rPr sz="2000" b="1" i="0">
                 <a:solidFill>
                   <a:srgbClr val="0D4DA3"/>
                 </a:solidFill>
@@ -8429,19 +8634,28 @@
               </a:rPr>
               <a:t>.48</a:t>
             </a:r>
-          </a:p>
-        </p:txBody>
-      </p:sp>
-      <p:sp>
-        <p:nvSpPr>
-          <p:cNvPr id="107" name="TextBox 106"/>
-          <p:cNvSpPr txBox="1"/>
-          <p:nvPr/>
-        </p:nvSpPr>
-        <p:spPr>
-          <a:xfrm>
-            <a:off x="26044397" y="21628276"/>
-            <a:ext cx="3454147" cy="457200"/>
+            <a:r>
+              <a:rPr sz="1700" b="1" i="0">
+                <a:solidFill>
+                  <a:srgbClr val="0D4DA3"/>
+                </a:solidFill>
+                <a:latin typeface="Times New Roman"/>
+              </a:rPr>
+              <a:t> +9%</a:t>
+            </a:r>
+          </a:p>
+        </p:txBody>
+      </p:sp>
+      <p:sp>
+        <p:nvSpPr>
+          <p:cNvPr id="109" name="TextBox 108"/>
+          <p:cNvSpPr txBox="1"/>
+          <p:nvPr/>
+        </p:nvSpPr>
+        <p:spPr>
+          <a:xfrm>
+            <a:off x="26433018" y="21628276"/>
+            <a:ext cx="3065526" cy="457200"/>
           </a:xfrm>
           <a:prstGeom prst="rect">
             <a:avLst/>
@@ -8456,7 +8670,7 @@
           <a:p>
             <a:pPr algn="r"/>
             <a:r>
-              <a:rPr sz="1800" b="0" i="0">
+              <a:rPr sz="1700" b="0" i="0">
                 <a:solidFill>
                   <a:srgbClr val="6F6F6F"/>
                 </a:solidFill>
@@ -8465,7 +8679,7 @@
               <a:t>.83→</a:t>
             </a:r>
             <a:r>
-              <a:rPr sz="2100" b="1" i="0">
+              <a:rPr sz="2000" b="1" i="0">
                 <a:solidFill>
                   <a:srgbClr val="0D4DA3"/>
                 </a:solidFill>
@@ -8474,7 +8688,7 @@
               <a:t>.83</a:t>
             </a:r>
             <a:r>
-              <a:rPr sz="1800" b="1" i="0">
+              <a:rPr sz="1700" b="1" i="0">
                 <a:solidFill>
                   <a:srgbClr val="0D4DA3"/>
                 </a:solidFill>
@@ -8487,7 +8701,7 @@
       </p:sp>
       <p:sp>
         <p:nvSpPr>
-          <p:cNvPr id="108" name="Rectangle 107"/>
+          <p:cNvPr id="110" name="Rectangle 109"/>
           <p:cNvSpPr/>
           <p:nvPr/>
         </p:nvSpPr>
@@ -8531,7 +8745,7 @@
       </p:sp>
       <p:sp>
         <p:nvSpPr>
-          <p:cNvPr id="109" name="TextBox 108"/>
+          <p:cNvPr id="111" name="TextBox 110"/>
           <p:cNvSpPr txBox="1"/>
           <p:nvPr/>
         </p:nvSpPr>
@@ -8609,7 +8823,7 @@
       </p:sp>
       <p:pic>
         <p:nvPicPr>
-          <p:cNvPr id="110" name="Picture 109" descr="asset_fig3.png"/>
+          <p:cNvPr id="112" name="Picture 111" descr="asset_fig3.png"/>
           <p:cNvPicPr>
             <a:picLocks noChangeAspect="1"/>
           </p:cNvPicPr>
@@ -8633,7 +8847,7 @@
       </p:pic>
       <p:sp>
         <p:nvSpPr>
-          <p:cNvPr id="111" name="TextBox 110"/>
+          <p:cNvPr id="113" name="TextBox 112"/>
           <p:cNvSpPr txBox="1"/>
           <p:nvPr/>
         </p:nvSpPr>
@@ -8675,7 +8889,7 @@
       </p:sp>
       <p:sp>
         <p:nvSpPr>
-          <p:cNvPr id="112" name="TextBox 111"/>
+          <p:cNvPr id="114" name="TextBox 113"/>
           <p:cNvSpPr txBox="1"/>
           <p:nvPr/>
         </p:nvSpPr>
@@ -8717,7 +8931,7 @@
       </p:sp>
       <p:sp>
         <p:nvSpPr>
-          <p:cNvPr id="113" name="Rectangle 112"/>
+          <p:cNvPr id="115" name="Rectangle 114"/>
           <p:cNvSpPr/>
           <p:nvPr/>
         </p:nvSpPr>
@@ -8761,7 +8975,7 @@
       </p:sp>
       <p:sp>
         <p:nvSpPr>
-          <p:cNvPr id="114" name="TextBox 113"/>
+          <p:cNvPr id="116" name="TextBox 115"/>
           <p:cNvSpPr txBox="1"/>
           <p:nvPr/>
         </p:nvSpPr>
@@ -8812,7 +9026,7 @@
       </p:sp>
       <p:sp>
         <p:nvSpPr>
-          <p:cNvPr id="115" name="TextBox 114"/>
+          <p:cNvPr id="117" name="TextBox 116"/>
           <p:cNvSpPr txBox="1"/>
           <p:nvPr/>
         </p:nvSpPr>
@@ -8847,7 +9061,7 @@
       </p:sp>
       <p:sp>
         <p:nvSpPr>
-          <p:cNvPr id="116" name="TextBox 115"/>
+          <p:cNvPr id="118" name="TextBox 117"/>
           <p:cNvSpPr txBox="1"/>
           <p:nvPr/>
         </p:nvSpPr>
@@ -8882,7 +9096,7 @@
       </p:sp>
       <p:sp>
         <p:nvSpPr>
-          <p:cNvPr id="117" name="TextBox 116"/>
+          <p:cNvPr id="119" name="TextBox 118"/>
           <p:cNvSpPr txBox="1"/>
           <p:nvPr/>
         </p:nvSpPr>
@@ -8917,7 +9131,7 @@
       </p:sp>
       <p:sp>
         <p:nvSpPr>
-          <p:cNvPr id="118" name="Rectangle 117"/>
+          <p:cNvPr id="120" name="Rectangle 119"/>
           <p:cNvSpPr/>
           <p:nvPr/>
         </p:nvSpPr>
@@ -8961,7 +9175,7 @@
       </p:sp>
       <p:sp>
         <p:nvSpPr>
-          <p:cNvPr id="119" name="TextBox 118"/>
+          <p:cNvPr id="121" name="TextBox 120"/>
           <p:cNvSpPr txBox="1"/>
           <p:nvPr/>
         </p:nvSpPr>
@@ -8996,7 +9210,7 @@
       </p:sp>
       <p:sp>
         <p:nvSpPr>
-          <p:cNvPr id="120" name="TextBox 119"/>
+          <p:cNvPr id="122" name="TextBox 121"/>
           <p:cNvSpPr txBox="1"/>
           <p:nvPr/>
         </p:nvSpPr>
@@ -9040,7 +9254,7 @@
       </p:sp>
       <p:sp>
         <p:nvSpPr>
-          <p:cNvPr id="121" name="TextBox 120"/>
+          <p:cNvPr id="123" name="TextBox 122"/>
           <p:cNvSpPr txBox="1"/>
           <p:nvPr/>
         </p:nvSpPr>
@@ -9084,7 +9298,7 @@
       </p:sp>
       <p:sp>
         <p:nvSpPr>
-          <p:cNvPr id="122" name="Rectangle 121"/>
+          <p:cNvPr id="124" name="Rectangle 123"/>
           <p:cNvSpPr/>
           <p:nvPr/>
         </p:nvSpPr>
@@ -9128,7 +9342,7 @@
       </p:sp>
       <p:sp>
         <p:nvSpPr>
-          <p:cNvPr id="123" name="TextBox 122"/>
+          <p:cNvPr id="125" name="TextBox 124"/>
           <p:cNvSpPr txBox="1"/>
           <p:nvPr/>
         </p:nvSpPr>
@@ -9163,7 +9377,7 @@
       </p:sp>
       <p:sp>
         <p:nvSpPr>
-          <p:cNvPr id="124" name="TextBox 123"/>
+          <p:cNvPr id="126" name="TextBox 125"/>
           <p:cNvSpPr txBox="1"/>
           <p:nvPr/>
         </p:nvSpPr>
@@ -9207,7 +9421,7 @@
       </p:sp>
       <p:sp>
         <p:nvSpPr>
-          <p:cNvPr id="125" name="TextBox 124"/>
+          <p:cNvPr id="127" name="TextBox 126"/>
           <p:cNvSpPr txBox="1"/>
           <p:nvPr/>
         </p:nvSpPr>
@@ -9251,7 +9465,7 @@
       </p:sp>
       <p:sp>
         <p:nvSpPr>
-          <p:cNvPr id="126" name="Rectangle 125"/>
+          <p:cNvPr id="128" name="Rectangle 127"/>
           <p:cNvSpPr/>
           <p:nvPr/>
         </p:nvSpPr>
@@ -9295,7 +9509,7 @@
       </p:sp>
       <p:sp>
         <p:nvSpPr>
-          <p:cNvPr id="127" name="TextBox 126"/>
+          <p:cNvPr id="129" name="TextBox 128"/>
           <p:cNvSpPr txBox="1"/>
           <p:nvPr/>
         </p:nvSpPr>
@@ -9330,7 +9544,7 @@
       </p:sp>
       <p:sp>
         <p:nvSpPr>
-          <p:cNvPr id="128" name="TextBox 127"/>
+          <p:cNvPr id="130" name="TextBox 129"/>
           <p:cNvSpPr txBox="1"/>
           <p:nvPr/>
         </p:nvSpPr>
@@ -9374,7 +9588,7 @@
       </p:sp>
       <p:sp>
         <p:nvSpPr>
-          <p:cNvPr id="129" name="TextBox 128"/>
+          <p:cNvPr id="131" name="TextBox 130"/>
           <p:cNvSpPr txBox="1"/>
           <p:nvPr/>
         </p:nvSpPr>
@@ -9418,7 +9632,7 @@
       </p:sp>
       <p:sp>
         <p:nvSpPr>
-          <p:cNvPr id="130" name="Rectangle 129"/>
+          <p:cNvPr id="132" name="Rectangle 131"/>
           <p:cNvSpPr/>
           <p:nvPr/>
         </p:nvSpPr>
@@ -9462,7 +9676,7 @@
       </p:sp>
       <p:sp>
         <p:nvSpPr>
-          <p:cNvPr id="131" name="TextBox 130"/>
+          <p:cNvPr id="133" name="TextBox 132"/>
           <p:cNvSpPr txBox="1"/>
           <p:nvPr/>
         </p:nvSpPr>
@@ -9497,7 +9711,7 @@
       </p:sp>
       <p:sp>
         <p:nvSpPr>
-          <p:cNvPr id="132" name="TextBox 131"/>
+          <p:cNvPr id="134" name="TextBox 133"/>
           <p:cNvSpPr txBox="1"/>
           <p:nvPr/>
         </p:nvSpPr>
@@ -9541,7 +9755,7 @@
       </p:sp>
       <p:sp>
         <p:nvSpPr>
-          <p:cNvPr id="133" name="TextBox 132"/>
+          <p:cNvPr id="135" name="TextBox 134"/>
           <p:cNvSpPr txBox="1"/>
           <p:nvPr/>
         </p:nvSpPr>
@@ -9585,7 +9799,7 @@
       </p:sp>
       <p:sp>
         <p:nvSpPr>
-          <p:cNvPr id="134" name="Rectangle 133"/>
+          <p:cNvPr id="136" name="Rectangle 135"/>
           <p:cNvSpPr/>
           <p:nvPr/>
         </p:nvSpPr>
@@ -9629,7 +9843,7 @@
       </p:sp>
       <p:sp>
         <p:nvSpPr>
-          <p:cNvPr id="135" name="TextBox 134"/>
+          <p:cNvPr id="137" name="TextBox 136"/>
           <p:cNvSpPr txBox="1"/>
           <p:nvPr/>
         </p:nvSpPr>
@@ -9671,7 +9885,7 @@
       </p:sp>
       <p:sp>
         <p:nvSpPr>
-          <p:cNvPr id="136" name="TextBox 135"/>
+          <p:cNvPr id="138" name="TextBox 137"/>
           <p:cNvSpPr txBox="1"/>
           <p:nvPr/>
         </p:nvSpPr>
@@ -9722,7 +9936,7 @@
       </p:sp>
       <p:sp>
         <p:nvSpPr>
-          <p:cNvPr id="137" name="Rectangle 136"/>
+          <p:cNvPr id="139" name="Rectangle 138"/>
           <p:cNvSpPr/>
           <p:nvPr/>
         </p:nvSpPr>
@@ -9768,7 +9982,7 @@
       </p:sp>
       <p:sp>
         <p:nvSpPr>
-          <p:cNvPr id="138" name="Rectangle 137"/>
+          <p:cNvPr id="140" name="Rectangle 139"/>
           <p:cNvSpPr/>
           <p:nvPr/>
         </p:nvSpPr>
@@ -9812,7 +10026,7 @@
       </p:sp>
       <p:sp>
         <p:nvSpPr>
-          <p:cNvPr id="139" name="TextBox 138"/>
+          <p:cNvPr id="141" name="TextBox 140"/>
           <p:cNvSpPr txBox="1"/>
           <p:nvPr/>
         </p:nvSpPr>
@@ -9847,7 +10061,7 @@
       </p:sp>
       <p:sp>
         <p:nvSpPr>
-          <p:cNvPr id="140" name="TextBox 139"/>
+          <p:cNvPr id="142" name="TextBox 141"/>
           <p:cNvSpPr txBox="1"/>
           <p:nvPr/>
         </p:nvSpPr>
@@ -9882,7 +10096,7 @@
       </p:sp>
       <p:sp>
         <p:nvSpPr>
-          <p:cNvPr id="141" name="Rectangle 140"/>
+          <p:cNvPr id="143" name="Rectangle 142"/>
           <p:cNvSpPr/>
           <p:nvPr/>
         </p:nvSpPr>
@@ -9928,7 +10142,7 @@
       </p:sp>
       <p:sp>
         <p:nvSpPr>
-          <p:cNvPr id="142" name="Rectangle 141"/>
+          <p:cNvPr id="144" name="Rectangle 143"/>
           <p:cNvSpPr/>
           <p:nvPr/>
         </p:nvSpPr>
@@ -9972,7 +10186,7 @@
       </p:sp>
       <p:sp>
         <p:nvSpPr>
-          <p:cNvPr id="143" name="TextBox 142"/>
+          <p:cNvPr id="145" name="TextBox 144"/>
           <p:cNvSpPr txBox="1"/>
           <p:nvPr/>
         </p:nvSpPr>
@@ -10007,7 +10221,7 @@
       </p:sp>
       <p:sp>
         <p:nvSpPr>
-          <p:cNvPr id="144" name="TextBox 143"/>
+          <p:cNvPr id="146" name="TextBox 145"/>
           <p:cNvSpPr txBox="1"/>
           <p:nvPr/>
         </p:nvSpPr>
@@ -10042,7 +10256,7 @@
       </p:sp>
       <p:sp>
         <p:nvSpPr>
-          <p:cNvPr id="145" name="Rectangle 144"/>
+          <p:cNvPr id="147" name="Rectangle 146"/>
           <p:cNvSpPr/>
           <p:nvPr/>
         </p:nvSpPr>
@@ -10088,7 +10302,7 @@
       </p:sp>
       <p:sp>
         <p:nvSpPr>
-          <p:cNvPr id="146" name="Rectangle 145"/>
+          <p:cNvPr id="148" name="Rectangle 147"/>
           <p:cNvSpPr/>
           <p:nvPr/>
         </p:nvSpPr>
@@ -10132,7 +10346,7 @@
       </p:sp>
       <p:sp>
         <p:nvSpPr>
-          <p:cNvPr id="147" name="TextBox 146"/>
+          <p:cNvPr id="149" name="TextBox 148"/>
           <p:cNvSpPr txBox="1"/>
           <p:nvPr/>
         </p:nvSpPr>
@@ -10167,7 +10381,7 @@
       </p:sp>
       <p:sp>
         <p:nvSpPr>
-          <p:cNvPr id="148" name="TextBox 147"/>
+          <p:cNvPr id="150" name="TextBox 149"/>
           <p:cNvSpPr txBox="1"/>
           <p:nvPr/>
         </p:nvSpPr>
@@ -10202,7 +10416,7 @@
       </p:sp>
       <p:sp>
         <p:nvSpPr>
-          <p:cNvPr id="149" name="Rectangle 148"/>
+          <p:cNvPr id="151" name="Rectangle 150"/>
           <p:cNvSpPr/>
           <p:nvPr/>
         </p:nvSpPr>
@@ -10248,7 +10462,7 @@
       </p:sp>
       <p:sp>
         <p:nvSpPr>
-          <p:cNvPr id="150" name="Rectangle 149"/>
+          <p:cNvPr id="152" name="Rectangle 151"/>
           <p:cNvSpPr/>
           <p:nvPr/>
         </p:nvSpPr>
@@ -10292,7 +10506,7 @@
       </p:sp>
       <p:sp>
         <p:nvSpPr>
-          <p:cNvPr id="151" name="TextBox 150"/>
+          <p:cNvPr id="153" name="TextBox 152"/>
           <p:cNvSpPr txBox="1"/>
           <p:nvPr/>
         </p:nvSpPr>
@@ -10327,7 +10541,7 @@
       </p:sp>
       <p:sp>
         <p:nvSpPr>
-          <p:cNvPr id="152" name="TextBox 151"/>
+          <p:cNvPr id="154" name="TextBox 153"/>
           <p:cNvSpPr txBox="1"/>
           <p:nvPr/>
         </p:nvSpPr>
@@ -10362,7 +10576,7 @@
       </p:sp>
       <p:sp>
         <p:nvSpPr>
-          <p:cNvPr id="153" name="TextBox 152"/>
+          <p:cNvPr id="155" name="TextBox 154"/>
           <p:cNvSpPr txBox="1"/>
           <p:nvPr/>
         </p:nvSpPr>
@@ -10413,7 +10627,7 @@
       </p:sp>
       <p:sp>
         <p:nvSpPr>
-          <p:cNvPr id="154" name="Rectangle 153"/>
+          <p:cNvPr id="156" name="Rectangle 155"/>
           <p:cNvSpPr/>
           <p:nvPr/>
         </p:nvSpPr>
@@ -10457,7 +10671,7 @@
       </p:sp>
       <p:sp>
         <p:nvSpPr>
-          <p:cNvPr id="155" name="TextBox 154"/>
+          <p:cNvPr id="157" name="TextBox 156"/>
           <p:cNvSpPr txBox="1"/>
           <p:nvPr/>
         </p:nvSpPr>
@@ -10536,7 +10750,7 @@
       </p:sp>
       <p:sp>
         <p:nvSpPr>
-          <p:cNvPr id="156" name="Rectangle 155"/>
+          <p:cNvPr id="158" name="Rectangle 157"/>
           <p:cNvSpPr/>
           <p:nvPr/>
         </p:nvSpPr>
@@ -10580,7 +10794,7 @@
       </p:sp>
       <p:sp>
         <p:nvSpPr>
-          <p:cNvPr id="157" name="Rectangle 156"/>
+          <p:cNvPr id="159" name="Rectangle 158"/>
           <p:cNvSpPr/>
           <p:nvPr/>
         </p:nvSpPr>
@@ -10624,7 +10838,7 @@
       </p:sp>
       <p:pic>
         <p:nvPicPr>
-          <p:cNvPr id="158" name="Picture 157" descr="asset_cikm.png"/>
+          <p:cNvPr id="160" name="Picture 159" descr="asset_cikm.png"/>
           <p:cNvPicPr>
             <a:picLocks noChangeAspect="1"/>
           </p:cNvPicPr>
@@ -10648,7 +10862,7 @@
       </p:pic>
       <p:sp>
         <p:nvSpPr>
-          <p:cNvPr id="159" name="TextBox 158"/>
+          <p:cNvPr id="161" name="TextBox 160"/>
           <p:cNvSpPr txBox="1"/>
           <p:nvPr/>
         </p:nvSpPr>
@@ -10690,7 +10904,7 @@
       </p:sp>
       <p:sp>
         <p:nvSpPr>
-          <p:cNvPr id="160" name="TextBox 159"/>
+          <p:cNvPr id="162" name="TextBox 161"/>
           <p:cNvSpPr txBox="1"/>
           <p:nvPr/>
         </p:nvSpPr>

</xml_diff>

<commit_message>
fix(poster): tighten R@10/R@100 spacing inside each direction group
</commit_message>
<xml_diff>
--- a/poster/PMC_CIKM2026_poster.pptx
+++ b/poster/PMC_CIKM2026_poster.pptx
@@ -6057,8 +6057,8 @@
         </p:nvSpPr>
         <p:spPr>
           <a:xfrm>
-            <a:off x="18521172" y="18024778"/>
-            <a:ext cx="5488686" cy="365760"/>
+            <a:off x="20080224" y="18024778"/>
+            <a:ext cx="4297680" cy="365760"/>
           </a:xfrm>
           <a:prstGeom prst="rect">
             <a:avLst/>
@@ -6092,8 +6092,8 @@
         </p:nvSpPr>
         <p:spPr>
           <a:xfrm>
-            <a:off x="18795492" y="18408826"/>
-            <a:ext cx="4940046" cy="15240"/>
+            <a:off x="20263104" y="18408826"/>
+            <a:ext cx="3931920" cy="15240"/>
           </a:xfrm>
           <a:prstGeom prst="rect">
             <a:avLst/>
@@ -6136,8 +6136,8 @@
         </p:nvSpPr>
         <p:spPr>
           <a:xfrm>
-            <a:off x="24009858" y="18024778"/>
-            <a:ext cx="5488686" cy="365760"/>
+            <a:off x="25200864" y="18024778"/>
+            <a:ext cx="4297680" cy="365760"/>
           </a:xfrm>
           <a:prstGeom prst="rect">
             <a:avLst/>
@@ -6171,8 +6171,8 @@
         </p:nvSpPr>
         <p:spPr>
           <a:xfrm>
-            <a:off x="24284178" y="18408826"/>
-            <a:ext cx="4940046" cy="15240"/>
+            <a:off x="25383744" y="18408826"/>
+            <a:ext cx="3931920" cy="15240"/>
           </a:xfrm>
           <a:prstGeom prst="rect">
             <a:avLst/>
@@ -6251,7 +6251,7 @@
         <p:spPr>
           <a:xfrm>
             <a:off x="16143732" y="18445402"/>
-            <a:ext cx="2377440" cy="365760"/>
+            <a:ext cx="3936492" cy="365760"/>
           </a:xfrm>
           <a:prstGeom prst="rect">
             <a:avLst/>
@@ -6285,8 +6285,8 @@
         </p:nvSpPr>
         <p:spPr>
           <a:xfrm>
-            <a:off x="18521172" y="18445402"/>
-            <a:ext cx="2423160" cy="365760"/>
+            <a:off x="20080224" y="18445402"/>
+            <a:ext cx="2148840" cy="365760"/>
           </a:xfrm>
           <a:prstGeom prst="rect">
             <a:avLst/>
@@ -6320,8 +6320,8 @@
         </p:nvSpPr>
         <p:spPr>
           <a:xfrm>
-            <a:off x="20944332" y="18445402"/>
-            <a:ext cx="3065526" cy="365760"/>
+            <a:off x="22229064" y="18445402"/>
+            <a:ext cx="2148840" cy="365760"/>
           </a:xfrm>
           <a:prstGeom prst="rect">
             <a:avLst/>
@@ -6355,8 +6355,8 @@
         </p:nvSpPr>
         <p:spPr>
           <a:xfrm>
-            <a:off x="24009858" y="18445402"/>
-            <a:ext cx="2423160" cy="365760"/>
+            <a:off x="25200864" y="18445402"/>
+            <a:ext cx="2148840" cy="365760"/>
           </a:xfrm>
           <a:prstGeom prst="rect">
             <a:avLst/>
@@ -6390,8 +6390,8 @@
         </p:nvSpPr>
         <p:spPr>
           <a:xfrm>
-            <a:off x="26433018" y="18445402"/>
-            <a:ext cx="3065526" cy="365760"/>
+            <a:off x="27349704" y="18445402"/>
+            <a:ext cx="2148840" cy="365760"/>
           </a:xfrm>
           <a:prstGeom prst="rect">
             <a:avLst/>
@@ -6505,7 +6505,7 @@
         <p:spPr>
           <a:xfrm>
             <a:off x="16143732" y="18885076"/>
-            <a:ext cx="2377440" cy="457200"/>
+            <a:ext cx="3936492" cy="457200"/>
           </a:xfrm>
           <a:prstGeom prst="rect">
             <a:avLst/>
@@ -6539,8 +6539,8 @@
         </p:nvSpPr>
         <p:spPr>
           <a:xfrm>
-            <a:off x="18521172" y="18885076"/>
-            <a:ext cx="2423160" cy="457200"/>
+            <a:off x="20080224" y="18885076"/>
+            <a:ext cx="2148840" cy="457200"/>
           </a:xfrm>
           <a:prstGeom prst="rect">
             <a:avLst/>
@@ -6592,8 +6592,8 @@
         </p:nvSpPr>
         <p:spPr>
           <a:xfrm>
-            <a:off x="20944332" y="18885076"/>
-            <a:ext cx="3065526" cy="457200"/>
+            <a:off x="22229064" y="18885076"/>
+            <a:ext cx="2148840" cy="457200"/>
           </a:xfrm>
           <a:prstGeom prst="rect">
             <a:avLst/>
@@ -6645,8 +6645,8 @@
         </p:nvSpPr>
         <p:spPr>
           <a:xfrm>
-            <a:off x="24009858" y="18885076"/>
-            <a:ext cx="2423160" cy="457200"/>
+            <a:off x="25200864" y="18885076"/>
+            <a:ext cx="2148840" cy="457200"/>
           </a:xfrm>
           <a:prstGeom prst="rect">
             <a:avLst/>
@@ -6698,8 +6698,8 @@
         </p:nvSpPr>
         <p:spPr>
           <a:xfrm>
-            <a:off x="26433018" y="18885076"/>
-            <a:ext cx="3065526" cy="457200"/>
+            <a:off x="27349704" y="18885076"/>
+            <a:ext cx="2148840" cy="457200"/>
           </a:xfrm>
           <a:prstGeom prst="rect">
             <a:avLst/>
@@ -6831,7 +6831,7 @@
         <p:spPr>
           <a:xfrm>
             <a:off x="16143732" y="19342276"/>
-            <a:ext cx="2377440" cy="457200"/>
+            <a:ext cx="3936492" cy="457200"/>
           </a:xfrm>
           <a:prstGeom prst="rect">
             <a:avLst/>
@@ -6865,8 +6865,8 @@
         </p:nvSpPr>
         <p:spPr>
           <a:xfrm>
-            <a:off x="18521172" y="19342276"/>
-            <a:ext cx="2423160" cy="457200"/>
+            <a:off x="20080224" y="19342276"/>
+            <a:ext cx="2148840" cy="457200"/>
           </a:xfrm>
           <a:prstGeom prst="rect">
             <a:avLst/>
@@ -6918,8 +6918,8 @@
         </p:nvSpPr>
         <p:spPr>
           <a:xfrm>
-            <a:off x="20944332" y="19342276"/>
-            <a:ext cx="3065526" cy="457200"/>
+            <a:off x="22229064" y="19342276"/>
+            <a:ext cx="2148840" cy="457200"/>
           </a:xfrm>
           <a:prstGeom prst="rect">
             <a:avLst/>
@@ -6971,8 +6971,8 @@
         </p:nvSpPr>
         <p:spPr>
           <a:xfrm>
-            <a:off x="24009858" y="19342276"/>
-            <a:ext cx="2423160" cy="457200"/>
+            <a:off x="25200864" y="19342276"/>
+            <a:ext cx="2148840" cy="457200"/>
           </a:xfrm>
           <a:prstGeom prst="rect">
             <a:avLst/>
@@ -7024,8 +7024,8 @@
         </p:nvSpPr>
         <p:spPr>
           <a:xfrm>
-            <a:off x="26433018" y="19342276"/>
-            <a:ext cx="3065526" cy="457200"/>
+            <a:off x="27349704" y="19342276"/>
+            <a:ext cx="2148840" cy="457200"/>
           </a:xfrm>
           <a:prstGeom prst="rect">
             <a:avLst/>
@@ -7157,7 +7157,7 @@
         <p:spPr>
           <a:xfrm>
             <a:off x="16143732" y="19799476"/>
-            <a:ext cx="2377440" cy="457200"/>
+            <a:ext cx="3936492" cy="457200"/>
           </a:xfrm>
           <a:prstGeom prst="rect">
             <a:avLst/>
@@ -7191,8 +7191,8 @@
         </p:nvSpPr>
         <p:spPr>
           <a:xfrm>
-            <a:off x="18521172" y="19799476"/>
-            <a:ext cx="2423160" cy="457200"/>
+            <a:off x="20080224" y="19799476"/>
+            <a:ext cx="2148840" cy="457200"/>
           </a:xfrm>
           <a:prstGeom prst="rect">
             <a:avLst/>
@@ -7244,8 +7244,8 @@
         </p:nvSpPr>
         <p:spPr>
           <a:xfrm>
-            <a:off x="20944332" y="19799476"/>
-            <a:ext cx="3065526" cy="457200"/>
+            <a:off x="22229064" y="19799476"/>
+            <a:ext cx="2148840" cy="457200"/>
           </a:xfrm>
           <a:prstGeom prst="rect">
             <a:avLst/>
@@ -7297,8 +7297,8 @@
         </p:nvSpPr>
         <p:spPr>
           <a:xfrm>
-            <a:off x="24009858" y="19799476"/>
-            <a:ext cx="2423160" cy="457200"/>
+            <a:off x="25200864" y="19799476"/>
+            <a:ext cx="2148840" cy="457200"/>
           </a:xfrm>
           <a:prstGeom prst="rect">
             <a:avLst/>
@@ -7350,8 +7350,8 @@
         </p:nvSpPr>
         <p:spPr>
           <a:xfrm>
-            <a:off x="26433018" y="19799476"/>
-            <a:ext cx="3065526" cy="457200"/>
+            <a:off x="27349704" y="19799476"/>
+            <a:ext cx="2148840" cy="457200"/>
           </a:xfrm>
           <a:prstGeom prst="rect">
             <a:avLst/>
@@ -7483,7 +7483,7 @@
         <p:spPr>
           <a:xfrm>
             <a:off x="16143732" y="20256676"/>
-            <a:ext cx="2377440" cy="457200"/>
+            <a:ext cx="3936492" cy="457200"/>
           </a:xfrm>
           <a:prstGeom prst="rect">
             <a:avLst/>
@@ -7517,8 +7517,8 @@
         </p:nvSpPr>
         <p:spPr>
           <a:xfrm>
-            <a:off x="18521172" y="20256676"/>
-            <a:ext cx="2423160" cy="457200"/>
+            <a:off x="20080224" y="20256676"/>
+            <a:ext cx="2148840" cy="457200"/>
           </a:xfrm>
           <a:prstGeom prst="rect">
             <a:avLst/>
@@ -7570,8 +7570,8 @@
         </p:nvSpPr>
         <p:spPr>
           <a:xfrm>
-            <a:off x="20944332" y="20256676"/>
-            <a:ext cx="3065526" cy="457200"/>
+            <a:off x="22229064" y="20256676"/>
+            <a:ext cx="2148840" cy="457200"/>
           </a:xfrm>
           <a:prstGeom prst="rect">
             <a:avLst/>
@@ -7623,8 +7623,8 @@
         </p:nvSpPr>
         <p:spPr>
           <a:xfrm>
-            <a:off x="24009858" y="20256676"/>
-            <a:ext cx="2423160" cy="457200"/>
+            <a:off x="25200864" y="20256676"/>
+            <a:ext cx="2148840" cy="457200"/>
           </a:xfrm>
           <a:prstGeom prst="rect">
             <a:avLst/>
@@ -7676,8 +7676,8 @@
         </p:nvSpPr>
         <p:spPr>
           <a:xfrm>
-            <a:off x="26433018" y="20256676"/>
-            <a:ext cx="3065526" cy="457200"/>
+            <a:off x="27349704" y="20256676"/>
+            <a:ext cx="2148840" cy="457200"/>
           </a:xfrm>
           <a:prstGeom prst="rect">
             <a:avLst/>
@@ -7809,7 +7809,7 @@
         <p:spPr>
           <a:xfrm>
             <a:off x="16143732" y="20713876"/>
-            <a:ext cx="2377440" cy="457200"/>
+            <a:ext cx="3936492" cy="457200"/>
           </a:xfrm>
           <a:prstGeom prst="rect">
             <a:avLst/>
@@ -7843,8 +7843,8 @@
         </p:nvSpPr>
         <p:spPr>
           <a:xfrm>
-            <a:off x="18521172" y="20713876"/>
-            <a:ext cx="2423160" cy="457200"/>
+            <a:off x="20080224" y="20713876"/>
+            <a:ext cx="2148840" cy="457200"/>
           </a:xfrm>
           <a:prstGeom prst="rect">
             <a:avLst/>
@@ -7896,8 +7896,8 @@
         </p:nvSpPr>
         <p:spPr>
           <a:xfrm>
-            <a:off x="20944332" y="20713876"/>
-            <a:ext cx="3065526" cy="457200"/>
+            <a:off x="22229064" y="20713876"/>
+            <a:ext cx="2148840" cy="457200"/>
           </a:xfrm>
           <a:prstGeom prst="rect">
             <a:avLst/>
@@ -7949,8 +7949,8 @@
         </p:nvSpPr>
         <p:spPr>
           <a:xfrm>
-            <a:off x="24009858" y="20713876"/>
-            <a:ext cx="2423160" cy="457200"/>
+            <a:off x="25200864" y="20713876"/>
+            <a:ext cx="2148840" cy="457200"/>
           </a:xfrm>
           <a:prstGeom prst="rect">
             <a:avLst/>
@@ -8002,8 +8002,8 @@
         </p:nvSpPr>
         <p:spPr>
           <a:xfrm>
-            <a:off x="26433018" y="20713876"/>
-            <a:ext cx="3065526" cy="457200"/>
+            <a:off x="27349704" y="20713876"/>
+            <a:ext cx="2148840" cy="457200"/>
           </a:xfrm>
           <a:prstGeom prst="rect">
             <a:avLst/>
@@ -8135,7 +8135,7 @@
         <p:spPr>
           <a:xfrm>
             <a:off x="16143732" y="21171076"/>
-            <a:ext cx="2377440" cy="457200"/>
+            <a:ext cx="3936492" cy="457200"/>
           </a:xfrm>
           <a:prstGeom prst="rect">
             <a:avLst/>
@@ -8169,8 +8169,8 @@
         </p:nvSpPr>
         <p:spPr>
           <a:xfrm>
-            <a:off x="18521172" y="21171076"/>
-            <a:ext cx="2423160" cy="457200"/>
+            <a:off x="20080224" y="21171076"/>
+            <a:ext cx="2148840" cy="457200"/>
           </a:xfrm>
           <a:prstGeom prst="rect">
             <a:avLst/>
@@ -8222,8 +8222,8 @@
         </p:nvSpPr>
         <p:spPr>
           <a:xfrm>
-            <a:off x="20944332" y="21171076"/>
-            <a:ext cx="3065526" cy="457200"/>
+            <a:off x="22229064" y="21171076"/>
+            <a:ext cx="2148840" cy="457200"/>
           </a:xfrm>
           <a:prstGeom prst="rect">
             <a:avLst/>
@@ -8275,8 +8275,8 @@
         </p:nvSpPr>
         <p:spPr>
           <a:xfrm>
-            <a:off x="24009858" y="21171076"/>
-            <a:ext cx="2423160" cy="457200"/>
+            <a:off x="25200864" y="21171076"/>
+            <a:ext cx="2148840" cy="457200"/>
           </a:xfrm>
           <a:prstGeom prst="rect">
             <a:avLst/>
@@ -8328,8 +8328,8 @@
         </p:nvSpPr>
         <p:spPr>
           <a:xfrm>
-            <a:off x="26433018" y="21171076"/>
-            <a:ext cx="3065526" cy="457200"/>
+            <a:off x="27349704" y="21171076"/>
+            <a:ext cx="2148840" cy="457200"/>
           </a:xfrm>
           <a:prstGeom prst="rect">
             <a:avLst/>
@@ -8461,7 +8461,7 @@
         <p:spPr>
           <a:xfrm>
             <a:off x="16143732" y="21628276"/>
-            <a:ext cx="2377440" cy="457200"/>
+            <a:ext cx="3936492" cy="457200"/>
           </a:xfrm>
           <a:prstGeom prst="rect">
             <a:avLst/>
@@ -8495,8 +8495,8 @@
         </p:nvSpPr>
         <p:spPr>
           <a:xfrm>
-            <a:off x="18521172" y="21628276"/>
-            <a:ext cx="2423160" cy="457200"/>
+            <a:off x="20080224" y="21628276"/>
+            <a:ext cx="2148840" cy="457200"/>
           </a:xfrm>
           <a:prstGeom prst="rect">
             <a:avLst/>
@@ -8548,8 +8548,8 @@
         </p:nvSpPr>
         <p:spPr>
           <a:xfrm>
-            <a:off x="20944332" y="21628276"/>
-            <a:ext cx="3065526" cy="457200"/>
+            <a:off x="22229064" y="21628276"/>
+            <a:ext cx="2148840" cy="457200"/>
           </a:xfrm>
           <a:prstGeom prst="rect">
             <a:avLst/>
@@ -8601,8 +8601,8 @@
         </p:nvSpPr>
         <p:spPr>
           <a:xfrm>
-            <a:off x="24009858" y="21628276"/>
-            <a:ext cx="2423160" cy="457200"/>
+            <a:off x="25200864" y="21628276"/>
+            <a:ext cx="2148840" cy="457200"/>
           </a:xfrm>
           <a:prstGeom prst="rect">
             <a:avLst/>
@@ -8654,8 +8654,8 @@
         </p:nvSpPr>
         <p:spPr>
           <a:xfrm>
-            <a:off x="26433018" y="21628276"/>
-            <a:ext cx="3065526" cy="457200"/>
+            <a:off x="27349704" y="21628276"/>
+            <a:ext cx="2148840" cy="457200"/>
           </a:xfrm>
           <a:prstGeom prst="rect">
             <a:avLst/>

</xml_diff>

<commit_message>
style(poster): center table numerics; bold ink for PMC values, crimson deltas
Drop blue number text: improved values are bold black, +d% deltas
crimson; numeric columns and their subheaders centered per mockup.
</commit_message>
<xml_diff>
--- a/poster/PMC_CIKM2026_poster.pptx
+++ b/poster/PMC_CIKM2026_poster.pptx
@@ -6299,7 +6299,7 @@
           </a:bodyPr>
           <a:lstStyle/>
           <a:p>
-            <a:pPr algn="r"/>
+            <a:pPr algn="ctr"/>
             <a:r>
               <a:rPr sz="2000" b="1" i="0">
                 <a:solidFill>
@@ -6334,7 +6334,7 @@
           </a:bodyPr>
           <a:lstStyle/>
           <a:p>
-            <a:pPr algn="r"/>
+            <a:pPr algn="ctr"/>
             <a:r>
               <a:rPr sz="2000" b="1" i="0">
                 <a:solidFill>
@@ -6369,7 +6369,7 @@
           </a:bodyPr>
           <a:lstStyle/>
           <a:p>
-            <a:pPr algn="r"/>
+            <a:pPr algn="ctr"/>
             <a:r>
               <a:rPr sz="2000" b="1" i="0">
                 <a:solidFill>
@@ -6404,7 +6404,7 @@
           </a:bodyPr>
           <a:lstStyle/>
           <a:p>
-            <a:pPr algn="r"/>
+            <a:pPr algn="ctr"/>
             <a:r>
               <a:rPr sz="2000" b="1" i="0">
                 <a:solidFill>
@@ -6553,7 +6553,7 @@
           </a:bodyPr>
           <a:lstStyle/>
           <a:p>
-            <a:pPr algn="r"/>
+            <a:pPr algn="ctr"/>
             <a:r>
               <a:rPr sz="1700" b="0" i="0">
                 <a:solidFill>
@@ -6566,7 +6566,7 @@
             <a:r>
               <a:rPr sz="2000" b="1" i="0">
                 <a:solidFill>
-                  <a:srgbClr val="0D4DA3"/>
+                  <a:srgbClr val="1F1F1F"/>
                 </a:solidFill>
                 <a:latin typeface="Times New Roman"/>
               </a:rPr>
@@ -6575,7 +6575,7 @@
             <a:r>
               <a:rPr sz="1700" b="1" i="0">
                 <a:solidFill>
-                  <a:srgbClr val="0D4DA3"/>
+                  <a:srgbClr val="8B0029"/>
                 </a:solidFill>
                 <a:latin typeface="Times New Roman"/>
               </a:rPr>
@@ -6606,7 +6606,7 @@
           </a:bodyPr>
           <a:lstStyle/>
           <a:p>
-            <a:pPr algn="r"/>
+            <a:pPr algn="ctr"/>
             <a:r>
               <a:rPr sz="1700" b="0" i="0">
                 <a:solidFill>
@@ -6619,7 +6619,7 @@
             <a:r>
               <a:rPr sz="2000" b="1" i="0">
                 <a:solidFill>
-                  <a:srgbClr val="0D4DA3"/>
+                  <a:srgbClr val="1F1F1F"/>
                 </a:solidFill>
                 <a:latin typeface="Times New Roman"/>
               </a:rPr>
@@ -6628,7 +6628,7 @@
             <a:r>
               <a:rPr sz="1700" b="1" i="0">
                 <a:solidFill>
-                  <a:srgbClr val="0D4DA3"/>
+                  <a:srgbClr val="8B0029"/>
                 </a:solidFill>
                 <a:latin typeface="Times New Roman"/>
               </a:rPr>
@@ -6659,7 +6659,7 @@
           </a:bodyPr>
           <a:lstStyle/>
           <a:p>
-            <a:pPr algn="r"/>
+            <a:pPr algn="ctr"/>
             <a:r>
               <a:rPr sz="1700" b="0" i="0">
                 <a:solidFill>
@@ -6672,7 +6672,7 @@
             <a:r>
               <a:rPr sz="2000" b="1" i="0">
                 <a:solidFill>
-                  <a:srgbClr val="0D4DA3"/>
+                  <a:srgbClr val="1F1F1F"/>
                 </a:solidFill>
                 <a:latin typeface="Times New Roman"/>
               </a:rPr>
@@ -6681,7 +6681,7 @@
             <a:r>
               <a:rPr sz="1700" b="1" i="0">
                 <a:solidFill>
-                  <a:srgbClr val="0D4DA3"/>
+                  <a:srgbClr val="8B0029"/>
                 </a:solidFill>
                 <a:latin typeface="Times New Roman"/>
               </a:rPr>
@@ -6712,7 +6712,7 @@
           </a:bodyPr>
           <a:lstStyle/>
           <a:p>
-            <a:pPr algn="r"/>
+            <a:pPr algn="ctr"/>
             <a:r>
               <a:rPr sz="1700" b="0" i="0">
                 <a:solidFill>
@@ -6725,7 +6725,7 @@
             <a:r>
               <a:rPr sz="2000" b="1" i="0">
                 <a:solidFill>
-                  <a:srgbClr val="0D4DA3"/>
+                  <a:srgbClr val="1F1F1F"/>
                 </a:solidFill>
                 <a:latin typeface="Times New Roman"/>
               </a:rPr>
@@ -6734,7 +6734,7 @@
             <a:r>
               <a:rPr sz="1700" b="1" i="0">
                 <a:solidFill>
-                  <a:srgbClr val="0D4DA3"/>
+                  <a:srgbClr val="8B0029"/>
                 </a:solidFill>
                 <a:latin typeface="Times New Roman"/>
               </a:rPr>
@@ -6879,7 +6879,7 @@
           </a:bodyPr>
           <a:lstStyle/>
           <a:p>
-            <a:pPr algn="r"/>
+            <a:pPr algn="ctr"/>
             <a:r>
               <a:rPr sz="1700" b="0" i="0">
                 <a:solidFill>
@@ -6892,7 +6892,7 @@
             <a:r>
               <a:rPr sz="2000" b="1" i="0">
                 <a:solidFill>
-                  <a:srgbClr val="0D4DA3"/>
+                  <a:srgbClr val="1F1F1F"/>
                 </a:solidFill>
                 <a:latin typeface="Times New Roman"/>
               </a:rPr>
@@ -6901,7 +6901,7 @@
             <a:r>
               <a:rPr sz="1700" b="1" i="0">
                 <a:solidFill>
-                  <a:srgbClr val="0D4DA3"/>
+                  <a:srgbClr val="8B0029"/>
                 </a:solidFill>
                 <a:latin typeface="Times New Roman"/>
               </a:rPr>
@@ -6932,7 +6932,7 @@
           </a:bodyPr>
           <a:lstStyle/>
           <a:p>
-            <a:pPr algn="r"/>
+            <a:pPr algn="ctr"/>
             <a:r>
               <a:rPr sz="1700" b="0" i="0">
                 <a:solidFill>
@@ -6945,7 +6945,7 @@
             <a:r>
               <a:rPr sz="2000" b="1" i="0">
                 <a:solidFill>
-                  <a:srgbClr val="0D4DA3"/>
+                  <a:srgbClr val="1F1F1F"/>
                 </a:solidFill>
                 <a:latin typeface="Times New Roman"/>
               </a:rPr>
@@ -6954,7 +6954,7 @@
             <a:r>
               <a:rPr sz="1700" b="1" i="0">
                 <a:solidFill>
-                  <a:srgbClr val="0D4DA3"/>
+                  <a:srgbClr val="8B0029"/>
                 </a:solidFill>
                 <a:latin typeface="Times New Roman"/>
               </a:rPr>
@@ -6985,7 +6985,7 @@
           </a:bodyPr>
           <a:lstStyle/>
           <a:p>
-            <a:pPr algn="r"/>
+            <a:pPr algn="ctr"/>
             <a:r>
               <a:rPr sz="1700" b="0" i="0">
                 <a:solidFill>
@@ -6998,7 +6998,7 @@
             <a:r>
               <a:rPr sz="2000" b="1" i="0">
                 <a:solidFill>
-                  <a:srgbClr val="0D4DA3"/>
+                  <a:srgbClr val="1F1F1F"/>
                 </a:solidFill>
                 <a:latin typeface="Times New Roman"/>
               </a:rPr>
@@ -7007,7 +7007,7 @@
             <a:r>
               <a:rPr sz="1700" b="1" i="0">
                 <a:solidFill>
-                  <a:srgbClr val="0D4DA3"/>
+                  <a:srgbClr val="8B0029"/>
                 </a:solidFill>
                 <a:latin typeface="Times New Roman"/>
               </a:rPr>
@@ -7038,7 +7038,7 @@
           </a:bodyPr>
           <a:lstStyle/>
           <a:p>
-            <a:pPr algn="r"/>
+            <a:pPr algn="ctr"/>
             <a:r>
               <a:rPr sz="1700" b="0" i="0">
                 <a:solidFill>
@@ -7051,7 +7051,7 @@
             <a:r>
               <a:rPr sz="2000" b="1" i="0">
                 <a:solidFill>
-                  <a:srgbClr val="0D4DA3"/>
+                  <a:srgbClr val="1F1F1F"/>
                 </a:solidFill>
                 <a:latin typeface="Times New Roman"/>
               </a:rPr>
@@ -7060,7 +7060,7 @@
             <a:r>
               <a:rPr sz="1700" b="1" i="0">
                 <a:solidFill>
-                  <a:srgbClr val="0D4DA3"/>
+                  <a:srgbClr val="8B0029"/>
                 </a:solidFill>
                 <a:latin typeface="Times New Roman"/>
               </a:rPr>
@@ -7205,7 +7205,7 @@
           </a:bodyPr>
           <a:lstStyle/>
           <a:p>
-            <a:pPr algn="r"/>
+            <a:pPr algn="ctr"/>
             <a:r>
               <a:rPr sz="1700" b="0" i="0">
                 <a:solidFill>
@@ -7218,7 +7218,7 @@
             <a:r>
               <a:rPr sz="2000" b="1" i="0">
                 <a:solidFill>
-                  <a:srgbClr val="0D4DA3"/>
+                  <a:srgbClr val="1F1F1F"/>
                 </a:solidFill>
                 <a:latin typeface="Times New Roman"/>
               </a:rPr>
@@ -7227,7 +7227,7 @@
             <a:r>
               <a:rPr sz="1700" b="1" i="0">
                 <a:solidFill>
-                  <a:srgbClr val="0D4DA3"/>
+                  <a:srgbClr val="8B0029"/>
                 </a:solidFill>
                 <a:latin typeface="Times New Roman"/>
               </a:rPr>
@@ -7258,7 +7258,7 @@
           </a:bodyPr>
           <a:lstStyle/>
           <a:p>
-            <a:pPr algn="r"/>
+            <a:pPr algn="ctr"/>
             <a:r>
               <a:rPr sz="1700" b="0" i="0">
                 <a:solidFill>
@@ -7271,7 +7271,7 @@
             <a:r>
               <a:rPr sz="2000" b="1" i="0">
                 <a:solidFill>
-                  <a:srgbClr val="0D4DA3"/>
+                  <a:srgbClr val="1F1F1F"/>
                 </a:solidFill>
                 <a:latin typeface="Times New Roman"/>
               </a:rPr>
@@ -7280,7 +7280,7 @@
             <a:r>
               <a:rPr sz="1700" b="1" i="0">
                 <a:solidFill>
-                  <a:srgbClr val="0D4DA3"/>
+                  <a:srgbClr val="8B0029"/>
                 </a:solidFill>
                 <a:latin typeface="Times New Roman"/>
               </a:rPr>
@@ -7311,7 +7311,7 @@
           </a:bodyPr>
           <a:lstStyle/>
           <a:p>
-            <a:pPr algn="r"/>
+            <a:pPr algn="ctr"/>
             <a:r>
               <a:rPr sz="1700" b="0" i="0">
                 <a:solidFill>
@@ -7324,7 +7324,7 @@
             <a:r>
               <a:rPr sz="2000" b="1" i="0">
                 <a:solidFill>
-                  <a:srgbClr val="0D4DA3"/>
+                  <a:srgbClr val="1F1F1F"/>
                 </a:solidFill>
                 <a:latin typeface="Times New Roman"/>
               </a:rPr>
@@ -7333,7 +7333,7 @@
             <a:r>
               <a:rPr sz="1700" b="1" i="0">
                 <a:solidFill>
-                  <a:srgbClr val="0D4DA3"/>
+                  <a:srgbClr val="8B0029"/>
                 </a:solidFill>
                 <a:latin typeface="Times New Roman"/>
               </a:rPr>
@@ -7364,7 +7364,7 @@
           </a:bodyPr>
           <a:lstStyle/>
           <a:p>
-            <a:pPr algn="r"/>
+            <a:pPr algn="ctr"/>
             <a:r>
               <a:rPr sz="1700" b="0" i="0">
                 <a:solidFill>
@@ -7377,7 +7377,7 @@
             <a:r>
               <a:rPr sz="2000" b="1" i="0">
                 <a:solidFill>
-                  <a:srgbClr val="0D4DA3"/>
+                  <a:srgbClr val="1F1F1F"/>
                 </a:solidFill>
                 <a:latin typeface="Times New Roman"/>
               </a:rPr>
@@ -7386,7 +7386,7 @@
             <a:r>
               <a:rPr sz="1700" b="1" i="0">
                 <a:solidFill>
-                  <a:srgbClr val="0D4DA3"/>
+                  <a:srgbClr val="8B0029"/>
                 </a:solidFill>
                 <a:latin typeface="Times New Roman"/>
               </a:rPr>
@@ -7531,7 +7531,7 @@
           </a:bodyPr>
           <a:lstStyle/>
           <a:p>
-            <a:pPr algn="r"/>
+            <a:pPr algn="ctr"/>
             <a:r>
               <a:rPr sz="1700" b="0" i="0">
                 <a:solidFill>
@@ -7544,7 +7544,7 @@
             <a:r>
               <a:rPr sz="2000" b="1" i="0">
                 <a:solidFill>
-                  <a:srgbClr val="0D4DA3"/>
+                  <a:srgbClr val="1F1F1F"/>
                 </a:solidFill>
                 <a:latin typeface="Times New Roman"/>
               </a:rPr>
@@ -7553,7 +7553,7 @@
             <a:r>
               <a:rPr sz="1700" b="1" i="0">
                 <a:solidFill>
-                  <a:srgbClr val="0D4DA3"/>
+                  <a:srgbClr val="8B0029"/>
                 </a:solidFill>
                 <a:latin typeface="Times New Roman"/>
               </a:rPr>
@@ -7584,7 +7584,7 @@
           </a:bodyPr>
           <a:lstStyle/>
           <a:p>
-            <a:pPr algn="r"/>
+            <a:pPr algn="ctr"/>
             <a:r>
               <a:rPr sz="1700" b="0" i="0">
                 <a:solidFill>
@@ -7597,7 +7597,7 @@
             <a:r>
               <a:rPr sz="2000" b="1" i="0">
                 <a:solidFill>
-                  <a:srgbClr val="0D4DA3"/>
+                  <a:srgbClr val="1F1F1F"/>
                 </a:solidFill>
                 <a:latin typeface="Times New Roman"/>
               </a:rPr>
@@ -7606,7 +7606,7 @@
             <a:r>
               <a:rPr sz="1700" b="1" i="0">
                 <a:solidFill>
-                  <a:srgbClr val="0D4DA3"/>
+                  <a:srgbClr val="8B0029"/>
                 </a:solidFill>
                 <a:latin typeface="Times New Roman"/>
               </a:rPr>
@@ -7637,7 +7637,7 @@
           </a:bodyPr>
           <a:lstStyle/>
           <a:p>
-            <a:pPr algn="r"/>
+            <a:pPr algn="ctr"/>
             <a:r>
               <a:rPr sz="1700" b="0" i="0">
                 <a:solidFill>
@@ -7650,7 +7650,7 @@
             <a:r>
               <a:rPr sz="2000" b="1" i="0">
                 <a:solidFill>
-                  <a:srgbClr val="0D4DA3"/>
+                  <a:srgbClr val="1F1F1F"/>
                 </a:solidFill>
                 <a:latin typeface="Times New Roman"/>
               </a:rPr>
@@ -7659,7 +7659,7 @@
             <a:r>
               <a:rPr sz="1700" b="1" i="0">
                 <a:solidFill>
-                  <a:srgbClr val="0D4DA3"/>
+                  <a:srgbClr val="8B0029"/>
                 </a:solidFill>
                 <a:latin typeface="Times New Roman"/>
               </a:rPr>
@@ -7690,7 +7690,7 @@
           </a:bodyPr>
           <a:lstStyle/>
           <a:p>
-            <a:pPr algn="r"/>
+            <a:pPr algn="ctr"/>
             <a:r>
               <a:rPr sz="1700" b="0" i="0">
                 <a:solidFill>
@@ -7703,7 +7703,7 @@
             <a:r>
               <a:rPr sz="2000" b="1" i="0">
                 <a:solidFill>
-                  <a:srgbClr val="0D4DA3"/>
+                  <a:srgbClr val="1F1F1F"/>
                 </a:solidFill>
                 <a:latin typeface="Times New Roman"/>
               </a:rPr>
@@ -7712,7 +7712,7 @@
             <a:r>
               <a:rPr sz="1700" b="1" i="0">
                 <a:solidFill>
-                  <a:srgbClr val="0D4DA3"/>
+                  <a:srgbClr val="8B0029"/>
                 </a:solidFill>
                 <a:latin typeface="Times New Roman"/>
               </a:rPr>
@@ -7857,7 +7857,7 @@
           </a:bodyPr>
           <a:lstStyle/>
           <a:p>
-            <a:pPr algn="r"/>
+            <a:pPr algn="ctr"/>
             <a:r>
               <a:rPr sz="1700" b="0" i="0">
                 <a:solidFill>
@@ -7870,7 +7870,7 @@
             <a:r>
               <a:rPr sz="2000" b="1" i="0">
                 <a:solidFill>
-                  <a:srgbClr val="0D4DA3"/>
+                  <a:srgbClr val="1F1F1F"/>
                 </a:solidFill>
                 <a:latin typeface="Times New Roman"/>
               </a:rPr>
@@ -7879,7 +7879,7 @@
             <a:r>
               <a:rPr sz="1700" b="1" i="0">
                 <a:solidFill>
-                  <a:srgbClr val="0D4DA3"/>
+                  <a:srgbClr val="8B0029"/>
                 </a:solidFill>
                 <a:latin typeface="Times New Roman"/>
               </a:rPr>
@@ -7910,7 +7910,7 @@
           </a:bodyPr>
           <a:lstStyle/>
           <a:p>
-            <a:pPr algn="r"/>
+            <a:pPr algn="ctr"/>
             <a:r>
               <a:rPr sz="1700" b="0" i="0">
                 <a:solidFill>
@@ -7923,7 +7923,7 @@
             <a:r>
               <a:rPr sz="2000" b="1" i="0">
                 <a:solidFill>
-                  <a:srgbClr val="0D4DA3"/>
+                  <a:srgbClr val="1F1F1F"/>
                 </a:solidFill>
                 <a:latin typeface="Times New Roman"/>
               </a:rPr>
@@ -7932,7 +7932,7 @@
             <a:r>
               <a:rPr sz="1700" b="1" i="0">
                 <a:solidFill>
-                  <a:srgbClr val="0D4DA3"/>
+                  <a:srgbClr val="8B0029"/>
                 </a:solidFill>
                 <a:latin typeface="Times New Roman"/>
               </a:rPr>
@@ -7963,7 +7963,7 @@
           </a:bodyPr>
           <a:lstStyle/>
           <a:p>
-            <a:pPr algn="r"/>
+            <a:pPr algn="ctr"/>
             <a:r>
               <a:rPr sz="1700" b="0" i="0">
                 <a:solidFill>
@@ -7976,7 +7976,7 @@
             <a:r>
               <a:rPr sz="2000" b="1" i="0">
                 <a:solidFill>
-                  <a:srgbClr val="0D4DA3"/>
+                  <a:srgbClr val="1F1F1F"/>
                 </a:solidFill>
                 <a:latin typeface="Times New Roman"/>
               </a:rPr>
@@ -7985,7 +7985,7 @@
             <a:r>
               <a:rPr sz="1700" b="1" i="0">
                 <a:solidFill>
-                  <a:srgbClr val="0D4DA3"/>
+                  <a:srgbClr val="8B0029"/>
                 </a:solidFill>
                 <a:latin typeface="Times New Roman"/>
               </a:rPr>
@@ -8016,7 +8016,7 @@
           </a:bodyPr>
           <a:lstStyle/>
           <a:p>
-            <a:pPr algn="r"/>
+            <a:pPr algn="ctr"/>
             <a:r>
               <a:rPr sz="1700" b="0" i="0">
                 <a:solidFill>
@@ -8029,7 +8029,7 @@
             <a:r>
               <a:rPr sz="2000" b="1" i="0">
                 <a:solidFill>
-                  <a:srgbClr val="0D4DA3"/>
+                  <a:srgbClr val="1F1F1F"/>
                 </a:solidFill>
                 <a:latin typeface="Times New Roman"/>
               </a:rPr>
@@ -8038,7 +8038,7 @@
             <a:r>
               <a:rPr sz="1700" b="1" i="0">
                 <a:solidFill>
-                  <a:srgbClr val="0D4DA3"/>
+                  <a:srgbClr val="8B0029"/>
                 </a:solidFill>
                 <a:latin typeface="Times New Roman"/>
               </a:rPr>
@@ -8183,7 +8183,7 @@
           </a:bodyPr>
           <a:lstStyle/>
           <a:p>
-            <a:pPr algn="r"/>
+            <a:pPr algn="ctr"/>
             <a:r>
               <a:rPr sz="1700" b="0" i="0">
                 <a:solidFill>
@@ -8196,7 +8196,7 @@
             <a:r>
               <a:rPr sz="2000" b="1" i="0">
                 <a:solidFill>
-                  <a:srgbClr val="0D4DA3"/>
+                  <a:srgbClr val="1F1F1F"/>
                 </a:solidFill>
                 <a:latin typeface="Times New Roman"/>
               </a:rPr>
@@ -8205,7 +8205,7 @@
             <a:r>
               <a:rPr sz="1700" b="1" i="0">
                 <a:solidFill>
-                  <a:srgbClr val="0D4DA3"/>
+                  <a:srgbClr val="8B0029"/>
                 </a:solidFill>
                 <a:latin typeface="Times New Roman"/>
               </a:rPr>
@@ -8236,7 +8236,7 @@
           </a:bodyPr>
           <a:lstStyle/>
           <a:p>
-            <a:pPr algn="r"/>
+            <a:pPr algn="ctr"/>
             <a:r>
               <a:rPr sz="1700" b="0" i="0">
                 <a:solidFill>
@@ -8249,7 +8249,7 @@
             <a:r>
               <a:rPr sz="2000" b="1" i="0">
                 <a:solidFill>
-                  <a:srgbClr val="0D4DA3"/>
+                  <a:srgbClr val="1F1F1F"/>
                 </a:solidFill>
                 <a:latin typeface="Times New Roman"/>
               </a:rPr>
@@ -8258,7 +8258,7 @@
             <a:r>
               <a:rPr sz="1700" b="1" i="0">
                 <a:solidFill>
-                  <a:srgbClr val="0D4DA3"/>
+                  <a:srgbClr val="8B0029"/>
                 </a:solidFill>
                 <a:latin typeface="Times New Roman"/>
               </a:rPr>
@@ -8289,7 +8289,7 @@
           </a:bodyPr>
           <a:lstStyle/>
           <a:p>
-            <a:pPr algn="r"/>
+            <a:pPr algn="ctr"/>
             <a:r>
               <a:rPr sz="1700" b="0" i="0">
                 <a:solidFill>
@@ -8302,7 +8302,7 @@
             <a:r>
               <a:rPr sz="2000" b="1" i="0">
                 <a:solidFill>
-                  <a:srgbClr val="0D4DA3"/>
+                  <a:srgbClr val="1F1F1F"/>
                 </a:solidFill>
                 <a:latin typeface="Times New Roman"/>
               </a:rPr>
@@ -8311,7 +8311,7 @@
             <a:r>
               <a:rPr sz="1700" b="1" i="0">
                 <a:solidFill>
-                  <a:srgbClr val="0D4DA3"/>
+                  <a:srgbClr val="8B0029"/>
                 </a:solidFill>
                 <a:latin typeface="Times New Roman"/>
               </a:rPr>
@@ -8342,7 +8342,7 @@
           </a:bodyPr>
           <a:lstStyle/>
           <a:p>
-            <a:pPr algn="r"/>
+            <a:pPr algn="ctr"/>
             <a:r>
               <a:rPr sz="1700" b="0" i="0">
                 <a:solidFill>
@@ -8355,7 +8355,7 @@
             <a:r>
               <a:rPr sz="2000" b="1" i="0">
                 <a:solidFill>
-                  <a:srgbClr val="0D4DA3"/>
+                  <a:srgbClr val="1F1F1F"/>
                 </a:solidFill>
                 <a:latin typeface="Times New Roman"/>
               </a:rPr>
@@ -8364,7 +8364,7 @@
             <a:r>
               <a:rPr sz="1700" b="1" i="0">
                 <a:solidFill>
-                  <a:srgbClr val="0D4DA3"/>
+                  <a:srgbClr val="8B0029"/>
                 </a:solidFill>
                 <a:latin typeface="Times New Roman"/>
               </a:rPr>
@@ -8509,7 +8509,7 @@
           </a:bodyPr>
           <a:lstStyle/>
           <a:p>
-            <a:pPr algn="r"/>
+            <a:pPr algn="ctr"/>
             <a:r>
               <a:rPr sz="1700" b="0" i="0">
                 <a:solidFill>
@@ -8522,7 +8522,7 @@
             <a:r>
               <a:rPr sz="2000" b="1" i="0">
                 <a:solidFill>
-                  <a:srgbClr val="0D4DA3"/>
+                  <a:srgbClr val="1F1F1F"/>
                 </a:solidFill>
                 <a:latin typeface="Times New Roman"/>
               </a:rPr>
@@ -8531,7 +8531,7 @@
             <a:r>
               <a:rPr sz="1700" b="1" i="0">
                 <a:solidFill>
-                  <a:srgbClr val="0D4DA3"/>
+                  <a:srgbClr val="8B0029"/>
                 </a:solidFill>
                 <a:latin typeface="Times New Roman"/>
               </a:rPr>
@@ -8562,7 +8562,7 @@
           </a:bodyPr>
           <a:lstStyle/>
           <a:p>
-            <a:pPr algn="r"/>
+            <a:pPr algn="ctr"/>
             <a:r>
               <a:rPr sz="1700" b="0" i="0">
                 <a:solidFill>
@@ -8575,7 +8575,7 @@
             <a:r>
               <a:rPr sz="2000" b="1" i="0">
                 <a:solidFill>
-                  <a:srgbClr val="0D4DA3"/>
+                  <a:srgbClr val="1F1F1F"/>
                 </a:solidFill>
                 <a:latin typeface="Times New Roman"/>
               </a:rPr>
@@ -8584,7 +8584,7 @@
             <a:r>
               <a:rPr sz="1700" b="1" i="0">
                 <a:solidFill>
-                  <a:srgbClr val="0D4DA3"/>
+                  <a:srgbClr val="8B0029"/>
                 </a:solidFill>
                 <a:latin typeface="Times New Roman"/>
               </a:rPr>
@@ -8615,7 +8615,7 @@
           </a:bodyPr>
           <a:lstStyle/>
           <a:p>
-            <a:pPr algn="r"/>
+            <a:pPr algn="ctr"/>
             <a:r>
               <a:rPr sz="1700" b="0" i="0">
                 <a:solidFill>
@@ -8628,7 +8628,7 @@
             <a:r>
               <a:rPr sz="2000" b="1" i="0">
                 <a:solidFill>
-                  <a:srgbClr val="0D4DA3"/>
+                  <a:srgbClr val="1F1F1F"/>
                 </a:solidFill>
                 <a:latin typeface="Times New Roman"/>
               </a:rPr>
@@ -8637,7 +8637,7 @@
             <a:r>
               <a:rPr sz="1700" b="1" i="0">
                 <a:solidFill>
-                  <a:srgbClr val="0D4DA3"/>
+                  <a:srgbClr val="8B0029"/>
                 </a:solidFill>
                 <a:latin typeface="Times New Roman"/>
               </a:rPr>
@@ -8668,7 +8668,7 @@
           </a:bodyPr>
           <a:lstStyle/>
           <a:p>
-            <a:pPr algn="r"/>
+            <a:pPr algn="ctr"/>
             <a:r>
               <a:rPr sz="1700" b="0" i="0">
                 <a:solidFill>
@@ -8681,7 +8681,7 @@
             <a:r>
               <a:rPr sz="2000" b="1" i="0">
                 <a:solidFill>
-                  <a:srgbClr val="0D4DA3"/>
+                  <a:srgbClr val="1F1F1F"/>
                 </a:solidFill>
                 <a:latin typeface="Times New Roman"/>
               </a:rPr>
@@ -8690,7 +8690,7 @@
             <a:r>
               <a:rPr sz="1700" b="1" i="0">
                 <a:solidFill>
-                  <a:srgbClr val="0D4DA3"/>
+                  <a:srgbClr val="8B0029"/>
                 </a:solidFill>
                 <a:latin typeface="Times New Roman"/>
               </a:rPr>
@@ -8785,11 +8785,20 @@
             <a:r>
               <a:rPr sz="2200" b="1" i="0">
                 <a:solidFill>
-                  <a:srgbClr val="0D4DA3"/>
-                </a:solidFill>
-                <a:latin typeface="Times New Roman"/>
-              </a:rPr>
-              <a:t>.143 (+32%)</a:t>
+                  <a:srgbClr val="1F1F1F"/>
+                </a:solidFill>
+                <a:latin typeface="Times New Roman"/>
+              </a:rPr>
+              <a:t>.143 </a:t>
+            </a:r>
+            <a:r>
+              <a:rPr sz="2200" b="1" i="0">
+                <a:solidFill>
+                  <a:srgbClr val="8B0029"/>
+                </a:solidFill>
+                <a:latin typeface="Times New Roman"/>
+              </a:rPr>
+              <a:t>(+32%)</a:t>
             </a:r>
             <a:r>
               <a:rPr sz="2200" b="0" i="0">
@@ -8803,11 +8812,20 @@
             <a:r>
               <a:rPr sz="2200" b="1" i="0">
                 <a:solidFill>
-                  <a:srgbClr val="0D4DA3"/>
-                </a:solidFill>
-                <a:latin typeface="Times New Roman"/>
-              </a:rPr>
-              <a:t>.277 (+40%)</a:t>
+                  <a:srgbClr val="1F1F1F"/>
+                </a:solidFill>
+                <a:latin typeface="Times New Roman"/>
+              </a:rPr>
+              <a:t>.277 </a:t>
+            </a:r>
+            <a:r>
+              <a:rPr sz="2200" b="1" i="0">
+                <a:solidFill>
+                  <a:srgbClr val="8B0029"/>
+                </a:solidFill>
+                <a:latin typeface="Times New Roman"/>
+              </a:rPr>
+              <a:t>(+40%)</a:t>
             </a:r>
             <a:r>
               <a:rPr sz="2200" b="0" i="0">
@@ -9243,7 +9261,7 @@
             <a:r>
               <a:rPr sz="2300" b="1" i="0">
                 <a:solidFill>
-                  <a:srgbClr val="0D4DA3"/>
+                  <a:srgbClr val="1F1F1F"/>
                 </a:solidFill>
                 <a:latin typeface="Times New Roman"/>
               </a:rPr>
@@ -9287,7 +9305,7 @@
             <a:r>
               <a:rPr sz="2300" b="1" i="0">
                 <a:solidFill>
-                  <a:srgbClr val="0D4DA3"/>
+                  <a:srgbClr val="1F1F1F"/>
                 </a:solidFill>
                 <a:latin typeface="Times New Roman"/>
               </a:rPr>
@@ -9410,7 +9428,7 @@
             <a:r>
               <a:rPr sz="2300" b="1" i="0">
                 <a:solidFill>
-                  <a:srgbClr val="0D4DA3"/>
+                  <a:srgbClr val="1F1F1F"/>
                 </a:solidFill>
                 <a:latin typeface="Times New Roman"/>
               </a:rPr>
@@ -9454,7 +9472,7 @@
             <a:r>
               <a:rPr sz="2300" b="1" i="0">
                 <a:solidFill>
-                  <a:srgbClr val="0D4DA3"/>
+                  <a:srgbClr val="1F1F1F"/>
                 </a:solidFill>
                 <a:latin typeface="Times New Roman"/>
               </a:rPr>
@@ -9577,7 +9595,7 @@
             <a:r>
               <a:rPr sz="2300" b="1" i="0">
                 <a:solidFill>
-                  <a:srgbClr val="0D4DA3"/>
+                  <a:srgbClr val="1F1F1F"/>
                 </a:solidFill>
                 <a:latin typeface="Times New Roman"/>
               </a:rPr>
@@ -9621,7 +9639,7 @@
             <a:r>
               <a:rPr sz="2300" b="1" i="0">
                 <a:solidFill>
-                  <a:srgbClr val="0D4DA3"/>
+                  <a:srgbClr val="1F1F1F"/>
                 </a:solidFill>
                 <a:latin typeface="Times New Roman"/>
               </a:rPr>
@@ -9744,7 +9762,7 @@
             <a:r>
               <a:rPr sz="2300" b="1" i="0">
                 <a:solidFill>
-                  <a:srgbClr val="0D4DA3"/>
+                  <a:srgbClr val="1F1F1F"/>
                 </a:solidFill>
                 <a:latin typeface="Times New Roman"/>
               </a:rPr>
@@ -9788,7 +9806,7 @@
             <a:r>
               <a:rPr sz="2300" b="1" i="0">
                 <a:solidFill>
-                  <a:srgbClr val="0D4DA3"/>
+                  <a:srgbClr val="1F1F1F"/>
                 </a:solidFill>
                 <a:latin typeface="Times New Roman"/>
               </a:rPr>

</xml_diff>

<commit_message>
feat(poster): larger equation subscripts + per-equation variable legends
Subscripts 0.72x -> 0.82x of base size; each display equation gains a
one-line gray legend ({symbol: name} pairs) under it.
</commit_message>
<xml_diff>
--- a/poster/PMC_CIKM2026_poster.pptx
+++ b/poster/PMC_CIKM2026_poster.pptx
@@ -3755,7 +3755,7 @@
               <a:t>  g = μ</a:t>
             </a:r>
             <a:r>
-              <a:rPr sz="1584" b="0" i="0" baseline="-25000">
+              <a:rPr sz="1804" b="0" i="0" baseline="-25000">
                 <a:solidFill>
                   <a:srgbClr val="1F1F1F"/>
                 </a:solidFill>
@@ -3773,7 +3773,7 @@
               <a:t> − μ</a:t>
             </a:r>
             <a:r>
-              <a:rPr sz="1584" b="0" i="0" baseline="-25000">
+              <a:rPr sz="1804" b="0" i="0" baseline="-25000">
                 <a:solidFill>
                   <a:srgbClr val="1F1F1F"/>
                 </a:solidFill>
@@ -3899,7 +3899,7 @@
               <a:t>BQ encodes each dimension as  sign(x</a:t>
             </a:r>
             <a:r>
-              <a:rPr sz="1584" b="0" i="0" baseline="-25000">
+              <a:rPr sz="1804" b="0" i="0" baseline="-25000">
                 <a:solidFill>
                   <a:srgbClr val="1F1F1F"/>
                 </a:solidFill>
@@ -3917,7 +3917,7 @@
               <a:t> − c</a:t>
             </a:r>
             <a:r>
-              <a:rPr sz="1584" b="0" i="0" baseline="-25000">
+              <a:rPr sz="1804" b="0" i="0" baseline="-25000">
                 <a:solidFill>
                   <a:srgbClr val="1F1F1F"/>
                 </a:solidFill>
@@ -3935,7 +3935,7 @@
               <a:t>)  relative to a centroid c (RaBitQ, Lucene BBQ). With one bit the decision boundary passes exactly through c with zero error margin — and the same centroid routes queries to IVF lists, so one offset corrupts codes and routing at once. Let δ</a:t>
             </a:r>
             <a:r>
-              <a:rPr sz="1584" b="0" i="0" baseline="-25000">
+              <a:rPr sz="1804" b="0" i="0" baseline="-25000">
                 <a:solidFill>
                   <a:srgbClr val="1F1F1F"/>
                 </a:solidFill>
@@ -3953,7 +3953,7 @@
               <a:t> = x</a:t>
             </a:r>
             <a:r>
-              <a:rPr sz="1584" b="0" i="0" baseline="-25000">
+              <a:rPr sz="1804" b="0" i="0" baseline="-25000">
                 <a:solidFill>
                   <a:srgbClr val="1F1F1F"/>
                 </a:solidFill>
@@ -3971,7 +3971,7 @@
               <a:t> − c</a:t>
             </a:r>
             <a:r>
-              <a:rPr sz="1584" b="0" i="0" baseline="-25000">
+              <a:rPr sz="1804" b="0" i="0" baseline="-25000">
                 <a:solidFill>
                   <a:srgbClr val="1F1F1F"/>
                 </a:solidFill>
@@ -4031,7 +4031,7 @@
               <a:t>δ</a:t>
             </a:r>
             <a:r>
-              <a:rPr sz="1943" b="1" i="0" baseline="-25000">
+              <a:rPr sz="2213" b="1" i="0" baseline="-25000">
                 <a:solidFill>
                   <a:srgbClr val="1F1F1F"/>
                 </a:solidFill>
@@ -4049,7 +4049,7 @@
               <a:t> (δ</a:t>
             </a:r>
             <a:r>
-              <a:rPr sz="1943" b="1" i="0" baseline="-25000">
+              <a:rPr sz="2213" b="1" i="0" baseline="-25000">
                 <a:solidFill>
                   <a:srgbClr val="1F1F1F"/>
                 </a:solidFill>
@@ -4067,7 +4067,7 @@
               <a:t> − α g</a:t>
             </a:r>
             <a:r>
-              <a:rPr sz="1943" b="1" i="0" baseline="-25000">
+              <a:rPr sz="2213" b="1" i="0" baseline="-25000">
                 <a:solidFill>
                   <a:srgbClr val="1F1F1F"/>
                 </a:solidFill>
@@ -4085,7 +4085,7 @@
               <a:t>)  &lt;  0 ,      i.e.,      0  &lt;  δ</a:t>
             </a:r>
             <a:r>
-              <a:rPr sz="1943" b="1" i="0" baseline="-25000">
+              <a:rPr sz="2213" b="1" i="0" baseline="-25000">
                 <a:solidFill>
                   <a:srgbClr val="1F1F1F"/>
                 </a:solidFill>
@@ -4103,7 +4103,7 @@
               <a:t> / (α g</a:t>
             </a:r>
             <a:r>
-              <a:rPr sz="1943" b="1" i="0" baseline="-25000">
+              <a:rPr sz="2213" b="1" i="0" baseline="-25000">
                 <a:solidFill>
                   <a:srgbClr val="1F1F1F"/>
                 </a:solidFill>
@@ -4131,7 +4131,121 @@
         </p:nvSpPr>
         <p:spPr>
           <a:xfrm>
-            <a:off x="777240" y="22081926"/>
+            <a:off x="777240" y="21917334"/>
+            <a:ext cx="14040612" cy="371855"/>
+          </a:xfrm>
+          <a:prstGeom prst="rect">
+            <a:avLst/>
+          </a:prstGeom>
+          <a:noFill/>
+        </p:spPr>
+        <p:txBody>
+          <a:bodyPr wrap="square" lIns="0" rIns="0" tIns="0" bIns="0">
+            <a:spAutoFit/>
+          </a:bodyPr>
+          <a:lstStyle/>
+          <a:p>
+            <a:pPr algn="ctr">
+              <a:lnSpc>
+                <a:spcPct val="122000"/>
+              </a:lnSpc>
+              <a:spcAft>
+                <a:spcPts val="0"/>
+              </a:spcAft>
+            </a:pPr>
+            <a:r>
+              <a:rPr sz="2000" b="0" i="1">
+                <a:solidFill>
+                  <a:srgbClr val="6F6F6F"/>
+                </a:solidFill>
+                <a:latin typeface="Times New Roman"/>
+              </a:rPr>
+              <a:t>δ</a:t>
+            </a:r>
+            <a:r>
+              <a:rPr sz="1639" b="0" i="1" baseline="-25000">
+                <a:solidFill>
+                  <a:srgbClr val="6F6F6F"/>
+                </a:solidFill>
+                <a:latin typeface="Times New Roman"/>
+              </a:rPr>
+              <a:t>i</a:t>
+            </a:r>
+            <a:r>
+              <a:rPr sz="2000" b="0" i="1">
+                <a:solidFill>
+                  <a:srgbClr val="6F6F6F"/>
+                </a:solidFill>
+                <a:latin typeface="Times New Roman"/>
+              </a:rPr>
+              <a:t>: residual x</a:t>
+            </a:r>
+            <a:r>
+              <a:rPr sz="1639" b="0" i="1" baseline="-25000">
+                <a:solidFill>
+                  <a:srgbClr val="6F6F6F"/>
+                </a:solidFill>
+                <a:latin typeface="Times New Roman"/>
+              </a:rPr>
+              <a:t>i</a:t>
+            </a:r>
+            <a:r>
+              <a:rPr sz="2000" b="0" i="1">
+                <a:solidFill>
+                  <a:srgbClr val="6F6F6F"/>
+                </a:solidFill>
+                <a:latin typeface="Times New Roman"/>
+              </a:rPr>
+              <a:t> − c</a:t>
+            </a:r>
+            <a:r>
+              <a:rPr sz="1639" b="0" i="1" baseline="-25000">
+                <a:solidFill>
+                  <a:srgbClr val="6F6F6F"/>
+                </a:solidFill>
+                <a:latin typeface="Times New Roman"/>
+              </a:rPr>
+              <a:t>i</a:t>
+            </a:r>
+            <a:r>
+              <a:rPr sz="2000" b="0" i="1">
+                <a:solidFill>
+                  <a:srgbClr val="6F6F6F"/>
+                </a:solidFill>
+                <a:latin typeface="Times New Roman"/>
+              </a:rPr>
+              <a:t>   ·   g</a:t>
+            </a:r>
+            <a:r>
+              <a:rPr sz="1639" b="0" i="1" baseline="-25000">
+                <a:solidFill>
+                  <a:srgbClr val="6F6F6F"/>
+                </a:solidFill>
+                <a:latin typeface="Times New Roman"/>
+              </a:rPr>
+              <a:t>i</a:t>
+            </a:r>
+            <a:r>
+              <a:rPr sz="2000" b="0" i="1">
+                <a:solidFill>
+                  <a:srgbClr val="6F6F6F"/>
+                </a:solidFill>
+                <a:latin typeface="Times New Roman"/>
+              </a:rPr>
+              <a:t>: gap component   ·   α: shift strength</a:t>
+            </a:r>
+          </a:p>
+        </p:txBody>
+      </p:sp>
+      <p:sp>
+        <p:nvSpPr>
+          <p:cNvPr id="23" name="TextBox 22"/>
+          <p:cNvSpPr txBox="1"/>
+          <p:nvPr/>
+        </p:nvSpPr>
+        <p:spPr>
+          <a:xfrm>
+            <a:off x="777240" y="22453781"/>
             <a:ext cx="14040612" cy="472541"/>
           </a:xfrm>
           <a:prstGeom prst="rect">
@@ -4167,13 +4281,13 @@
       </p:sp>
       <p:sp>
         <p:nvSpPr>
-          <p:cNvPr id="23" name="TextBox 22"/>
-          <p:cNvSpPr txBox="1"/>
-          <p:nvPr/>
-        </p:nvSpPr>
-        <p:spPr>
-          <a:xfrm>
-            <a:off x="777240" y="22700771"/>
+          <p:cNvPr id="24" name="TextBox 23"/>
+          <p:cNvSpPr txBox="1"/>
+          <p:nvPr/>
+        </p:nvSpPr>
+        <p:spPr>
+          <a:xfrm>
+            <a:off x="777240" y="23072626"/>
             <a:ext cx="14040612" cy="557784"/>
           </a:xfrm>
           <a:prstGeom prst="rect">
@@ -4205,7 +4319,7 @@
               <a:t>E[F]  ≈  α Σ</a:t>
             </a:r>
             <a:r>
-              <a:rPr sz="2160" b="1" i="0" baseline="-25000">
+              <a:rPr sz="2460" b="1" i="0" baseline="-25000">
                 <a:solidFill>
                   <a:srgbClr val="1F1F1F"/>
                 </a:solidFill>
@@ -4223,7 +4337,7 @@
               <a:t> p</a:t>
             </a:r>
             <a:r>
-              <a:rPr sz="2160" b="1" i="0" baseline="-25000">
+              <a:rPr sz="2460" b="1" i="0" baseline="-25000">
                 <a:solidFill>
                   <a:srgbClr val="1F1F1F"/>
                 </a:solidFill>
@@ -4241,7 +4355,7 @@
               <a:t>(0) |g</a:t>
             </a:r>
             <a:r>
-              <a:rPr sz="2160" b="1" i="0" baseline="-25000">
+              <a:rPr sz="2460" b="1" i="0" baseline="-25000">
                 <a:solidFill>
                   <a:srgbClr val="1F1F1F"/>
                 </a:solidFill>
@@ -4263,13 +4377,73 @@
       </p:sp>
       <p:sp>
         <p:nvSpPr>
-          <p:cNvPr id="24" name="TextBox 23"/>
-          <p:cNvSpPr txBox="1"/>
-          <p:nvPr/>
-        </p:nvSpPr>
-        <p:spPr>
-          <a:xfrm>
-            <a:off x="777240" y="23423147"/>
+          <p:cNvPr id="25" name="TextBox 24"/>
+          <p:cNvSpPr txBox="1"/>
+          <p:nvPr/>
+        </p:nvSpPr>
+        <p:spPr>
+          <a:xfrm>
+            <a:off x="777240" y="23630410"/>
+            <a:ext cx="14040612" cy="371855"/>
+          </a:xfrm>
+          <a:prstGeom prst="rect">
+            <a:avLst/>
+          </a:prstGeom>
+          <a:noFill/>
+        </p:spPr>
+        <p:txBody>
+          <a:bodyPr wrap="square" lIns="0" rIns="0" tIns="0" bIns="0">
+            <a:spAutoFit/>
+          </a:bodyPr>
+          <a:lstStyle/>
+          <a:p>
+            <a:pPr algn="ctr">
+              <a:lnSpc>
+                <a:spcPct val="122000"/>
+              </a:lnSpc>
+              <a:spcAft>
+                <a:spcPts val="0"/>
+              </a:spcAft>
+            </a:pPr>
+            <a:r>
+              <a:rPr sz="2000" b="0" i="1">
+                <a:solidFill>
+                  <a:srgbClr val="6F6F6F"/>
+                </a:solidFill>
+                <a:latin typeface="Times New Roman"/>
+              </a:rPr>
+              <a:t>E[F]: expected bit flips   ·   p</a:t>
+            </a:r>
+            <a:r>
+              <a:rPr sz="1639" b="0" i="1" baseline="-25000">
+                <a:solidFill>
+                  <a:srgbClr val="6F6F6F"/>
+                </a:solidFill>
+                <a:latin typeface="Times New Roman"/>
+              </a:rPr>
+              <a:t>i</a:t>
+            </a:r>
+            <a:r>
+              <a:rPr sz="2000" b="0" i="1">
+                <a:solidFill>
+                  <a:srgbClr val="6F6F6F"/>
+                </a:solidFill>
+                <a:latin typeface="Times New Roman"/>
+              </a:rPr>
+              <a:t>(0): residual density at the code boundary</a:t>
+            </a:r>
+          </a:p>
+        </p:txBody>
+      </p:sp>
+      <p:sp>
+        <p:nvSpPr>
+          <p:cNvPr id="26" name="TextBox 25"/>
+          <p:cNvSpPr txBox="1"/>
+          <p:nvPr/>
+        </p:nvSpPr>
+        <p:spPr>
+          <a:xfrm>
+            <a:off x="777240" y="24166857"/>
             <a:ext cx="14040612" cy="881583"/>
           </a:xfrm>
           <a:prstGeom prst="rect">
@@ -4301,7 +4475,7 @@
               <a:t>a density-weighted ℓ₁ norm of the gap: flip risk grows with |g</a:t>
             </a:r>
             <a:r>
-              <a:rPr sz="1584" b="0" i="0" baseline="-25000">
+              <a:rPr sz="1804" b="0" i="0" baseline="-25000">
                 <a:solidFill>
                   <a:srgbClr val="1F1F1F"/>
                 </a:solidFill>
@@ -4323,13 +4497,13 @@
       </p:sp>
       <p:sp>
         <p:nvSpPr>
-          <p:cNvPr id="25" name="Rectangle 24"/>
+          <p:cNvPr id="27" name="Rectangle 26"/>
           <p:cNvSpPr/>
           <p:nvPr/>
         </p:nvSpPr>
         <p:spPr>
           <a:xfrm>
-            <a:off x="777240" y="24432746"/>
+            <a:off x="777240" y="25176456"/>
             <a:ext cx="14040612" cy="1384604"/>
           </a:xfrm>
           <a:prstGeom prst="rect">
@@ -4369,13 +4543,13 @@
       </p:sp>
       <p:sp>
         <p:nvSpPr>
-          <p:cNvPr id="26" name="TextBox 25"/>
-          <p:cNvSpPr txBox="1"/>
-          <p:nvPr/>
-        </p:nvSpPr>
-        <p:spPr>
-          <a:xfrm>
-            <a:off x="1014984" y="24670490"/>
+          <p:cNvPr id="28" name="TextBox 27"/>
+          <p:cNvSpPr txBox="1"/>
+          <p:nvPr/>
+        </p:nvSpPr>
+        <p:spPr>
+          <a:xfrm>
+            <a:off x="1014984" y="25414200"/>
             <a:ext cx="13565124" cy="909116"/>
           </a:xfrm>
           <a:prstGeom prst="rect">
@@ -4438,13 +4612,13 @@
       </p:sp>
       <p:sp>
         <p:nvSpPr>
-          <p:cNvPr id="27" name="TextBox 26"/>
-          <p:cNvSpPr txBox="1"/>
-          <p:nvPr/>
-        </p:nvSpPr>
-        <p:spPr>
-          <a:xfrm>
-            <a:off x="777240" y="25890502"/>
+          <p:cNvPr id="29" name="TextBox 28"/>
+          <p:cNvSpPr txBox="1"/>
+          <p:nvPr/>
+        </p:nvSpPr>
+        <p:spPr>
+          <a:xfrm>
+            <a:off x="777240" y="26634212"/>
             <a:ext cx="14040612" cy="560070"/>
           </a:xfrm>
           <a:prstGeom prst="rect">
@@ -4480,13 +4654,13 @@
       </p:sp>
       <p:sp>
         <p:nvSpPr>
-          <p:cNvPr id="28" name="Rectangle 27"/>
+          <p:cNvPr id="30" name="Rectangle 29"/>
           <p:cNvSpPr/>
           <p:nvPr/>
         </p:nvSpPr>
         <p:spPr>
           <a:xfrm>
-            <a:off x="777240" y="26496292"/>
+            <a:off x="777240" y="27240002"/>
             <a:ext cx="14040612" cy="31750"/>
           </a:xfrm>
           <a:prstGeom prst="rect">
@@ -4524,13 +4698,13 @@
       </p:sp>
       <p:sp>
         <p:nvSpPr>
-          <p:cNvPr id="29" name="TextBox 28"/>
-          <p:cNvSpPr txBox="1"/>
-          <p:nvPr/>
-        </p:nvSpPr>
-        <p:spPr>
-          <a:xfrm>
-            <a:off x="777240" y="26573762"/>
+          <p:cNvPr id="31" name="TextBox 30"/>
+          <p:cNvSpPr txBox="1"/>
+          <p:nvPr/>
+        </p:nvSpPr>
+        <p:spPr>
+          <a:xfrm>
+            <a:off x="777240" y="27317472"/>
             <a:ext cx="14040612" cy="881583"/>
           </a:xfrm>
           <a:prstGeom prst="rect">
@@ -4566,13 +4740,13 @@
       </p:sp>
       <p:sp>
         <p:nvSpPr>
-          <p:cNvPr id="30" name="TextBox 29"/>
-          <p:cNvSpPr txBox="1"/>
-          <p:nvPr/>
-        </p:nvSpPr>
-        <p:spPr>
-          <a:xfrm>
-            <a:off x="777240" y="27601649"/>
+          <p:cNvPr id="32" name="TextBox 31"/>
+          <p:cNvSpPr txBox="1"/>
+          <p:nvPr/>
+        </p:nvSpPr>
+        <p:spPr>
+          <a:xfrm>
+            <a:off x="777240" y="28345359"/>
             <a:ext cx="14040612" cy="502005"/>
           </a:xfrm>
           <a:prstGeom prst="rect">
@@ -4608,13 +4782,13 @@
       </p:sp>
       <p:sp>
         <p:nvSpPr>
-          <p:cNvPr id="31" name="TextBox 30"/>
-          <p:cNvSpPr txBox="1"/>
-          <p:nvPr/>
-        </p:nvSpPr>
-        <p:spPr>
-          <a:xfrm>
-            <a:off x="777240" y="28103654"/>
+          <p:cNvPr id="33" name="TextBox 32"/>
+          <p:cNvSpPr txBox="1"/>
+          <p:nvPr/>
+        </p:nvSpPr>
+        <p:spPr>
+          <a:xfrm>
+            <a:off x="777240" y="28847364"/>
             <a:ext cx="14040612" cy="371855"/>
           </a:xfrm>
           <a:prstGeom prst="rect">
@@ -4643,20 +4817,20 @@
                 </a:solidFill>
                 <a:latin typeface="Times New Roman"/>
               </a:rPr>
-              <a:t>α ∈ [0,1];  α = 1  →  q′ = q</a:t>
-            </a:r>
-          </a:p>
-        </p:txBody>
-      </p:sp>
-      <p:sp>
-        <p:nvSpPr>
-          <p:cNvPr id="32" name="TextBox 31"/>
-          <p:cNvSpPr txBox="1"/>
-          <p:nvPr/>
-        </p:nvSpPr>
-        <p:spPr>
-          <a:xfrm>
-            <a:off x="777240" y="28640101"/>
+              <a:t>x: database vector   ·   q: query   ·   g: modality gap   ·   α ∈ [0,1]: shift strength  (α = 1  →  q′ = q)</a:t>
+            </a:r>
+          </a:p>
+        </p:txBody>
+      </p:sp>
+      <p:sp>
+        <p:nvSpPr>
+          <p:cNvPr id="34" name="TextBox 33"/>
+          <p:cNvSpPr txBox="1"/>
+          <p:nvPr/>
+        </p:nvSpPr>
+        <p:spPr>
+          <a:xfrm>
+            <a:off x="777240" y="29383811"/>
             <a:ext cx="14040612" cy="1290624"/>
           </a:xfrm>
           <a:prstGeom prst="rect">
@@ -4692,13 +4866,13 @@
       </p:sp>
       <p:sp>
         <p:nvSpPr>
-          <p:cNvPr id="33" name="Rectangle 32"/>
+          <p:cNvPr id="35" name="Rectangle 34"/>
           <p:cNvSpPr/>
           <p:nvPr/>
         </p:nvSpPr>
         <p:spPr>
           <a:xfrm>
-            <a:off x="777240" y="30077029"/>
+            <a:off x="777240" y="30820739"/>
             <a:ext cx="14040612" cy="27940"/>
           </a:xfrm>
           <a:prstGeom prst="rect">
@@ -4736,13 +4910,13 @@
       </p:sp>
       <p:sp>
         <p:nvSpPr>
-          <p:cNvPr id="34" name="TextBox 33"/>
-          <p:cNvSpPr txBox="1"/>
-          <p:nvPr/>
-        </p:nvSpPr>
-        <p:spPr>
-          <a:xfrm>
-            <a:off x="777240" y="30168469"/>
+          <p:cNvPr id="36" name="TextBox 35"/>
+          <p:cNvSpPr txBox="1"/>
+          <p:nvPr/>
+        </p:nvSpPr>
+        <p:spPr>
+          <a:xfrm>
+            <a:off x="777240" y="30912179"/>
             <a:ext cx="14040612" cy="427634"/>
           </a:xfrm>
           <a:prstGeom prst="rect">
@@ -4778,13 +4952,13 @@
       </p:sp>
       <p:sp>
         <p:nvSpPr>
-          <p:cNvPr id="35" name="Rectangle 34"/>
+          <p:cNvPr id="37" name="Rectangle 36"/>
           <p:cNvSpPr/>
           <p:nvPr/>
         </p:nvSpPr>
         <p:spPr>
           <a:xfrm>
-            <a:off x="777240" y="30669255"/>
+            <a:off x="777240" y="31412965"/>
             <a:ext cx="14040612" cy="12700"/>
           </a:xfrm>
           <a:prstGeom prst="rect">
@@ -4822,13 +4996,13 @@
       </p:sp>
       <p:sp>
         <p:nvSpPr>
-          <p:cNvPr id="36" name="TextBox 35"/>
-          <p:cNvSpPr txBox="1"/>
-          <p:nvPr/>
-        </p:nvSpPr>
-        <p:spPr>
-          <a:xfrm>
-            <a:off x="777240" y="30760695"/>
+          <p:cNvPr id="38" name="TextBox 37"/>
+          <p:cNvSpPr txBox="1"/>
+          <p:nvPr/>
+        </p:nvSpPr>
+        <p:spPr>
+          <a:xfrm>
+            <a:off x="777240" y="31504405"/>
             <a:ext cx="14040612" cy="4087368"/>
           </a:xfrm>
           <a:prstGeom prst="rect">
@@ -4916,7 +5090,7 @@
               <a:t>1:  μ</a:t>
             </a:r>
             <a:r>
-              <a:rPr sz="1512" b="0" i="0" baseline="-25000">
+              <a:rPr sz="1722" b="0" i="0" baseline="-25000">
                 <a:solidFill>
                   <a:srgbClr val="1F1F1F"/>
                 </a:solidFill>
@@ -4934,7 +5108,7 @@
               <a:t> ← mean(Q);   μ</a:t>
             </a:r>
             <a:r>
-              <a:rPr sz="1512" b="0" i="0" baseline="-25000">
+              <a:rPr sz="1722" b="0" i="0" baseline="-25000">
                 <a:solidFill>
                   <a:srgbClr val="1F1F1F"/>
                 </a:solidFill>
@@ -4971,7 +5145,7 @@
               <a:t>2:  g ← μ</a:t>
             </a:r>
             <a:r>
-              <a:rPr sz="1512" b="0" i="0" baseline="-25000">
+              <a:rPr sz="1722" b="0" i="0" baseline="-25000">
                 <a:solidFill>
                   <a:srgbClr val="1F1F1F"/>
                 </a:solidFill>
@@ -4989,7 +5163,7 @@
               <a:t> − μ</a:t>
             </a:r>
             <a:r>
-              <a:rPr sz="1512" b="0" i="0" baseline="-25000">
+              <a:rPr sz="1722" b="0" i="0" baseline="-25000">
                 <a:solidFill>
                   <a:srgbClr val="1F1F1F"/>
                 </a:solidFill>
@@ -5097,13 +5271,13 @@
       </p:sp>
       <p:sp>
         <p:nvSpPr>
-          <p:cNvPr id="37" name="Rectangle 36"/>
+          <p:cNvPr id="39" name="Rectangle 38"/>
           <p:cNvSpPr/>
           <p:nvPr/>
         </p:nvSpPr>
         <p:spPr>
           <a:xfrm>
-            <a:off x="777240" y="34921215"/>
+            <a:off x="777240" y="35664925"/>
             <a:ext cx="14040612" cy="27940"/>
           </a:xfrm>
           <a:prstGeom prst="rect">
@@ -5141,13 +5315,13 @@
       </p:sp>
       <p:sp>
         <p:nvSpPr>
-          <p:cNvPr id="38" name="TextBox 37"/>
-          <p:cNvSpPr txBox="1"/>
-          <p:nvPr/>
-        </p:nvSpPr>
-        <p:spPr>
-          <a:xfrm>
-            <a:off x="777240" y="35213823"/>
+          <p:cNvPr id="40" name="TextBox 39"/>
+          <p:cNvSpPr txBox="1"/>
+          <p:nvPr/>
+        </p:nvSpPr>
+        <p:spPr>
+          <a:xfrm>
+            <a:off x="777240" y="35957533"/>
             <a:ext cx="14040612" cy="472541"/>
           </a:xfrm>
           <a:prstGeom prst="rect">
@@ -5188,7 +5362,7 @@
               <a:t>Correction restricted to the top-P% of dimensions ranked by |g</a:t>
             </a:r>
             <a:r>
-              <a:rPr sz="1584" b="0" i="0" baseline="-25000">
+              <a:rPr sz="1804" b="0" i="0" baseline="-25000">
                 <a:solidFill>
                   <a:srgbClr val="1F1F1F"/>
                 </a:solidFill>
@@ -5210,13 +5384,13 @@
       </p:sp>
       <p:sp>
         <p:nvSpPr>
-          <p:cNvPr id="39" name="TextBox 38"/>
-          <p:cNvSpPr txBox="1"/>
-          <p:nvPr/>
-        </p:nvSpPr>
-        <p:spPr>
-          <a:xfrm>
-            <a:off x="777240" y="35832668"/>
+          <p:cNvPr id="41" name="TextBox 40"/>
+          <p:cNvSpPr txBox="1"/>
+          <p:nvPr/>
+        </p:nvSpPr>
+        <p:spPr>
+          <a:xfrm>
+            <a:off x="777240" y="36576378"/>
             <a:ext cx="14040612" cy="464820"/>
           </a:xfrm>
           <a:prstGeom prst="rect">
@@ -5248,7 +5422,7 @@
               <a:t>g</a:t>
             </a:r>
             <a:r>
-              <a:rPr sz="1800" b="1" i="0" baseline="-25000">
+              <a:rPr sz="2050" b="1" i="0" baseline="-25000">
                 <a:solidFill>
                   <a:srgbClr val="1F1F1F"/>
                 </a:solidFill>
@@ -5266,7 +5440,7 @@
               <a:t> = g</a:t>
             </a:r>
             <a:r>
-              <a:rPr sz="1800" b="1" i="0" baseline="-25000">
+              <a:rPr sz="2050" b="1" i="0" baseline="-25000">
                 <a:solidFill>
                   <a:srgbClr val="1F1F1F"/>
                 </a:solidFill>
@@ -5284,7 +5458,7 @@
               <a:t>  if  |g</a:t>
             </a:r>
             <a:r>
-              <a:rPr sz="1800" b="1" i="0" baseline="-25000">
+              <a:rPr sz="2050" b="1" i="0" baseline="-25000">
                 <a:solidFill>
                   <a:srgbClr val="1F1F1F"/>
                 </a:solidFill>
@@ -5302,7 +5476,7 @@
               <a:t>| ≥ |g|</a:t>
             </a:r>
             <a:r>
-              <a:rPr sz="1800" b="1" i="0" baseline="-25000">
+              <a:rPr sz="2050" b="1" i="0" baseline="-25000">
                 <a:solidFill>
                   <a:srgbClr val="1F1F1F"/>
                 </a:solidFill>
@@ -5320,7 +5494,7 @@
               <a:t> ,  0  otherwise ;      x′</a:t>
             </a:r>
             <a:r>
-              <a:rPr sz="1800" b="1" i="0" baseline="-25000">
+              <a:rPr sz="2050" b="1" i="0" baseline="-25000">
                 <a:solidFill>
                   <a:srgbClr val="1F1F1F"/>
                 </a:solidFill>
@@ -5338,7 +5512,7 @@
               <a:t> = (x + α g</a:t>
             </a:r>
             <a:r>
-              <a:rPr sz="1800" b="1" i="0" baseline="-25000">
+              <a:rPr sz="2050" b="1" i="0" baseline="-25000">
                 <a:solidFill>
                   <a:srgbClr val="1F1F1F"/>
                 </a:solidFill>
@@ -5356,7 +5530,7 @@
               <a:t>) / ‖x + α g</a:t>
             </a:r>
             <a:r>
-              <a:rPr sz="1800" b="1" i="0" baseline="-25000">
+              <a:rPr sz="2050" b="1" i="0" baseline="-25000">
                 <a:solidFill>
                   <a:srgbClr val="1F1F1F"/>
                 </a:solidFill>
@@ -5378,14 +5552,14 @@
       </p:sp>
       <p:sp>
         <p:nvSpPr>
-          <p:cNvPr id="40" name="TextBox 39"/>
-          <p:cNvSpPr txBox="1"/>
-          <p:nvPr/>
-        </p:nvSpPr>
-        <p:spPr>
-          <a:xfrm>
-            <a:off x="777240" y="36608384"/>
-            <a:ext cx="14040612" cy="464820"/>
+          <p:cNvPr id="42" name="TextBox 41"/>
+          <p:cNvSpPr txBox="1"/>
+          <p:nvPr/>
+        </p:nvSpPr>
+        <p:spPr>
+          <a:xfrm>
+            <a:off x="777240" y="37041198"/>
+            <a:ext cx="14040612" cy="371855"/>
           </a:xfrm>
           <a:prstGeom prst="rect">
             <a:avLst/>
@@ -5407,99 +5581,63 @@
               </a:spcAft>
             </a:pPr>
             <a:r>
-              <a:rPr sz="2500" b="1" i="0">
-                <a:solidFill>
-                  <a:srgbClr val="1F1F1F"/>
-                </a:solidFill>
-                <a:latin typeface="Times New Roman"/>
-              </a:rPr>
-              <a:t>E(P)  =  Σ</a:t>
-            </a:r>
-            <a:r>
-              <a:rPr sz="1800" b="1" i="0" baseline="-25000">
-                <a:solidFill>
-                  <a:srgbClr val="1F1F1F"/>
-                </a:solidFill>
-                <a:latin typeface="Times New Roman"/>
-              </a:rPr>
-              <a:t>i ∈ S(P)</a:t>
-            </a:r>
-            <a:r>
-              <a:rPr sz="2500" b="1" i="0">
-                <a:solidFill>
-                  <a:srgbClr val="1F1F1F"/>
-                </a:solidFill>
-                <a:latin typeface="Times New Roman"/>
-              </a:rPr>
-              <a:t> g</a:t>
-            </a:r>
-            <a:r>
-              <a:rPr sz="1800" b="1" i="0" baseline="-25000">
-                <a:solidFill>
-                  <a:srgbClr val="1F1F1F"/>
-                </a:solidFill>
-                <a:latin typeface="Times New Roman"/>
-              </a:rPr>
-              <a:t>i</a:t>
-            </a:r>
-            <a:r>
-              <a:rPr sz="2500" b="1" i="0">
-                <a:solidFill>
-                  <a:srgbClr val="1F1F1F"/>
-                </a:solidFill>
-                <a:latin typeface="Times New Roman"/>
-              </a:rPr>
-              <a:t>²  /  ‖g‖² ,      S(P) = { i : |g</a:t>
-            </a:r>
-            <a:r>
-              <a:rPr sz="1800" b="1" i="0" baseline="-25000">
-                <a:solidFill>
-                  <a:srgbClr val="1F1F1F"/>
-                </a:solidFill>
-                <a:latin typeface="Times New Roman"/>
-              </a:rPr>
-              <a:t>i</a:t>
-            </a:r>
-            <a:r>
-              <a:rPr sz="2500" b="1" i="0">
-                <a:solidFill>
-                  <a:srgbClr val="1F1F1F"/>
-                </a:solidFill>
-                <a:latin typeface="Times New Roman"/>
-              </a:rPr>
-              <a:t>| ≥ |g|</a:t>
-            </a:r>
-            <a:r>
-              <a:rPr sz="1800" b="1" i="0" baseline="-25000">
-                <a:solidFill>
-                  <a:srgbClr val="1F1F1F"/>
+              <a:rPr sz="2000" b="0" i="1">
+                <a:solidFill>
+                  <a:srgbClr val="6F6F6F"/>
+                </a:solidFill>
+                <a:latin typeface="Times New Roman"/>
+              </a:rPr>
+              <a:t>g</a:t>
+            </a:r>
+            <a:r>
+              <a:rPr sz="1639" b="0" i="1" baseline="-25000">
+                <a:solidFill>
+                  <a:srgbClr val="6F6F6F"/>
+                </a:solidFill>
+                <a:latin typeface="Times New Roman"/>
+              </a:rPr>
+              <a:t>sel</a:t>
+            </a:r>
+            <a:r>
+              <a:rPr sz="2000" b="0" i="1">
+                <a:solidFill>
+                  <a:srgbClr val="6F6F6F"/>
+                </a:solidFill>
+                <a:latin typeface="Times New Roman"/>
+              </a:rPr>
+              <a:t>: truncated gap   ·   |g|</a:t>
+            </a:r>
+            <a:r>
+              <a:rPr sz="1639" b="0" i="1" baseline="-25000">
+                <a:solidFill>
+                  <a:srgbClr val="6F6F6F"/>
                 </a:solidFill>
                 <a:latin typeface="Times New Roman"/>
               </a:rPr>
               <a:t>(P)</a:t>
             </a:r>
             <a:r>
-              <a:rPr sz="2500" b="1" i="0">
-                <a:solidFill>
-                  <a:srgbClr val="1F1F1F"/>
-                </a:solidFill>
-                <a:latin typeface="Times New Roman"/>
-              </a:rPr>
-              <a:t> }</a:t>
-            </a:r>
-          </a:p>
-        </p:txBody>
-      </p:sp>
-      <p:sp>
-        <p:nvSpPr>
-          <p:cNvPr id="41" name="TextBox 40"/>
-          <p:cNvSpPr txBox="1"/>
-          <p:nvPr/>
-        </p:nvSpPr>
-        <p:spPr>
-          <a:xfrm>
-            <a:off x="777240" y="37073204"/>
-            <a:ext cx="14040612" cy="371855"/>
+              <a:rPr sz="2000" b="0" i="1">
+                <a:solidFill>
+                  <a:srgbClr val="6F6F6F"/>
+                </a:solidFill>
+                <a:latin typeface="Times New Roman"/>
+              </a:rPr>
+              <a:t>: top-P% magnitude threshold</a:t>
+            </a:r>
+          </a:p>
+        </p:txBody>
+      </p:sp>
+      <p:sp>
+        <p:nvSpPr>
+          <p:cNvPr id="43" name="TextBox 42"/>
+          <p:cNvSpPr txBox="1"/>
+          <p:nvPr/>
+        </p:nvSpPr>
+        <p:spPr>
+          <a:xfrm>
+            <a:off x="777240" y="37723949"/>
+            <a:ext cx="14040612" cy="464820"/>
           </a:xfrm>
           <a:prstGeom prst="rect">
             <a:avLst/>
@@ -5521,26 +5659,140 @@
               </a:spcAft>
             </a:pPr>
             <a:r>
+              <a:rPr sz="2500" b="1" i="0">
+                <a:solidFill>
+                  <a:srgbClr val="1F1F1F"/>
+                </a:solidFill>
+                <a:latin typeface="Times New Roman"/>
+              </a:rPr>
+              <a:t>E(P)  =  Σ</a:t>
+            </a:r>
+            <a:r>
+              <a:rPr sz="2050" b="1" i="0" baseline="-25000">
+                <a:solidFill>
+                  <a:srgbClr val="1F1F1F"/>
+                </a:solidFill>
+                <a:latin typeface="Times New Roman"/>
+              </a:rPr>
+              <a:t>i ∈ S(P)</a:t>
+            </a:r>
+            <a:r>
+              <a:rPr sz="2500" b="1" i="0">
+                <a:solidFill>
+                  <a:srgbClr val="1F1F1F"/>
+                </a:solidFill>
+                <a:latin typeface="Times New Roman"/>
+              </a:rPr>
+              <a:t> g</a:t>
+            </a:r>
+            <a:r>
+              <a:rPr sz="2050" b="1" i="0" baseline="-25000">
+                <a:solidFill>
+                  <a:srgbClr val="1F1F1F"/>
+                </a:solidFill>
+                <a:latin typeface="Times New Roman"/>
+              </a:rPr>
+              <a:t>i</a:t>
+            </a:r>
+            <a:r>
+              <a:rPr sz="2500" b="1" i="0">
+                <a:solidFill>
+                  <a:srgbClr val="1F1F1F"/>
+                </a:solidFill>
+                <a:latin typeface="Times New Roman"/>
+              </a:rPr>
+              <a:t>²  /  ‖g‖² ,      S(P) = { i : |g</a:t>
+            </a:r>
+            <a:r>
+              <a:rPr sz="2050" b="1" i="0" baseline="-25000">
+                <a:solidFill>
+                  <a:srgbClr val="1F1F1F"/>
+                </a:solidFill>
+                <a:latin typeface="Times New Roman"/>
+              </a:rPr>
+              <a:t>i</a:t>
+            </a:r>
+            <a:r>
+              <a:rPr sz="2500" b="1" i="0">
+                <a:solidFill>
+                  <a:srgbClr val="1F1F1F"/>
+                </a:solidFill>
+                <a:latin typeface="Times New Roman"/>
+              </a:rPr>
+              <a:t>| ≥ |g|</a:t>
+            </a:r>
+            <a:r>
+              <a:rPr sz="2050" b="1" i="0" baseline="-25000">
+                <a:solidFill>
+                  <a:srgbClr val="1F1F1F"/>
+                </a:solidFill>
+                <a:latin typeface="Times New Roman"/>
+              </a:rPr>
+              <a:t>(P)</a:t>
+            </a:r>
+            <a:r>
+              <a:rPr sz="2500" b="1" i="0">
+                <a:solidFill>
+                  <a:srgbClr val="1F1F1F"/>
+                </a:solidFill>
+                <a:latin typeface="Times New Roman"/>
+              </a:rPr>
+              <a:t> }</a:t>
+            </a:r>
+          </a:p>
+        </p:txBody>
+      </p:sp>
+      <p:sp>
+        <p:nvSpPr>
+          <p:cNvPr id="44" name="TextBox 43"/>
+          <p:cNvSpPr txBox="1"/>
+          <p:nvPr/>
+        </p:nvSpPr>
+        <p:spPr>
+          <a:xfrm>
+            <a:off x="777240" y="38188769"/>
+            <a:ext cx="14040612" cy="371855"/>
+          </a:xfrm>
+          <a:prstGeom prst="rect">
+            <a:avLst/>
+          </a:prstGeom>
+          <a:noFill/>
+        </p:spPr>
+        <p:txBody>
+          <a:bodyPr wrap="square" lIns="0" rIns="0" tIns="0" bIns="0">
+            <a:spAutoFit/>
+          </a:bodyPr>
+          <a:lstStyle/>
+          <a:p>
+            <a:pPr algn="ctr">
+              <a:lnSpc>
+                <a:spcPct val="122000"/>
+              </a:lnSpc>
+              <a:spcAft>
+                <a:spcPts val="0"/>
+              </a:spcAft>
+            </a:pPr>
+            <a:r>
               <a:rPr sz="2000" b="0" i="1">
                 <a:solidFill>
                   <a:srgbClr val="6F6F6F"/>
                 </a:solidFill>
                 <a:latin typeface="Times New Roman"/>
               </a:rPr>
-              <a:t>cumulative gap energy captured by the selected dimensions</a:t>
-            </a:r>
-          </a:p>
-        </p:txBody>
-      </p:sp>
-      <p:sp>
-        <p:nvSpPr>
-          <p:cNvPr id="42" name="TextBox 41"/>
-          <p:cNvSpPr txBox="1"/>
-          <p:nvPr/>
-        </p:nvSpPr>
-        <p:spPr>
-          <a:xfrm>
-            <a:off x="777240" y="37609651"/>
+              <a:t>E(P): captured gap-energy fraction   ·   S(P): top-P% index set</a:t>
+            </a:r>
+          </a:p>
+        </p:txBody>
+      </p:sp>
+      <p:sp>
+        <p:nvSpPr>
+          <p:cNvPr id="45" name="TextBox 44"/>
+          <p:cNvSpPr txBox="1"/>
+          <p:nvPr/>
+        </p:nvSpPr>
+        <p:spPr>
+          <a:xfrm>
+            <a:off x="777240" y="38725216"/>
             <a:ext cx="14040612" cy="1290624"/>
           </a:xfrm>
           <a:prstGeom prst="rect">
@@ -5572,7 +5824,7 @@
               <a:t>isolates the mechanism. Since flip risk concentrates in high-|g</a:t>
             </a:r>
             <a:r>
-              <a:rPr sz="1584" b="0" i="0" baseline="-25000">
+              <a:rPr sz="1804" b="0" i="0" baseline="-25000">
                 <a:solidFill>
                   <a:srgbClr val="1F1F1F"/>
                 </a:solidFill>
@@ -5594,7 +5846,7 @@
       </p:sp>
       <p:sp>
         <p:nvSpPr>
-          <p:cNvPr id="43" name="TextBox 42"/>
+          <p:cNvPr id="46" name="TextBox 45"/>
           <p:cNvSpPr txBox="1"/>
           <p:nvPr/>
         </p:nvSpPr>
@@ -5636,7 +5888,7 @@
       </p:sp>
       <p:sp>
         <p:nvSpPr>
-          <p:cNvPr id="44" name="Rectangle 43"/>
+          <p:cNvPr id="47" name="Rectangle 46"/>
           <p:cNvSpPr/>
           <p:nvPr/>
         </p:nvSpPr>
@@ -5680,7 +5932,7 @@
       </p:sp>
       <p:pic>
         <p:nvPicPr>
-          <p:cNvPr id="45" name="Picture 44" descr="asset_fig2ov.png"/>
+          <p:cNvPr id="48" name="Picture 47" descr="asset_fig2ov.png"/>
           <p:cNvPicPr>
             <a:picLocks noChangeAspect="1"/>
           </p:cNvPicPr>
@@ -5704,7 +5956,7 @@
       </p:pic>
       <p:sp>
         <p:nvSpPr>
-          <p:cNvPr id="46" name="TextBox 45"/>
+          <p:cNvPr id="49" name="TextBox 48"/>
           <p:cNvSpPr txBox="1"/>
           <p:nvPr/>
         </p:nvSpPr>
@@ -5742,7 +5994,7 @@
               <a:t>Calibration estimates μ</a:t>
             </a:r>
             <a:r>
-              <a:rPr sz="1584" b="0" i="0" baseline="-25000">
+              <a:rPr sz="1804" b="0" i="0" baseline="-25000">
                 <a:solidFill>
                   <a:srgbClr val="1F1F1F"/>
                 </a:solidFill>
@@ -5760,7 +6012,7 @@
               <a:t>, μ</a:t>
             </a:r>
             <a:r>
-              <a:rPr sz="1584" b="0" i="0" baseline="-25000">
+              <a:rPr sz="1804" b="0" i="0" baseline="-25000">
                 <a:solidFill>
                   <a:srgbClr val="1F1F1F"/>
                 </a:solidFill>
@@ -5778,7 +6030,7 @@
               <a:t> and g = μ</a:t>
             </a:r>
             <a:r>
-              <a:rPr sz="1584" b="0" i="0" baseline="-25000">
+              <a:rPr sz="1804" b="0" i="0" baseline="-25000">
                 <a:solidFill>
                   <a:srgbClr val="1F1F1F"/>
                 </a:solidFill>
@@ -5796,7 +6048,7 @@
               <a:t> − μ</a:t>
             </a:r>
             <a:r>
-              <a:rPr sz="1584" b="0" i="0" baseline="-25000">
+              <a:rPr sz="1804" b="0" i="0" baseline="-25000">
                 <a:solidFill>
                   <a:srgbClr val="1F1F1F"/>
                 </a:solidFill>
@@ -5818,7 +6070,7 @@
       </p:sp>
       <p:sp>
         <p:nvSpPr>
-          <p:cNvPr id="47" name="TextBox 46"/>
+          <p:cNvPr id="50" name="TextBox 49"/>
           <p:cNvSpPr txBox="1"/>
           <p:nvPr/>
         </p:nvSpPr>
@@ -5860,7 +6112,7 @@
       </p:sp>
       <p:sp>
         <p:nvSpPr>
-          <p:cNvPr id="48" name="Rectangle 47"/>
+          <p:cNvPr id="51" name="Rectangle 50"/>
           <p:cNvSpPr/>
           <p:nvPr/>
         </p:nvSpPr>
@@ -5904,7 +6156,7 @@
       </p:sp>
       <p:sp>
         <p:nvSpPr>
-          <p:cNvPr id="49" name="TextBox 48"/>
+          <p:cNvPr id="52" name="TextBox 51"/>
           <p:cNvSpPr txBox="1"/>
           <p:nvPr/>
         </p:nvSpPr>
@@ -5942,7 +6194,7 @@
               <a:t>Five benchmarks (MSCOCO, Flickr30K, Clotho, AudioCaps, LAION-400M — up to 407 M vectors), three frozen encoders (CLIP-B/32, CLIP-L/14, ImageBind) and four BQ index types; FAISS IVFRaBitQFastScan at 72–136 B/vec, n</a:t>
             </a:r>
             <a:r>
-              <a:rPr sz="1512" b="0" i="0" baseline="-25000">
+              <a:rPr sz="1722" b="0" i="0" baseline="-25000">
                 <a:solidFill>
                   <a:srgbClr val="6F6F6F"/>
                 </a:solidFill>
@@ -5960,7 +6212,7 @@
               <a:t> = ⌈√n⌉, n</a:t>
             </a:r>
             <a:r>
-              <a:rPr sz="1512" b="0" i="0" baseline="-25000">
+              <a:rPr sz="1722" b="0" i="0" baseline="-25000">
                 <a:solidFill>
                   <a:srgbClr val="6F6F6F"/>
                 </a:solidFill>
@@ -5978,7 +6230,7 @@
               <a:t> ≈ n</a:t>
             </a:r>
             <a:r>
-              <a:rPr sz="1512" b="0" i="0" baseline="-25000">
+              <a:rPr sz="1722" b="0" i="0" baseline="-25000">
                 <a:solidFill>
                   <a:srgbClr val="6F6F6F"/>
                 </a:solidFill>
@@ -6000,7 +6252,7 @@
       </p:sp>
       <p:sp>
         <p:nvSpPr>
-          <p:cNvPr id="50" name="TextBox 49"/>
+          <p:cNvPr id="53" name="TextBox 52"/>
           <p:cNvSpPr txBox="1"/>
           <p:nvPr/>
         </p:nvSpPr>
@@ -6051,7 +6303,7 @@
       </p:sp>
       <p:sp>
         <p:nvSpPr>
-          <p:cNvPr id="51" name="TextBox 50"/>
+          <p:cNvPr id="54" name="TextBox 53"/>
           <p:cNvSpPr txBox="1"/>
           <p:nvPr/>
         </p:nvSpPr>
@@ -6086,7 +6338,7 @@
       </p:sp>
       <p:sp>
         <p:nvSpPr>
-          <p:cNvPr id="52" name="Rectangle 51"/>
+          <p:cNvPr id="55" name="Rectangle 54"/>
           <p:cNvSpPr/>
           <p:nvPr/>
         </p:nvSpPr>
@@ -6130,7 +6382,7 @@
       </p:sp>
       <p:sp>
         <p:nvSpPr>
-          <p:cNvPr id="53" name="TextBox 52"/>
+          <p:cNvPr id="56" name="TextBox 55"/>
           <p:cNvSpPr txBox="1"/>
           <p:nvPr/>
         </p:nvSpPr>
@@ -6165,7 +6417,7 @@
       </p:sp>
       <p:sp>
         <p:nvSpPr>
-          <p:cNvPr id="54" name="Rectangle 53"/>
+          <p:cNvPr id="57" name="Rectangle 56"/>
           <p:cNvSpPr/>
           <p:nvPr/>
         </p:nvSpPr>
@@ -6209,7 +6461,7 @@
       </p:sp>
       <p:sp>
         <p:nvSpPr>
-          <p:cNvPr id="55" name="TextBox 54"/>
+          <p:cNvPr id="58" name="TextBox 57"/>
           <p:cNvSpPr txBox="1"/>
           <p:nvPr/>
         </p:nvSpPr>
@@ -6244,7 +6496,7 @@
       </p:sp>
       <p:sp>
         <p:nvSpPr>
-          <p:cNvPr id="56" name="TextBox 55"/>
+          <p:cNvPr id="59" name="TextBox 58"/>
           <p:cNvSpPr txBox="1"/>
           <p:nvPr/>
         </p:nvSpPr>
@@ -6279,7 +6531,7 @@
       </p:sp>
       <p:sp>
         <p:nvSpPr>
-          <p:cNvPr id="57" name="TextBox 56"/>
+          <p:cNvPr id="60" name="TextBox 59"/>
           <p:cNvSpPr txBox="1"/>
           <p:nvPr/>
         </p:nvSpPr>
@@ -6314,7 +6566,7 @@
       </p:sp>
       <p:sp>
         <p:nvSpPr>
-          <p:cNvPr id="58" name="TextBox 57"/>
+          <p:cNvPr id="61" name="TextBox 60"/>
           <p:cNvSpPr txBox="1"/>
           <p:nvPr/>
         </p:nvSpPr>
@@ -6349,7 +6601,7 @@
       </p:sp>
       <p:sp>
         <p:nvSpPr>
-          <p:cNvPr id="59" name="TextBox 58"/>
+          <p:cNvPr id="62" name="TextBox 61"/>
           <p:cNvSpPr txBox="1"/>
           <p:nvPr/>
         </p:nvSpPr>
@@ -6384,7 +6636,7 @@
       </p:sp>
       <p:sp>
         <p:nvSpPr>
-          <p:cNvPr id="60" name="TextBox 59"/>
+          <p:cNvPr id="63" name="TextBox 62"/>
           <p:cNvSpPr txBox="1"/>
           <p:nvPr/>
         </p:nvSpPr>
@@ -6419,7 +6671,7 @@
       </p:sp>
       <p:sp>
         <p:nvSpPr>
-          <p:cNvPr id="61" name="Rectangle 60"/>
+          <p:cNvPr id="64" name="Rectangle 63"/>
           <p:cNvSpPr/>
           <p:nvPr/>
         </p:nvSpPr>
@@ -6463,7 +6715,7 @@
       </p:sp>
       <p:sp>
         <p:nvSpPr>
-          <p:cNvPr id="62" name="TextBox 61"/>
+          <p:cNvPr id="65" name="TextBox 64"/>
           <p:cNvSpPr txBox="1"/>
           <p:nvPr/>
         </p:nvSpPr>
@@ -6498,7 +6750,7 @@
       </p:sp>
       <p:sp>
         <p:nvSpPr>
-          <p:cNvPr id="63" name="TextBox 62"/>
+          <p:cNvPr id="66" name="TextBox 65"/>
           <p:cNvSpPr txBox="1"/>
           <p:nvPr/>
         </p:nvSpPr>
@@ -6533,7 +6785,7 @@
       </p:sp>
       <p:sp>
         <p:nvSpPr>
-          <p:cNvPr id="64" name="TextBox 63"/>
+          <p:cNvPr id="67" name="TextBox 66"/>
           <p:cNvSpPr txBox="1"/>
           <p:nvPr/>
         </p:nvSpPr>
@@ -6586,7 +6838,7 @@
       </p:sp>
       <p:sp>
         <p:nvSpPr>
-          <p:cNvPr id="65" name="TextBox 64"/>
+          <p:cNvPr id="68" name="TextBox 67"/>
           <p:cNvSpPr txBox="1"/>
           <p:nvPr/>
         </p:nvSpPr>
@@ -6639,7 +6891,7 @@
       </p:sp>
       <p:sp>
         <p:nvSpPr>
-          <p:cNvPr id="66" name="TextBox 65"/>
+          <p:cNvPr id="69" name="TextBox 68"/>
           <p:cNvSpPr txBox="1"/>
           <p:nvPr/>
         </p:nvSpPr>
@@ -6692,7 +6944,7 @@
       </p:sp>
       <p:sp>
         <p:nvSpPr>
-          <p:cNvPr id="67" name="TextBox 66"/>
+          <p:cNvPr id="70" name="TextBox 69"/>
           <p:cNvSpPr txBox="1"/>
           <p:nvPr/>
         </p:nvSpPr>
@@ -6745,7 +6997,7 @@
       </p:sp>
       <p:sp>
         <p:nvSpPr>
-          <p:cNvPr id="68" name="Rectangle 67"/>
+          <p:cNvPr id="71" name="Rectangle 70"/>
           <p:cNvSpPr/>
           <p:nvPr/>
         </p:nvSpPr>
@@ -6789,7 +7041,7 @@
       </p:sp>
       <p:sp>
         <p:nvSpPr>
-          <p:cNvPr id="69" name="TextBox 68"/>
+          <p:cNvPr id="72" name="TextBox 71"/>
           <p:cNvSpPr txBox="1"/>
           <p:nvPr/>
         </p:nvSpPr>
@@ -6824,7 +7076,7 @@
       </p:sp>
       <p:sp>
         <p:nvSpPr>
-          <p:cNvPr id="70" name="TextBox 69"/>
+          <p:cNvPr id="73" name="TextBox 72"/>
           <p:cNvSpPr txBox="1"/>
           <p:nvPr/>
         </p:nvSpPr>
@@ -6859,7 +7111,7 @@
       </p:sp>
       <p:sp>
         <p:nvSpPr>
-          <p:cNvPr id="71" name="TextBox 70"/>
+          <p:cNvPr id="74" name="TextBox 73"/>
           <p:cNvSpPr txBox="1"/>
           <p:nvPr/>
         </p:nvSpPr>
@@ -6912,7 +7164,7 @@
       </p:sp>
       <p:sp>
         <p:nvSpPr>
-          <p:cNvPr id="72" name="TextBox 71"/>
+          <p:cNvPr id="75" name="TextBox 74"/>
           <p:cNvSpPr txBox="1"/>
           <p:nvPr/>
         </p:nvSpPr>
@@ -6965,7 +7217,7 @@
       </p:sp>
       <p:sp>
         <p:nvSpPr>
-          <p:cNvPr id="73" name="TextBox 72"/>
+          <p:cNvPr id="76" name="TextBox 75"/>
           <p:cNvSpPr txBox="1"/>
           <p:nvPr/>
         </p:nvSpPr>
@@ -7018,7 +7270,7 @@
       </p:sp>
       <p:sp>
         <p:nvSpPr>
-          <p:cNvPr id="74" name="TextBox 73"/>
+          <p:cNvPr id="77" name="TextBox 76"/>
           <p:cNvSpPr txBox="1"/>
           <p:nvPr/>
         </p:nvSpPr>
@@ -7071,7 +7323,7 @@
       </p:sp>
       <p:sp>
         <p:nvSpPr>
-          <p:cNvPr id="75" name="Rectangle 74"/>
+          <p:cNvPr id="78" name="Rectangle 77"/>
           <p:cNvSpPr/>
           <p:nvPr/>
         </p:nvSpPr>
@@ -7115,7 +7367,7 @@
       </p:sp>
       <p:sp>
         <p:nvSpPr>
-          <p:cNvPr id="76" name="TextBox 75"/>
+          <p:cNvPr id="79" name="TextBox 78"/>
           <p:cNvSpPr txBox="1"/>
           <p:nvPr/>
         </p:nvSpPr>
@@ -7150,7 +7402,7 @@
       </p:sp>
       <p:sp>
         <p:nvSpPr>
-          <p:cNvPr id="77" name="TextBox 76"/>
+          <p:cNvPr id="80" name="TextBox 79"/>
           <p:cNvSpPr txBox="1"/>
           <p:nvPr/>
         </p:nvSpPr>
@@ -7185,7 +7437,7 @@
       </p:sp>
       <p:sp>
         <p:nvSpPr>
-          <p:cNvPr id="78" name="TextBox 77"/>
+          <p:cNvPr id="81" name="TextBox 80"/>
           <p:cNvSpPr txBox="1"/>
           <p:nvPr/>
         </p:nvSpPr>
@@ -7238,7 +7490,7 @@
       </p:sp>
       <p:sp>
         <p:nvSpPr>
-          <p:cNvPr id="79" name="TextBox 78"/>
+          <p:cNvPr id="82" name="TextBox 81"/>
           <p:cNvSpPr txBox="1"/>
           <p:nvPr/>
         </p:nvSpPr>
@@ -7291,7 +7543,7 @@
       </p:sp>
       <p:sp>
         <p:nvSpPr>
-          <p:cNvPr id="80" name="TextBox 79"/>
+          <p:cNvPr id="83" name="TextBox 82"/>
           <p:cNvSpPr txBox="1"/>
           <p:nvPr/>
         </p:nvSpPr>
@@ -7344,7 +7596,7 @@
       </p:sp>
       <p:sp>
         <p:nvSpPr>
-          <p:cNvPr id="81" name="TextBox 80"/>
+          <p:cNvPr id="84" name="TextBox 83"/>
           <p:cNvSpPr txBox="1"/>
           <p:nvPr/>
         </p:nvSpPr>
@@ -7397,7 +7649,7 @@
       </p:sp>
       <p:sp>
         <p:nvSpPr>
-          <p:cNvPr id="82" name="Rectangle 81"/>
+          <p:cNvPr id="85" name="Rectangle 84"/>
           <p:cNvSpPr/>
           <p:nvPr/>
         </p:nvSpPr>
@@ -7441,7 +7693,7 @@
       </p:sp>
       <p:sp>
         <p:nvSpPr>
-          <p:cNvPr id="83" name="TextBox 82"/>
+          <p:cNvPr id="86" name="TextBox 85"/>
           <p:cNvSpPr txBox="1"/>
           <p:nvPr/>
         </p:nvSpPr>
@@ -7476,7 +7728,7 @@
       </p:sp>
       <p:sp>
         <p:nvSpPr>
-          <p:cNvPr id="84" name="TextBox 83"/>
+          <p:cNvPr id="87" name="TextBox 86"/>
           <p:cNvSpPr txBox="1"/>
           <p:nvPr/>
         </p:nvSpPr>
@@ -7511,7 +7763,7 @@
       </p:sp>
       <p:sp>
         <p:nvSpPr>
-          <p:cNvPr id="85" name="TextBox 84"/>
+          <p:cNvPr id="88" name="TextBox 87"/>
           <p:cNvSpPr txBox="1"/>
           <p:nvPr/>
         </p:nvSpPr>
@@ -7564,7 +7816,7 @@
       </p:sp>
       <p:sp>
         <p:nvSpPr>
-          <p:cNvPr id="86" name="TextBox 85"/>
+          <p:cNvPr id="89" name="TextBox 88"/>
           <p:cNvSpPr txBox="1"/>
           <p:nvPr/>
         </p:nvSpPr>
@@ -7617,7 +7869,7 @@
       </p:sp>
       <p:sp>
         <p:nvSpPr>
-          <p:cNvPr id="87" name="TextBox 86"/>
+          <p:cNvPr id="90" name="TextBox 89"/>
           <p:cNvSpPr txBox="1"/>
           <p:nvPr/>
         </p:nvSpPr>
@@ -7670,7 +7922,7 @@
       </p:sp>
       <p:sp>
         <p:nvSpPr>
-          <p:cNvPr id="88" name="TextBox 87"/>
+          <p:cNvPr id="91" name="TextBox 90"/>
           <p:cNvSpPr txBox="1"/>
           <p:nvPr/>
         </p:nvSpPr>
@@ -7723,7 +7975,7 @@
       </p:sp>
       <p:sp>
         <p:nvSpPr>
-          <p:cNvPr id="89" name="Rectangle 88"/>
+          <p:cNvPr id="92" name="Rectangle 91"/>
           <p:cNvSpPr/>
           <p:nvPr/>
         </p:nvSpPr>
@@ -7767,7 +8019,7 @@
       </p:sp>
       <p:sp>
         <p:nvSpPr>
-          <p:cNvPr id="90" name="TextBox 89"/>
+          <p:cNvPr id="93" name="TextBox 92"/>
           <p:cNvSpPr txBox="1"/>
           <p:nvPr/>
         </p:nvSpPr>
@@ -7802,7 +8054,7 @@
       </p:sp>
       <p:sp>
         <p:nvSpPr>
-          <p:cNvPr id="91" name="TextBox 90"/>
+          <p:cNvPr id="94" name="TextBox 93"/>
           <p:cNvSpPr txBox="1"/>
           <p:nvPr/>
         </p:nvSpPr>
@@ -7837,7 +8089,7 @@
       </p:sp>
       <p:sp>
         <p:nvSpPr>
-          <p:cNvPr id="92" name="TextBox 91"/>
+          <p:cNvPr id="95" name="TextBox 94"/>
           <p:cNvSpPr txBox="1"/>
           <p:nvPr/>
         </p:nvSpPr>
@@ -7890,7 +8142,7 @@
       </p:sp>
       <p:sp>
         <p:nvSpPr>
-          <p:cNvPr id="93" name="TextBox 92"/>
+          <p:cNvPr id="96" name="TextBox 95"/>
           <p:cNvSpPr txBox="1"/>
           <p:nvPr/>
         </p:nvSpPr>
@@ -7943,7 +8195,7 @@
       </p:sp>
       <p:sp>
         <p:nvSpPr>
-          <p:cNvPr id="94" name="TextBox 93"/>
+          <p:cNvPr id="97" name="TextBox 96"/>
           <p:cNvSpPr txBox="1"/>
           <p:nvPr/>
         </p:nvSpPr>
@@ -7996,7 +8248,7 @@
       </p:sp>
       <p:sp>
         <p:nvSpPr>
-          <p:cNvPr id="95" name="TextBox 94"/>
+          <p:cNvPr id="98" name="TextBox 97"/>
           <p:cNvSpPr txBox="1"/>
           <p:nvPr/>
         </p:nvSpPr>
@@ -8049,7 +8301,7 @@
       </p:sp>
       <p:sp>
         <p:nvSpPr>
-          <p:cNvPr id="96" name="Rectangle 95"/>
+          <p:cNvPr id="99" name="Rectangle 98"/>
           <p:cNvSpPr/>
           <p:nvPr/>
         </p:nvSpPr>
@@ -8093,7 +8345,7 @@
       </p:sp>
       <p:sp>
         <p:nvSpPr>
-          <p:cNvPr id="97" name="TextBox 96"/>
+          <p:cNvPr id="100" name="TextBox 99"/>
           <p:cNvSpPr txBox="1"/>
           <p:nvPr/>
         </p:nvSpPr>
@@ -8128,7 +8380,7 @@
       </p:sp>
       <p:sp>
         <p:nvSpPr>
-          <p:cNvPr id="98" name="TextBox 97"/>
+          <p:cNvPr id="101" name="TextBox 100"/>
           <p:cNvSpPr txBox="1"/>
           <p:nvPr/>
         </p:nvSpPr>
@@ -8163,7 +8415,7 @@
       </p:sp>
       <p:sp>
         <p:nvSpPr>
-          <p:cNvPr id="99" name="TextBox 98"/>
+          <p:cNvPr id="102" name="TextBox 101"/>
           <p:cNvSpPr txBox="1"/>
           <p:nvPr/>
         </p:nvSpPr>
@@ -8216,7 +8468,7 @@
       </p:sp>
       <p:sp>
         <p:nvSpPr>
-          <p:cNvPr id="100" name="TextBox 99"/>
+          <p:cNvPr id="103" name="TextBox 102"/>
           <p:cNvSpPr txBox="1"/>
           <p:nvPr/>
         </p:nvSpPr>
@@ -8269,7 +8521,7 @@
       </p:sp>
       <p:sp>
         <p:nvSpPr>
-          <p:cNvPr id="101" name="TextBox 100"/>
+          <p:cNvPr id="104" name="TextBox 103"/>
           <p:cNvSpPr txBox="1"/>
           <p:nvPr/>
         </p:nvSpPr>
@@ -8322,7 +8574,7 @@
       </p:sp>
       <p:sp>
         <p:nvSpPr>
-          <p:cNvPr id="102" name="TextBox 101"/>
+          <p:cNvPr id="105" name="TextBox 104"/>
           <p:cNvSpPr txBox="1"/>
           <p:nvPr/>
         </p:nvSpPr>
@@ -8375,7 +8627,7 @@
       </p:sp>
       <p:sp>
         <p:nvSpPr>
-          <p:cNvPr id="103" name="Rectangle 102"/>
+          <p:cNvPr id="106" name="Rectangle 105"/>
           <p:cNvSpPr/>
           <p:nvPr/>
         </p:nvSpPr>
@@ -8419,7 +8671,7 @@
       </p:sp>
       <p:sp>
         <p:nvSpPr>
-          <p:cNvPr id="104" name="TextBox 103"/>
+          <p:cNvPr id="107" name="TextBox 106"/>
           <p:cNvSpPr txBox="1"/>
           <p:nvPr/>
         </p:nvSpPr>
@@ -8454,7 +8706,7 @@
       </p:sp>
       <p:sp>
         <p:nvSpPr>
-          <p:cNvPr id="105" name="TextBox 104"/>
+          <p:cNvPr id="108" name="TextBox 107"/>
           <p:cNvSpPr txBox="1"/>
           <p:nvPr/>
         </p:nvSpPr>
@@ -8489,7 +8741,7 @@
       </p:sp>
       <p:sp>
         <p:nvSpPr>
-          <p:cNvPr id="106" name="TextBox 105"/>
+          <p:cNvPr id="109" name="TextBox 108"/>
           <p:cNvSpPr txBox="1"/>
           <p:nvPr/>
         </p:nvSpPr>
@@ -8542,7 +8794,7 @@
       </p:sp>
       <p:sp>
         <p:nvSpPr>
-          <p:cNvPr id="107" name="TextBox 106"/>
+          <p:cNvPr id="110" name="TextBox 109"/>
           <p:cNvSpPr txBox="1"/>
           <p:nvPr/>
         </p:nvSpPr>
@@ -8595,7 +8847,7 @@
       </p:sp>
       <p:sp>
         <p:nvSpPr>
-          <p:cNvPr id="108" name="TextBox 107"/>
+          <p:cNvPr id="111" name="TextBox 110"/>
           <p:cNvSpPr txBox="1"/>
           <p:nvPr/>
         </p:nvSpPr>
@@ -8648,7 +8900,7 @@
       </p:sp>
       <p:sp>
         <p:nvSpPr>
-          <p:cNvPr id="109" name="TextBox 108"/>
+          <p:cNvPr id="112" name="TextBox 111"/>
           <p:cNvSpPr txBox="1"/>
           <p:nvPr/>
         </p:nvSpPr>
@@ -8701,7 +8953,7 @@
       </p:sp>
       <p:sp>
         <p:nvSpPr>
-          <p:cNvPr id="110" name="Rectangle 109"/>
+          <p:cNvPr id="113" name="Rectangle 112"/>
           <p:cNvSpPr/>
           <p:nvPr/>
         </p:nvSpPr>
@@ -8745,7 +8997,7 @@
       </p:sp>
       <p:sp>
         <p:nvSpPr>
-          <p:cNvPr id="111" name="TextBox 110"/>
+          <p:cNvPr id="114" name="TextBox 113"/>
           <p:cNvSpPr txBox="1"/>
           <p:nvPr/>
         </p:nvSpPr>
@@ -8841,7 +9093,7 @@
       </p:sp>
       <p:pic>
         <p:nvPicPr>
-          <p:cNvPr id="112" name="Picture 111" descr="asset_fig3.png"/>
+          <p:cNvPr id="115" name="Picture 114" descr="asset_fig3.png"/>
           <p:cNvPicPr>
             <a:picLocks noChangeAspect="1"/>
           </p:cNvPicPr>
@@ -8865,7 +9117,7 @@
       </p:pic>
       <p:sp>
         <p:nvSpPr>
-          <p:cNvPr id="113" name="TextBox 112"/>
+          <p:cNvPr id="116" name="TextBox 115"/>
           <p:cNvSpPr txBox="1"/>
           <p:nvPr/>
         </p:nvSpPr>
@@ -8907,7 +9159,7 @@
       </p:sp>
       <p:sp>
         <p:nvSpPr>
-          <p:cNvPr id="114" name="TextBox 113"/>
+          <p:cNvPr id="117" name="TextBox 116"/>
           <p:cNvSpPr txBox="1"/>
           <p:nvPr/>
         </p:nvSpPr>
@@ -8949,7 +9201,7 @@
       </p:sp>
       <p:sp>
         <p:nvSpPr>
-          <p:cNvPr id="115" name="Rectangle 114"/>
+          <p:cNvPr id="118" name="Rectangle 117"/>
           <p:cNvSpPr/>
           <p:nvPr/>
         </p:nvSpPr>
@@ -8993,7 +9245,7 @@
       </p:sp>
       <p:sp>
         <p:nvSpPr>
-          <p:cNvPr id="116" name="TextBox 115"/>
+          <p:cNvPr id="119" name="TextBox 118"/>
           <p:cNvSpPr txBox="1"/>
           <p:nvPr/>
         </p:nvSpPr>
@@ -9044,7 +9296,7 @@
       </p:sp>
       <p:sp>
         <p:nvSpPr>
-          <p:cNvPr id="117" name="TextBox 116"/>
+          <p:cNvPr id="120" name="TextBox 119"/>
           <p:cNvSpPr txBox="1"/>
           <p:nvPr/>
         </p:nvSpPr>
@@ -9079,7 +9331,7 @@
       </p:sp>
       <p:sp>
         <p:nvSpPr>
-          <p:cNvPr id="118" name="TextBox 117"/>
+          <p:cNvPr id="121" name="TextBox 120"/>
           <p:cNvSpPr txBox="1"/>
           <p:nvPr/>
         </p:nvSpPr>
@@ -9114,7 +9366,7 @@
       </p:sp>
       <p:sp>
         <p:nvSpPr>
-          <p:cNvPr id="119" name="TextBox 118"/>
+          <p:cNvPr id="122" name="TextBox 121"/>
           <p:cNvSpPr txBox="1"/>
           <p:nvPr/>
         </p:nvSpPr>
@@ -9149,7 +9401,7 @@
       </p:sp>
       <p:sp>
         <p:nvSpPr>
-          <p:cNvPr id="120" name="Rectangle 119"/>
+          <p:cNvPr id="123" name="Rectangle 122"/>
           <p:cNvSpPr/>
           <p:nvPr/>
         </p:nvSpPr>
@@ -9193,7 +9445,7 @@
       </p:sp>
       <p:sp>
         <p:nvSpPr>
-          <p:cNvPr id="121" name="TextBox 120"/>
+          <p:cNvPr id="124" name="TextBox 123"/>
           <p:cNvSpPr txBox="1"/>
           <p:nvPr/>
         </p:nvSpPr>
@@ -9228,7 +9480,7 @@
       </p:sp>
       <p:sp>
         <p:nvSpPr>
-          <p:cNvPr id="122" name="TextBox 121"/>
+          <p:cNvPr id="125" name="TextBox 124"/>
           <p:cNvSpPr txBox="1"/>
           <p:nvPr/>
         </p:nvSpPr>
@@ -9272,7 +9524,7 @@
       </p:sp>
       <p:sp>
         <p:nvSpPr>
-          <p:cNvPr id="123" name="TextBox 122"/>
+          <p:cNvPr id="126" name="TextBox 125"/>
           <p:cNvSpPr txBox="1"/>
           <p:nvPr/>
         </p:nvSpPr>
@@ -9316,7 +9568,7 @@
       </p:sp>
       <p:sp>
         <p:nvSpPr>
-          <p:cNvPr id="124" name="Rectangle 123"/>
+          <p:cNvPr id="127" name="Rectangle 126"/>
           <p:cNvSpPr/>
           <p:nvPr/>
         </p:nvSpPr>
@@ -9360,7 +9612,7 @@
       </p:sp>
       <p:sp>
         <p:nvSpPr>
-          <p:cNvPr id="125" name="TextBox 124"/>
+          <p:cNvPr id="128" name="TextBox 127"/>
           <p:cNvSpPr txBox="1"/>
           <p:nvPr/>
         </p:nvSpPr>
@@ -9395,7 +9647,7 @@
       </p:sp>
       <p:sp>
         <p:nvSpPr>
-          <p:cNvPr id="126" name="TextBox 125"/>
+          <p:cNvPr id="129" name="TextBox 128"/>
           <p:cNvSpPr txBox="1"/>
           <p:nvPr/>
         </p:nvSpPr>
@@ -9439,7 +9691,7 @@
       </p:sp>
       <p:sp>
         <p:nvSpPr>
-          <p:cNvPr id="127" name="TextBox 126"/>
+          <p:cNvPr id="130" name="TextBox 129"/>
           <p:cNvSpPr txBox="1"/>
           <p:nvPr/>
         </p:nvSpPr>
@@ -9483,7 +9735,7 @@
       </p:sp>
       <p:sp>
         <p:nvSpPr>
-          <p:cNvPr id="128" name="Rectangle 127"/>
+          <p:cNvPr id="131" name="Rectangle 130"/>
           <p:cNvSpPr/>
           <p:nvPr/>
         </p:nvSpPr>
@@ -9527,7 +9779,7 @@
       </p:sp>
       <p:sp>
         <p:nvSpPr>
-          <p:cNvPr id="129" name="TextBox 128"/>
+          <p:cNvPr id="132" name="TextBox 131"/>
           <p:cNvSpPr txBox="1"/>
           <p:nvPr/>
         </p:nvSpPr>
@@ -9562,7 +9814,7 @@
       </p:sp>
       <p:sp>
         <p:nvSpPr>
-          <p:cNvPr id="130" name="TextBox 129"/>
+          <p:cNvPr id="133" name="TextBox 132"/>
           <p:cNvSpPr txBox="1"/>
           <p:nvPr/>
         </p:nvSpPr>
@@ -9606,7 +9858,7 @@
       </p:sp>
       <p:sp>
         <p:nvSpPr>
-          <p:cNvPr id="131" name="TextBox 130"/>
+          <p:cNvPr id="134" name="TextBox 133"/>
           <p:cNvSpPr txBox="1"/>
           <p:nvPr/>
         </p:nvSpPr>
@@ -9650,7 +9902,7 @@
       </p:sp>
       <p:sp>
         <p:nvSpPr>
-          <p:cNvPr id="132" name="Rectangle 131"/>
+          <p:cNvPr id="135" name="Rectangle 134"/>
           <p:cNvSpPr/>
           <p:nvPr/>
         </p:nvSpPr>
@@ -9694,7 +9946,7 @@
       </p:sp>
       <p:sp>
         <p:nvSpPr>
-          <p:cNvPr id="133" name="TextBox 132"/>
+          <p:cNvPr id="136" name="TextBox 135"/>
           <p:cNvSpPr txBox="1"/>
           <p:nvPr/>
         </p:nvSpPr>
@@ -9729,7 +9981,7 @@
       </p:sp>
       <p:sp>
         <p:nvSpPr>
-          <p:cNvPr id="134" name="TextBox 133"/>
+          <p:cNvPr id="137" name="TextBox 136"/>
           <p:cNvSpPr txBox="1"/>
           <p:nvPr/>
         </p:nvSpPr>
@@ -9773,7 +10025,7 @@
       </p:sp>
       <p:sp>
         <p:nvSpPr>
-          <p:cNvPr id="135" name="TextBox 134"/>
+          <p:cNvPr id="138" name="TextBox 137"/>
           <p:cNvSpPr txBox="1"/>
           <p:nvPr/>
         </p:nvSpPr>
@@ -9817,7 +10069,7 @@
       </p:sp>
       <p:sp>
         <p:nvSpPr>
-          <p:cNvPr id="136" name="Rectangle 135"/>
+          <p:cNvPr id="139" name="Rectangle 138"/>
           <p:cNvSpPr/>
           <p:nvPr/>
         </p:nvSpPr>
@@ -9861,7 +10113,7 @@
       </p:sp>
       <p:sp>
         <p:nvSpPr>
-          <p:cNvPr id="137" name="TextBox 136"/>
+          <p:cNvPr id="140" name="TextBox 139"/>
           <p:cNvSpPr txBox="1"/>
           <p:nvPr/>
         </p:nvSpPr>
@@ -9903,7 +10155,7 @@
       </p:sp>
       <p:sp>
         <p:nvSpPr>
-          <p:cNvPr id="138" name="TextBox 137"/>
+          <p:cNvPr id="141" name="TextBox 140"/>
           <p:cNvSpPr txBox="1"/>
           <p:nvPr/>
         </p:nvSpPr>
@@ -9954,7 +10206,7 @@
       </p:sp>
       <p:sp>
         <p:nvSpPr>
-          <p:cNvPr id="139" name="Rectangle 138"/>
+          <p:cNvPr id="142" name="Rectangle 141"/>
           <p:cNvSpPr/>
           <p:nvPr/>
         </p:nvSpPr>
@@ -10000,7 +10252,7 @@
       </p:sp>
       <p:sp>
         <p:nvSpPr>
-          <p:cNvPr id="140" name="Rectangle 139"/>
+          <p:cNvPr id="143" name="Rectangle 142"/>
           <p:cNvSpPr/>
           <p:nvPr/>
         </p:nvSpPr>
@@ -10044,7 +10296,7 @@
       </p:sp>
       <p:sp>
         <p:nvSpPr>
-          <p:cNvPr id="141" name="TextBox 140"/>
+          <p:cNvPr id="144" name="TextBox 143"/>
           <p:cNvSpPr txBox="1"/>
           <p:nvPr/>
         </p:nvSpPr>
@@ -10079,7 +10331,7 @@
       </p:sp>
       <p:sp>
         <p:nvSpPr>
-          <p:cNvPr id="142" name="TextBox 141"/>
+          <p:cNvPr id="145" name="TextBox 144"/>
           <p:cNvSpPr txBox="1"/>
           <p:nvPr/>
         </p:nvSpPr>
@@ -10114,7 +10366,7 @@
       </p:sp>
       <p:sp>
         <p:nvSpPr>
-          <p:cNvPr id="143" name="Rectangle 142"/>
+          <p:cNvPr id="146" name="Rectangle 145"/>
           <p:cNvSpPr/>
           <p:nvPr/>
         </p:nvSpPr>
@@ -10160,7 +10412,7 @@
       </p:sp>
       <p:sp>
         <p:nvSpPr>
-          <p:cNvPr id="144" name="Rectangle 143"/>
+          <p:cNvPr id="147" name="Rectangle 146"/>
           <p:cNvSpPr/>
           <p:nvPr/>
         </p:nvSpPr>
@@ -10204,7 +10456,7 @@
       </p:sp>
       <p:sp>
         <p:nvSpPr>
-          <p:cNvPr id="145" name="TextBox 144"/>
+          <p:cNvPr id="148" name="TextBox 147"/>
           <p:cNvSpPr txBox="1"/>
           <p:nvPr/>
         </p:nvSpPr>
@@ -10239,7 +10491,7 @@
       </p:sp>
       <p:sp>
         <p:nvSpPr>
-          <p:cNvPr id="146" name="TextBox 145"/>
+          <p:cNvPr id="149" name="TextBox 148"/>
           <p:cNvSpPr txBox="1"/>
           <p:nvPr/>
         </p:nvSpPr>
@@ -10274,7 +10526,7 @@
       </p:sp>
       <p:sp>
         <p:nvSpPr>
-          <p:cNvPr id="147" name="Rectangle 146"/>
+          <p:cNvPr id="150" name="Rectangle 149"/>
           <p:cNvSpPr/>
           <p:nvPr/>
         </p:nvSpPr>
@@ -10320,7 +10572,7 @@
       </p:sp>
       <p:sp>
         <p:nvSpPr>
-          <p:cNvPr id="148" name="Rectangle 147"/>
+          <p:cNvPr id="151" name="Rectangle 150"/>
           <p:cNvSpPr/>
           <p:nvPr/>
         </p:nvSpPr>
@@ -10364,7 +10616,7 @@
       </p:sp>
       <p:sp>
         <p:nvSpPr>
-          <p:cNvPr id="149" name="TextBox 148"/>
+          <p:cNvPr id="152" name="TextBox 151"/>
           <p:cNvSpPr txBox="1"/>
           <p:nvPr/>
         </p:nvSpPr>
@@ -10399,7 +10651,7 @@
       </p:sp>
       <p:sp>
         <p:nvSpPr>
-          <p:cNvPr id="150" name="TextBox 149"/>
+          <p:cNvPr id="153" name="TextBox 152"/>
           <p:cNvSpPr txBox="1"/>
           <p:nvPr/>
         </p:nvSpPr>
@@ -10434,7 +10686,7 @@
       </p:sp>
       <p:sp>
         <p:nvSpPr>
-          <p:cNvPr id="151" name="Rectangle 150"/>
+          <p:cNvPr id="154" name="Rectangle 153"/>
           <p:cNvSpPr/>
           <p:nvPr/>
         </p:nvSpPr>
@@ -10480,7 +10732,7 @@
       </p:sp>
       <p:sp>
         <p:nvSpPr>
-          <p:cNvPr id="152" name="Rectangle 151"/>
+          <p:cNvPr id="155" name="Rectangle 154"/>
           <p:cNvSpPr/>
           <p:nvPr/>
         </p:nvSpPr>
@@ -10524,7 +10776,7 @@
       </p:sp>
       <p:sp>
         <p:nvSpPr>
-          <p:cNvPr id="153" name="TextBox 152"/>
+          <p:cNvPr id="156" name="TextBox 155"/>
           <p:cNvSpPr txBox="1"/>
           <p:nvPr/>
         </p:nvSpPr>
@@ -10559,7 +10811,7 @@
       </p:sp>
       <p:sp>
         <p:nvSpPr>
-          <p:cNvPr id="154" name="TextBox 153"/>
+          <p:cNvPr id="157" name="TextBox 156"/>
           <p:cNvSpPr txBox="1"/>
           <p:nvPr/>
         </p:nvSpPr>
@@ -10594,7 +10846,7 @@
       </p:sp>
       <p:sp>
         <p:nvSpPr>
-          <p:cNvPr id="155" name="TextBox 154"/>
+          <p:cNvPr id="158" name="TextBox 157"/>
           <p:cNvSpPr txBox="1"/>
           <p:nvPr/>
         </p:nvSpPr>
@@ -10645,7 +10897,7 @@
       </p:sp>
       <p:sp>
         <p:nvSpPr>
-          <p:cNvPr id="156" name="Rectangle 155"/>
+          <p:cNvPr id="159" name="Rectangle 158"/>
           <p:cNvSpPr/>
           <p:nvPr/>
         </p:nvSpPr>
@@ -10689,7 +10941,7 @@
       </p:sp>
       <p:sp>
         <p:nvSpPr>
-          <p:cNvPr id="157" name="TextBox 156"/>
+          <p:cNvPr id="160" name="TextBox 159"/>
           <p:cNvSpPr txBox="1"/>
           <p:nvPr/>
         </p:nvSpPr>
@@ -10727,7 +10979,7 @@
               <a:t>Correct the index, not the query:  a one-time, database-side centroid correction repairs IVF routing and binary quantization together — zero query-time transform, zero extra index memory, QPS unchanged at every n</a:t>
             </a:r>
             <a:r>
-              <a:rPr sz="1655" b="1" i="0" baseline="-25000">
+              <a:rPr sz="1886" b="1" i="0" baseline="-25000">
                 <a:solidFill>
                   <a:srgbClr val="FFFFFF"/>
                 </a:solidFill>
@@ -10768,7 +11020,7 @@
       </p:sp>
       <p:sp>
         <p:nvSpPr>
-          <p:cNvPr id="158" name="Rectangle 157"/>
+          <p:cNvPr id="161" name="Rectangle 160"/>
           <p:cNvSpPr/>
           <p:nvPr/>
         </p:nvSpPr>
@@ -10812,7 +11064,7 @@
       </p:sp>
       <p:sp>
         <p:nvSpPr>
-          <p:cNvPr id="159" name="Rectangle 158"/>
+          <p:cNvPr id="162" name="Rectangle 161"/>
           <p:cNvSpPr/>
           <p:nvPr/>
         </p:nvSpPr>
@@ -10856,7 +11108,7 @@
       </p:sp>
       <p:pic>
         <p:nvPicPr>
-          <p:cNvPr id="160" name="Picture 159" descr="asset_cikm.png"/>
+          <p:cNvPr id="163" name="Picture 162" descr="asset_cikm.png"/>
           <p:cNvPicPr>
             <a:picLocks noChangeAspect="1"/>
           </p:cNvPicPr>
@@ -10880,7 +11132,7 @@
       </p:pic>
       <p:sp>
         <p:nvSpPr>
-          <p:cNvPr id="161" name="TextBox 160"/>
+          <p:cNvPr id="164" name="TextBox 163"/>
           <p:cNvSpPr txBox="1"/>
           <p:nvPr/>
         </p:nvSpPr>
@@ -10922,7 +11174,7 @@
       </p:sp>
       <p:sp>
         <p:nvSpPr>
-          <p:cNvPr id="162" name="TextBox 161"/>
+          <p:cNvPr id="165" name="TextBox 164"/>
           <p:cNvSpPr txBox="1"/>
           <p:nvPr/>
         </p:nvSpPr>

</xml_diff>

<commit_message>
style(poster): larger equation fonts (28-34pt) and 0.90x subscripts
</commit_message>
<xml_diff>
--- a/poster/PMC_CIKM2026_poster.pptx
+++ b/poster/PMC_CIKM2026_poster.pptx
@@ -3755,7 +3755,7 @@
               <a:t>  g = μ</a:t>
             </a:r>
             <a:r>
-              <a:rPr sz="1804" b="0" i="0" baseline="-25000">
+              <a:rPr sz="1980" b="0" i="0" baseline="-25000">
                 <a:solidFill>
                   <a:srgbClr val="1F1F1F"/>
                 </a:solidFill>
@@ -3773,7 +3773,7 @@
               <a:t> − μ</a:t>
             </a:r>
             <a:r>
-              <a:rPr sz="1804" b="0" i="0" baseline="-25000">
+              <a:rPr sz="1980" b="0" i="0" baseline="-25000">
                 <a:solidFill>
                   <a:srgbClr val="1F1F1F"/>
                 </a:solidFill>
@@ -3899,7 +3899,7 @@
               <a:t>BQ encodes each dimension as  sign(x</a:t>
             </a:r>
             <a:r>
-              <a:rPr sz="1804" b="0" i="0" baseline="-25000">
+              <a:rPr sz="1980" b="0" i="0" baseline="-25000">
                 <a:solidFill>
                   <a:srgbClr val="1F1F1F"/>
                 </a:solidFill>
@@ -3917,7 +3917,7 @@
               <a:t> − c</a:t>
             </a:r>
             <a:r>
-              <a:rPr sz="1804" b="0" i="0" baseline="-25000">
+              <a:rPr sz="1980" b="0" i="0" baseline="-25000">
                 <a:solidFill>
                   <a:srgbClr val="1F1F1F"/>
                 </a:solidFill>
@@ -3935,7 +3935,7 @@
               <a:t>)  relative to a centroid c (RaBitQ, Lucene BBQ). With one bit the decision boundary passes exactly through c with zero error margin — and the same centroid routes queries to IVF lists, so one offset corrupts codes and routing at once. Let δ</a:t>
             </a:r>
             <a:r>
-              <a:rPr sz="1804" b="0" i="0" baseline="-25000">
+              <a:rPr sz="1980" b="0" i="0" baseline="-25000">
                 <a:solidFill>
                   <a:srgbClr val="1F1F1F"/>
                 </a:solidFill>
@@ -3953,7 +3953,7 @@
               <a:t> = x</a:t>
             </a:r>
             <a:r>
-              <a:rPr sz="1804" b="0" i="0" baseline="-25000">
+              <a:rPr sz="1980" b="0" i="0" baseline="-25000">
                 <a:solidFill>
                   <a:srgbClr val="1F1F1F"/>
                 </a:solidFill>
@@ -3971,7 +3971,7 @@
               <a:t> − c</a:t>
             </a:r>
             <a:r>
-              <a:rPr sz="1804" b="0" i="0" baseline="-25000">
+              <a:rPr sz="1980" b="0" i="0" baseline="-25000">
                 <a:solidFill>
                   <a:srgbClr val="1F1F1F"/>
                 </a:solidFill>
@@ -4000,7 +4000,7 @@
         <p:spPr>
           <a:xfrm>
             <a:off x="777240" y="21415329"/>
-            <a:ext cx="14040612" cy="502005"/>
+            <a:ext cx="14040612" cy="557784"/>
           </a:xfrm>
           <a:prstGeom prst="rect">
             <a:avLst/>
@@ -4022,7 +4022,7 @@
               </a:spcAft>
             </a:pPr>
             <a:r>
-              <a:rPr sz="2700" b="1" i="0">
+              <a:rPr sz="3000" b="1" i="0">
                 <a:solidFill>
                   <a:srgbClr val="1F1F1F"/>
                 </a:solidFill>
@@ -4031,7 +4031,7 @@
               <a:t>δ</a:t>
             </a:r>
             <a:r>
-              <a:rPr sz="2213" b="1" i="0" baseline="-25000">
+              <a:rPr sz="2700" b="1" i="0" baseline="-25000">
                 <a:solidFill>
                   <a:srgbClr val="1F1F1F"/>
                 </a:solidFill>
@@ -4040,7 +4040,7 @@
               <a:t>i</a:t>
             </a:r>
             <a:r>
-              <a:rPr sz="2700" b="1" i="0">
+              <a:rPr sz="3000" b="1" i="0">
                 <a:solidFill>
                   <a:srgbClr val="1F1F1F"/>
                 </a:solidFill>
@@ -4049,7 +4049,7 @@
               <a:t> (δ</a:t>
             </a:r>
             <a:r>
-              <a:rPr sz="2213" b="1" i="0" baseline="-25000">
+              <a:rPr sz="2700" b="1" i="0" baseline="-25000">
                 <a:solidFill>
                   <a:srgbClr val="1F1F1F"/>
                 </a:solidFill>
@@ -4058,7 +4058,7 @@
               <a:t>i</a:t>
             </a:r>
             <a:r>
-              <a:rPr sz="2700" b="1" i="0">
+              <a:rPr sz="3000" b="1" i="0">
                 <a:solidFill>
                   <a:srgbClr val="1F1F1F"/>
                 </a:solidFill>
@@ -4067,7 +4067,7 @@
               <a:t> − α g</a:t>
             </a:r>
             <a:r>
-              <a:rPr sz="2213" b="1" i="0" baseline="-25000">
+              <a:rPr sz="2700" b="1" i="0" baseline="-25000">
                 <a:solidFill>
                   <a:srgbClr val="1F1F1F"/>
                 </a:solidFill>
@@ -4076,7 +4076,7 @@
               <a:t>i</a:t>
             </a:r>
             <a:r>
-              <a:rPr sz="2700" b="1" i="0">
+              <a:rPr sz="3000" b="1" i="0">
                 <a:solidFill>
                   <a:srgbClr val="1F1F1F"/>
                 </a:solidFill>
@@ -4085,7 +4085,7 @@
               <a:t>)  &lt;  0 ,      i.e.,      0  &lt;  δ</a:t>
             </a:r>
             <a:r>
-              <a:rPr sz="2213" b="1" i="0" baseline="-25000">
+              <a:rPr sz="2700" b="1" i="0" baseline="-25000">
                 <a:solidFill>
                   <a:srgbClr val="1F1F1F"/>
                 </a:solidFill>
@@ -4094,7 +4094,7 @@
               <a:t>i</a:t>
             </a:r>
             <a:r>
-              <a:rPr sz="2700" b="1" i="0">
+              <a:rPr sz="3000" b="1" i="0">
                 <a:solidFill>
                   <a:srgbClr val="1F1F1F"/>
                 </a:solidFill>
@@ -4103,7 +4103,7 @@
               <a:t> / (α g</a:t>
             </a:r>
             <a:r>
-              <a:rPr sz="2213" b="1" i="0" baseline="-25000">
+              <a:rPr sz="2700" b="1" i="0" baseline="-25000">
                 <a:solidFill>
                   <a:srgbClr val="1F1F1F"/>
                 </a:solidFill>
@@ -4112,7 +4112,7 @@
               <a:t>i</a:t>
             </a:r>
             <a:r>
-              <a:rPr sz="2700" b="1" i="0">
+              <a:rPr sz="3000" b="1" i="0">
                 <a:solidFill>
                   <a:srgbClr val="1F1F1F"/>
                 </a:solidFill>
@@ -4131,7 +4131,7 @@
         </p:nvSpPr>
         <p:spPr>
           <a:xfrm>
-            <a:off x="777240" y="21917334"/>
+            <a:off x="777240" y="21973113"/>
             <a:ext cx="14040612" cy="371855"/>
           </a:xfrm>
           <a:prstGeom prst="rect">
@@ -4163,7 +4163,7 @@
               <a:t>δ</a:t>
             </a:r>
             <a:r>
-              <a:rPr sz="1639" b="0" i="1" baseline="-25000">
+              <a:rPr sz="1800" b="0" i="1" baseline="-25000">
                 <a:solidFill>
                   <a:srgbClr val="6F6F6F"/>
                 </a:solidFill>
@@ -4181,7 +4181,7 @@
               <a:t>: residual x</a:t>
             </a:r>
             <a:r>
-              <a:rPr sz="1639" b="0" i="1" baseline="-25000">
+              <a:rPr sz="1800" b="0" i="1" baseline="-25000">
                 <a:solidFill>
                   <a:srgbClr val="6F6F6F"/>
                 </a:solidFill>
@@ -4199,7 +4199,7 @@
               <a:t> − c</a:t>
             </a:r>
             <a:r>
-              <a:rPr sz="1639" b="0" i="1" baseline="-25000">
+              <a:rPr sz="1800" b="0" i="1" baseline="-25000">
                 <a:solidFill>
                   <a:srgbClr val="6F6F6F"/>
                 </a:solidFill>
@@ -4217,7 +4217,7 @@
               <a:t>   ·   g</a:t>
             </a:r>
             <a:r>
-              <a:rPr sz="1639" b="0" i="1" baseline="-25000">
+              <a:rPr sz="1800" b="0" i="1" baseline="-25000">
                 <a:solidFill>
                   <a:srgbClr val="6F6F6F"/>
                 </a:solidFill>
@@ -4245,7 +4245,7 @@
         </p:nvSpPr>
         <p:spPr>
           <a:xfrm>
-            <a:off x="777240" y="22453781"/>
+            <a:off x="777240" y="22509560"/>
             <a:ext cx="14040612" cy="472541"/>
           </a:xfrm>
           <a:prstGeom prst="rect">
@@ -4287,8 +4287,8 @@
         </p:nvSpPr>
         <p:spPr>
           <a:xfrm>
-            <a:off x="777240" y="23072626"/>
-            <a:ext cx="14040612" cy="557784"/>
+            <a:off x="777240" y="23128405"/>
+            <a:ext cx="14040612" cy="632155"/>
           </a:xfrm>
           <a:prstGeom prst="rect">
             <a:avLst/>
@@ -4310,7 +4310,7 @@
               </a:spcAft>
             </a:pPr>
             <a:r>
-              <a:rPr sz="3000" b="1" i="0">
+              <a:rPr sz="3400" b="1" i="0">
                 <a:solidFill>
                   <a:srgbClr val="1F1F1F"/>
                 </a:solidFill>
@@ -4319,7 +4319,7 @@
               <a:t>E[F]  ≈  α Σ</a:t>
             </a:r>
             <a:r>
-              <a:rPr sz="2460" b="1" i="0" baseline="-25000">
+              <a:rPr sz="3060" b="1" i="0" baseline="-25000">
                 <a:solidFill>
                   <a:srgbClr val="1F1F1F"/>
                 </a:solidFill>
@@ -4328,7 +4328,7 @@
               <a:t>i</a:t>
             </a:r>
             <a:r>
-              <a:rPr sz="3000" b="1" i="0">
+              <a:rPr sz="3400" b="1" i="0">
                 <a:solidFill>
                   <a:srgbClr val="1F1F1F"/>
                 </a:solidFill>
@@ -4337,7 +4337,7 @@
               <a:t> p</a:t>
             </a:r>
             <a:r>
-              <a:rPr sz="2460" b="1" i="0" baseline="-25000">
+              <a:rPr sz="3060" b="1" i="0" baseline="-25000">
                 <a:solidFill>
                   <a:srgbClr val="1F1F1F"/>
                 </a:solidFill>
@@ -4346,7 +4346,7 @@
               <a:t>i</a:t>
             </a:r>
             <a:r>
-              <a:rPr sz="3000" b="1" i="0">
+              <a:rPr sz="3400" b="1" i="0">
                 <a:solidFill>
                   <a:srgbClr val="1F1F1F"/>
                 </a:solidFill>
@@ -4355,7 +4355,7 @@
               <a:t>(0) |g</a:t>
             </a:r>
             <a:r>
-              <a:rPr sz="2460" b="1" i="0" baseline="-25000">
+              <a:rPr sz="3060" b="1" i="0" baseline="-25000">
                 <a:solidFill>
                   <a:srgbClr val="1F1F1F"/>
                 </a:solidFill>
@@ -4364,7 +4364,7 @@
               <a:t>i</a:t>
             </a:r>
             <a:r>
-              <a:rPr sz="3000" b="1" i="0">
+              <a:rPr sz="3400" b="1" i="0">
                 <a:solidFill>
                   <a:srgbClr val="1F1F1F"/>
                 </a:solidFill>
@@ -4383,7 +4383,7 @@
         </p:nvSpPr>
         <p:spPr>
           <a:xfrm>
-            <a:off x="777240" y="23630410"/>
+            <a:off x="777240" y="23760560"/>
             <a:ext cx="14040612" cy="371855"/>
           </a:xfrm>
           <a:prstGeom prst="rect">
@@ -4415,7 +4415,7 @@
               <a:t>E[F]: expected bit flips   ·   p</a:t>
             </a:r>
             <a:r>
-              <a:rPr sz="1639" b="0" i="1" baseline="-25000">
+              <a:rPr sz="1800" b="0" i="1" baseline="-25000">
                 <a:solidFill>
                   <a:srgbClr val="6F6F6F"/>
                 </a:solidFill>
@@ -4443,7 +4443,7 @@
         </p:nvSpPr>
         <p:spPr>
           <a:xfrm>
-            <a:off x="777240" y="24166857"/>
+            <a:off x="777240" y="24297007"/>
             <a:ext cx="14040612" cy="881583"/>
           </a:xfrm>
           <a:prstGeom prst="rect">
@@ -4475,7 +4475,7 @@
               <a:t>a density-weighted ℓ₁ norm of the gap: flip risk grows with |g</a:t>
             </a:r>
             <a:r>
-              <a:rPr sz="1804" b="0" i="0" baseline="-25000">
+              <a:rPr sz="1980" b="0" i="0" baseline="-25000">
                 <a:solidFill>
                   <a:srgbClr val="1F1F1F"/>
                 </a:solidFill>
@@ -4503,7 +4503,7 @@
         </p:nvSpPr>
         <p:spPr>
           <a:xfrm>
-            <a:off x="777240" y="25176456"/>
+            <a:off x="777240" y="25306606"/>
             <a:ext cx="14040612" cy="1384604"/>
           </a:xfrm>
           <a:prstGeom prst="rect">
@@ -4549,7 +4549,7 @@
         </p:nvSpPr>
         <p:spPr>
           <a:xfrm>
-            <a:off x="1014984" y="25414200"/>
+            <a:off x="1014984" y="25544350"/>
             <a:ext cx="13565124" cy="909116"/>
           </a:xfrm>
           <a:prstGeom prst="rect">
@@ -4618,7 +4618,7 @@
         </p:nvSpPr>
         <p:spPr>
           <a:xfrm>
-            <a:off x="777240" y="26634212"/>
+            <a:off x="777240" y="26764362"/>
             <a:ext cx="14040612" cy="560070"/>
           </a:xfrm>
           <a:prstGeom prst="rect">
@@ -4660,7 +4660,7 @@
         </p:nvSpPr>
         <p:spPr>
           <a:xfrm>
-            <a:off x="777240" y="27240002"/>
+            <a:off x="777240" y="27370152"/>
             <a:ext cx="14040612" cy="31750"/>
           </a:xfrm>
           <a:prstGeom prst="rect">
@@ -4704,7 +4704,7 @@
         </p:nvSpPr>
         <p:spPr>
           <a:xfrm>
-            <a:off x="777240" y="27317472"/>
+            <a:off x="777240" y="27447622"/>
             <a:ext cx="14040612" cy="881583"/>
           </a:xfrm>
           <a:prstGeom prst="rect">
@@ -4746,8 +4746,8 @@
         </p:nvSpPr>
         <p:spPr>
           <a:xfrm>
-            <a:off x="777240" y="28345359"/>
-            <a:ext cx="14040612" cy="502005"/>
+            <a:off x="777240" y="28475509"/>
+            <a:ext cx="14040612" cy="557784"/>
           </a:xfrm>
           <a:prstGeom prst="rect">
             <a:avLst/>
@@ -4769,7 +4769,7 @@
               </a:spcAft>
             </a:pPr>
             <a:r>
-              <a:rPr sz="2700" b="1" i="0">
+              <a:rPr sz="3000" b="1" i="0">
                 <a:solidFill>
                   <a:srgbClr val="1F1F1F"/>
                 </a:solidFill>
@@ -4788,7 +4788,7 @@
         </p:nvSpPr>
         <p:spPr>
           <a:xfrm>
-            <a:off x="777240" y="28847364"/>
+            <a:off x="777240" y="29033293"/>
             <a:ext cx="14040612" cy="371855"/>
           </a:xfrm>
           <a:prstGeom prst="rect">
@@ -4830,7 +4830,7 @@
         </p:nvSpPr>
         <p:spPr>
           <a:xfrm>
-            <a:off x="777240" y="29383811"/>
+            <a:off x="777240" y="29569740"/>
             <a:ext cx="14040612" cy="1290624"/>
           </a:xfrm>
           <a:prstGeom prst="rect">
@@ -4872,7 +4872,7 @@
         </p:nvSpPr>
         <p:spPr>
           <a:xfrm>
-            <a:off x="777240" y="30820739"/>
+            <a:off x="777240" y="31006668"/>
             <a:ext cx="14040612" cy="27940"/>
           </a:xfrm>
           <a:prstGeom prst="rect">
@@ -4916,7 +4916,7 @@
         </p:nvSpPr>
         <p:spPr>
           <a:xfrm>
-            <a:off x="777240" y="30912179"/>
+            <a:off x="777240" y="31098108"/>
             <a:ext cx="14040612" cy="427634"/>
           </a:xfrm>
           <a:prstGeom prst="rect">
@@ -4958,7 +4958,7 @@
         </p:nvSpPr>
         <p:spPr>
           <a:xfrm>
-            <a:off x="777240" y="31412965"/>
+            <a:off x="777240" y="31598894"/>
             <a:ext cx="14040612" cy="12700"/>
           </a:xfrm>
           <a:prstGeom prst="rect">
@@ -5002,7 +5002,7 @@
         </p:nvSpPr>
         <p:spPr>
           <a:xfrm>
-            <a:off x="777240" y="31504405"/>
+            <a:off x="777240" y="31690334"/>
             <a:ext cx="14040612" cy="4087368"/>
           </a:xfrm>
           <a:prstGeom prst="rect">
@@ -5090,7 +5090,7 @@
               <a:t>1:  μ</a:t>
             </a:r>
             <a:r>
-              <a:rPr sz="1722" b="0" i="0" baseline="-25000">
+              <a:rPr sz="1890" b="0" i="0" baseline="-25000">
                 <a:solidFill>
                   <a:srgbClr val="1F1F1F"/>
                 </a:solidFill>
@@ -5108,7 +5108,7 @@
               <a:t> ← mean(Q);   μ</a:t>
             </a:r>
             <a:r>
-              <a:rPr sz="1722" b="0" i="0" baseline="-25000">
+              <a:rPr sz="1890" b="0" i="0" baseline="-25000">
                 <a:solidFill>
                   <a:srgbClr val="1F1F1F"/>
                 </a:solidFill>
@@ -5145,7 +5145,7 @@
               <a:t>2:  g ← μ</a:t>
             </a:r>
             <a:r>
-              <a:rPr sz="1722" b="0" i="0" baseline="-25000">
+              <a:rPr sz="1890" b="0" i="0" baseline="-25000">
                 <a:solidFill>
                   <a:srgbClr val="1F1F1F"/>
                 </a:solidFill>
@@ -5163,7 +5163,7 @@
               <a:t> − μ</a:t>
             </a:r>
             <a:r>
-              <a:rPr sz="1722" b="0" i="0" baseline="-25000">
+              <a:rPr sz="1890" b="0" i="0" baseline="-25000">
                 <a:solidFill>
                   <a:srgbClr val="1F1F1F"/>
                 </a:solidFill>
@@ -5277,7 +5277,7 @@
         </p:nvSpPr>
         <p:spPr>
           <a:xfrm>
-            <a:off x="777240" y="35664925"/>
+            <a:off x="777240" y="35850854"/>
             <a:ext cx="14040612" cy="27940"/>
           </a:xfrm>
           <a:prstGeom prst="rect">
@@ -5321,7 +5321,7 @@
         </p:nvSpPr>
         <p:spPr>
           <a:xfrm>
-            <a:off x="777240" y="35957533"/>
+            <a:off x="777240" y="36143462"/>
             <a:ext cx="14040612" cy="472541"/>
           </a:xfrm>
           <a:prstGeom prst="rect">
@@ -5362,7 +5362,7 @@
               <a:t>Correction restricted to the top-P% of dimensions ranked by |g</a:t>
             </a:r>
             <a:r>
-              <a:rPr sz="1804" b="0" i="0" baseline="-25000">
+              <a:rPr sz="1980" b="0" i="0" baseline="-25000">
                 <a:solidFill>
                   <a:srgbClr val="1F1F1F"/>
                 </a:solidFill>
@@ -5390,8 +5390,8 @@
         </p:nvSpPr>
         <p:spPr>
           <a:xfrm>
-            <a:off x="777240" y="36576378"/>
-            <a:ext cx="14040612" cy="464820"/>
+            <a:off x="777240" y="36762307"/>
+            <a:ext cx="14040612" cy="520598"/>
           </a:xfrm>
           <a:prstGeom prst="rect">
             <a:avLst/>
@@ -5413,7 +5413,7 @@
               </a:spcAft>
             </a:pPr>
             <a:r>
-              <a:rPr sz="2500" b="1" i="0">
+              <a:rPr sz="2800" b="1" i="0">
                 <a:solidFill>
                   <a:srgbClr val="1F1F1F"/>
                 </a:solidFill>
@@ -5422,7 +5422,7 @@
               <a:t>g</a:t>
             </a:r>
             <a:r>
-              <a:rPr sz="2050" b="1" i="0" baseline="-25000">
+              <a:rPr sz="2520" b="1" i="0" baseline="-25000">
                 <a:solidFill>
                   <a:srgbClr val="1F1F1F"/>
                 </a:solidFill>
@@ -5431,7 +5431,7 @@
               <a:t>sel,i</a:t>
             </a:r>
             <a:r>
-              <a:rPr sz="2500" b="1" i="0">
+              <a:rPr sz="2800" b="1" i="0">
                 <a:solidFill>
                   <a:srgbClr val="1F1F1F"/>
                 </a:solidFill>
@@ -5440,7 +5440,7 @@
               <a:t> = g</a:t>
             </a:r>
             <a:r>
-              <a:rPr sz="2050" b="1" i="0" baseline="-25000">
+              <a:rPr sz="2520" b="1" i="0" baseline="-25000">
                 <a:solidFill>
                   <a:srgbClr val="1F1F1F"/>
                 </a:solidFill>
@@ -5449,7 +5449,7 @@
               <a:t>i</a:t>
             </a:r>
             <a:r>
-              <a:rPr sz="2500" b="1" i="0">
+              <a:rPr sz="2800" b="1" i="0">
                 <a:solidFill>
                   <a:srgbClr val="1F1F1F"/>
                 </a:solidFill>
@@ -5458,7 +5458,7 @@
               <a:t>  if  |g</a:t>
             </a:r>
             <a:r>
-              <a:rPr sz="2050" b="1" i="0" baseline="-25000">
+              <a:rPr sz="2520" b="1" i="0" baseline="-25000">
                 <a:solidFill>
                   <a:srgbClr val="1F1F1F"/>
                 </a:solidFill>
@@ -5467,7 +5467,7 @@
               <a:t>i</a:t>
             </a:r>
             <a:r>
-              <a:rPr sz="2500" b="1" i="0">
+              <a:rPr sz="2800" b="1" i="0">
                 <a:solidFill>
                   <a:srgbClr val="1F1F1F"/>
                 </a:solidFill>
@@ -5476,7 +5476,7 @@
               <a:t>| ≥ |g|</a:t>
             </a:r>
             <a:r>
-              <a:rPr sz="2050" b="1" i="0" baseline="-25000">
+              <a:rPr sz="2520" b="1" i="0" baseline="-25000">
                 <a:solidFill>
                   <a:srgbClr val="1F1F1F"/>
                 </a:solidFill>
@@ -5485,7 +5485,7 @@
               <a:t>(P)</a:t>
             </a:r>
             <a:r>
-              <a:rPr sz="2500" b="1" i="0">
+              <a:rPr sz="2800" b="1" i="0">
                 <a:solidFill>
                   <a:srgbClr val="1F1F1F"/>
                 </a:solidFill>
@@ -5494,7 +5494,7 @@
               <a:t> ,  0  otherwise ;      x′</a:t>
             </a:r>
             <a:r>
-              <a:rPr sz="2050" b="1" i="0" baseline="-25000">
+              <a:rPr sz="2520" b="1" i="0" baseline="-25000">
                 <a:solidFill>
                   <a:srgbClr val="1F1F1F"/>
                 </a:solidFill>
@@ -5503,7 +5503,7 @@
               <a:t>sel</a:t>
             </a:r>
             <a:r>
-              <a:rPr sz="2500" b="1" i="0">
+              <a:rPr sz="2800" b="1" i="0">
                 <a:solidFill>
                   <a:srgbClr val="1F1F1F"/>
                 </a:solidFill>
@@ -5512,7 +5512,7 @@
               <a:t> = (x + α g</a:t>
             </a:r>
             <a:r>
-              <a:rPr sz="2050" b="1" i="0" baseline="-25000">
+              <a:rPr sz="2520" b="1" i="0" baseline="-25000">
                 <a:solidFill>
                   <a:srgbClr val="1F1F1F"/>
                 </a:solidFill>
@@ -5521,7 +5521,7 @@
               <a:t>sel</a:t>
             </a:r>
             <a:r>
-              <a:rPr sz="2500" b="1" i="0">
+              <a:rPr sz="2800" b="1" i="0">
                 <a:solidFill>
                   <a:srgbClr val="1F1F1F"/>
                 </a:solidFill>
@@ -5530,7 +5530,7 @@
               <a:t>) / ‖x + α g</a:t>
             </a:r>
             <a:r>
-              <a:rPr sz="2050" b="1" i="0" baseline="-25000">
+              <a:rPr sz="2520" b="1" i="0" baseline="-25000">
                 <a:solidFill>
                   <a:srgbClr val="1F1F1F"/>
                 </a:solidFill>
@@ -5539,7 +5539,7 @@
               <a:t>sel</a:t>
             </a:r>
             <a:r>
-              <a:rPr sz="2500" b="1" i="0">
+              <a:rPr sz="2800" b="1" i="0">
                 <a:solidFill>
                   <a:srgbClr val="1F1F1F"/>
                 </a:solidFill>
@@ -5558,7 +5558,7 @@
         </p:nvSpPr>
         <p:spPr>
           <a:xfrm>
-            <a:off x="777240" y="37041198"/>
+            <a:off x="777240" y="37282905"/>
             <a:ext cx="14040612" cy="371855"/>
           </a:xfrm>
           <a:prstGeom prst="rect">
@@ -5590,7 +5590,7 @@
               <a:t>g</a:t>
             </a:r>
             <a:r>
-              <a:rPr sz="1639" b="0" i="1" baseline="-25000">
+              <a:rPr sz="1800" b="0" i="1" baseline="-25000">
                 <a:solidFill>
                   <a:srgbClr val="6F6F6F"/>
                 </a:solidFill>
@@ -5608,7 +5608,7 @@
               <a:t>: truncated gap   ·   |g|</a:t>
             </a:r>
             <a:r>
-              <a:rPr sz="1639" b="0" i="1" baseline="-25000">
+              <a:rPr sz="1800" b="0" i="1" baseline="-25000">
                 <a:solidFill>
                   <a:srgbClr val="6F6F6F"/>
                 </a:solidFill>
@@ -5636,8 +5636,8 @@
         </p:nvSpPr>
         <p:spPr>
           <a:xfrm>
-            <a:off x="777240" y="37723949"/>
-            <a:ext cx="14040612" cy="464820"/>
+            <a:off x="777240" y="37965656"/>
+            <a:ext cx="14040612" cy="520598"/>
           </a:xfrm>
           <a:prstGeom prst="rect">
             <a:avLst/>
@@ -5659,7 +5659,7 @@
               </a:spcAft>
             </a:pPr>
             <a:r>
-              <a:rPr sz="2500" b="1" i="0">
+              <a:rPr sz="2800" b="1" i="0">
                 <a:solidFill>
                   <a:srgbClr val="1F1F1F"/>
                 </a:solidFill>
@@ -5668,7 +5668,7 @@
               <a:t>E(P)  =  Σ</a:t>
             </a:r>
             <a:r>
-              <a:rPr sz="2050" b="1" i="0" baseline="-25000">
+              <a:rPr sz="2520" b="1" i="0" baseline="-25000">
                 <a:solidFill>
                   <a:srgbClr val="1F1F1F"/>
                 </a:solidFill>
@@ -5677,7 +5677,7 @@
               <a:t>i ∈ S(P)</a:t>
             </a:r>
             <a:r>
-              <a:rPr sz="2500" b="1" i="0">
+              <a:rPr sz="2800" b="1" i="0">
                 <a:solidFill>
                   <a:srgbClr val="1F1F1F"/>
                 </a:solidFill>
@@ -5686,7 +5686,7 @@
               <a:t> g</a:t>
             </a:r>
             <a:r>
-              <a:rPr sz="2050" b="1" i="0" baseline="-25000">
+              <a:rPr sz="2520" b="1" i="0" baseline="-25000">
                 <a:solidFill>
                   <a:srgbClr val="1F1F1F"/>
                 </a:solidFill>
@@ -5695,7 +5695,7 @@
               <a:t>i</a:t>
             </a:r>
             <a:r>
-              <a:rPr sz="2500" b="1" i="0">
+              <a:rPr sz="2800" b="1" i="0">
                 <a:solidFill>
                   <a:srgbClr val="1F1F1F"/>
                 </a:solidFill>
@@ -5704,7 +5704,7 @@
               <a:t>²  /  ‖g‖² ,      S(P) = { i : |g</a:t>
             </a:r>
             <a:r>
-              <a:rPr sz="2050" b="1" i="0" baseline="-25000">
+              <a:rPr sz="2520" b="1" i="0" baseline="-25000">
                 <a:solidFill>
                   <a:srgbClr val="1F1F1F"/>
                 </a:solidFill>
@@ -5713,7 +5713,7 @@
               <a:t>i</a:t>
             </a:r>
             <a:r>
-              <a:rPr sz="2500" b="1" i="0">
+              <a:rPr sz="2800" b="1" i="0">
                 <a:solidFill>
                   <a:srgbClr val="1F1F1F"/>
                 </a:solidFill>
@@ -5722,7 +5722,7 @@
               <a:t>| ≥ |g|</a:t>
             </a:r>
             <a:r>
-              <a:rPr sz="2050" b="1" i="0" baseline="-25000">
+              <a:rPr sz="2520" b="1" i="0" baseline="-25000">
                 <a:solidFill>
                   <a:srgbClr val="1F1F1F"/>
                 </a:solidFill>
@@ -5731,7 +5731,7 @@
               <a:t>(P)</a:t>
             </a:r>
             <a:r>
-              <a:rPr sz="2500" b="1" i="0">
+              <a:rPr sz="2800" b="1" i="0">
                 <a:solidFill>
                   <a:srgbClr val="1F1F1F"/>
                 </a:solidFill>
@@ -5750,7 +5750,7 @@
         </p:nvSpPr>
         <p:spPr>
           <a:xfrm>
-            <a:off x="777240" y="38188769"/>
+            <a:off x="777240" y="38486254"/>
             <a:ext cx="14040612" cy="371855"/>
           </a:xfrm>
           <a:prstGeom prst="rect">
@@ -5792,7 +5792,7 @@
         </p:nvSpPr>
         <p:spPr>
           <a:xfrm>
-            <a:off x="777240" y="38725216"/>
+            <a:off x="777240" y="39022701"/>
             <a:ext cx="14040612" cy="1290624"/>
           </a:xfrm>
           <a:prstGeom prst="rect">
@@ -5824,7 +5824,7 @@
               <a:t>isolates the mechanism. Since flip risk concentrates in high-|g</a:t>
             </a:r>
             <a:r>
-              <a:rPr sz="1804" b="0" i="0" baseline="-25000">
+              <a:rPr sz="1980" b="0" i="0" baseline="-25000">
                 <a:solidFill>
                   <a:srgbClr val="1F1F1F"/>
                 </a:solidFill>
@@ -5994,7 +5994,7 @@
               <a:t>Calibration estimates μ</a:t>
             </a:r>
             <a:r>
-              <a:rPr sz="1804" b="0" i="0" baseline="-25000">
+              <a:rPr sz="1980" b="0" i="0" baseline="-25000">
                 <a:solidFill>
                   <a:srgbClr val="1F1F1F"/>
                 </a:solidFill>
@@ -6012,7 +6012,7 @@
               <a:t>, μ</a:t>
             </a:r>
             <a:r>
-              <a:rPr sz="1804" b="0" i="0" baseline="-25000">
+              <a:rPr sz="1980" b="0" i="0" baseline="-25000">
                 <a:solidFill>
                   <a:srgbClr val="1F1F1F"/>
                 </a:solidFill>
@@ -6030,7 +6030,7 @@
               <a:t> and g = μ</a:t>
             </a:r>
             <a:r>
-              <a:rPr sz="1804" b="0" i="0" baseline="-25000">
+              <a:rPr sz="1980" b="0" i="0" baseline="-25000">
                 <a:solidFill>
                   <a:srgbClr val="1F1F1F"/>
                 </a:solidFill>
@@ -6048,7 +6048,7 @@
               <a:t> − μ</a:t>
             </a:r>
             <a:r>
-              <a:rPr sz="1804" b="0" i="0" baseline="-25000">
+              <a:rPr sz="1980" b="0" i="0" baseline="-25000">
                 <a:solidFill>
                   <a:srgbClr val="1F1F1F"/>
                 </a:solidFill>
@@ -6194,7 +6194,7 @@
               <a:t>Five benchmarks (MSCOCO, Flickr30K, Clotho, AudioCaps, LAION-400M — up to 407 M vectors), three frozen encoders (CLIP-B/32, CLIP-L/14, ImageBind) and four BQ index types; FAISS IVFRaBitQFastScan at 72–136 B/vec, n</a:t>
             </a:r>
             <a:r>
-              <a:rPr sz="1722" b="0" i="0" baseline="-25000">
+              <a:rPr sz="1890" b="0" i="0" baseline="-25000">
                 <a:solidFill>
                   <a:srgbClr val="6F6F6F"/>
                 </a:solidFill>
@@ -6212,7 +6212,7 @@
               <a:t> = ⌈√n⌉, n</a:t>
             </a:r>
             <a:r>
-              <a:rPr sz="1722" b="0" i="0" baseline="-25000">
+              <a:rPr sz="1890" b="0" i="0" baseline="-25000">
                 <a:solidFill>
                   <a:srgbClr val="6F6F6F"/>
                 </a:solidFill>
@@ -6230,7 +6230,7 @@
               <a:t> ≈ n</a:t>
             </a:r>
             <a:r>
-              <a:rPr sz="1722" b="0" i="0" baseline="-25000">
+              <a:rPr sz="1890" b="0" i="0" baseline="-25000">
                 <a:solidFill>
                   <a:srgbClr val="6F6F6F"/>
                 </a:solidFill>
@@ -10979,7 +10979,7 @@
               <a:t>Correct the index, not the query:  a one-time, database-side centroid correction repairs IVF routing and binary quantization together — zero query-time transform, zero extra index memory, QPS unchanged at every n</a:t>
             </a:r>
             <a:r>
-              <a:rPr sz="1886" b="1" i="0" baseline="-25000">
+              <a:rPr sz="2070" b="1" i="0" baseline="-25000">
                 <a:solidFill>
                   <a:srgbClr val="FFFFFF"/>
                 </a:solidFill>

</xml_diff>

<commit_message>
style(poster): soften Analysis bar/band highlights; trim footer
Lighter gray/blue bar fills with ink labels; conclusion band on pale
blue with ink text; drop DOI and NRF/MSIT line from the footer.
</commit_message>
<xml_diff>
--- a/poster/PMC_CIKM2026_poster.pptx
+++ b/poster/PMC_CIKM2026_poster.pptx
@@ -10265,7 +10265,7 @@
             <a:avLst/>
           </a:prstGeom>
           <a:solidFill>
-            <a:srgbClr val="6F6F6F"/>
+            <a:srgbClr val="C6C6C6"/>
           </a:solidFill>
           <a:ln>
             <a:noFill/>
@@ -10320,7 +10320,7 @@
             <a:r>
               <a:rPr sz="2400" b="0" i="0">
                 <a:solidFill>
-                  <a:srgbClr val="FFFFFF"/>
+                  <a:srgbClr val="1F1F1F"/>
                 </a:solidFill>
                 <a:latin typeface="Times New Roman"/>
               </a:rPr>
@@ -10425,7 +10425,7 @@
             <a:avLst/>
           </a:prstGeom>
           <a:solidFill>
-            <a:srgbClr val="6F6F6F"/>
+            <a:srgbClr val="C6C6C6"/>
           </a:solidFill>
           <a:ln>
             <a:noFill/>
@@ -10480,7 +10480,7 @@
             <a:r>
               <a:rPr sz="2400" b="0" i="0">
                 <a:solidFill>
-                  <a:srgbClr val="FFFFFF"/>
+                  <a:srgbClr val="1F1F1F"/>
                 </a:solidFill>
                 <a:latin typeface="Times New Roman"/>
               </a:rPr>
@@ -10585,7 +10585,7 @@
             <a:avLst/>
           </a:prstGeom>
           <a:solidFill>
-            <a:srgbClr val="6F6F6F"/>
+            <a:srgbClr val="C6C6C6"/>
           </a:solidFill>
           <a:ln>
             <a:noFill/>
@@ -10640,7 +10640,7 @@
             <a:r>
               <a:rPr sz="2400" b="0" i="0">
                 <a:solidFill>
-                  <a:srgbClr val="FFFFFF"/>
+                  <a:srgbClr val="1F1F1F"/>
                 </a:solidFill>
                 <a:latin typeface="Times New Roman"/>
               </a:rPr>
@@ -10745,7 +10745,7 @@
             <a:avLst/>
           </a:prstGeom>
           <a:solidFill>
-            <a:srgbClr val="0D4DA3"/>
+            <a:srgbClr val="8FAED9"/>
           </a:solidFill>
           <a:ln>
             <a:noFill/>
@@ -10800,7 +10800,7 @@
             <a:r>
               <a:rPr sz="2400" b="0" i="0">
                 <a:solidFill>
-                  <a:srgbClr val="FFFFFF"/>
+                  <a:srgbClr val="1F1F1F"/>
                 </a:solidFill>
                 <a:latin typeface="Times New Roman"/>
               </a:rPr>
@@ -10910,7 +10910,7 @@
             <a:avLst/>
           </a:prstGeom>
           <a:solidFill>
-            <a:srgbClr val="0D4DA3"/>
+            <a:srgbClr val="E6EDF7"/>
           </a:solidFill>
           <a:ln>
             <a:noFill/>
@@ -10972,16 +10972,25 @@
             <a:r>
               <a:rPr sz="2300" b="1" i="0">
                 <a:solidFill>
-                  <a:srgbClr val="FFFFFF"/>
-                </a:solidFill>
-                <a:latin typeface="Times New Roman"/>
-              </a:rPr>
-              <a:t>Correct the index, not the query:  a one-time, database-side centroid correction repairs IVF routing and binary quantization together — zero query-time transform, zero extra index memory, QPS unchanged at every n</a:t>
+                  <a:srgbClr val="0D4DA3"/>
+                </a:solidFill>
+                <a:latin typeface="Times New Roman"/>
+              </a:rPr>
+              <a:t>Correct the index, not the query:  </a:t>
+            </a:r>
+            <a:r>
+              <a:rPr sz="2300" b="1" i="0">
+                <a:solidFill>
+                  <a:srgbClr val="1F1F1F"/>
+                </a:solidFill>
+                <a:latin typeface="Times New Roman"/>
+              </a:rPr>
+              <a:t>a one-time, database-side centroid correction repairs IVF routing and binary quantization together — zero query-time transform, zero extra index memory, QPS unchanged at every n</a:t>
             </a:r>
             <a:r>
               <a:rPr sz="2070" b="1" i="0" baseline="-25000">
                 <a:solidFill>
-                  <a:srgbClr val="FFFFFF"/>
+                  <a:srgbClr val="1F1F1F"/>
                 </a:solidFill>
                 <a:latin typeface="Times New Roman"/>
               </a:rPr>
@@ -10990,7 +10999,7 @@
             <a:r>
               <a:rPr sz="2300" b="1" i="0">
                 <a:solidFill>
-                  <a:srgbClr val="FFFFFF"/>
+                  <a:srgbClr val="1F1F1F"/>
                 </a:solidFill>
                 <a:latin typeface="Times New Roman"/>
               </a:rPr>
@@ -11009,7 +11018,7 @@
             <a:r>
               <a:rPr sz="2000" b="0" i="0">
                 <a:solidFill>
-                  <a:srgbClr val="FFFFFF"/>
+                  <a:srgbClr val="6F6F6F"/>
                 </a:solidFill>
                 <a:latin typeface="Times New Roman"/>
               </a:rPr>
@@ -11209,7 +11218,7 @@
                 </a:solidFill>
                 <a:latin typeface="Times New Roman"/>
               </a:rPr>
-              <a:t>DOI 10.1145/3799682.3840007   ·   CC-BY 4.0   ·   Supported by the National Research Foundation of Korea (MSIT), No. 00359638   ·   Code and reproduction package: github.com/sehoon787/PMC</a:t>
+              <a:t>CC-BY 4.0   ·   Code and reproduction package:  github.com/sehoon787/PMC</a:t>
             </a:r>
           </a:p>
         </p:txBody>

</xml_diff>

<commit_message>
style(poster): bold + crimson star on the winning DB-only (PMC) bar
</commit_message>
<xml_diff>
--- a/poster/PMC_CIKM2026_poster.pptx
+++ b/poster/PMC_CIKM2026_poster.pptx
@@ -10353,7 +10353,7 @@
           <a:p>
             <a:pPr algn="l"/>
             <a:r>
-              <a:rPr sz="2400" b="1" i="0">
+              <a:rPr sz="2400" b="0" i="0">
                 <a:solidFill>
                   <a:srgbClr val="1F1F1F"/>
                 </a:solidFill>
@@ -10513,7 +10513,7 @@
           <a:p>
             <a:pPr algn="l"/>
             <a:r>
-              <a:rPr sz="2400" b="1" i="0">
+              <a:rPr sz="2400" b="0" i="0">
                 <a:solidFill>
                   <a:srgbClr val="1F1F1F"/>
                 </a:solidFill>
@@ -10673,7 +10673,7 @@
           <a:p>
             <a:pPr algn="l"/>
             <a:r>
-              <a:rPr sz="2400" b="1" i="0">
+              <a:rPr sz="2400" b="0" i="0">
                 <a:solidFill>
                   <a:srgbClr val="1F1F1F"/>
                 </a:solidFill>
@@ -10776,14 +10776,58 @@
       </p:sp>
       <p:sp>
         <p:nvSpPr>
-          <p:cNvPr id="156" name="TextBox 155"/>
-          <p:cNvSpPr txBox="1"/>
-          <p:nvPr/>
-        </p:nvSpPr>
-        <p:spPr>
-          <a:xfrm>
-            <a:off x="15622524" y="36209150"/>
-            <a:ext cx="12211812" cy="457200"/>
+          <p:cNvPr id="156" name="5-Point Star 155"/>
+          <p:cNvSpPr/>
+          <p:nvPr/>
+        </p:nvSpPr>
+        <p:spPr>
+          <a:xfrm>
+            <a:off x="15604236" y="36282302"/>
+            <a:ext cx="310896" cy="310896"/>
+          </a:xfrm>
+          <a:prstGeom prst="star5">
+            <a:avLst/>
+          </a:prstGeom>
+          <a:solidFill>
+            <a:srgbClr val="8B0029"/>
+          </a:solidFill>
+          <a:ln>
+            <a:noFill/>
+          </a:ln>
+          <a:effectLst/>
+        </p:spPr>
+        <p:style>
+          <a:lnRef idx="1">
+            <a:schemeClr val="accent1"/>
+          </a:lnRef>
+          <a:fillRef idx="3">
+            <a:schemeClr val="accent1"/>
+          </a:fillRef>
+          <a:effectRef idx="2">
+            <a:schemeClr val="accent1"/>
+          </a:effectRef>
+          <a:fontRef idx="minor">
+            <a:schemeClr val="lt1"/>
+          </a:fontRef>
+        </p:style>
+        <p:txBody>
+          <a:bodyPr rtlCol="0" anchor="ctr"/>
+          <a:lstStyle/>
+          <a:p>
+            <a:pPr algn="ctr"/>
+          </a:p>
+        </p:txBody>
+      </p:sp>
+      <p:sp>
+        <p:nvSpPr>
+          <p:cNvPr id="157" name="TextBox 156"/>
+          <p:cNvSpPr txBox="1"/>
+          <p:nvPr/>
+        </p:nvSpPr>
+        <p:spPr>
+          <a:xfrm>
+            <a:off x="16024860" y="36209150"/>
+            <a:ext cx="11809476" cy="457200"/>
           </a:xfrm>
           <a:prstGeom prst="rect">
             <a:avLst/>
@@ -10798,7 +10842,7 @@
           <a:p>
             <a:pPr algn="l"/>
             <a:r>
-              <a:rPr sz="2400" b="0" i="0">
+              <a:rPr sz="2400" b="1" i="0">
                 <a:solidFill>
                   <a:srgbClr val="1F1F1F"/>
                 </a:solidFill>
@@ -10811,7 +10855,7 @@
       </p:sp>
       <p:sp>
         <p:nvSpPr>
-          <p:cNvPr id="157" name="TextBox 156"/>
+          <p:cNvPr id="158" name="TextBox 157"/>
           <p:cNvSpPr txBox="1"/>
           <p:nvPr/>
         </p:nvSpPr>
@@ -10846,7 +10890,7 @@
       </p:sp>
       <p:sp>
         <p:nvSpPr>
-          <p:cNvPr id="158" name="TextBox 157"/>
+          <p:cNvPr id="159" name="TextBox 158"/>
           <p:cNvSpPr txBox="1"/>
           <p:nvPr/>
         </p:nvSpPr>
@@ -10897,7 +10941,7 @@
       </p:sp>
       <p:sp>
         <p:nvSpPr>
-          <p:cNvPr id="159" name="Rectangle 158"/>
+          <p:cNvPr id="160" name="Rectangle 159"/>
           <p:cNvSpPr/>
           <p:nvPr/>
         </p:nvSpPr>
@@ -10941,7 +10985,7 @@
       </p:sp>
       <p:sp>
         <p:nvSpPr>
-          <p:cNvPr id="160" name="TextBox 159"/>
+          <p:cNvPr id="161" name="TextBox 160"/>
           <p:cNvSpPr txBox="1"/>
           <p:nvPr/>
         </p:nvSpPr>
@@ -11029,7 +11073,7 @@
       </p:sp>
       <p:sp>
         <p:nvSpPr>
-          <p:cNvPr id="161" name="Rectangle 160"/>
+          <p:cNvPr id="162" name="Rectangle 161"/>
           <p:cNvSpPr/>
           <p:nvPr/>
         </p:nvSpPr>
@@ -11073,7 +11117,7 @@
       </p:sp>
       <p:sp>
         <p:nvSpPr>
-          <p:cNvPr id="162" name="Rectangle 161"/>
+          <p:cNvPr id="163" name="Rectangle 162"/>
           <p:cNvSpPr/>
           <p:nvPr/>
         </p:nvSpPr>
@@ -11117,7 +11161,7 @@
       </p:sp>
       <p:pic>
         <p:nvPicPr>
-          <p:cNvPr id="163" name="Picture 162" descr="asset_cikm.png"/>
+          <p:cNvPr id="164" name="Picture 163" descr="asset_cikm.png"/>
           <p:cNvPicPr>
             <a:picLocks noChangeAspect="1"/>
           </p:cNvPicPr>
@@ -11141,7 +11185,7 @@
       </p:pic>
       <p:sp>
         <p:nvSpPr>
-          <p:cNvPr id="164" name="TextBox 163"/>
+          <p:cNvPr id="165" name="TextBox 164"/>
           <p:cNvSpPr txBox="1"/>
           <p:nvPr/>
         </p:nvSpPr>
@@ -11183,7 +11227,7 @@
       </p:sp>
       <p:sp>
         <p:nvSpPr>
-          <p:cNvPr id="165" name="TextBox 164"/>
+          <p:cNvPr id="166" name="TextBox 165"/>
           <p:cNvSpPr txBox="1"/>
           <p:nvPr/>
         </p:nvSpPr>

</xml_diff>

<commit_message>
style(poster): gold star at the right end of the winning bar
</commit_message>
<xml_diff>
--- a/poster/PMC_CIKM2026_poster.pptx
+++ b/poster/PMC_CIKM2026_poster.pptx
@@ -10782,14 +10782,14 @@
         </p:nvSpPr>
         <p:spPr>
           <a:xfrm>
-            <a:off x="15604236" y="36282302"/>
-            <a:ext cx="310896" cy="310896"/>
+            <a:off x="27441144" y="36273158"/>
+            <a:ext cx="329184" cy="329184"/>
           </a:xfrm>
           <a:prstGeom prst="star5">
             <a:avLst/>
           </a:prstGeom>
           <a:solidFill>
-            <a:srgbClr val="8B0029"/>
+            <a:srgbClr val="F5C518"/>
           </a:solidFill>
           <a:ln>
             <a:noFill/>
@@ -10826,8 +10826,8 @@
         </p:nvSpPr>
         <p:spPr>
           <a:xfrm>
-            <a:off x="16024860" y="36209150"/>
-            <a:ext cx="11809476" cy="457200"/>
+            <a:off x="15622524" y="36209150"/>
+            <a:ext cx="12211812" cy="457200"/>
           </a:xfrm>
           <a:prstGeom prst="rect">
             <a:avLst/>

</xml_diff>

<commit_message>
style(poster): deeper gold star with dark outline for visibility
</commit_message>
<xml_diff>
--- a/poster/PMC_CIKM2026_poster.pptx
+++ b/poster/PMC_CIKM2026_poster.pptx
@@ -10782,17 +10782,19 @@
         </p:nvSpPr>
         <p:spPr>
           <a:xfrm>
-            <a:off x="27441144" y="36273158"/>
-            <a:ext cx="329184" cy="329184"/>
+            <a:off x="27413712" y="36254870"/>
+            <a:ext cx="365760" cy="365760"/>
           </a:xfrm>
           <a:prstGeom prst="star5">
             <a:avLst/>
           </a:prstGeom>
           <a:solidFill>
-            <a:srgbClr val="F5C518"/>
+            <a:srgbClr val="F0A202"/>
           </a:solidFill>
-          <a:ln>
-            <a:noFill/>
+          <a:ln w="17780">
+            <a:solidFill>
+              <a:srgbClr val="8A5A00"/>
+            </a:solidFill>
           </a:ln>
           <a:effectLst/>
         </p:spPr>

</xml_diff>

<commit_message>
style(poster): larger star with darker, thicker outline
</commit_message>
<xml_diff>
--- a/poster/PMC_CIKM2026_poster.pptx
+++ b/poster/PMC_CIKM2026_poster.pptx
@@ -10782,8 +10782,8 @@
         </p:nvSpPr>
         <p:spPr>
           <a:xfrm>
-            <a:off x="27413712" y="36254870"/>
-            <a:ext cx="365760" cy="365760"/>
+            <a:off x="27340560" y="36227438"/>
+            <a:ext cx="420624" cy="420624"/>
           </a:xfrm>
           <a:prstGeom prst="star5">
             <a:avLst/>
@@ -10791,9 +10791,9 @@
           <a:solidFill>
             <a:srgbClr val="F0A202"/>
           </a:solidFill>
-          <a:ln w="17780">
+          <a:ln w="30480">
             <a:solidFill>
-              <a:srgbClr val="8A5A00"/>
+              <a:srgbClr val="5C3A00"/>
             </a:solidFill>
           </a:ln>
           <a:effectLst/>

</xml_diff>

<commit_message>
style(poster): fatter star points via adjustment handle
</commit_message>
<xml_diff>
--- a/poster/PMC_CIKM2026_poster.pptx
+++ b/poster/PMC_CIKM2026_poster.pptx
@@ -10782,11 +10782,15 @@
         </p:nvSpPr>
         <p:spPr>
           <a:xfrm>
-            <a:off x="27340560" y="36227438"/>
-            <a:ext cx="420624" cy="420624"/>
+            <a:off x="27322272" y="36218294"/>
+            <a:ext cx="438912" cy="438912"/>
           </a:xfrm>
           <a:prstGeom prst="star5">
-            <a:avLst/>
+            <a:avLst>
+              <a:gd name="adj" fmla="val 32000"/>
+              <a:gd name="hf" fmla="val 105146"/>
+              <a:gd name="vf" fmla="val 110557"/>
+            </a:avLst>
           </a:prstGeom>
           <a:solidFill>
             <a:srgbClr val="F0A202"/>

</xml_diff>